<commit_message>
Erstat session 1 cover-logo med 512×512 fra edc.dk
Det udtrukne PDF-logo var 81×81 og pixelerede synligt på cover-slidet.
Hentede android-chrome-512x512.png fra edc.dk i stedet og forstørrede
samtidig logoet på cover, dividers og outro så det får mere visuel vægt.

Co-Authored-By: Claude Opus 4.7 (1M context) <noreply@anthropic.com>
</commit_message>
<xml_diff>
--- a/slides/session1.pptx
+++ b/slides/session1.pptx
@@ -5043,8 +5043,8 @@
         </p:blipFill>
         <p:spPr>
           <a:xfrm>
-            <a:off x="5641848" y="2103120"/>
-            <a:ext cx="914400" cy="914400"/>
+            <a:off x="5364327" y="1645920"/>
+            <a:ext cx="1463040" cy="1463040"/>
           </a:xfrm>
           <a:prstGeom prst="rect">
             <a:avLst/>
@@ -7606,8 +7606,8 @@
         </p:blipFill>
         <p:spPr>
           <a:xfrm>
-            <a:off x="5641848" y="2103120"/>
-            <a:ext cx="914400" cy="914400"/>
+            <a:off x="5364327" y="1645920"/>
+            <a:ext cx="1463040" cy="1463040"/>
           </a:xfrm>
           <a:prstGeom prst="rect">
             <a:avLst/>
@@ -8436,8 +8436,8 @@
         </p:blipFill>
         <p:spPr>
           <a:xfrm>
-            <a:off x="5641848" y="822960"/>
-            <a:ext cx="822960" cy="822960"/>
+            <a:off x="5547207" y="640080"/>
+            <a:ext cx="1097280" cy="1097280"/>
           </a:xfrm>
           <a:prstGeom prst="rect">
             <a:avLst/>
@@ -12930,8 +12930,8 @@
         </p:blipFill>
         <p:spPr>
           <a:xfrm>
-            <a:off x="5641848" y="2103120"/>
-            <a:ext cx="914400" cy="914400"/>
+            <a:off x="5364327" y="1645920"/>
+            <a:ext cx="1463040" cy="1463040"/>
           </a:xfrm>
           <a:prstGeom prst="rect">
             <a:avLst/>

</xml_diff>

<commit_message>
Fjern logo fra session 1 cover, gør titlen større
Logoet på cover-slidet føltes redundant — section-dividers og
content-slides har det stadig. Med logoet væk har cover-slidet plads
til at gøre titlen større og mere central.

Co-Authored-By: Claude Opus 4.7 (1M context) <noreply@anthropic.com>
</commit_message>
<xml_diff>
--- a/slides/session1.pptx
+++ b/slides/session1.pptx
@@ -5027,39 +5027,15 @@
           </a:p>
         </p:txBody>
       </p:sp>
-      <p:pic>
-        <p:nvPicPr>
-          <p:cNvPr id="3" name="Picture 2" descr="edc_logo.png"/>
-          <p:cNvPicPr>
-            <a:picLocks noChangeAspect="1"/>
-          </p:cNvPicPr>
-          <p:nvPr/>
-        </p:nvPicPr>
-        <p:blipFill>
-          <a:blip r:embed="rId2"/>
-          <a:stretch>
-            <a:fillRect/>
-          </a:stretch>
-        </p:blipFill>
-        <p:spPr>
-          <a:xfrm>
-            <a:off x="5364327" y="1645920"/>
-            <a:ext cx="1463040" cy="1463040"/>
-          </a:xfrm>
-          <a:prstGeom prst="rect">
-            <a:avLst/>
-          </a:prstGeom>
-        </p:spPr>
-      </p:pic>
-      <p:sp>
-        <p:nvSpPr>
-          <p:cNvPr id="4" name="TextBox 3"/>
+      <p:sp>
+        <p:nvSpPr>
+          <p:cNvPr id="3" name="TextBox 2"/>
           <p:cNvSpPr txBox="1"/>
           <p:nvPr/>
         </p:nvSpPr>
         <p:spPr>
           <a:xfrm>
-            <a:off x="0" y="3657600"/>
+            <a:off x="0" y="2651760"/>
             <a:ext cx="12191695" cy="548640"/>
           </a:xfrm>
           <a:prstGeom prst="rect">
@@ -5092,14 +5068,14 @@
       </p:sp>
       <p:sp>
         <p:nvSpPr>
-          <p:cNvPr id="5" name="TextBox 4"/>
+          <p:cNvPr id="4" name="TextBox 3"/>
           <p:cNvSpPr txBox="1"/>
           <p:nvPr/>
         </p:nvSpPr>
         <p:spPr>
           <a:xfrm>
-            <a:off x="0" y="4297680"/>
-            <a:ext cx="12191695" cy="914400"/>
+            <a:off x="0" y="3291840"/>
+            <a:ext cx="12191695" cy="1097280"/>
           </a:xfrm>
           <a:prstGeom prst="rect">
             <a:avLst/>
@@ -5118,7 +5094,7 @@
               </a:lnSpc>
             </a:pPr>
             <a:r>
-              <a:rPr sz="4400" b="1" i="0">
+              <a:rPr sz="5400" b="1" i="0">
                 <a:solidFill>
                   <a:srgbClr val="FFFFFF"/>
                 </a:solidFill>
@@ -5131,13 +5107,13 @@
       </p:sp>
       <p:sp>
         <p:nvSpPr>
-          <p:cNvPr id="6" name="TextBox 5"/>
+          <p:cNvPr id="5" name="TextBox 4"/>
           <p:cNvSpPr txBox="1"/>
           <p:nvPr/>
         </p:nvSpPr>
         <p:spPr>
           <a:xfrm>
-            <a:off x="0" y="5029200"/>
+            <a:off x="0" y="4297680"/>
             <a:ext cx="12191695" cy="548640"/>
           </a:xfrm>
           <a:prstGeom prst="rect">
@@ -5157,7 +5133,7 @@
               </a:lnSpc>
             </a:pPr>
             <a:r>
-              <a:rPr sz="1800" b="0" i="0">
+              <a:rPr sz="2000" b="0" i="0">
                 <a:solidFill>
                   <a:srgbClr val="C8D4E8"/>
                 </a:solidFill>
@@ -5170,7 +5146,7 @@
       </p:sp>
       <p:sp>
         <p:nvSpPr>
-          <p:cNvPr id="7" name="Rectangle 6"/>
+          <p:cNvPr id="6" name="Rectangle 5"/>
           <p:cNvSpPr/>
           <p:nvPr/>
         </p:nvSpPr>

</xml_diff>

<commit_message>
Strukturér session 1 noter med LÆS / SIG / GØR-sektioner
Matias kunne ikke nemt skanne noterne og se forskel på baggrundsinfo
og hvad han skulle sige ordret. Nu har hver note klare overskrifter:
LÆS (kontekst), SIG (ordret citat), GØR (handlinger).

Co-Authored-By: Claude Opus 4.7 (1M context) <noreply@anthropic.com>
</commit_message>
<xml_diff>
--- a/slides/session1.pptx
+++ b/slides/session1.pptx
@@ -517,25 +517,29 @@
           <a:lstStyle/>
           <a:p>
             <a:r>
-              <a:t>VELKOMST · 0:00–0:05</a:t>
+              <a:t>─── LÆS ───</a:t>
+            </a:r>
+          </a:p>
+          <a:p>
+            <a:r>
+              <a:t>Velkomst · 0:00–0:05. Første øjeblik — bare rammesæt. Vent ikke for længe; kom videre.</a:t>
             </a:r>
           </a:p>
           <a:p/>
           <a:p>
             <a:r>
-              <a:t>Velkommen. Jeg er Matias, det her er Michael. Vi er facilitatorer for de næste 5 uger.</a:t>
+              <a:t>─── SIG ───</a:t>
+            </a:r>
+          </a:p>
+          <a:p>
+            <a:r>
+              <a:t>"Velkommen. Jeg er Matias, og det her er Michael. Vi er facilitatorer for de næste 5 uger."</a:t>
             </a:r>
           </a:p>
           <a:p/>
           <a:p>
             <a:r>
-              <a:t>Sig: 'Det her er ikke et kursus hvor I lytter til os. Det er en træningslejr hvor I lærer ved at gøre — og fra session 2 også ved at undervise jeres kollegaer.'</a:t>
-            </a:r>
-          </a:p>
-          <a:p/>
-          <a:p>
-            <a:r>
-              <a:t>Vent ikke for længe på dette slide — kom videre.</a:t>
+              <a:t>"Det her er ikke et kursus hvor I lytter til os. Det er en træningslejr hvor I lærer ved at gøre — og fra session 2 også ved at undervise jeres kollegaer."</a:t>
             </a:r>
           </a:p>
         </p:txBody>
@@ -605,31 +609,73 @@
           <a:lstStyle/>
           <a:p>
             <a:r>
-              <a:t>DÅRLIG PROMPT · 0:22–0:26</a:t>
+              <a:t>─── LÆS ───</a:t>
+            </a:r>
+          </a:p>
+          <a:p>
+            <a:r>
+              <a:t>Realistisk dårlig · 0:22–0:26. Vi har kørt det her 3 gange — den lander forskelligt hver gang.</a:t>
             </a:r>
           </a:p>
           <a:p/>
           <a:p>
             <a:r>
-              <a:t>Sig først: 'Det her ligner en prompt de fleste skriver på autopilot — vi nævner symptomet, men ikke hvor i koden det skal fixes. Det er IKKE en stråmand, det er hverdag.'</a:t>
+              <a:t>─── SIG ───</a:t>
+            </a:r>
+          </a:p>
+          <a:p>
+            <a:r>
+              <a:t>"Det her ligner en prompt de fleste skriver på autopilot — vi nævner symptomet, men ikke hvor i koden det skal fixes."</a:t>
             </a:r>
           </a:p>
           <a:p/>
           <a:p>
             <a:r>
-              <a:t>Kopier prompten ind. Tryk enter.</a:t>
+              <a:t>"Det er IKKE en stråmand, det er hverdag."</a:t>
             </a:r>
           </a:p>
           <a:p/>
           <a:p>
             <a:r>
-              <a:t>Mens Claude arbejder, fortæl: 'Forventning: den finder ET fix der virker. Men vi har kørt det her 3 gange — den lander forskelligt hver gang.'</a:t>
+              <a:t>─── GØR ───</a:t>
+            </a:r>
+          </a:p>
+          <a:p>
+            <a:r>
+              <a:t>Kopier prompten fra slidet ind i Claude. Tryk enter.</a:t>
             </a:r>
           </a:p>
           <a:p/>
           <a:p>
             <a:r>
-              <a:t>Når den er færdig: vis hvad den gjorde, refresh /demo, og sig: 'Det virker! Men hold den her i baghovedet.'</a:t>
+              <a:t>─── SIG (mens Claude arbejder) ───</a:t>
+            </a:r>
+          </a:p>
+          <a:p>
+            <a:r>
+              <a:t>"Forventning: den finder ET fix der virker. Men hold den her i baghovedet — vi har kørt det 3 gange, den lander forskelligt hver gang."</a:t>
+            </a:r>
+          </a:p>
+          <a:p/>
+          <a:p>
+            <a:r>
+              <a:t>─── GØR ───</a:t>
+            </a:r>
+          </a:p>
+          <a:p>
+            <a:r>
+              <a:t>Når Claude er færdig: vis hvad den gjorde, refresh /demo.</a:t>
+            </a:r>
+          </a:p>
+          <a:p/>
+          <a:p>
+            <a:r>
+              <a:t>─── SIG ───</a:t>
+            </a:r>
+          </a:p>
+          <a:p>
+            <a:r>
+              <a:t>"Det virker! Men hold det her i baghovedet."</a:t>
             </a:r>
           </a:p>
         </p:txBody>
@@ -699,13 +745,23 @@
           <a:lstStyle/>
           <a:p>
             <a:r>
-              <a:t>GOD PROMPT · 0:26–0:31</a:t>
+              <a:t>─── LÆS ───</a:t>
+            </a:r>
+          </a:p>
+          <a:p>
+            <a:r>
+              <a:t>Samme opgave, med kontekst · 0:26–0:31.</a:t>
             </a:r>
           </a:p>
           <a:p/>
           <a:p>
             <a:r>
-              <a:t>Først: rul tilbage. Sig højt mens du gør det:</a:t>
+              <a:t>─── GØR ───</a:t>
+            </a:r>
+          </a:p>
+          <a:p>
+            <a:r>
+              <a:t>Rul tilbage i terminalen (vis det højt mens du gør det):</a:t>
             </a:r>
           </a:p>
           <a:p>
@@ -721,25 +777,39 @@
           <a:p/>
           <a:p>
             <a:r>
-              <a:t>Sig: 'Nu siger vi præcis HVOR (3 filer), HVAD (én helper), og HVORDAN (da-DK, DKK, 0 decimaler).'</a:t>
+              <a:t>─── SIG ───</a:t>
+            </a:r>
+          </a:p>
+          <a:p>
+            <a:r>
+              <a:t>"Nu siger vi præcis HVOR (3 filer), HVAD (én helper), og HVORDAN (da-DK, DKK, 0 decimaler)."</a:t>
             </a:r>
           </a:p>
           <a:p/>
           <a:p>
             <a:r>
+              <a:t>─── GØR ───</a:t>
+            </a:r>
+          </a:p>
+          <a:p>
+            <a:r>
               <a:t>Kopier den gode prompt ind. Tryk enter.</a:t>
             </a:r>
           </a:p>
+          <a:p>
+            <a:r>
+              <a:t>Når den er færdig: vis at den lavede ÉN helper i propertyService.ts, og at de andre 2 filer importerer den. Refresh /demo.</a:t>
+            </a:r>
+          </a:p>
           <a:p/>
           <a:p>
             <a:r>
-              <a:t>Når den er færdig: vis at den lavede ÉN helper i propertyService.ts, og at de andre 2 filer importerer den. Refresh /demo.</a:t>
-            </a:r>
-          </a:p>
-          <a:p/>
-          <a:p>
-            <a:r>
-              <a:t>Sig: 'Samme visuelle resultat. Helt anden kode-struktur.'</a:t>
+              <a:t>─── SIG ───</a:t>
+            </a:r>
+          </a:p>
+          <a:p>
+            <a:r>
+              <a:t>"Samme visuelle resultat. Helt anden kode-struktur."</a:t>
             </a:r>
           </a:p>
         </p:txBody>
@@ -809,41 +879,41 @@
           <a:lstStyle/>
           <a:p>
             <a:r>
-              <a:t>POINTEN · 0:31–0:33</a:t>
+              <a:t>─── LÆS ───</a:t>
+            </a:r>
+          </a:p>
+          <a:p>
+            <a:r>
+              <a:t>Sig det højt · 0:31–0:33. Det her er momentet hvor du SKAL sige det højt — ikke bare lade slidet tale. Det er hele dagen i én sætning.</a:t>
             </a:r>
           </a:p>
           <a:p/>
           <a:p>
             <a:r>
-              <a:t>Det her er momentet hvor I skal sige det højt — ikke bare lade slidet tale.</a:t>
+              <a:t>─── SIG ───</a:t>
+            </a:r>
+          </a:p>
+          <a:p>
+            <a:r>
+              <a:t>"Begge fixes virker visuelt — kr. står overalt. Men kig på koden:"</a:t>
             </a:r>
           </a:p>
           <a:p/>
           <a:p>
             <a:r>
-              <a:t>Sig: 'Begge fixes virker visuelt — kr. står overalt. Men kig på koden:</a:t>
-            </a:r>
-          </a:p>
-          <a:p>
-            <a:r>
-              <a:t>- Den dårlige duplikerede logikken 3 steder.</a:t>
-            </a:r>
-          </a:p>
-          <a:p>
-            <a:r>
-              <a:t>- Den gode lavede én helper, brugt 3 steder.'</a:t>
+              <a:t>"Den dårlige duplikerede logikken 3 steder."</a:t>
             </a:r>
           </a:p>
           <a:p/>
           <a:p>
             <a:r>
-              <a:t>'Om 3 måneder, når en designer beder om at vise øre i favorit-listen, er det den forskel der bestemmer om I bruger 5 minutter eller 30.'</a:t>
+              <a:t>"Den gode lavede én helper, brugt 3 steder."</a:t>
             </a:r>
           </a:p>
           <a:p/>
           <a:p>
             <a:r>
-              <a:t>Det er pointen. Det er hele dagen i én sætning.</a:t>
+              <a:t>"Om 3 måneder, når en designer beder om at vise øre i favorit-listen, er det den forskel der bestemmer om I bruger 5 minutter eller 30."</a:t>
             </a:r>
           </a:p>
         </p:txBody>
@@ -913,31 +983,41 @@
           <a:lstStyle/>
           <a:p>
             <a:r>
-              <a:t>VIGTIGT FORBEHOLD · 0:33–0:35</a:t>
+              <a:t>─── LÆS ───</a:t>
+            </a:r>
+          </a:p>
+          <a:p>
+            <a:r>
+              <a:t>Forsikring · 0:33–0:35. Det her slide er forsikring mod den deltager der siger "jamen den dårlige fungerede jo fint". Anerkend det direkte — det er ærligt.</a:t>
             </a:r>
           </a:p>
           <a:p/>
           <a:p>
             <a:r>
-              <a:t>Det her slide er forsikring mod den deltager der siger 'jamen den dårlige fungerede jo fint'.</a:t>
+              <a:t>─── SIG ───</a:t>
+            </a:r>
+          </a:p>
+          <a:p>
+            <a:r>
+              <a:t>"I har ret. På denne lille demo med Opus 4.7 er forskellen subtil — Claude er smart nok til at finde et fix der virker, selv når prompten er vag."</a:t>
             </a:r>
           </a:p>
           <a:p/>
           <a:p>
             <a:r>
-              <a:t>Sig direkte: 'I har ret. På denne lille demo med Opus 4.7 er forskellen subtil — Claude er smart nok til at finde et fix der virker, selv når prompten er vag.'</a:t>
+              <a:t>"Men i jeres rigtige projekter — 100k+ linjer, DTO'er, mappere, migrations, konventioner der ikke er skrevet ned — eksploderer det."</a:t>
             </a:r>
           </a:p>
           <a:p/>
           <a:p>
             <a:r>
-              <a:t>'Men i jeres rigtige projekter — 100k+ linjer, DTO'er, mappere, migrations, konventioner der ikke er skrevet ned — eksploderer det. En vag prompt rammer den forkerte fil, glemmer halvdelen af kæden, eller introducerer et abstraktionslag der konflikter med jeres eksisterende.'</a:t>
+              <a:t>"En vag prompt rammer den forkerte fil, glemmer halvdelen af kæden, eller introducerer et abstraktionslag der konflikter med jeres eksisterende."</a:t>
             </a:r>
           </a:p>
           <a:p/>
           <a:p>
             <a:r>
-              <a:t>'Vi træner mønsteret her hvor det er sikkert at fejle — så det sidder i fingrene når I er midt i en rigtig PR mandag morgen.'</a:t>
+              <a:t>"Vi træner mønsteret her hvor det er sikkert at fejle — så det sidder i fingrene når I er midt i en rigtig PR mandag morgen."</a:t>
             </a:r>
           </a:p>
         </p:txBody>
@@ -1007,19 +1087,35 @@
           <a:lstStyle/>
           <a:p>
             <a:r>
-              <a:t>HANDS-ON · 0:35 — start</a:t>
+              <a:t>─── LÆS ───</a:t>
+            </a:r>
+          </a:p>
+          <a:p>
+            <a:r>
+              <a:t>Korte instrukser · 0:35 — start. De skal i gang.</a:t>
             </a:r>
           </a:p>
           <a:p/>
           <a:p>
             <a:r>
-              <a:t>Korte og klare instrukser. Læs slidet højt — kort.</a:t>
+              <a:t>─── SIG ───</a:t>
+            </a:r>
+          </a:p>
+          <a:p>
+            <a:r>
+              <a:t>"Nu jer."</a:t>
             </a:r>
           </a:p>
           <a:p/>
           <a:p>
             <a:r>
-              <a:t>Sig: 'Nu jer. Par jer op 2 og 2 — gerne på tværs af teams så I møder nogen nye. I har 20 minutter.'</a:t>
+              <a:t>"Par jer op 2 og 2 — gerne på tværs af teams så I møder nogen nye."</a:t>
+            </a:r>
+          </a:p>
+          <a:p/>
+          <a:p>
+            <a:r>
+              <a:t>"I har 20 minutter."</a:t>
             </a:r>
           </a:p>
         </p:txBody>
@@ -1089,45 +1185,46 @@
           <a:lstStyle/>
           <a:p>
             <a:r>
-              <a:t>HANDS-ON FORTSAT · 0:35–0:55</a:t>
+              <a:t>─── LÆS ───</a:t>
+            </a:r>
+          </a:p>
+          <a:p>
+            <a:r>
+              <a:t>Mens de arbejder · 0:35–0:55. Gå rundt. Hjælp dem der sidder fast. Lyt efter en god 'aha'-bemærkning du kan bede dem dele bagefter.</a:t>
             </a:r>
           </a:p>
           <a:p/>
           <a:p>
             <a:r>
-              <a:t>Pege på slidet og læs trinene højt. Sørg for at de:</a:t>
-            </a:r>
-          </a:p>
-          <a:p>
-            <a:r>
-              <a:t>1. Får clonet repoet (én af dem)</a:t>
-            </a:r>
-          </a:p>
-          <a:p>
-            <a:r>
-              <a:t>2. Kører Claude i demo/-mappen</a:t>
-            </a:r>
-          </a:p>
-          <a:p>
-            <a:r>
-              <a:t>3. PRØVER BEGGE prompts — ikke bare den gode</a:t>
-            </a:r>
-          </a:p>
-          <a:p>
-            <a:r>
-              <a:t>4. Diskuterer forskellen sammen</a:t>
+              <a:t>─── SIG (i starten) ───</a:t>
+            </a:r>
+          </a:p>
+          <a:p>
+            <a:r>
+              <a:t>"Læs trinene på slidet: clone, npm install, claude i demo. Vælg én opgave fra demoen."</a:t>
             </a:r>
           </a:p>
           <a:p/>
           <a:p>
             <a:r>
-              <a:t>Mens de arbejder: gå rundt. Hjælp dem der sidder fast. Lyt efter en god 'aha'-bemærkning du kan bede dem dele bagefter.</a:t>
+              <a:t>"Det vigtigste: prøv BEGGE prompts — ikke bare den gode. Diskuter forskellen sammen."</a:t>
             </a:r>
           </a:p>
           <a:p/>
           <a:p>
             <a:r>
-              <a:t>Med 5 min tilbage: 'Saml jer — én indsigt højt fra hvert par. Den der overraskede jer mest.'</a:t>
+              <a:t>"Hvis I sidder fast, ræk hånden op — vi går rundt."</a:t>
+            </a:r>
+          </a:p>
+          <a:p/>
+          <a:p>
+            <a:r>
+              <a:t>─── SIG (med 5 min tilbage) ───</a:t>
+            </a:r>
+          </a:p>
+          <a:p>
+            <a:r>
+              <a:t>"Saml jer — én indsigt højt fra hvert par. Den der overraskede jer mest."</a:t>
             </a:r>
           </a:p>
         </p:txBody>
@@ -1197,31 +1294,47 @@
           <a:lstStyle/>
           <a:p>
             <a:r>
-              <a:t>AFSLUTNING · 0:55–1:00</a:t>
+              <a:t>─── LÆS ───</a:t>
+            </a:r>
+          </a:p>
+          <a:p>
+            <a:r>
+              <a:t>Afslutning · 0:55–1:00. Hjemmeopgave nem. Bekræft næste præsentant igen ved navn så de ved det er reelt.</a:t>
             </a:r>
           </a:p>
           <a:p/>
           <a:p>
             <a:r>
-              <a:t>Sig direkte: 'Hjemmeopgaven er nem. Brug Claude Code på MINDST én rigtig opgave inden torsdag — i et af jeres rigtige projekter, ikke demoen.'</a:t>
+              <a:t>─── SIG ───</a:t>
+            </a:r>
+          </a:p>
+          <a:p>
+            <a:r>
+              <a:t>"Hjemmeopgaven er nem. Brug Claude Code på MINDST én rigtig opgave inden torsdag — i et af jeres rigtige projekter, ikke demoen."</a:t>
             </a:r>
           </a:p>
           <a:p/>
           <a:p>
             <a:r>
-              <a:t>'Tag to prompts med til torsdag: én der virkede godt, og én der ikke gjorde. Vi starter session 2 med at dele dem. Vi lærer mest af de fejlede prompts.'</a:t>
+              <a:t>"Tag to prompts med til torsdag: én der virkede godt, og én der ikke gjorde."</a:t>
             </a:r>
           </a:p>
           <a:p/>
           <a:p>
             <a:r>
-              <a:t>Bekræft næste præsentant igen ved navn så de ved det er reelt: '[Navn] tager session 2 om Plan mode. Jeg sender slide-skabelon og pre-work-video senest mandag.'</a:t>
+              <a:t>"Vi starter session 2 med at dele dem. Vi lærer mest af de fejlede prompts."</a:t>
             </a:r>
           </a:p>
           <a:p/>
           <a:p>
             <a:r>
-              <a:t>Tak for i dag.</a:t>
+              <a:t>"[Navn] tager session 2 om Plan mode. Jeg sender slide-skabelon og pre-work-video senest mandag."</a:t>
+            </a:r>
+          </a:p>
+          <a:p/>
+          <a:p>
+            <a:r>
+              <a:t>"Tak for i dag."</a:t>
             </a:r>
           </a:p>
         </p:txBody>
@@ -1291,25 +1404,35 @@
           <a:lstStyle/>
           <a:p>
             <a:r>
-              <a:t>DAGSORDEN · 0:05–0:07</a:t>
+              <a:t>─── LÆS ───</a:t>
+            </a:r>
+          </a:p>
+          <a:p>
+            <a:r>
+              <a:t>Hurtigt overblik · 0:05–0:07. Peg på de fremhævede (blå) felter — det er de tre hoveddele. Pause efter 30 min er en mental anker.</a:t>
             </a:r>
           </a:p>
           <a:p/>
           <a:p>
             <a:r>
-              <a:t>Hurtigt overblik — peg på de fremhævede felter (de blå): det er de tre hoveddele.</a:t>
+              <a:t>─── SIG ───</a:t>
+            </a:r>
+          </a:p>
+          <a:p>
+            <a:r>
+              <a:t>"Lige om lidt fortæller jeg lidt om hvordan de næste 5 uger ser ud."</a:t>
             </a:r>
           </a:p>
           <a:p/>
           <a:p>
             <a:r>
-              <a:t>Sig: 'Lige om lidt fortæller jeg lidt om hvordan de næste 5 uger ser ud. Så går vi i terminalen og laver en live demo. Og så er det jer der skal kode.'</a:t>
+              <a:t>"Så går vi i terminalen og laver en live demo."</a:t>
             </a:r>
           </a:p>
           <a:p/>
           <a:p>
             <a:r>
-              <a:t>Pause efter 30 min er en god mental anker — folk slapper af når de ved hvornår de kan trække vejret.</a:t>
+              <a:t>"Og så er det jer der skal kode."</a:t>
             </a:r>
           </a:p>
         </p:txBody>
@@ -1379,25 +1502,35 @@
           <a:lstStyle/>
           <a:p>
             <a:r>
-              <a:t>VORES ROLLE · 0:07–0:10</a:t>
+              <a:t>─── LÆS ───</a:t>
+            </a:r>
+          </a:p>
+          <a:p>
+            <a:r>
+              <a:t>Vigtigste pointe i dag · 0:07–0:10. Hvis de bare lytter, lærer de ingenting. Hvis de underviser hinanden, sidder det fast.</a:t>
             </a:r>
           </a:p>
           <a:p/>
           <a:p>
             <a:r>
-              <a:t>Det her er den vigtigste pointe i dag: vi er ikke guruer. Hvis I bare lytter, lærer I ingenting. Hvis I underviser hinanden, sidder det fast.</a:t>
+              <a:t>─── SIG ───</a:t>
+            </a:r>
+          </a:p>
+          <a:p>
+            <a:r>
+              <a:t>"Det her er den vigtigste pointe i dag: Michael og jeg er facilitatorer, ikke guruer."</a:t>
             </a:r>
           </a:p>
           <a:p/>
           <a:p>
             <a:r>
-              <a:t>Sig direkte: 'Jeg ved ikke nødvendigvis mere end jer om Claude Code om 5 uger. Det her er et hold der lærer sammen.'</a:t>
+              <a:t>"Jeg ved ikke nødvendigvis mere end jer om Claude Code om 5 uger. Det her er et hold der lærer sammen."</a:t>
             </a:r>
           </a:p>
           <a:p/>
           <a:p>
             <a:r>
-              <a:t>Forklar at vi hjælper med slides ugen før — så ingen står alene. Det er præcis 1 time, det er ikke en disputats.</a:t>
+              <a:t>"Fra session 2 er det én af jer der præsenterer dagens emne. Vi hjælper med slides ugen før, så ingen står alene med det."</a:t>
             </a:r>
           </a:p>
         </p:txBody>
@@ -1467,28 +1600,48 @@
           <a:lstStyle/>
           <a:p>
             <a:r>
-              <a:t>VÆLG NÆSTE PRÆSENTANT · 0:10–0:13</a:t>
+              <a:t>─── LÆS ───</a:t>
+            </a:r>
+          </a:p>
+          <a:p>
+            <a:r>
+              <a:t>Akavet øjeblik · 0:10–0:13. Stil spørgsmålet og hold mund. Lad stilheden virke. Hvis ingen melder sig efter 10 sek: vælg én du ved godt har lyst — eller én der ser frisk ud.</a:t>
             </a:r>
           </a:p>
           <a:p/>
           <a:p>
             <a:r>
-              <a:t>Det her øjeblik er lidt akavet — det er meningen. Stil spørgsmålet og hold mund.</a:t>
+              <a:t>─── SIG ───</a:t>
+            </a:r>
+          </a:p>
+          <a:p>
+            <a:r>
+              <a:t>"Hvem vil tage session 2 om Plan mode? Det er torsdag, jeg hjælper jer med slides senest mandag eftermiddag."</a:t>
             </a:r>
           </a:p>
           <a:p/>
           <a:p>
             <a:r>
-              <a:t>Sig: 'Hvem vil tage session 2 om Plan mode? Det er torsdag, jeg hjælper jer med slides senest mandag eftermiddag.'</a:t>
+              <a:t>[Vent. Tæl til 10 i hovedet.]</a:t>
             </a:r>
           </a:p>
           <a:p/>
           <a:p>
             <a:r>
-              <a:t>Vent. Lad stilheden arbejde for jer. Hvis ingen melder sig efter 10 sekunder, så vælg én du ved godt har lyst — eller én der ser frisk ud. Sig venligt: '[Navn] — vil du tage den?'</a:t>
+              <a:t>Hvis ingen melder sig:</a:t>
+            </a:r>
+          </a:p>
+          <a:p>
+            <a:r>
+              <a:t>"[Navn] — vil du tage den?"</a:t>
             </a:r>
           </a:p>
           <a:p/>
+          <a:p>
+            <a:r>
+              <a:t>─── GØR ───</a:t>
+            </a:r>
+          </a:p>
           <a:p>
             <a:r>
               <a:t>Når én melder sig: TAK højt. Det sætter normen for resten af forløbet.</a:t>
@@ -1561,25 +1714,35 @@
           <a:lstStyle/>
           <a:p>
             <a:r>
-              <a:t>DAGENS KERNE · 0:13–0:15</a:t>
+              <a:t>─── LÆS ───</a:t>
+            </a:r>
+          </a:p>
+          <a:p>
+            <a:r>
+              <a:t>Saml i ÉN sætning · 0:13–0:15. Sig den langsomt. Det er hele dagen i én linje.</a:t>
             </a:r>
           </a:p>
           <a:p/>
           <a:p>
             <a:r>
-              <a:t>Saml det op til ÉN sætning. Sig den langsomt:</a:t>
+              <a:t>─── SIG ───</a:t>
+            </a:r>
+          </a:p>
+          <a:p>
+            <a:r>
+              <a:t>"En dårlig prompt giver generisk kode."</a:t>
             </a:r>
           </a:p>
           <a:p/>
           <a:p>
             <a:r>
-              <a:t>'En dårlig prompt giver generisk kode. En god prompt giver produktionsklar kode.'</a:t>
+              <a:t>"En god prompt giver produktionsklar kode."</a:t>
             </a:r>
           </a:p>
           <a:p/>
           <a:p>
             <a:r>
-              <a:t>Forskellen er kontekst. Det er det vi træner i dag. Resten af de næste 5 uger bygger ovenpå det.</a:t>
+              <a:t>"Forskellen er kontekst. Det er det vi træner i dag."</a:t>
             </a:r>
           </a:p>
         </p:txBody>
@@ -1649,40 +1812,53 @@
           <a:lstStyle/>
           <a:p>
             <a:r>
-              <a:t>DE 4 BYGGEKLODSER · 0:15–0:18</a:t>
+              <a:t>─── LÆS ───</a:t>
+            </a:r>
+          </a:p>
+          <a:p>
+            <a:r>
+              <a:t>Mønsteret · 0:15–0:18. Det her skal de kunne udenad efter session 1. Læs dem op én af gangen og giv et lille eksempel for hver.</a:t>
             </a:r>
           </a:p>
           <a:p/>
           <a:p>
             <a:r>
-              <a:t>Det her er det MØNSTER I skal kunne udenad efter session 1. Læs dem op én af gangen og giv et lille eksempel:</a:t>
+              <a:t>─── SIG ───</a:t>
+            </a:r>
+          </a:p>
+          <a:p>
+            <a:r>
+              <a:t>"En god prompt har altid 4 dele."</a:t>
             </a:r>
           </a:p>
           <a:p/>
           <a:p>
             <a:r>
-              <a:t>1. KONTEKST — 'Læs lib/propertyService.ts og components/PropertyCard.tsx'</a:t>
-            </a:r>
-          </a:p>
-          <a:p>
-            <a:r>
-              <a:t>2. OPGAVE — 'Lav en formatPrice-helper og brug den i begge filer'</a:t>
-            </a:r>
-          </a:p>
-          <a:p>
-            <a:r>
-              <a:t>3. BEGRÆNSNINGER — 'Rør intet andet. Ingen commit.'</a:t>
-            </a:r>
-          </a:p>
-          <a:p>
-            <a:r>
-              <a:t>4. FORVENTET OUTPUT — 'Priser vises som 8.500.000 kr. — alle 3 steder'</a:t>
+              <a:t>"1. Kontekst — fx: Læs lib/propertyService.ts og components/PropertyCard.tsx."</a:t>
             </a:r>
           </a:p>
           <a:p/>
           <a:p>
             <a:r>
-              <a:t>Lov dem at vi vender tilbage til mønsteret hver eneste session.</a:t>
+              <a:t>"2. Opgave — fx: Lav en formatPrice-helper og brug den i begge filer."</a:t>
+            </a:r>
+          </a:p>
+          <a:p/>
+          <a:p>
+            <a:r>
+              <a:t>"3. Begrænsninger — fx: Rør intet andet. Ingen commit."</a:t>
+            </a:r>
+          </a:p>
+          <a:p/>
+          <a:p>
+            <a:r>
+              <a:t>"4. Forventet output — fx: Priser vises som 8.500.000 kr. — alle 3 steder."</a:t>
+            </a:r>
+          </a:p>
+          <a:p/>
+          <a:p>
+            <a:r>
+              <a:t>"Vi vender tilbage til de 4 byggeklodser hver eneste session de næste 5 uger."</a:t>
             </a:r>
           </a:p>
         </p:txBody>
@@ -1752,31 +1928,41 @@
           <a:lstStyle/>
           <a:p>
             <a:r>
-              <a:t>TRYGHED · 0:18–0:20</a:t>
+              <a:t>─── LÆS ───</a:t>
+            </a:r>
+          </a:p>
+          <a:p>
+            <a:r>
+              <a:t>Tryghed fra dag 1 · 0:18–0:20. Vi går i dybden i session 3, men de skal vide om det FRA i dag. Pointe: hvis de aldrig kan rulle tilbage, tør de aldrig prøve noget nyt.</a:t>
             </a:r>
           </a:p>
           <a:p/>
           <a:p>
             <a:r>
-              <a:t>Det her er et trick I skal vide om FRA dag 1, selvom vi går i dybden i session 3.</a:t>
+              <a:t>─── SIG ───</a:t>
+            </a:r>
+          </a:p>
+          <a:p>
+            <a:r>
+              <a:t>"Når Claude laver noget I fortryder — eller koden går i sort — så tryk Esc to gange."</a:t>
             </a:r>
           </a:p>
           <a:p/>
           <a:p>
             <a:r>
-              <a:t>Sig: 'Når Claude laver noget I fortryder — eller koden går i sort — så tryk Esc to gange. Der kommer en menu hvor I kan rulle tilbage til ethvert tidligere punkt i samtalen. Filerne, conversation, eller begge dele.'</a:t>
+              <a:t>"Der kommer en menu hvor I kan rulle tilbage til ethvert tidligere punkt i samtalen. Filerne, conversation, eller begge dele."</a:t>
             </a:r>
           </a:p>
           <a:p/>
           <a:p>
             <a:r>
-              <a:t>Pointe (læs slidet højt): 'Det er det her der gør det trygt at lade Claude prøve noget vildt.'</a:t>
+              <a:t>"Det er det her der gør det trygt at lade Claude prøve noget vildt."</a:t>
             </a:r>
           </a:p>
           <a:p/>
           <a:p>
             <a:r>
-              <a:t>Sig: 'I må gerne bruge det fra første prompt I skriver i dag.'</a:t>
+              <a:t>"I må gerne bruge det fra første prompt I skriver i dag."</a:t>
             </a:r>
           </a:p>
         </p:txBody>
@@ -1846,45 +2032,61 @@
           <a:lstStyle/>
           <a:p>
             <a:r>
-              <a:t>LIVE DEMO · 0:20 — start</a:t>
+              <a:t>─── LÆS ───</a:t>
+            </a:r>
+          </a:p>
+          <a:p>
+            <a:r>
+              <a:t>Skift til terminal · 0:20 — start.</a:t>
             </a:r>
           </a:p>
           <a:p/>
           <a:p>
             <a:r>
-              <a:t>OK — nu skifter vi til terminal og browser. Slides bliver siddende på dette billede mens I forklarer setup'et.</a:t>
+              <a:t>TJEKLISTE FØR DU KØRER:</a:t>
+            </a:r>
+          </a:p>
+          <a:p>
+            <a:r>
+              <a:t>  □ git status er clean</a:t>
+            </a:r>
+          </a:p>
+          <a:p>
+            <a:r>
+              <a:t>  □ /demo er åben i browseren med USD-priser synlige</a:t>
+            </a:r>
+          </a:p>
+          <a:p>
+            <a:r>
+              <a:t>  □ claude --dangerously-skip-permissions kører i demo/-mappen</a:t>
+            </a:r>
+          </a:p>
+          <a:p>
+            <a:r>
+              <a:t>  □ Du kan se BÅDE terminal og browser samtidig på projektoren</a:t>
             </a:r>
           </a:p>
           <a:p/>
           <a:p>
             <a:r>
-              <a:t>Sig: 'I de næste 15 minutter skriver jeg samme opgave til Claude — først dårligt, så godt. Kig BÅDE på terminalen og på /demo i browseren ved siden af.'</a:t>
+              <a:t>─── SIG ───</a:t>
+            </a:r>
+          </a:p>
+          <a:p>
+            <a:r>
+              <a:t>"OK — nu skifter vi til terminal og browser."</a:t>
             </a:r>
           </a:p>
           <a:p/>
           <a:p>
             <a:r>
-              <a:t>TJEKLISTE FØR DU KØRER:</a:t>
-            </a:r>
-          </a:p>
-          <a:p>
-            <a:r>
-              <a:t>□ git status er clean</a:t>
-            </a:r>
-          </a:p>
-          <a:p>
-            <a:r>
-              <a:t>□ /demo er åben i browseren med USD-priser synlige</a:t>
-            </a:r>
-          </a:p>
-          <a:p>
-            <a:r>
-              <a:t>□ claude --dangerously-skip-permissions kører i demo/-mappen</a:t>
-            </a:r>
-          </a:p>
-          <a:p>
-            <a:r>
-              <a:t>□ Du kan se BÅDE terminal og browser samtidig på projektoren</a:t>
+              <a:t>"I de næste 15 minutter skriver jeg samme opgave til Claude — først dårligt, så godt."</a:t>
+            </a:r>
+          </a:p>
+          <a:p/>
+          <a:p>
+            <a:r>
+              <a:t>"Kig BÅDE på terminalen og på /demo i browseren ved siden af."</a:t>
             </a:r>
           </a:p>
         </p:txBody>
@@ -1954,31 +2156,56 @@
           <a:lstStyle/>
           <a:p>
             <a:r>
-              <a:t>VIS BUG'EN · 0:20–0:22</a:t>
+              <a:t>─── LÆS ───</a:t>
+            </a:r>
+          </a:p>
+          <a:p>
+            <a:r>
+              <a:t>Vis bug'en · 0:20–0:22.</a:t>
             </a:r>
           </a:p>
           <a:p/>
           <a:p>
             <a:r>
+              <a:t>─── GØR ───</a:t>
+            </a:r>
+          </a:p>
+          <a:p>
+            <a:r>
               <a:t>Skift til browseren. Scroll ned ad /demo. Peg eksplicit på priserne.</a:t>
             </a:r>
           </a:p>
+          <a:p>
+            <a:r>
+              <a:t>Klik på en bolig — vis at detaljesiden har samme problem.</a:t>
+            </a:r>
+          </a:p>
+          <a:p>
+            <a:r>
+              <a:t>Søg "demo@edc.dk" i favorit-widgeten — også USD-priser.</a:t>
+            </a:r>
+          </a:p>
           <a:p/>
           <a:p>
             <a:r>
-              <a:t>Sig: 'Det her er en dansk bolig-side. Priserne er i amerikanske dollars MED cents. Hele sitet er i stykker visuelt.'</a:t>
+              <a:t>─── SIG ───</a:t>
+            </a:r>
+          </a:p>
+          <a:p>
+            <a:r>
+              <a:t>"Det her er en dansk bolig-side. Priserne er i amerikanske dollars MED cents. Hele sitet er i stykker visuelt."</a:t>
             </a:r>
           </a:p>
           <a:p/>
           <a:p>
             <a:r>
-              <a:t>Klik på en bolig — vis at detaljesiden har samme problem. Søg demo@edc.dk i favorit-widgeten — også USD-priser.</a:t>
+              <a:t>"Pris-formateringen ligger inline 3 steder uden helper. Det er ikke konstrueret — det er typisk consequence af 'hurtigt fix' nogen lavede engang."</a:t>
             </a:r>
           </a:p>
           <a:p/>
           <a:p>
             <a:r>
-              <a:t>Sig: 'Det er det her vi vil have Claude til at fixe. Pris-formateringen ligger inline 3 steder uden helper. Det er ikke konstrueret — det er typisk consequence af 'hurtigt fix' nogen lavede engang.'</a:t>
+              <a:t>"Det er det her vi vil have Claude til at fixe."</a:t>
             </a:r>
           </a:p>
         </p:txBody>

</xml_diff>

<commit_message>
Fjern pause + skift hands-on til solo + erstat "guruer" med "eksperter"
- Dagsorden: pause er væk (ingen tid på 1 time), live demo strækker
  fra 0:15 til 0:35 i stedet
- Hands-on er nu solo på egen maskine, ikke par-arbejde — deltagerne
  skal selv mærke forskellen i fingrene
- "Facilitatorer, ikke guruer" → "Facilitatorer, ikke eksperter"
  (mindre prætentiøst sprog)

Synkroniseret med slides/session1.pptx og api/session.js (workshop-sitet).

Co-Authored-By: Claude Opus 4.7 (1M context) <noreply@anthropic.com>
</commit_message>
<xml_diff>
--- a/slides/session1.pptx
+++ b/slides/session1.pptx
@@ -1109,7 +1109,7 @@
           <a:p/>
           <a:p>
             <a:r>
-              <a:t>"Par jer op 2 og 2 — gerne på tværs af teams så I møder nogen nye."</a:t>
+              <a:t>"Solo på din egen maskine — du skal selv mærke forskellen i fingrene."</a:t>
             </a:r>
           </a:p>
           <a:p/>
@@ -1207,13 +1207,13 @@
           <a:p/>
           <a:p>
             <a:r>
-              <a:t>"Det vigtigste: prøv BEGGE prompts — ikke bare den gode. Diskuter forskellen sammen."</a:t>
+              <a:t>"Det vigtigste: prøv BEGGE prompts — ikke bare den gode. Læg mærke til forskellen."</a:t>
             </a:r>
           </a:p>
           <a:p/>
           <a:p>
             <a:r>
-              <a:t>"Hvis I sidder fast, ræk hånden op — vi går rundt."</a:t>
+              <a:t>"Hvis du sidder fast, ræk hånden op — vi går rundt."</a:t>
             </a:r>
           </a:p>
           <a:p/>
@@ -1224,7 +1224,7 @@
           </a:p>
           <a:p>
             <a:r>
-              <a:t>"Saml jer — én indsigt højt fra hvert par. Den der overraskede jer mest."</a:t>
+              <a:t>"Saml jer — én indsigt højt fra hver. Den der overraskede jer mest."</a:t>
             </a:r>
           </a:p>
         </p:txBody>
@@ -1409,7 +1409,7 @@
           </a:p>
           <a:p>
             <a:r>
-              <a:t>Hurtigt overblik · 0:05–0:07. Peg på de fremhævede (blå) felter — det er de tre hoveddele. Pause efter 30 min er en mental anker.</a:t>
+              <a:t>Hurtigt overblik · 0:05–0:07. Peg på de fremhævede (blå) felter — det er de tre hoveddele. Ingen pause på en time, men det går stærkt.</a:t>
             </a:r>
           </a:p>
           <a:p/>
@@ -1432,7 +1432,7 @@
           <a:p/>
           <a:p>
             <a:r>
-              <a:t>"Og så er det jer der skal kode."</a:t>
+              <a:t>"Og så er det jer der skal kode — solo på jeres egen maskine."</a:t>
             </a:r>
           </a:p>
         </p:txBody>
@@ -1518,7 +1518,7 @@
           </a:p>
           <a:p>
             <a:r>
-              <a:t>"Det her er den vigtigste pointe i dag: Michael og jeg er facilitatorer, ikke guruer."</a:t>
+              <a:t>"Det her er den vigtigste pointe i dag: Michael og jeg er facilitatorer, ikke eksperter."</a:t>
             </a:r>
           </a:p>
           <a:p/>
@@ -7929,7 +7929,7 @@
                 </a:solidFill>
                 <a:latin typeface="Helvetica"/>
               </a:rPr>
-              <a:t>20 minutter · par jer 2 og 2</a:t>
+              <a:t>20 minutter · solo på din egen maskine</a:t>
             </a:r>
           </a:p>
         </p:txBody>
@@ -8117,7 +8117,7 @@
               </a:spcAft>
             </a:pPr>
             <a:r>
-              <a:rPr sz="1700" b="1">
+              <a:rPr sz="1800" b="1">
                 <a:solidFill>
                   <a:srgbClr val="122A52"/>
                 </a:solidFill>
@@ -8126,13 +8126,58 @@
               <a:t>■   </a:t>
             </a:r>
             <a:r>
-              <a:rPr sz="1700" b="0">
+              <a:rPr sz="1800" b="1">
                 <a:solidFill>
                   <a:srgbClr val="122A52"/>
                 </a:solidFill>
                 <a:latin typeface="Helvetica"/>
               </a:rPr>
-              <a:t>Par jer op — gerne på tværs af teams</a:t>
+              <a:t>git clone</a:t>
+            </a:r>
+            <a:r>
+              <a:rPr sz="1800" b="0">
+                <a:solidFill>
+                  <a:srgbClr val="122A52"/>
+                </a:solidFill>
+                <a:latin typeface="Helvetica"/>
+              </a:rPr>
+              <a:t> + </a:t>
+            </a:r>
+            <a:r>
+              <a:rPr sz="1800" b="1">
+                <a:solidFill>
+                  <a:srgbClr val="122A52"/>
+                </a:solidFill>
+                <a:latin typeface="Helvetica"/>
+              </a:rPr>
+              <a:t>npm install</a:t>
+            </a:r>
+            <a:r>
+              <a:rPr sz="1800" b="0">
+                <a:solidFill>
+                  <a:srgbClr val="122A52"/>
+                </a:solidFill>
+                <a:latin typeface="Helvetica"/>
+              </a:rPr>
+              <a:t> + </a:t>
+            </a:r>
+            <a:r>
+              <a:rPr sz="1800" b="1">
+                <a:solidFill>
+                  <a:srgbClr val="122A52"/>
+                </a:solidFill>
+                <a:latin typeface="Helvetica"/>
+              </a:rPr>
+              <a:t>claude</a:t>
+            </a:r>
+            <a:r>
+              <a:rPr sz="1800" b="0">
+                <a:solidFill>
+                  <a:srgbClr val="122A52"/>
+                </a:solidFill>
+                <a:latin typeface="Helvetica"/>
+              </a:rPr>
+              <a:t> i `demo/`-mappen</a:t>
             </a:r>
           </a:p>
           <a:p>
@@ -8145,7 +8190,7 @@
               </a:spcAft>
             </a:pPr>
             <a:r>
-              <a:rPr sz="1700" b="1">
+              <a:rPr sz="1800" b="1">
                 <a:solidFill>
                   <a:srgbClr val="122A52"/>
                 </a:solidFill>
@@ -8154,67 +8199,13 @@
               <a:t>■   </a:t>
             </a:r>
             <a:r>
-              <a:rPr sz="1700" b="0">
+              <a:rPr sz="1800" b="0">
                 <a:solidFill>
                   <a:srgbClr val="122A52"/>
                 </a:solidFill>
                 <a:latin typeface="Helvetica"/>
               </a:rPr>
-              <a:t>En af jer kører: </a:t>
-            </a:r>
-            <a:r>
-              <a:rPr sz="1700" b="1">
-                <a:solidFill>
-                  <a:srgbClr val="122A52"/>
-                </a:solidFill>
-                <a:latin typeface="Helvetica"/>
-              </a:rPr>
-              <a:t>git clone</a:t>
-            </a:r>
-            <a:r>
-              <a:rPr sz="1700" b="0">
-                <a:solidFill>
-                  <a:srgbClr val="122A52"/>
-                </a:solidFill>
-                <a:latin typeface="Helvetica"/>
-              </a:rPr>
-              <a:t> + </a:t>
-            </a:r>
-            <a:r>
-              <a:rPr sz="1700" b="1">
-                <a:solidFill>
-                  <a:srgbClr val="122A52"/>
-                </a:solidFill>
-                <a:latin typeface="Helvetica"/>
-              </a:rPr>
-              <a:t>npm install</a:t>
-            </a:r>
-            <a:r>
-              <a:rPr sz="1700" b="0">
-                <a:solidFill>
-                  <a:srgbClr val="122A52"/>
-                </a:solidFill>
-                <a:latin typeface="Helvetica"/>
-              </a:rPr>
-              <a:t> + </a:t>
-            </a:r>
-            <a:r>
-              <a:rPr sz="1700" b="1">
-                <a:solidFill>
-                  <a:srgbClr val="122A52"/>
-                </a:solidFill>
-                <a:latin typeface="Helvetica"/>
-              </a:rPr>
-              <a:t>claude</a:t>
-            </a:r>
-            <a:r>
-              <a:rPr sz="1700" b="0">
-                <a:solidFill>
-                  <a:srgbClr val="122A52"/>
-                </a:solidFill>
-                <a:latin typeface="Helvetica"/>
-              </a:rPr>
-              <a:t> i `demo/`-mappen</a:t>
+              <a:t>Vælg én opgave fra demoen (pris-bug, performance, eller favorit-knap)</a:t>
             </a:r>
           </a:p>
           <a:p>
@@ -8227,7 +8218,7 @@
               </a:spcAft>
             </a:pPr>
             <a:r>
-              <a:rPr sz="1700" b="1">
+              <a:rPr sz="1800" b="1">
                 <a:solidFill>
                   <a:srgbClr val="122A52"/>
                 </a:solidFill>
@@ -8236,13 +8227,31 @@
               <a:t>■   </a:t>
             </a:r>
             <a:r>
-              <a:rPr sz="1700" b="0">
+              <a:rPr sz="1800" b="0">
                 <a:solidFill>
                   <a:srgbClr val="122A52"/>
                 </a:solidFill>
                 <a:latin typeface="Helvetica"/>
               </a:rPr>
-              <a:t>Vælg én opgave fra demoen (pris-bug, performance, eller favorit-knap)</a:t>
+              <a:t>Skriv først en </a:t>
+            </a:r>
+            <a:r>
+              <a:rPr sz="1800" b="1">
+                <a:solidFill>
+                  <a:srgbClr val="122A52"/>
+                </a:solidFill>
+                <a:latin typeface="Helvetica"/>
+              </a:rPr>
+              <a:t>hurtig prompt</a:t>
+            </a:r>
+            <a:r>
+              <a:rPr sz="1800" b="0">
+                <a:solidFill>
+                  <a:srgbClr val="122A52"/>
+                </a:solidFill>
+                <a:latin typeface="Helvetica"/>
+              </a:rPr>
+              <a:t> — som du ville skrive på en travl dag</a:t>
             </a:r>
           </a:p>
           <a:p>
@@ -8255,7 +8264,7 @@
               </a:spcAft>
             </a:pPr>
             <a:r>
-              <a:rPr sz="1700" b="1">
+              <a:rPr sz="1800" b="1">
                 <a:solidFill>
                   <a:srgbClr val="122A52"/>
                 </a:solidFill>
@@ -8264,31 +8273,40 @@
               <a:t>■   </a:t>
             </a:r>
             <a:r>
-              <a:rPr sz="1700" b="0">
+              <a:rPr sz="1800" b="1">
                 <a:solidFill>
                   <a:srgbClr val="122A52"/>
                 </a:solidFill>
                 <a:latin typeface="Helvetica"/>
               </a:rPr>
-              <a:t>Skriv først en </a:t>
-            </a:r>
-            <a:r>
-              <a:rPr sz="1700" b="1">
+              <a:t>git checkout .</a:t>
+            </a:r>
+            <a:r>
+              <a:rPr sz="1800" b="0">
                 <a:solidFill>
                   <a:srgbClr val="122A52"/>
                 </a:solidFill>
                 <a:latin typeface="Helvetica"/>
               </a:rPr>
-              <a:t>hurtig prompt</a:t>
-            </a:r>
-            <a:r>
-              <a:rPr sz="1700" b="0">
+              <a:t> og </a:t>
+            </a:r>
+            <a:r>
+              <a:rPr sz="1800" b="1">
                 <a:solidFill>
                   <a:srgbClr val="122A52"/>
                 </a:solidFill>
                 <a:latin typeface="Helvetica"/>
               </a:rPr>
-              <a:t> — som I ville skrive på en travl dag</a:t>
+              <a:t>/clear</a:t>
+            </a:r>
+            <a:r>
+              <a:rPr sz="1800" b="0">
+                <a:solidFill>
+                  <a:srgbClr val="122A52"/>
+                </a:solidFill>
+                <a:latin typeface="Helvetica"/>
+              </a:rPr>
+              <a:t> for at rulle tilbage</a:t>
             </a:r>
           </a:p>
           <a:p>
@@ -8301,7 +8319,7 @@
               </a:spcAft>
             </a:pPr>
             <a:r>
-              <a:rPr sz="1700" b="1">
+              <a:rPr sz="1800" b="1">
                 <a:solidFill>
                   <a:srgbClr val="122A52"/>
                 </a:solidFill>
@@ -8310,40 +8328,22 @@
               <a:t>■   </a:t>
             </a:r>
             <a:r>
-              <a:rPr sz="1700" b="1">
+              <a:rPr sz="1800" b="0">
                 <a:solidFill>
                   <a:srgbClr val="122A52"/>
                 </a:solidFill>
                 <a:latin typeface="Helvetica"/>
               </a:rPr>
-              <a:t>git checkout .</a:t>
-            </a:r>
-            <a:r>
-              <a:rPr sz="1700" b="0">
+              <a:t>Skriv så en prompt med </a:t>
+            </a:r>
+            <a:r>
+              <a:rPr sz="1800" b="1">
                 <a:solidFill>
                   <a:srgbClr val="122A52"/>
                 </a:solidFill>
                 <a:latin typeface="Helvetica"/>
               </a:rPr>
-              <a:t> og </a:t>
-            </a:r>
-            <a:r>
-              <a:rPr sz="1700" b="1">
-                <a:solidFill>
-                  <a:srgbClr val="122A52"/>
-                </a:solidFill>
-                <a:latin typeface="Helvetica"/>
-              </a:rPr>
-              <a:t>/clear</a:t>
-            </a:r>
-            <a:r>
-              <a:rPr sz="1700" b="0">
-                <a:solidFill>
-                  <a:srgbClr val="122A52"/>
-                </a:solidFill>
-                <a:latin typeface="Helvetica"/>
-              </a:rPr>
-              <a:t> for at rulle tilbage</a:t>
+              <a:t>alle 4 byggeklodser</a:t>
             </a:r>
           </a:p>
           <a:p>
@@ -8356,7 +8356,7 @@
               </a:spcAft>
             </a:pPr>
             <a:r>
-              <a:rPr sz="1700" b="1">
+              <a:rPr sz="1800" b="1">
                 <a:solidFill>
                   <a:srgbClr val="122A52"/>
                 </a:solidFill>
@@ -8365,50 +8365,13 @@
               <a:t>■   </a:t>
             </a:r>
             <a:r>
-              <a:rPr sz="1700" b="0">
+              <a:rPr sz="1800" b="0">
                 <a:solidFill>
                   <a:srgbClr val="122A52"/>
                 </a:solidFill>
                 <a:latin typeface="Helvetica"/>
               </a:rPr>
-              <a:t>Skriv så en prompt med </a:t>
-            </a:r>
-            <a:r>
-              <a:rPr sz="1700" b="1">
-                <a:solidFill>
-                  <a:srgbClr val="122A52"/>
-                </a:solidFill>
-                <a:latin typeface="Helvetica"/>
-              </a:rPr>
-              <a:t>alle 4 byggeklodser</a:t>
-            </a:r>
-          </a:p>
-          <a:p>
-            <a:pPr algn="l">
-              <a:lnSpc>
-                <a:spcPct val="160000"/>
-              </a:lnSpc>
-              <a:spcAft>
-                <a:spcPts val="1000"/>
-              </a:spcAft>
-            </a:pPr>
-            <a:r>
-              <a:rPr sz="1700" b="1">
-                <a:solidFill>
-                  <a:srgbClr val="122A52"/>
-                </a:solidFill>
-                <a:latin typeface="Helvetica"/>
-              </a:rPr>
-              <a:t>■   </a:t>
-            </a:r>
-            <a:r>
-              <a:rPr sz="1700" b="0">
-                <a:solidFill>
-                  <a:srgbClr val="122A52"/>
-                </a:solidFill>
-                <a:latin typeface="Helvetica"/>
-              </a:rPr>
-              <a:t>Sammenlign: hvad var forskellen? Hvilken ville I committe?</a:t>
+              <a:t>Sammenlign: hvad var forskellen? Hvilken ville du committe?</a:t>
             </a:r>
           </a:p>
         </p:txBody>
@@ -9366,7 +9329,7 @@
                 </a:solidFill>
                 <a:latin typeface="Helvetica"/>
               </a:rPr>
-              <a:t>0:15–0:30</a:t>
+              <a:t>0:15–0:35</a:t>
             </a:r>
           </a:p>
         </p:txBody>
@@ -9438,7 +9401,7 @@
             <a:avLst/>
           </a:prstGeom>
           <a:solidFill>
-            <a:srgbClr val="9CA3AF"/>
+            <a:srgbClr val="122A52"/>
           </a:solidFill>
           <a:ln>
             <a:noFill/>
@@ -9470,7 +9433,7 @@
                 </a:solidFill>
                 <a:latin typeface="Helvetica"/>
               </a:rPr>
-              <a:t>0:30–0:35</a:t>
+              <a:t>0:35–0:55</a:t>
             </a:r>
           </a:p>
         </p:txBody>
@@ -9485,6 +9448,58 @@
           <a:xfrm>
             <a:off x="2697480" y="3739896"/>
             <a:ext cx="8778240" cy="502920"/>
+          </a:xfrm>
+          <a:prstGeom prst="rect">
+            <a:avLst/>
+          </a:prstGeom>
+          <a:solidFill>
+            <a:srgbClr val="122A52"/>
+          </a:solidFill>
+          <a:ln>
+            <a:noFill/>
+          </a:ln>
+        </p:spPr>
+        <p:style>
+          <a:lnRef idx="1">
+            <a:schemeClr val="accent1"/>
+          </a:lnRef>
+          <a:fillRef idx="3">
+            <a:schemeClr val="accent1"/>
+          </a:fillRef>
+          <a:effectRef idx="2">
+            <a:schemeClr val="accent1"/>
+          </a:effectRef>
+          <a:fontRef idx="minor">
+            <a:schemeClr val="lt1"/>
+          </a:fontRef>
+        </p:style>
+        <p:txBody>
+          <a:bodyPr rtlCol="0" anchor="ctr" lIns="228600" rIns="182880"/>
+          <a:lstStyle/>
+          <a:p>
+            <a:pPr algn="l"/>
+            <a:r>
+              <a:rPr sz="1500" b="1">
+                <a:solidFill>
+                  <a:srgbClr val="FFFFFF"/>
+                </a:solidFill>
+                <a:latin typeface="Helvetica"/>
+              </a:rPr>
+              <a:t>Hands-on — solo på din egen maskine</a:t>
+            </a:r>
+          </a:p>
+        </p:txBody>
+      </p:sp>
+      <p:sp>
+        <p:nvSpPr>
+          <p:cNvPr id="13" name="Rectangle 12"/>
+          <p:cNvSpPr/>
+          <p:nvPr/>
+        </p:nvSpPr>
+        <p:spPr>
+          <a:xfrm>
+            <a:off x="777240" y="4315968"/>
+            <a:ext cx="1828800" cy="502920"/>
           </a:xfrm>
           <a:prstGeom prst="rect">
             <a:avLst/>
@@ -9511,6 +9526,58 @@
           </a:fontRef>
         </p:style>
         <p:txBody>
+          <a:bodyPr rtlCol="0" anchor="ctr" lIns="182880" rIns="182880"/>
+          <a:lstStyle/>
+          <a:p>
+            <a:pPr algn="l"/>
+            <a:r>
+              <a:rPr sz="1500" b="1">
+                <a:solidFill>
+                  <a:srgbClr val="FFFFFF"/>
+                </a:solidFill>
+                <a:latin typeface="Helvetica"/>
+              </a:rPr>
+              <a:t>0:55–1:00</a:t>
+            </a:r>
+          </a:p>
+        </p:txBody>
+      </p:sp>
+      <p:sp>
+        <p:nvSpPr>
+          <p:cNvPr id="14" name="Rectangle 13"/>
+          <p:cNvSpPr/>
+          <p:nvPr/>
+        </p:nvSpPr>
+        <p:spPr>
+          <a:xfrm>
+            <a:off x="2697480" y="4315968"/>
+            <a:ext cx="8778240" cy="502920"/>
+          </a:xfrm>
+          <a:prstGeom prst="rect">
+            <a:avLst/>
+          </a:prstGeom>
+          <a:solidFill>
+            <a:srgbClr val="9CA3AF"/>
+          </a:solidFill>
+          <a:ln>
+            <a:noFill/>
+          </a:ln>
+        </p:spPr>
+        <p:style>
+          <a:lnRef idx="1">
+            <a:schemeClr val="accent1"/>
+          </a:lnRef>
+          <a:fillRef idx="3">
+            <a:schemeClr val="accent1"/>
+          </a:fillRef>
+          <a:effectRef idx="2">
+            <a:schemeClr val="accent1"/>
+          </a:effectRef>
+          <a:fontRef idx="minor">
+            <a:schemeClr val="lt1"/>
+          </a:fontRef>
+        </p:style>
+        <p:txBody>
           <a:bodyPr rtlCol="0" anchor="ctr" lIns="228600" rIns="182880"/>
           <a:lstStyle/>
           <a:p>
@@ -9522,21 +9589,21 @@
                 </a:solidFill>
                 <a:latin typeface="Helvetica"/>
               </a:rPr>
-              <a:t>Pause</a:t>
-            </a:r>
-          </a:p>
-        </p:txBody>
-      </p:sp>
-      <p:sp>
-        <p:nvSpPr>
-          <p:cNvPr id="13" name="Rectangle 12"/>
+              <a:t>Del indsigter + take-home</a:t>
+            </a:r>
+          </a:p>
+        </p:txBody>
+      </p:sp>
+      <p:sp>
+        <p:nvSpPr>
+          <p:cNvPr id="15" name="Rectangle 14"/>
           <p:cNvSpPr/>
           <p:nvPr/>
         </p:nvSpPr>
         <p:spPr>
           <a:xfrm>
-            <a:off x="777240" y="4315968"/>
-            <a:ext cx="1828800" cy="502920"/>
+            <a:off x="0" y="0"/>
+            <a:ext cx="12191695" cy="164592"/>
           </a:xfrm>
           <a:prstGeom prst="rect">
             <a:avLst/>
@@ -9563,32 +9630,23 @@
           </a:fontRef>
         </p:style>
         <p:txBody>
-          <a:bodyPr rtlCol="0" anchor="ctr" lIns="182880" rIns="182880"/>
-          <a:lstStyle/>
-          <a:p>
-            <a:pPr algn="l"/>
-            <a:r>
-              <a:rPr sz="1500" b="1">
-                <a:solidFill>
-                  <a:srgbClr val="FFFFFF"/>
-                </a:solidFill>
-                <a:latin typeface="Helvetica"/>
-              </a:rPr>
-              <a:t>0:35–0:55</a:t>
-            </a:r>
-          </a:p>
-        </p:txBody>
-      </p:sp>
-      <p:sp>
-        <p:nvSpPr>
-          <p:cNvPr id="14" name="Rectangle 13"/>
+          <a:bodyPr rtlCol="0" anchor="ctr"/>
+          <a:lstStyle/>
+          <a:p>
+            <a:pPr algn="ctr"/>
+          </a:p>
+        </p:txBody>
+      </p:sp>
+      <p:sp>
+        <p:nvSpPr>
+          <p:cNvPr id="16" name="Rectangle 15"/>
           <p:cNvSpPr/>
           <p:nvPr/>
         </p:nvSpPr>
         <p:spPr>
           <a:xfrm>
-            <a:off x="2697480" y="4315968"/>
-            <a:ext cx="8778240" cy="502920"/>
+            <a:off x="0" y="6693408"/>
+            <a:ext cx="12191695" cy="164592"/>
           </a:xfrm>
           <a:prstGeom prst="rect">
             <a:avLst/>
@@ -9615,162 +9673,6 @@
           </a:fontRef>
         </p:style>
         <p:txBody>
-          <a:bodyPr rtlCol="0" anchor="ctr" lIns="228600" rIns="182880"/>
-          <a:lstStyle/>
-          <a:p>
-            <a:pPr algn="l"/>
-            <a:r>
-              <a:rPr sz="1500" b="1">
-                <a:solidFill>
-                  <a:srgbClr val="FFFFFF"/>
-                </a:solidFill>
-                <a:latin typeface="Helvetica"/>
-              </a:rPr>
-              <a:t>Hands-on — par jer 2 og 2</a:t>
-            </a:r>
-          </a:p>
-        </p:txBody>
-      </p:sp>
-      <p:sp>
-        <p:nvSpPr>
-          <p:cNvPr id="15" name="Rectangle 14"/>
-          <p:cNvSpPr/>
-          <p:nvPr/>
-        </p:nvSpPr>
-        <p:spPr>
-          <a:xfrm>
-            <a:off x="777240" y="4892040"/>
-            <a:ext cx="1828800" cy="502920"/>
-          </a:xfrm>
-          <a:prstGeom prst="rect">
-            <a:avLst/>
-          </a:prstGeom>
-          <a:solidFill>
-            <a:srgbClr val="9CA3AF"/>
-          </a:solidFill>
-          <a:ln>
-            <a:noFill/>
-          </a:ln>
-        </p:spPr>
-        <p:style>
-          <a:lnRef idx="1">
-            <a:schemeClr val="accent1"/>
-          </a:lnRef>
-          <a:fillRef idx="3">
-            <a:schemeClr val="accent1"/>
-          </a:fillRef>
-          <a:effectRef idx="2">
-            <a:schemeClr val="accent1"/>
-          </a:effectRef>
-          <a:fontRef idx="minor">
-            <a:schemeClr val="lt1"/>
-          </a:fontRef>
-        </p:style>
-        <p:txBody>
-          <a:bodyPr rtlCol="0" anchor="ctr" lIns="182880" rIns="182880"/>
-          <a:lstStyle/>
-          <a:p>
-            <a:pPr algn="l"/>
-            <a:r>
-              <a:rPr sz="1500" b="1">
-                <a:solidFill>
-                  <a:srgbClr val="FFFFFF"/>
-                </a:solidFill>
-                <a:latin typeface="Helvetica"/>
-              </a:rPr>
-              <a:t>0:55–1:00</a:t>
-            </a:r>
-          </a:p>
-        </p:txBody>
-      </p:sp>
-      <p:sp>
-        <p:nvSpPr>
-          <p:cNvPr id="16" name="Rectangle 15"/>
-          <p:cNvSpPr/>
-          <p:nvPr/>
-        </p:nvSpPr>
-        <p:spPr>
-          <a:xfrm>
-            <a:off x="2697480" y="4892040"/>
-            <a:ext cx="8778240" cy="502920"/>
-          </a:xfrm>
-          <a:prstGeom prst="rect">
-            <a:avLst/>
-          </a:prstGeom>
-          <a:solidFill>
-            <a:srgbClr val="9CA3AF"/>
-          </a:solidFill>
-          <a:ln>
-            <a:noFill/>
-          </a:ln>
-        </p:spPr>
-        <p:style>
-          <a:lnRef idx="1">
-            <a:schemeClr val="accent1"/>
-          </a:lnRef>
-          <a:fillRef idx="3">
-            <a:schemeClr val="accent1"/>
-          </a:fillRef>
-          <a:effectRef idx="2">
-            <a:schemeClr val="accent1"/>
-          </a:effectRef>
-          <a:fontRef idx="minor">
-            <a:schemeClr val="lt1"/>
-          </a:fontRef>
-        </p:style>
-        <p:txBody>
-          <a:bodyPr rtlCol="0" anchor="ctr" lIns="228600" rIns="182880"/>
-          <a:lstStyle/>
-          <a:p>
-            <a:pPr algn="l"/>
-            <a:r>
-              <a:rPr sz="1500" b="1">
-                <a:solidFill>
-                  <a:srgbClr val="FFFFFF"/>
-                </a:solidFill>
-                <a:latin typeface="Helvetica"/>
-              </a:rPr>
-              <a:t>Del indsigter + take-home</a:t>
-            </a:r>
-          </a:p>
-        </p:txBody>
-      </p:sp>
-      <p:sp>
-        <p:nvSpPr>
-          <p:cNvPr id="17" name="Rectangle 16"/>
-          <p:cNvSpPr/>
-          <p:nvPr/>
-        </p:nvSpPr>
-        <p:spPr>
-          <a:xfrm>
-            <a:off x="0" y="0"/>
-            <a:ext cx="12191695" cy="164592"/>
-          </a:xfrm>
-          <a:prstGeom prst="rect">
-            <a:avLst/>
-          </a:prstGeom>
-          <a:solidFill>
-            <a:srgbClr val="122A52"/>
-          </a:solidFill>
-          <a:ln>
-            <a:noFill/>
-          </a:ln>
-        </p:spPr>
-        <p:style>
-          <a:lnRef idx="1">
-            <a:schemeClr val="accent1"/>
-          </a:lnRef>
-          <a:fillRef idx="3">
-            <a:schemeClr val="accent1"/>
-          </a:fillRef>
-          <a:effectRef idx="2">
-            <a:schemeClr val="accent1"/>
-          </a:effectRef>
-          <a:fontRef idx="minor">
-            <a:schemeClr val="lt1"/>
-          </a:fontRef>
-        </p:style>
-        <p:txBody>
           <a:bodyPr rtlCol="0" anchor="ctr"/>
           <a:lstStyle/>
           <a:p>
@@ -9780,50 +9682,7 @@
       </p:sp>
       <p:sp>
         <p:nvSpPr>
-          <p:cNvPr id="18" name="Rectangle 17"/>
-          <p:cNvSpPr/>
-          <p:nvPr/>
-        </p:nvSpPr>
-        <p:spPr>
-          <a:xfrm>
-            <a:off x="0" y="6693408"/>
-            <a:ext cx="12191695" cy="164592"/>
-          </a:xfrm>
-          <a:prstGeom prst="rect">
-            <a:avLst/>
-          </a:prstGeom>
-          <a:solidFill>
-            <a:srgbClr val="122A52"/>
-          </a:solidFill>
-          <a:ln>
-            <a:noFill/>
-          </a:ln>
-        </p:spPr>
-        <p:style>
-          <a:lnRef idx="1">
-            <a:schemeClr val="accent1"/>
-          </a:lnRef>
-          <a:fillRef idx="3">
-            <a:schemeClr val="accent1"/>
-          </a:fillRef>
-          <a:effectRef idx="2">
-            <a:schemeClr val="accent1"/>
-          </a:effectRef>
-          <a:fontRef idx="minor">
-            <a:schemeClr val="lt1"/>
-          </a:fontRef>
-        </p:style>
-        <p:txBody>
-          <a:bodyPr rtlCol="0" anchor="ctr"/>
-          <a:lstStyle/>
-          <a:p>
-            <a:pPr algn="ctr"/>
-          </a:p>
-        </p:txBody>
-      </p:sp>
-      <p:sp>
-        <p:nvSpPr>
-          <p:cNvPr id="19" name="TextBox 18"/>
+          <p:cNvPr id="17" name="TextBox 16"/>
           <p:cNvSpPr txBox="1"/>
           <p:nvPr/>
         </p:nvSpPr>
@@ -9862,7 +9721,7 @@
       </p:sp>
       <p:pic>
         <p:nvPicPr>
-          <p:cNvPr id="20" name="Picture 19" descr="edc_logo.png"/>
+          <p:cNvPr id="18" name="Picture 17" descr="edc_logo.png"/>
           <p:cNvPicPr>
             <a:picLocks noChangeAspect="1"/>
           </p:cNvPicPr>
@@ -9988,7 +9847,7 @@
                 </a:solidFill>
                 <a:latin typeface="Helvetica"/>
               </a:rPr>
-              <a:t> | Facilitatorer, ikke guruer</a:t>
+              <a:t> | Facilitatorer, ikke eksperter</a:t>
             </a:r>
           </a:p>
         </p:txBody>
@@ -10179,7 +10038,7 @@
                 </a:solidFill>
                 <a:latin typeface="Helvetica"/>
               </a:rPr>
-              <a:t> alle 5 uger. Vi er her for at gøre det trygt — ikke for at være eksperter på Claude Code. Det her er et hold der lærer sammen.</a:t>
+              <a:t> alle 5 uger. Vi er her for at gøre det trygt og holde tråden — det her er et hold der lærer sammen.</a:t>
             </a:r>
           </a:p>
         </p:txBody>

</xml_diff>

<commit_message>
Slide 4 + 5 finpudsning fra workshop-test
Slide 4 (Vælg næste præsentant):
- Fjern "1 time" — er underforstået fra dagsordenen
- Pre-work-video sendes "senest dagen før" (var: senest mandag eftermiddag)
- "Vi gentager øvelsen i starten af hver session" (var: slutningen)

Slide 5 (Dagens kerne):
- "Forskellen er hvor meget kontekst du giver Claude" → "Forskellen er
  hvor præcist du beskriver opgaven". "Kontekst" var tvetydigt — kunne
  forveksles med Claudes context window.

Synkroniseret med session.js.

Co-Authored-By: Claude Opus 4.7 (1M context) <noreply@anthropic.com>
</commit_message>
<xml_diff>
--- a/slides/session1.pptx
+++ b/slides/session1.pptx
@@ -1616,7 +1616,7 @@
           </a:p>
           <a:p>
             <a:r>
-              <a:t>"Hvem vil tage session 2 om Plan mode? Det er torsdag, jeg hjælper jer med slides senest mandag eftermiddag."</a:t>
+              <a:t>"Hvem vil tage session 2 om Plan mode? Det er torsdag, jeg sender slide-skabelon og pre-work-video senest dagen før."</a:t>
             </a:r>
           </a:p>
           <a:p/>
@@ -1742,7 +1742,7 @@
           <a:p/>
           <a:p>
             <a:r>
-              <a:t>"Forskellen er kontekst. Det er det vi træner i dag."</a:t>
+              <a:t>"Forskellen er hvor præcist du beskriver opgaven for Claude. Det er det vi træner i dag."</a:t>
             </a:r>
           </a:p>
         </p:txBody>
@@ -10708,7 +10708,7 @@
                 </a:solidFill>
                 <a:latin typeface="Helvetica"/>
               </a:rPr>
-              <a:t>Torsdag · uge 1 · 1 time</a:t>
+              <a:t>Torsdag · uge 1</a:t>
             </a:r>
           </a:p>
         </p:txBody>
@@ -10756,7 +10756,7 @@
                 </a:solidFill>
                 <a:latin typeface="Helvetica"/>
               </a:rPr>
-              <a:t>senest mandag eftermiddag</a:t>
+              <a:t>senest dagen før</a:t>
             </a:r>
             <a:r>
               <a:rPr sz="1500" b="0">
@@ -10765,7 +10765,7 @@
                 </a:solidFill>
                 <a:latin typeface="Helvetica"/>
               </a:rPr>
-              <a:t>, så I står ikke alene med det. Hvis ingen melder sig, vælger vi én — og vi gentager øvelsen i slutningen af hver session.</a:t>
+              <a:t>, så du står ikke alene med det. Hvis ingen melder sig, vælger vi én — og vi gentager øvelsen i starten af hver session.</a:t>
             </a:r>
           </a:p>
         </p:txBody>
@@ -11183,7 +11183,7 @@
                 </a:solidFill>
                 <a:latin typeface="Helvetica"/>
               </a:rPr>
-              <a:t>Forskellen er hvor meget kontekst du giver Claude.</a:t>
+              <a:t>Forskellen er hvor præcist du beskriver opgaven.</a:t>
             </a:r>
           </a:p>
         </p:txBody>

</xml_diff>

<commit_message>
Slide 6 finpudsning: drop "Verbum først", marker Begrænsninger optional
- "Verbum først" er gramatisk jargon — erstattet med konkrete eksempler
  ("Lav en helper", "Tilføj knap")
- Begrænsninger har nu en "Når relevant"-badge — ikke alle prompts
  behøver dem (fx "forklar denne fil")
- Subtitel blødgjort: "altid disse fire dele" → "Tænk i fire dele når
  du skriver en prompt"
- Heading-font reduceret fra 21pt til 18pt så "Begrænsninger" passer
  på én linje
- Speaker-noten opdateret til at adressere begge pointer

Co-Authored-By: Claude Opus 4.7 (1M context) <noreply@anthropic.com>
</commit_message>
<xml_diff>
--- a/slides/session1.pptx
+++ b/slides/session1.pptx
@@ -1817,7 +1817,7 @@
           </a:p>
           <a:p>
             <a:r>
-              <a:t>Mønsteret · 0:15–0:18. Det her skal de kunne udenad efter session 1. Læs dem op én af gangen og giv et lille eksempel for hver.</a:t>
+              <a:t>Mønsteret · 0:15–0:18. Det her skal de kunne udenad efter session 1. Læs dem op én af gangen og giv et lille eksempel for hver. Vigtigt: BEGRÆNSNINGER er markeret "når relevant" — det er ikke nødvendigt for hver prompt (fx ikke for "forklar denne fil"), men ved kode-ændringer er det guld værd.</a:t>
             </a:r>
           </a:p>
           <a:p/>
@@ -1828,37 +1828,37 @@
           </a:p>
           <a:p>
             <a:r>
-              <a:t>"En god prompt har altid 4 dele."</a:t>
+              <a:t>"Tænk i fire dele når du skriver en prompt:"</a:t>
             </a:r>
           </a:p>
           <a:p/>
           <a:p>
             <a:r>
-              <a:t>"1. Kontekst — fx: Læs lib/propertyService.ts og components/PropertyCard.tsx."</a:t>
+              <a:t>"1. Kontekst — fx: 'Læs lib/propertyService.ts og components/PropertyCard.tsx'."</a:t>
             </a:r>
           </a:p>
           <a:p/>
           <a:p>
             <a:r>
-              <a:t>"2. Opgave — fx: Lav en formatPrice-helper og brug den i begge filer."</a:t>
+              <a:t>"2. Opgave — konkret, fx: 'Lav en formatPrice-helper og brug den i begge filer'. Ikke 'der er noget med priserne...'."</a:t>
             </a:r>
           </a:p>
           <a:p/>
           <a:p>
             <a:r>
-              <a:t>"3. Begrænsninger — fx: Rør intet andet. Ingen commit."</a:t>
+              <a:t>"3. Begrænsninger — når relevant. Fx: 'Rør intet andet. Ingen commit.' Hvis du bare vil have Claude til at forklare en fil, kan du droppe det her."</a:t>
             </a:r>
           </a:p>
           <a:p/>
           <a:p>
             <a:r>
-              <a:t>"4. Forventet output — fx: Priser vises som 8.500.000 kr. — alle 3 steder."</a:t>
+              <a:t>"4. Forventet output — fx: 'Priser vises som 8.500.000 kr. alle 3 steder.'"</a:t>
             </a:r>
           </a:p>
           <a:p/>
           <a:p>
             <a:r>
-              <a:t>"Vi vender tilbage til de 4 byggeklodser hver eneste session de næste 5 uger."</a:t>
+              <a:t>"Vi vender tilbage til mønsteret hver eneste session de næste 5 uger."</a:t>
             </a:r>
           </a:p>
         </p:txBody>
@@ -11441,7 +11441,7 @@
                 </a:solidFill>
                 <a:latin typeface="Helvetica"/>
               </a:rPr>
-              <a:t> | En god prompt har altid disse fire dele</a:t>
+              <a:t> | Tænk i fire dele når du skriver en prompt</a:t>
             </a:r>
           </a:p>
         </p:txBody>
@@ -11454,8 +11454,8 @@
         </p:nvSpPr>
         <p:spPr>
           <a:xfrm>
-            <a:off x="640080" y="2103120"/>
-            <a:ext cx="2606040" cy="3108960"/>
+            <a:off x="594360" y="2011680"/>
+            <a:ext cx="2697480" cy="3291840"/>
           </a:xfrm>
           <a:prstGeom prst="rect">
             <a:avLst/>
@@ -11497,7 +11497,7 @@
         </p:nvSpPr>
         <p:spPr>
           <a:xfrm>
-            <a:off x="1005840" y="2468880"/>
+            <a:off x="960120" y="2377440"/>
             <a:ext cx="548640" cy="548640"/>
           </a:xfrm>
           <a:prstGeom prst="ellipse">
@@ -11549,8 +11549,8 @@
         </p:nvSpPr>
         <p:spPr>
           <a:xfrm>
-            <a:off x="1005840" y="3291840"/>
-            <a:ext cx="1874520" cy="640080"/>
+            <a:off x="868680" y="3200400"/>
+            <a:ext cx="2148840" cy="640080"/>
           </a:xfrm>
           <a:prstGeom prst="rect">
             <a:avLst/>
@@ -11569,7 +11569,7 @@
               </a:lnSpc>
             </a:pPr>
             <a:r>
-              <a:rPr sz="2100" b="1" i="0">
+              <a:rPr sz="1800" b="1" i="0">
                 <a:solidFill>
                   <a:srgbClr val="122A52"/>
                 </a:solidFill>
@@ -11588,8 +11588,8 @@
         </p:nvSpPr>
         <p:spPr>
           <a:xfrm>
-            <a:off x="1005840" y="4023360"/>
-            <a:ext cx="1874520" cy="1097280"/>
+            <a:off x="868680" y="3840480"/>
+            <a:ext cx="2148840" cy="1280160"/>
           </a:xfrm>
           <a:prstGeom prst="rect">
             <a:avLst/>
@@ -11628,8 +11628,8 @@
         </p:nvSpPr>
         <p:spPr>
           <a:xfrm>
-            <a:off x="3410712" y="2103120"/>
-            <a:ext cx="2606040" cy="3108960"/>
+            <a:off x="3410712" y="2011680"/>
+            <a:ext cx="2697480" cy="3291840"/>
           </a:xfrm>
           <a:prstGeom prst="rect">
             <a:avLst/>
@@ -11671,7 +11671,7 @@
         </p:nvSpPr>
         <p:spPr>
           <a:xfrm>
-            <a:off x="3776472" y="2468880"/>
+            <a:off x="3776472" y="2377440"/>
             <a:ext cx="548640" cy="548640"/>
           </a:xfrm>
           <a:prstGeom prst="ellipse">
@@ -11723,8 +11723,8 @@
         </p:nvSpPr>
         <p:spPr>
           <a:xfrm>
-            <a:off x="3776472" y="3291840"/>
-            <a:ext cx="1874520" cy="640080"/>
+            <a:off x="3685032" y="3200400"/>
+            <a:ext cx="2148840" cy="640080"/>
           </a:xfrm>
           <a:prstGeom prst="rect">
             <a:avLst/>
@@ -11743,7 +11743,7 @@
               </a:lnSpc>
             </a:pPr>
             <a:r>
-              <a:rPr sz="2100" b="1" i="0">
+              <a:rPr sz="1800" b="1" i="0">
                 <a:solidFill>
                   <a:srgbClr val="122A52"/>
                 </a:solidFill>
@@ -11762,8 +11762,8 @@
         </p:nvSpPr>
         <p:spPr>
           <a:xfrm>
-            <a:off x="3776472" y="4023360"/>
-            <a:ext cx="1874520" cy="1097280"/>
+            <a:off x="3685032" y="3840480"/>
+            <a:ext cx="2148840" cy="1280160"/>
           </a:xfrm>
           <a:prstGeom prst="rect">
             <a:avLst/>
@@ -11789,7 +11789,8 @@
                 <a:latin typeface="Helvetica"/>
               </a:rPr>
               <a:t>Hvad vil du have
-gjort? Verbum først.</a:t>
+gjort? Fx "Lav en
+helper", "Tilføj knap".</a:t>
             </a:r>
           </a:p>
         </p:txBody>
@@ -11802,8 +11803,8 @@
         </p:nvSpPr>
         <p:spPr>
           <a:xfrm>
-            <a:off x="6181344" y="2103120"/>
-            <a:ext cx="2606040" cy="3108960"/>
+            <a:off x="6227064" y="2011680"/>
+            <a:ext cx="2697480" cy="3291840"/>
           </a:xfrm>
           <a:prstGeom prst="rect">
             <a:avLst/>
@@ -11845,7 +11846,7 @@
         </p:nvSpPr>
         <p:spPr>
           <a:xfrm>
-            <a:off x="6547104" y="2468880"/>
+            <a:off x="6592824" y="2377440"/>
             <a:ext cx="548640" cy="548640"/>
           </a:xfrm>
           <a:prstGeom prst="ellipse">
@@ -11891,14 +11892,68 @@
       </p:sp>
       <p:sp>
         <p:nvSpPr>
-          <p:cNvPr id="14" name="TextBox 13"/>
+          <p:cNvPr id="14" name="Rounded Rectangle 13"/>
+          <p:cNvSpPr/>
+          <p:nvPr/>
+        </p:nvSpPr>
+        <p:spPr>
+          <a:xfrm>
+            <a:off x="7598664" y="2514600"/>
+            <a:ext cx="1097280" cy="274320"/>
+          </a:xfrm>
+          <a:prstGeom prst="roundRect">
+            <a:avLst>
+              <a:gd name="adj" fmla="val 50000"/>
+            </a:avLst>
+          </a:prstGeom>
+          <a:solidFill>
+            <a:srgbClr val="F5B81C"/>
+          </a:solidFill>
+          <a:ln>
+            <a:noFill/>
+          </a:ln>
+        </p:spPr>
+        <p:style>
+          <a:lnRef idx="1">
+            <a:schemeClr val="accent1"/>
+          </a:lnRef>
+          <a:fillRef idx="3">
+            <a:schemeClr val="accent1"/>
+          </a:fillRef>
+          <a:effectRef idx="2">
+            <a:schemeClr val="accent1"/>
+          </a:effectRef>
+          <a:fontRef idx="minor">
+            <a:schemeClr val="lt1"/>
+          </a:fontRef>
+        </p:style>
+        <p:txBody>
+          <a:bodyPr rtlCol="0" anchor="ctr" lIns="0" rIns="0" tIns="0" bIns="0"/>
+          <a:lstStyle/>
+          <a:p>
+            <a:pPr algn="ctr"/>
+            <a:r>
+              <a:rPr sz="1100" b="1">
+                <a:solidFill>
+                  <a:srgbClr val="122A52"/>
+                </a:solidFill>
+                <a:latin typeface="Helvetica"/>
+              </a:rPr>
+              <a:t>Når relevant</a:t>
+            </a:r>
+          </a:p>
+        </p:txBody>
+      </p:sp>
+      <p:sp>
+        <p:nvSpPr>
+          <p:cNvPr id="15" name="TextBox 14"/>
           <p:cNvSpPr txBox="1"/>
           <p:nvPr/>
         </p:nvSpPr>
         <p:spPr>
           <a:xfrm>
-            <a:off x="6547104" y="3291840"/>
-            <a:ext cx="1874520" cy="640080"/>
+            <a:off x="6501384" y="3200400"/>
+            <a:ext cx="2148840" cy="640080"/>
           </a:xfrm>
           <a:prstGeom prst="rect">
             <a:avLst/>
@@ -11917,7 +11972,7 @@
               </a:lnSpc>
             </a:pPr>
             <a:r>
-              <a:rPr sz="2100" b="1" i="0">
+              <a:rPr sz="1800" b="1" i="0">
                 <a:solidFill>
                   <a:srgbClr val="122A52"/>
                 </a:solidFill>
@@ -11930,14 +11985,14 @@
       </p:sp>
       <p:sp>
         <p:nvSpPr>
-          <p:cNvPr id="15" name="TextBox 14"/>
+          <p:cNvPr id="16" name="TextBox 15"/>
           <p:cNvSpPr txBox="1"/>
           <p:nvPr/>
         </p:nvSpPr>
         <p:spPr>
           <a:xfrm>
-            <a:off x="6547104" y="4023360"/>
-            <a:ext cx="1874520" cy="1097280"/>
+            <a:off x="6501384" y="3840480"/>
+            <a:ext cx="2148840" cy="1280160"/>
           </a:xfrm>
           <a:prstGeom prst="rect">
             <a:avLst/>
@@ -11970,14 +12025,14 @@
       </p:sp>
       <p:sp>
         <p:nvSpPr>
-          <p:cNvPr id="16" name="Rectangle 15"/>
+          <p:cNvPr id="17" name="Rectangle 16"/>
           <p:cNvSpPr/>
           <p:nvPr/>
         </p:nvSpPr>
         <p:spPr>
           <a:xfrm>
-            <a:off x="8951976" y="2103120"/>
-            <a:ext cx="2606040" cy="3108960"/>
+            <a:off x="9043416" y="2011680"/>
+            <a:ext cx="2697480" cy="3291840"/>
           </a:xfrm>
           <a:prstGeom prst="rect">
             <a:avLst/>
@@ -12013,13 +12068,13 @@
       </p:sp>
       <p:sp>
         <p:nvSpPr>
-          <p:cNvPr id="17" name="Oval 16"/>
+          <p:cNvPr id="18" name="Oval 17"/>
           <p:cNvSpPr/>
           <p:nvPr/>
         </p:nvSpPr>
         <p:spPr>
           <a:xfrm>
-            <a:off x="9317736" y="2468880"/>
+            <a:off x="9409176" y="2377440"/>
             <a:ext cx="548640" cy="548640"/>
           </a:xfrm>
           <a:prstGeom prst="ellipse">
@@ -12065,14 +12120,14 @@
       </p:sp>
       <p:sp>
         <p:nvSpPr>
-          <p:cNvPr id="18" name="TextBox 17"/>
+          <p:cNvPr id="19" name="TextBox 18"/>
           <p:cNvSpPr txBox="1"/>
           <p:nvPr/>
         </p:nvSpPr>
         <p:spPr>
           <a:xfrm>
-            <a:off x="9317736" y="3291840"/>
-            <a:ext cx="1874520" cy="640080"/>
+            <a:off x="9317736" y="3200400"/>
+            <a:ext cx="2148840" cy="640080"/>
           </a:xfrm>
           <a:prstGeom prst="rect">
             <a:avLst/>
@@ -12091,7 +12146,7 @@
               </a:lnSpc>
             </a:pPr>
             <a:r>
-              <a:rPr sz="2100" b="1" i="0">
+              <a:rPr sz="1800" b="1" i="0">
                 <a:solidFill>
                   <a:srgbClr val="122A52"/>
                 </a:solidFill>
@@ -12104,14 +12159,14 @@
       </p:sp>
       <p:sp>
         <p:nvSpPr>
-          <p:cNvPr id="19" name="TextBox 18"/>
+          <p:cNvPr id="20" name="TextBox 19"/>
           <p:cNvSpPr txBox="1"/>
           <p:nvPr/>
         </p:nvSpPr>
         <p:spPr>
           <a:xfrm>
-            <a:off x="9317736" y="4023360"/>
-            <a:ext cx="1874520" cy="1097280"/>
+            <a:off x="9317736" y="3840480"/>
+            <a:ext cx="2148840" cy="1280160"/>
           </a:xfrm>
           <a:prstGeom prst="rect">
             <a:avLst/>
@@ -12144,13 +12199,13 @@
       </p:sp>
       <p:sp>
         <p:nvSpPr>
-          <p:cNvPr id="20" name="TextBox 19"/>
+          <p:cNvPr id="21" name="TextBox 20"/>
           <p:cNvSpPr txBox="1"/>
           <p:nvPr/>
         </p:nvSpPr>
         <p:spPr>
           <a:xfrm>
-            <a:off x="548640" y="5532120"/>
+            <a:off x="548640" y="5623560"/>
             <a:ext cx="11091672" cy="548640"/>
           </a:xfrm>
           <a:prstGeom prst="rect">
@@ -12183,7 +12238,7 @@
       </p:sp>
       <p:sp>
         <p:nvSpPr>
-          <p:cNvPr id="21" name="Rectangle 20"/>
+          <p:cNvPr id="22" name="Rectangle 21"/>
           <p:cNvSpPr/>
           <p:nvPr/>
         </p:nvSpPr>
@@ -12226,7 +12281,7 @@
       </p:sp>
       <p:sp>
         <p:nvSpPr>
-          <p:cNvPr id="22" name="Rectangle 21"/>
+          <p:cNvPr id="23" name="Rectangle 22"/>
           <p:cNvSpPr/>
           <p:nvPr/>
         </p:nvSpPr>
@@ -12269,7 +12324,7 @@
       </p:sp>
       <p:sp>
         <p:nvSpPr>
-          <p:cNvPr id="23" name="TextBox 22"/>
+          <p:cNvPr id="24" name="TextBox 23"/>
           <p:cNvSpPr txBox="1"/>
           <p:nvPr/>
         </p:nvSpPr>
@@ -12308,7 +12363,7 @@
       </p:sp>
       <p:pic>
         <p:nvPicPr>
-          <p:cNvPr id="24" name="Picture 23" descr="edc_logo.png"/>
+          <p:cNvPr id="25" name="Picture 24" descr="edc_logo.png"/>
           <p:cNvPicPr>
             <a:picLocks noChangeAspect="1"/>
           </p:cNvPicPr>

</xml_diff>

<commit_message>
Live demo: skærm-deling + /prompts-side + fjern overflødige slides
Matias deler sin skærm under live demo og kører terminal + /demo
direkte. Slides er nu kun før og efter demoen — ikke under den.

Ændringer:
- Ny /prompts-side: clean copy-from layout med setup, dårlig/god
  prompt for pris-bug og bonus-prompts (performance, @-tricket).
  Stor "Kopier"-knap pr. blok, EDC-styling.
- vercel.json: ny rewrite for /prompts → /prompts.html
- Slides: fjernet 3 demo-prompt-display slides (Bug'en, Dårlig
  prompt, God prompt) — du viser det live på skærmen
- Slide 8 (Live demo divider) viser nu "/prompts" som stor URL —
  det er den side du kopierer fra under demoen
- Speaker note opdateret med tjekliste og demo-flow i 4 trin
- Deck er nu 13 slides (var 16)

Co-Authored-By: Claude Opus 4.7 (1M context) <noreply@anthropic.com>
</commit_message>
<xml_diff>
--- a/slides/session1.pptx
+++ b/slides/session1.pptx
@@ -18,9 +18,6 @@
     <p:sldId id="266" r:id="rId18"/>
     <p:sldId id="267" r:id="rId19"/>
     <p:sldId id="268" r:id="rId20"/>
-    <p:sldId id="269" r:id="rId21"/>
-    <p:sldId id="270" r:id="rId22"/>
-    <p:sldId id="271" r:id="rId23"/>
   </p:sldIdLst>
   <p:sldSz cx="12191695" cy="6858000" type="screen4x3"/>
   <p:notesSz cx="6858000" cy="9144000"/>
@@ -614,7 +611,7 @@
           </a:p>
           <a:p>
             <a:r>
-              <a:t>Realistisk dårlig · 0:22–0:26. Vi har kørt det her 3 gange — den lander forskelligt hver gang.</a:t>
+              <a:t>Forsikring · 0:33–0:35. Det her slide er forsikring mod den deltager der siger "jamen den dårlige fungerede jo fint". Anerkend det direkte — det er ærligt.</a:t>
             </a:r>
           </a:p>
           <a:p/>
@@ -625,57 +622,25 @@
           </a:p>
           <a:p>
             <a:r>
-              <a:t>"Det her ligner en prompt de fleste skriver på autopilot — vi nævner symptomet, men ikke hvor i koden det skal fixes."</a:t>
+              <a:t>"I har ret. På denne lille demo med Opus 4.7 er forskellen subtil — Claude er smart nok til at finde et fix der virker, selv når prompten er vag."</a:t>
             </a:r>
           </a:p>
           <a:p/>
           <a:p>
             <a:r>
-              <a:t>"Det er IKKE en stråmand, det er hverdag."</a:t>
+              <a:t>"Men i jeres rigtige projekter — 100k+ linjer, DTO'er, mappere, migrations, konventioner der ikke er skrevet ned — eksploderer det."</a:t>
             </a:r>
           </a:p>
           <a:p/>
           <a:p>
             <a:r>
-              <a:t>─── GØR ───</a:t>
-            </a:r>
-          </a:p>
-          <a:p>
-            <a:r>
-              <a:t>Kopier prompten fra slidet ind i Claude. Tryk enter.</a:t>
+              <a:t>"En vag prompt rammer den forkerte fil, glemmer halvdelen af kæden, eller introducerer et abstraktionslag der konflikter med jeres eksisterende."</a:t>
             </a:r>
           </a:p>
           <a:p/>
           <a:p>
             <a:r>
-              <a:t>─── SIG (mens Claude arbejder) ───</a:t>
-            </a:r>
-          </a:p>
-          <a:p>
-            <a:r>
-              <a:t>"Forventning: den finder ET fix der virker. Men hold den her i baghovedet — vi har kørt det 3 gange, den lander forskelligt hver gang."</a:t>
-            </a:r>
-          </a:p>
-          <a:p/>
-          <a:p>
-            <a:r>
-              <a:t>─── GØR ───</a:t>
-            </a:r>
-          </a:p>
-          <a:p>
-            <a:r>
-              <a:t>Når Claude er færdig: vis hvad den gjorde, refresh /demo.</a:t>
-            </a:r>
-          </a:p>
-          <a:p/>
-          <a:p>
-            <a:r>
-              <a:t>─── SIG ───</a:t>
-            </a:r>
-          </a:p>
-          <a:p>
-            <a:r>
-              <a:t>"Det virker! Men hold det her i baghovedet."</a:t>
+              <a:t>"Vi træner mønsteret her hvor det er sikkert at fejle — så det sidder i fingrene når I er midt i en rigtig PR mandag morgen."</a:t>
             </a:r>
           </a:p>
         </p:txBody>
@@ -750,66 +715,30 @@
           </a:p>
           <a:p>
             <a:r>
-              <a:t>Samme opgave, med kontekst · 0:26–0:31.</a:t>
+              <a:t>Korte instrukser · 0:35 — start. De skal i gang.</a:t>
             </a:r>
           </a:p>
           <a:p/>
           <a:p>
             <a:r>
-              <a:t>─── GØR ───</a:t>
-            </a:r>
-          </a:p>
-          <a:p>
-            <a:r>
-              <a:t>Rul tilbage i terminalen (vis det højt mens du gør det):</a:t>
-            </a:r>
-          </a:p>
-          <a:p>
-            <a:r>
-              <a:t>  git checkout .</a:t>
-            </a:r>
-          </a:p>
-          <a:p>
-            <a:r>
-              <a:t>  /clear</a:t>
+              <a:t>─── SIG ───</a:t>
+            </a:r>
+          </a:p>
+          <a:p>
+            <a:r>
+              <a:t>"Nu jer."</a:t>
             </a:r>
           </a:p>
           <a:p/>
           <a:p>
             <a:r>
-              <a:t>─── SIG ───</a:t>
-            </a:r>
-          </a:p>
-          <a:p>
-            <a:r>
-              <a:t>"Nu siger vi præcis HVOR (3 filer), HVAD (én helper), og HVORDAN (da-DK, DKK, 0 decimaler)."</a:t>
+              <a:t>"Solo på din egen maskine — du skal selv mærke forskellen i fingrene."</a:t>
             </a:r>
           </a:p>
           <a:p/>
           <a:p>
             <a:r>
-              <a:t>─── GØR ───</a:t>
-            </a:r>
-          </a:p>
-          <a:p>
-            <a:r>
-              <a:t>Kopier den gode prompt ind. Tryk enter.</a:t>
-            </a:r>
-          </a:p>
-          <a:p>
-            <a:r>
-              <a:t>Når den er færdig: vis at den lavede ÉN helper i propertyService.ts, og at de andre 2 filer importerer den. Refresh /demo.</a:t>
-            </a:r>
-          </a:p>
-          <a:p/>
-          <a:p>
-            <a:r>
-              <a:t>─── SIG ───</a:t>
-            </a:r>
-          </a:p>
-          <a:p>
-            <a:r>
-              <a:t>"Samme visuelle resultat. Helt anden kode-struktur."</a:t>
+              <a:t>"I har 20 minutter."</a:t>
             </a:r>
           </a:p>
         </p:txBody>
@@ -884,36 +813,41 @@
           </a:p>
           <a:p>
             <a:r>
-              <a:t>Sig det højt · 0:31–0:33. Det her er momentet hvor du SKAL sige det højt — ikke bare lade slidet tale. Det er hele dagen i én sætning.</a:t>
+              <a:t>Mens de arbejder · 0:35–0:55. Gå rundt. Hjælp dem der sidder fast. Lyt efter en god 'aha'-bemærkning du kan bede dem dele bagefter.</a:t>
             </a:r>
           </a:p>
           <a:p/>
           <a:p>
             <a:r>
-              <a:t>─── SIG ───</a:t>
-            </a:r>
-          </a:p>
-          <a:p>
-            <a:r>
-              <a:t>"Begge fixes virker visuelt — kr. står overalt. Men kig på koden:"</a:t>
+              <a:t>─── SIG (i starten) ───</a:t>
+            </a:r>
+          </a:p>
+          <a:p>
+            <a:r>
+              <a:t>"Læs trinene på slidet: clone, npm install, claude i demo. Vælg én opgave fra demoen."</a:t>
             </a:r>
           </a:p>
           <a:p/>
           <a:p>
             <a:r>
-              <a:t>"Den dårlige duplikerede logikken 3 steder."</a:t>
+              <a:t>"Det vigtigste: prøv BEGGE prompts — ikke bare den gode. Læg mærke til forskellen."</a:t>
             </a:r>
           </a:p>
           <a:p/>
           <a:p>
             <a:r>
-              <a:t>"Den gode lavede én helper, brugt 3 steder."</a:t>
+              <a:t>"Hvis du sidder fast, ræk hånden op — vi går rundt."</a:t>
             </a:r>
           </a:p>
           <a:p/>
           <a:p>
             <a:r>
-              <a:t>"Om 3 måneder, når en designer beder om at vise øre i favorit-listen, er det den forskel der bestemmer om I bruger 5 minutter eller 30."</a:t>
+              <a:t>─── SIG (med 5 min tilbage) ───</a:t>
+            </a:r>
+          </a:p>
+          <a:p>
+            <a:r>
+              <a:t>"Saml jer — én indsigt højt fra hver. Den der overraskede jer mest."</a:t>
             </a:r>
           </a:p>
         </p:txBody>
@@ -988,317 +922,6 @@
           </a:p>
           <a:p>
             <a:r>
-              <a:t>Forsikring · 0:33–0:35. Det her slide er forsikring mod den deltager der siger "jamen den dårlige fungerede jo fint". Anerkend det direkte — det er ærligt.</a:t>
-            </a:r>
-          </a:p>
-          <a:p/>
-          <a:p>
-            <a:r>
-              <a:t>─── SIG ───</a:t>
-            </a:r>
-          </a:p>
-          <a:p>
-            <a:r>
-              <a:t>"I har ret. På denne lille demo med Opus 4.7 er forskellen subtil — Claude er smart nok til at finde et fix der virker, selv når prompten er vag."</a:t>
-            </a:r>
-          </a:p>
-          <a:p/>
-          <a:p>
-            <a:r>
-              <a:t>"Men i jeres rigtige projekter — 100k+ linjer, DTO'er, mappere, migrations, konventioner der ikke er skrevet ned — eksploderer det."</a:t>
-            </a:r>
-          </a:p>
-          <a:p/>
-          <a:p>
-            <a:r>
-              <a:t>"En vag prompt rammer den forkerte fil, glemmer halvdelen af kæden, eller introducerer et abstraktionslag der konflikter med jeres eksisterende."</a:t>
-            </a:r>
-          </a:p>
-          <a:p/>
-          <a:p>
-            <a:r>
-              <a:t>"Vi træner mønsteret her hvor det er sikkert at fejle — så det sidder i fingrene når I er midt i en rigtig PR mandag morgen."</a:t>
-            </a:r>
-          </a:p>
-        </p:txBody>
-      </p:sp>
-      <p:sp>
-        <p:nvSpPr>
-          <p:cNvPr id="4" name="Slide Number Placeholder 3"/>
-          <p:cNvSpPr>
-            <a:spLocks noGrp="1"/>
-          </p:cNvSpPr>
-          <p:nvPr>
-            <p:ph type="sldNum" idx="5" sz="quarter"/>
-          </p:nvPr>
-        </p:nvSpPr>
-        <p:spPr/>
-      </p:sp>
-    </p:spTree>
-  </p:cSld>
-  <p:clrMapOvr>
-    <a:masterClrMapping/>
-  </p:clrMapOvr>
-</p:notes>
-</file>
-
-<file path=ppt/notesSlides/notesSlide14.xml><?xml version="1.0" encoding="utf-8"?>
-<p:notes xmlns:a="http://schemas.openxmlformats.org/drawingml/2006/main" xmlns:p="http://schemas.openxmlformats.org/presentationml/2006/main" xmlns:r="http://schemas.openxmlformats.org/officeDocument/2006/relationships">
-  <p:cSld>
-    <p:spTree>
-      <p:nvGrpSpPr>
-        <p:cNvPr id="1" name=""/>
-        <p:cNvGrpSpPr/>
-        <p:nvPr/>
-      </p:nvGrpSpPr>
-      <p:grpSpPr>
-        <a:xfrm>
-          <a:off x="0" y="0"/>
-          <a:ext cx="0" cy="0"/>
-          <a:chOff x="0" y="0"/>
-          <a:chExt cx="0" cy="0"/>
-        </a:xfrm>
-      </p:grpSpPr>
-      <p:sp>
-        <p:nvSpPr>
-          <p:cNvPr id="2" name="Slide Image Placeholder 1"/>
-          <p:cNvSpPr>
-            <a:spLocks noGrp="1"/>
-          </p:cNvSpPr>
-          <p:nvPr>
-            <p:ph type="sldImg" idx="2"/>
-          </p:nvPr>
-        </p:nvSpPr>
-        <p:spPr/>
-      </p:sp>
-      <p:sp>
-        <p:nvSpPr>
-          <p:cNvPr id="3" name="Notes Placeholder 2"/>
-          <p:cNvSpPr>
-            <a:spLocks noGrp="1"/>
-          </p:cNvSpPr>
-          <p:nvPr>
-            <p:ph type="body" idx="3" sz="quarter"/>
-          </p:nvPr>
-        </p:nvSpPr>
-        <p:spPr/>
-        <p:txBody>
-          <a:bodyPr/>
-          <a:lstStyle/>
-          <a:p>
-            <a:r>
-              <a:t>─── LÆS ───</a:t>
-            </a:r>
-          </a:p>
-          <a:p>
-            <a:r>
-              <a:t>Korte instrukser · 0:35 — start. De skal i gang.</a:t>
-            </a:r>
-          </a:p>
-          <a:p/>
-          <a:p>
-            <a:r>
-              <a:t>─── SIG ───</a:t>
-            </a:r>
-          </a:p>
-          <a:p>
-            <a:r>
-              <a:t>"Nu jer."</a:t>
-            </a:r>
-          </a:p>
-          <a:p/>
-          <a:p>
-            <a:r>
-              <a:t>"Solo på din egen maskine — du skal selv mærke forskellen i fingrene."</a:t>
-            </a:r>
-          </a:p>
-          <a:p/>
-          <a:p>
-            <a:r>
-              <a:t>"I har 20 minutter."</a:t>
-            </a:r>
-          </a:p>
-        </p:txBody>
-      </p:sp>
-      <p:sp>
-        <p:nvSpPr>
-          <p:cNvPr id="4" name="Slide Number Placeholder 3"/>
-          <p:cNvSpPr>
-            <a:spLocks noGrp="1"/>
-          </p:cNvSpPr>
-          <p:nvPr>
-            <p:ph type="sldNum" idx="5" sz="quarter"/>
-          </p:nvPr>
-        </p:nvSpPr>
-        <p:spPr/>
-      </p:sp>
-    </p:spTree>
-  </p:cSld>
-  <p:clrMapOvr>
-    <a:masterClrMapping/>
-  </p:clrMapOvr>
-</p:notes>
-</file>
-
-<file path=ppt/notesSlides/notesSlide15.xml><?xml version="1.0" encoding="utf-8"?>
-<p:notes xmlns:a="http://schemas.openxmlformats.org/drawingml/2006/main" xmlns:p="http://schemas.openxmlformats.org/presentationml/2006/main" xmlns:r="http://schemas.openxmlformats.org/officeDocument/2006/relationships">
-  <p:cSld>
-    <p:spTree>
-      <p:nvGrpSpPr>
-        <p:cNvPr id="1" name=""/>
-        <p:cNvGrpSpPr/>
-        <p:nvPr/>
-      </p:nvGrpSpPr>
-      <p:grpSpPr>
-        <a:xfrm>
-          <a:off x="0" y="0"/>
-          <a:ext cx="0" cy="0"/>
-          <a:chOff x="0" y="0"/>
-          <a:chExt cx="0" cy="0"/>
-        </a:xfrm>
-      </p:grpSpPr>
-      <p:sp>
-        <p:nvSpPr>
-          <p:cNvPr id="2" name="Slide Image Placeholder 1"/>
-          <p:cNvSpPr>
-            <a:spLocks noGrp="1"/>
-          </p:cNvSpPr>
-          <p:nvPr>
-            <p:ph type="sldImg" idx="2"/>
-          </p:nvPr>
-        </p:nvSpPr>
-        <p:spPr/>
-      </p:sp>
-      <p:sp>
-        <p:nvSpPr>
-          <p:cNvPr id="3" name="Notes Placeholder 2"/>
-          <p:cNvSpPr>
-            <a:spLocks noGrp="1"/>
-          </p:cNvSpPr>
-          <p:nvPr>
-            <p:ph type="body" idx="3" sz="quarter"/>
-          </p:nvPr>
-        </p:nvSpPr>
-        <p:spPr/>
-        <p:txBody>
-          <a:bodyPr/>
-          <a:lstStyle/>
-          <a:p>
-            <a:r>
-              <a:t>─── LÆS ───</a:t>
-            </a:r>
-          </a:p>
-          <a:p>
-            <a:r>
-              <a:t>Mens de arbejder · 0:35–0:55. Gå rundt. Hjælp dem der sidder fast. Lyt efter en god 'aha'-bemærkning du kan bede dem dele bagefter.</a:t>
-            </a:r>
-          </a:p>
-          <a:p/>
-          <a:p>
-            <a:r>
-              <a:t>─── SIG (i starten) ───</a:t>
-            </a:r>
-          </a:p>
-          <a:p>
-            <a:r>
-              <a:t>"Læs trinene på slidet: clone, npm install, claude i demo. Vælg én opgave fra demoen."</a:t>
-            </a:r>
-          </a:p>
-          <a:p/>
-          <a:p>
-            <a:r>
-              <a:t>"Det vigtigste: prøv BEGGE prompts — ikke bare den gode. Læg mærke til forskellen."</a:t>
-            </a:r>
-          </a:p>
-          <a:p/>
-          <a:p>
-            <a:r>
-              <a:t>"Hvis du sidder fast, ræk hånden op — vi går rundt."</a:t>
-            </a:r>
-          </a:p>
-          <a:p/>
-          <a:p>
-            <a:r>
-              <a:t>─── SIG (med 5 min tilbage) ───</a:t>
-            </a:r>
-          </a:p>
-          <a:p>
-            <a:r>
-              <a:t>"Saml jer — én indsigt højt fra hver. Den der overraskede jer mest."</a:t>
-            </a:r>
-          </a:p>
-        </p:txBody>
-      </p:sp>
-      <p:sp>
-        <p:nvSpPr>
-          <p:cNvPr id="4" name="Slide Number Placeholder 3"/>
-          <p:cNvSpPr>
-            <a:spLocks noGrp="1"/>
-          </p:cNvSpPr>
-          <p:nvPr>
-            <p:ph type="sldNum" idx="5" sz="quarter"/>
-          </p:nvPr>
-        </p:nvSpPr>
-        <p:spPr/>
-      </p:sp>
-    </p:spTree>
-  </p:cSld>
-  <p:clrMapOvr>
-    <a:masterClrMapping/>
-  </p:clrMapOvr>
-</p:notes>
-</file>
-
-<file path=ppt/notesSlides/notesSlide16.xml><?xml version="1.0" encoding="utf-8"?>
-<p:notes xmlns:a="http://schemas.openxmlformats.org/drawingml/2006/main" xmlns:p="http://schemas.openxmlformats.org/presentationml/2006/main" xmlns:r="http://schemas.openxmlformats.org/officeDocument/2006/relationships">
-  <p:cSld>
-    <p:spTree>
-      <p:nvGrpSpPr>
-        <p:cNvPr id="1" name=""/>
-        <p:cNvGrpSpPr/>
-        <p:nvPr/>
-      </p:nvGrpSpPr>
-      <p:grpSpPr>
-        <a:xfrm>
-          <a:off x="0" y="0"/>
-          <a:ext cx="0" cy="0"/>
-          <a:chOff x="0" y="0"/>
-          <a:chExt cx="0" cy="0"/>
-        </a:xfrm>
-      </p:grpSpPr>
-      <p:sp>
-        <p:nvSpPr>
-          <p:cNvPr id="2" name="Slide Image Placeholder 1"/>
-          <p:cNvSpPr>
-            <a:spLocks noGrp="1"/>
-          </p:cNvSpPr>
-          <p:nvPr>
-            <p:ph type="sldImg" idx="2"/>
-          </p:nvPr>
-        </p:nvSpPr>
-        <p:spPr/>
-      </p:sp>
-      <p:sp>
-        <p:nvSpPr>
-          <p:cNvPr id="3" name="Notes Placeholder 2"/>
-          <p:cNvSpPr>
-            <a:spLocks noGrp="1"/>
-          </p:cNvSpPr>
-          <p:nvPr>
-            <p:ph type="body" idx="3" sz="quarter"/>
-          </p:nvPr>
-        </p:nvSpPr>
-        <p:spPr/>
-        <p:txBody>
-          <a:bodyPr/>
-          <a:lstStyle/>
-          <a:p>
-            <a:r>
-              <a:t>─── LÆS ───</a:t>
-            </a:r>
-          </a:p>
-          <a:p>
-            <a:r>
               <a:t>Afslutning · 0:55–1:00. Hjemmeopgave nem. Bekræft næste præsentant igen ved navn så de ved det er reelt.</a:t>
             </a:r>
           </a:p>
@@ -2037,13 +1660,13 @@
           </a:p>
           <a:p>
             <a:r>
-              <a:t>Skift til terminal · 0:20 — start.</a:t>
+              <a:t>Skift til DIN skærm · 0:15–0:35 (ca. 20 min). Slidet med /prompts står på projektoren mens du kører hele demoen på din egen skærm (terminal + /demo).</a:t>
             </a:r>
           </a:p>
           <a:p/>
           <a:p>
             <a:r>
-              <a:t>TJEKLISTE FØR DU KØRER:</a:t>
+              <a:t>TJEKLISTE FØR DU SKIFTER:</a:t>
             </a:r>
           </a:p>
           <a:p>
@@ -2058,14 +1681,14 @@
           </a:p>
           <a:p>
             <a:r>
+              <a:t>  □ /prompts er åben i en anden tab — det er der du kopierer prompts fra</a:t>
+            </a:r>
+          </a:p>
+          <a:p>
+            <a:r>
               <a:t>  □ claude --dangerously-skip-permissions kører i demo/-mappen</a:t>
             </a:r>
           </a:p>
-          <a:p>
-            <a:r>
-              <a:t>  □ Du kan se BÅDE terminal og browser samtidig på projektoren</a:t>
-            </a:r>
-          </a:p>
           <a:p/>
           <a:p>
             <a:r>
@@ -2074,19 +1697,54 @@
           </a:p>
           <a:p>
             <a:r>
-              <a:t>"OK — nu skifter vi til terminal og browser."</a:t>
+              <a:t>"Nu deler jeg min skærm. I ser min terminal og /demo i browseren."</a:t>
             </a:r>
           </a:p>
           <a:p/>
           <a:p>
             <a:r>
-              <a:t>"I de næste 15 minutter skriver jeg samme opgave til Claude — først dårligt, så godt."</a:t>
+              <a:t>"Jeg har en /prompts-side åben hvor jeg kopierer prompts fra. Jeg gør det i denne rækkefølge:"</a:t>
             </a:r>
           </a:p>
           <a:p/>
           <a:p>
             <a:r>
-              <a:t>"Kig BÅDE på terminalen og på /demo i browseren ved siden af."</a:t>
+              <a:t>"1) Vis bug'en — scroll ned ad /demo, klik på en bolig, søg demo@edc.dk i favoritter."</a:t>
+            </a:r>
+          </a:p>
+          <a:p/>
+          <a:p>
+            <a:r>
+              <a:t>"2) Kør den DÅRLIGE prompt — kopier fra /prompts, paste i Claude."</a:t>
+            </a:r>
+          </a:p>
+          <a:p/>
+          <a:p>
+            <a:r>
+              <a:t>"3) git checkout . + /clear for at rulle tilbage."</a:t>
+            </a:r>
+          </a:p>
+          <a:p/>
+          <a:p>
+            <a:r>
+              <a:t>"4) Kør den GODE prompt — samme opgave, men nu med kontekst."</a:t>
+            </a:r>
+          </a:p>
+          <a:p/>
+          <a:p>
+            <a:r>
+              <a:t>"Kig med på begge ændringer — vi samler op bagefter."</a:t>
+            </a:r>
+          </a:p>
+          <a:p/>
+          <a:p>
+            <a:r>
+              <a:t>─── GØR (mellem prompts) ───</a:t>
+            </a:r>
+          </a:p>
+          <a:p>
+            <a:r>
+              <a:t>Refresh /demo i browseren mellem hver kørsel så de ser hvad der sker visuelt.</a:t>
             </a:r>
           </a:p>
         </p:txBody>
@@ -2161,51 +1819,36 @@
           </a:p>
           <a:p>
             <a:r>
-              <a:t>Vis bug'en · 0:20–0:22.</a:t>
+              <a:t>Sig det højt · 0:31–0:33. Det her er momentet hvor du SKAL sige det højt — ikke bare lade slidet tale. Det er hele dagen i én sætning.</a:t>
             </a:r>
           </a:p>
           <a:p/>
           <a:p>
             <a:r>
-              <a:t>─── GØR ───</a:t>
-            </a:r>
-          </a:p>
-          <a:p>
-            <a:r>
-              <a:t>Skift til browseren. Scroll ned ad /demo. Peg eksplicit på priserne.</a:t>
-            </a:r>
-          </a:p>
-          <a:p>
-            <a:r>
-              <a:t>Klik på en bolig — vis at detaljesiden har samme problem.</a:t>
-            </a:r>
-          </a:p>
-          <a:p>
-            <a:r>
-              <a:t>Søg "demo@edc.dk" i favorit-widgeten — også USD-priser.</a:t>
+              <a:t>─── SIG ───</a:t>
+            </a:r>
+          </a:p>
+          <a:p>
+            <a:r>
+              <a:t>"Begge fixes virker visuelt — kr. står overalt. Men kig på koden:"</a:t>
             </a:r>
           </a:p>
           <a:p/>
           <a:p>
             <a:r>
-              <a:t>─── SIG ───</a:t>
-            </a:r>
-          </a:p>
-          <a:p>
-            <a:r>
-              <a:t>"Det her er en dansk bolig-side. Priserne er i amerikanske dollars MED cents. Hele sitet er i stykker visuelt."</a:t>
+              <a:t>"Den dårlige duplikerede logikken 3 steder."</a:t>
             </a:r>
           </a:p>
           <a:p/>
           <a:p>
             <a:r>
-              <a:t>"Pris-formateringen ligger inline 3 steder uden helper. Det er ikke konstrueret — det er typisk consequence af 'hurtigt fix' nogen lavede engang."</a:t>
+              <a:t>"Den gode lavede én helper, brugt 3 steder."</a:t>
             </a:r>
           </a:p>
           <a:p/>
           <a:p>
             <a:r>
-              <a:t>"Det er det her vi vil have Claude til at fixe."</a:t>
+              <a:t>"Om 3 måneder, når en designer beder om at vise øre i favorit-listen, er det den forskel der bestemmer om I bruger 5 minutter eller 30."</a:t>
             </a:r>
           </a:p>
         </p:txBody>
@@ -5509,7 +5152,7 @@
                 </a:solidFill>
                 <a:latin typeface="Helvetica"/>
               </a:rPr>
-              <a:t>Forsøg 1</a:t>
+              <a:t>Vigtigt forbehold</a:t>
             </a:r>
             <a:r>
               <a:rPr sz="3400" b="0">
@@ -5518,29 +5161,27 @@
                 </a:solidFill>
                 <a:latin typeface="Helvetica"/>
               </a:rPr>
-              <a:t> | Dårlig prompt — "realistisk dårlig"</a:t>
-            </a:r>
-          </a:p>
-        </p:txBody>
-      </p:sp>
-      <p:sp>
-        <p:nvSpPr>
-          <p:cNvPr id="4" name="Rounded Rectangle 3"/>
+              <a:t> | Demoen er lille — virkeligheden er stor</a:t>
+            </a:r>
+          </a:p>
+        </p:txBody>
+      </p:sp>
+      <p:sp>
+        <p:nvSpPr>
+          <p:cNvPr id="4" name="5-Point Star 3"/>
           <p:cNvSpPr/>
           <p:nvPr/>
         </p:nvSpPr>
         <p:spPr>
           <a:xfrm>
-            <a:off x="640080" y="2011680"/>
-            <a:ext cx="10908792" cy="1828800"/>
-          </a:xfrm>
-          <a:prstGeom prst="roundRect">
-            <a:avLst>
-              <a:gd name="adj" fmla="val 4000"/>
-            </a:avLst>
+            <a:off x="731520" y="1920240"/>
+            <a:ext cx="822960" cy="822960"/>
+          </a:xfrm>
+          <a:prstGeom prst="star5">
+            <a:avLst/>
           </a:prstGeom>
           <a:solidFill>
-            <a:srgbClr val="0F1F3D"/>
+            <a:srgbClr val="122A52"/>
           </a:solidFill>
           <a:ln>
             <a:noFill/>
@@ -5561,55 +5202,10 @@
           </a:fontRef>
         </p:style>
         <p:txBody>
-          <a:bodyPr rtlCol="0" anchor="t" lIns="365760" rIns="365760" tIns="274320" bIns="274320" wrap="square"/>
-          <a:lstStyle/>
-          <a:p>
-            <a:pPr algn="l">
-              <a:lnSpc>
-                <a:spcPct val="125000"/>
-              </a:lnSpc>
-            </a:pPr>
-            <a:r>
-              <a:rPr sz="1800">
-                <a:solidFill>
-                  <a:srgbClr val="E2E8F0"/>
-                </a:solidFill>
-                <a:latin typeface="Menlo"/>
-              </a:rPr>
-              <a:t>Priserne på /demo vises som amerikanske dollars med cents</a:t>
-            </a:r>
-          </a:p>
-          <a:p>
-            <a:pPr algn="l">
-              <a:lnSpc>
-                <a:spcPct val="125000"/>
-              </a:lnSpc>
-            </a:pPr>
-            <a:r>
-              <a:rPr sz="1800">
-                <a:solidFill>
-                  <a:srgbClr val="E2E8F0"/>
-                </a:solidFill>
-                <a:latin typeface="Menlo"/>
-              </a:rPr>
-              <a:t>(fx "$8,500,000.00") overalt. Det er en dansk side.</a:t>
-            </a:r>
-          </a:p>
-          <a:p>
-            <a:pPr algn="l">
-              <a:lnSpc>
-                <a:spcPct val="125000"/>
-              </a:lnSpc>
-            </a:pPr>
-            <a:r>
-              <a:rPr sz="1800">
-                <a:solidFill>
-                  <a:srgbClr val="E2E8F0"/>
-                </a:solidFill>
-                <a:latin typeface="Menlo"/>
-              </a:rPr>
-              <a:t>Fix det. Ingen commit eller push.</a:t>
-            </a:r>
+          <a:bodyPr rtlCol="0" anchor="ctr"/>
+          <a:lstStyle/>
+          <a:p>
+            <a:pPr algn="ctr"/>
           </a:p>
         </p:txBody>
       </p:sp>
@@ -5621,8 +5217,8 @@
         </p:nvSpPr>
         <p:spPr>
           <a:xfrm>
-            <a:off x="640080" y="4114800"/>
-            <a:ext cx="10972800" cy="457200"/>
+            <a:off x="1920240" y="1965960"/>
+            <a:ext cx="9692640" cy="822960"/>
           </a:xfrm>
           <a:prstGeom prst="rect">
             <a:avLst/>
@@ -5637,17 +5233,26 @@
           <a:p>
             <a:pPr algn="l">
               <a:lnSpc>
-                <a:spcPct val="115000"/>
+                <a:spcPct val="130000"/>
               </a:lnSpc>
             </a:pPr>
             <a:r>
-              <a:rPr sz="2000" b="1" i="0">
+              <a:rPr sz="2000" b="1">
                 <a:solidFill>
                   <a:srgbClr val="122A52"/>
                 </a:solidFill>
                 <a:latin typeface="Helvetica"/>
               </a:rPr>
-              <a:t>Hvad sker der?</a:t>
+              <a:t>Forskellen ser subtil ud her.</a:t>
+            </a:r>
+            <a:r>
+              <a:rPr sz="2000" b="0">
+                <a:solidFill>
+                  <a:srgbClr val="122A52"/>
+                </a:solidFill>
+                <a:latin typeface="Helvetica"/>
+              </a:rPr>
+              <a:t> På jeres rigtige projekter eksploderer den.</a:t>
             </a:r>
           </a:p>
         </p:txBody>
@@ -5660,8 +5265,8 @@
         </p:nvSpPr>
         <p:spPr>
           <a:xfrm>
-            <a:off x="640080" y="4572000"/>
-            <a:ext cx="10972800" cy="1828800"/>
+            <a:off x="731520" y="3200400"/>
+            <a:ext cx="10789920" cy="3200400"/>
           </a:xfrm>
           <a:prstGeom prst="rect">
             <a:avLst/>
@@ -5676,14 +5281,14 @@
           <a:p>
             <a:pPr algn="l">
               <a:lnSpc>
-                <a:spcPct val="150000"/>
+                <a:spcPct val="160000"/>
               </a:lnSpc>
               <a:spcAft>
                 <a:spcPts val="1000"/>
               </a:spcAft>
             </a:pPr>
             <a:r>
-              <a:rPr sz="1600" b="1">
+              <a:rPr sz="1500" b="1">
                 <a:solidFill>
                   <a:srgbClr val="122A52"/>
                 </a:solidFill>
@@ -5692,26 +5297,35 @@
               <a:t>■   </a:t>
             </a:r>
             <a:r>
-              <a:rPr sz="1600" b="0">
+              <a:rPr sz="1500" b="1">
                 <a:solidFill>
                   <a:srgbClr val="122A52"/>
                 </a:solidFill>
                 <a:latin typeface="Helvetica"/>
               </a:rPr>
-              <a:t>Claude finder *et* fix — men forskelligt hver gang du kører prompten</a:t>
+              <a:t>Her:</a:t>
+            </a:r>
+            <a:r>
+              <a:rPr sz="1500" b="0">
+                <a:solidFill>
+                  <a:srgbClr val="122A52"/>
+                </a:solidFill>
+                <a:latin typeface="Helvetica"/>
+              </a:rPr>
+              <a:t> 5 filer, ét tydeligt symptom, Opus 4.7 — Claude finder *et* fix uanset hvor vag prompten er</a:t>
             </a:r>
           </a:p>
           <a:p>
             <a:pPr algn="l">
               <a:lnSpc>
-                <a:spcPct val="150000"/>
+                <a:spcPct val="160000"/>
               </a:lnSpc>
               <a:spcAft>
                 <a:spcPts val="1000"/>
               </a:spcAft>
             </a:pPr>
             <a:r>
-              <a:rPr sz="1600" b="1">
+              <a:rPr sz="1500" b="1">
                 <a:solidFill>
                   <a:srgbClr val="122A52"/>
                 </a:solidFill>
@@ -5720,26 +5334,35 @@
               <a:t>■   </a:t>
             </a:r>
             <a:r>
-              <a:rPr sz="1600" b="0">
+              <a:rPr sz="1500" b="1">
                 <a:solidFill>
                   <a:srgbClr val="122A52"/>
                 </a:solidFill>
                 <a:latin typeface="Helvetica"/>
               </a:rPr>
-              <a:t>Inline-duplikering 3 steder, eller patch kun én fil og misser resten</a:t>
+              <a:t>På jeres codebases:</a:t>
+            </a:r>
+            <a:r>
+              <a:rPr sz="1500" b="0">
+                <a:solidFill>
+                  <a:srgbClr val="122A52"/>
+                </a:solidFill>
+                <a:latin typeface="Helvetica"/>
+              </a:rPr>
+              <a:t> 100k+ linjer, 10+ års historik, DTO'er, mappere, migrations, uskrevne konventioner</a:t>
             </a:r>
           </a:p>
           <a:p>
             <a:pPr algn="l">
               <a:lnSpc>
-                <a:spcPct val="150000"/>
+                <a:spcPct val="160000"/>
               </a:lnSpc>
               <a:spcAft>
                 <a:spcPts val="1000"/>
               </a:spcAft>
             </a:pPr>
             <a:r>
-              <a:rPr sz="1600" b="1">
+              <a:rPr sz="1500" b="1">
                 <a:solidFill>
                   <a:srgbClr val="122A52"/>
                 </a:solidFill>
@@ -5748,13 +5371,59 @@
               <a:t>■   </a:t>
             </a:r>
             <a:r>
-              <a:rPr sz="1600" b="0">
+              <a:rPr sz="1500" b="1">
                 <a:solidFill>
                   <a:srgbClr val="122A52"/>
                 </a:solidFill>
                 <a:latin typeface="Helvetica"/>
               </a:rPr>
-              <a:t>Det "virker" — men efterlader kode der er svær at vedligeholde</a:t>
+              <a:t>Konsekvens af vag prompt:</a:t>
+            </a:r>
+            <a:r>
+              <a:rPr sz="1500" b="0">
+                <a:solidFill>
+                  <a:srgbClr val="122A52"/>
+                </a:solidFill>
+                <a:latin typeface="Helvetica"/>
+              </a:rPr>
+              <a:t> forkert fil · glemt halvdel af kæden · konfliktende abstraktion · brudt konvention</a:t>
+            </a:r>
+          </a:p>
+          <a:p>
+            <a:pPr algn="l">
+              <a:lnSpc>
+                <a:spcPct val="160000"/>
+              </a:lnSpc>
+              <a:spcAft>
+                <a:spcPts val="1000"/>
+              </a:spcAft>
+            </a:pPr>
+            <a:r>
+              <a:rPr sz="1500" b="1">
+                <a:solidFill>
+                  <a:srgbClr val="122A52"/>
+                </a:solidFill>
+                <a:latin typeface="Helvetica"/>
+              </a:rPr>
+              <a:t>■   </a:t>
+            </a:r>
+            <a:r>
+              <a:rPr sz="1500" b="1">
+                <a:solidFill>
+                  <a:srgbClr val="122A52"/>
+                </a:solidFill>
+                <a:latin typeface="Helvetica"/>
+              </a:rPr>
+              <a:t>Vi træner mønsteret HER</a:t>
+            </a:r>
+            <a:r>
+              <a:rPr sz="1500" b="0">
+                <a:solidFill>
+                  <a:srgbClr val="122A52"/>
+                </a:solidFill>
+                <a:latin typeface="Helvetica"/>
+              </a:rPr>
+              <a:t> — så det sidder i fingrene mandag morgen i en rigtig PR</a:t>
             </a:r>
           </a:p>
         </p:txBody>
@@ -5941,7 +5610,7 @@
             <a:avLst/>
           </a:prstGeom>
           <a:solidFill>
-            <a:srgbClr val="FFFFFF"/>
+            <a:srgbClr val="122A52"/>
           </a:solidFill>
           <a:ln>
             <a:noFill/>
@@ -5969,514 +5638,9 @@
           </a:p>
         </p:txBody>
       </p:sp>
-      <p:sp>
-        <p:nvSpPr>
-          <p:cNvPr id="3" name="TextBox 2"/>
-          <p:cNvSpPr txBox="1"/>
-          <p:nvPr/>
-        </p:nvSpPr>
-        <p:spPr>
-          <a:xfrm>
-            <a:off x="548640" y="457200"/>
-            <a:ext cx="11155680" cy="914400"/>
-          </a:xfrm>
-          <a:prstGeom prst="rect">
-            <a:avLst/>
-          </a:prstGeom>
-          <a:noFill/>
-        </p:spPr>
-        <p:txBody>
-          <a:bodyPr wrap="square" lIns="0" tIns="0" bIns="0" rIns="0">
-            <a:spAutoFit/>
-          </a:bodyPr>
-          <a:lstStyle/>
-          <a:p>
-            <a:pPr algn="l">
-              <a:lnSpc>
-                <a:spcPct val="110000"/>
-              </a:lnSpc>
-            </a:pPr>
-            <a:r>
-              <a:rPr sz="3400" b="1">
-                <a:solidFill>
-                  <a:srgbClr val="122A52"/>
-                </a:solidFill>
-                <a:latin typeface="Helvetica"/>
-              </a:rPr>
-              <a:t>Forsøg 2</a:t>
-            </a:r>
-            <a:r>
-              <a:rPr sz="3400" b="0">
-                <a:solidFill>
-                  <a:srgbClr val="122A52"/>
-                </a:solidFill>
-                <a:latin typeface="Helvetica"/>
-              </a:rPr>
-              <a:t> | God prompt — samme opgave, med kontekst</a:t>
-            </a:r>
-          </a:p>
-        </p:txBody>
-      </p:sp>
-      <p:sp>
-        <p:nvSpPr>
-          <p:cNvPr id="4" name="Rounded Rectangle 3"/>
-          <p:cNvSpPr/>
-          <p:nvPr/>
-        </p:nvSpPr>
-        <p:spPr>
-          <a:xfrm>
-            <a:off x="640080" y="1737360"/>
-            <a:ext cx="10908792" cy="4023360"/>
-          </a:xfrm>
-          <a:prstGeom prst="roundRect">
-            <a:avLst>
-              <a:gd name="adj" fmla="val 4000"/>
-            </a:avLst>
-          </a:prstGeom>
-          <a:solidFill>
-            <a:srgbClr val="0F1F3D"/>
-          </a:solidFill>
-          <a:ln>
-            <a:noFill/>
-          </a:ln>
-        </p:spPr>
-        <p:style>
-          <a:lnRef idx="1">
-            <a:schemeClr val="accent1"/>
-          </a:lnRef>
-          <a:fillRef idx="3">
-            <a:schemeClr val="accent1"/>
-          </a:fillRef>
-          <a:effectRef idx="2">
-            <a:schemeClr val="accent1"/>
-          </a:effectRef>
-          <a:fontRef idx="minor">
-            <a:schemeClr val="lt1"/>
-          </a:fontRef>
-        </p:style>
-        <p:txBody>
-          <a:bodyPr rtlCol="0" anchor="t" lIns="365760" rIns="365760" tIns="274320" bIns="274320" wrap="square"/>
-          <a:lstStyle/>
-          <a:p>
-            <a:pPr algn="l">
-              <a:lnSpc>
-                <a:spcPct val="125000"/>
-              </a:lnSpc>
-            </a:pPr>
-            <a:r>
-              <a:rPr sz="1400">
-                <a:solidFill>
-                  <a:srgbClr val="E2E8F0"/>
-                </a:solidFill>
-                <a:latin typeface="Menlo"/>
-              </a:rPr>
-              <a:t>Pris-formateringen ligger inline tre steder med</a:t>
-            </a:r>
-          </a:p>
-          <a:p>
-            <a:pPr algn="l">
-              <a:lnSpc>
-                <a:spcPct val="125000"/>
-              </a:lnSpc>
-            </a:pPr>
-            <a:r>
-              <a:rPr sz="1400">
-                <a:solidFill>
-                  <a:srgbClr val="E2E8F0"/>
-                </a:solidFill>
-                <a:latin typeface="Menlo"/>
-              </a:rPr>
-              <a:t>Intl.NumberFormat('en-US', { style: 'currency',</a:t>
-            </a:r>
-          </a:p>
-          <a:p>
-            <a:pPr algn="l">
-              <a:lnSpc>
-                <a:spcPct val="125000"/>
-              </a:lnSpc>
-            </a:pPr>
-            <a:r>
-              <a:rPr sz="1400">
-                <a:solidFill>
-                  <a:srgbClr val="E2E8F0"/>
-                </a:solidFill>
-                <a:latin typeface="Menlo"/>
-              </a:rPr>
-              <a:t>currency: 'USD', maximumFractionDigits: 2 }):</a:t>
-            </a:r>
-          </a:p>
-          <a:p>
-            <a:pPr algn="l">
-              <a:lnSpc>
-                <a:spcPct val="125000"/>
-              </a:lnSpc>
-            </a:pPr>
-            <a:r>
-              <a:rPr sz="1400">
-                <a:solidFill>
-                  <a:srgbClr val="E2E8F0"/>
-                </a:solidFill>
-                <a:latin typeface="Menlo"/>
-              </a:rPr>
-              <a:t> </a:t>
-            </a:r>
-          </a:p>
-          <a:p>
-            <a:pPr algn="l">
-              <a:lnSpc>
-                <a:spcPct val="125000"/>
-              </a:lnSpc>
-            </a:pPr>
-            <a:r>
-              <a:rPr sz="1400">
-                <a:solidFill>
-                  <a:srgbClr val="E2E8F0"/>
-                </a:solidFill>
-                <a:latin typeface="Menlo"/>
-              </a:rPr>
-              <a:t>- lib/propertyService.ts (i getAll, formattedPrice)</a:t>
-            </a:r>
-          </a:p>
-          <a:p>
-            <a:pPr algn="l">
-              <a:lnSpc>
-                <a:spcPct val="125000"/>
-              </a:lnSpc>
-            </a:pPr>
-            <a:r>
-              <a:rPr sz="1400">
-                <a:solidFill>
-                  <a:srgbClr val="E2E8F0"/>
-                </a:solidFill>
-                <a:latin typeface="Menlo"/>
-              </a:rPr>
-              <a:t>- components/PropertyCard.tsx</a:t>
-            </a:r>
-          </a:p>
-          <a:p>
-            <a:pPr algn="l">
-              <a:lnSpc>
-                <a:spcPct val="125000"/>
-              </a:lnSpc>
-            </a:pPr>
-            <a:r>
-              <a:rPr sz="1400">
-                <a:solidFill>
-                  <a:srgbClr val="E2E8F0"/>
-                </a:solidFill>
-                <a:latin typeface="Menlo"/>
-              </a:rPr>
-              <a:t>- app/properties/[id]/page.tsx (formattedPrice)</a:t>
-            </a:r>
-          </a:p>
-          <a:p>
-            <a:pPr algn="l">
-              <a:lnSpc>
-                <a:spcPct val="125000"/>
-              </a:lnSpc>
-            </a:pPr>
-            <a:r>
-              <a:rPr sz="1400">
-                <a:solidFill>
-                  <a:srgbClr val="E2E8F0"/>
-                </a:solidFill>
-                <a:latin typeface="Menlo"/>
-              </a:rPr>
-              <a:t> </a:t>
-            </a:r>
-          </a:p>
-          <a:p>
-            <a:pPr algn="l">
-              <a:lnSpc>
-                <a:spcPct val="125000"/>
-              </a:lnSpc>
-            </a:pPr>
-            <a:r>
-              <a:rPr sz="1400">
-                <a:solidFill>
-                  <a:srgbClr val="E2E8F0"/>
-                </a:solidFill>
-                <a:latin typeface="Menlo"/>
-              </a:rPr>
-              <a:t>Lav en formatPrice(price: number)-helper i</a:t>
-            </a:r>
-          </a:p>
-          <a:p>
-            <a:pPr algn="l">
-              <a:lnSpc>
-                <a:spcPct val="125000"/>
-              </a:lnSpc>
-            </a:pPr>
-            <a:r>
-              <a:rPr sz="1400">
-                <a:solidFill>
-                  <a:srgbClr val="E2E8F0"/>
-                </a:solidFill>
-                <a:latin typeface="Menlo"/>
-              </a:rPr>
-              <a:t>lib/propertyService.ts der bruger 'da-DK', 'DKK' og</a:t>
-            </a:r>
-          </a:p>
-          <a:p>
-            <a:pPr algn="l">
-              <a:lnSpc>
-                <a:spcPct val="125000"/>
-              </a:lnSpc>
-            </a:pPr>
-            <a:r>
-              <a:rPr sz="1400">
-                <a:solidFill>
-                  <a:srgbClr val="E2E8F0"/>
-                </a:solidFill>
-                <a:latin typeface="Menlo"/>
-              </a:rPr>
-              <a:t>maximumFractionDigits: 0. Brug den fra alle tre steder.</a:t>
-            </a:r>
-          </a:p>
-          <a:p>
-            <a:pPr algn="l">
-              <a:lnSpc>
-                <a:spcPct val="125000"/>
-              </a:lnSpc>
-            </a:pPr>
-            <a:r>
-              <a:rPr sz="1400">
-                <a:solidFill>
-                  <a:srgbClr val="E2E8F0"/>
-                </a:solidFill>
-                <a:latin typeface="Menlo"/>
-              </a:rPr>
-              <a:t> </a:t>
-            </a:r>
-          </a:p>
-          <a:p>
-            <a:pPr algn="l">
-              <a:lnSpc>
-                <a:spcPct val="125000"/>
-              </a:lnSpc>
-            </a:pPr>
-            <a:r>
-              <a:rPr sz="1400">
-                <a:solidFill>
-                  <a:srgbClr val="E2E8F0"/>
-                </a:solidFill>
-                <a:latin typeface="Menlo"/>
-              </a:rPr>
-              <a:t>Rør intet andet. Ingen commit eller push.</a:t>
-            </a:r>
-          </a:p>
-        </p:txBody>
-      </p:sp>
-      <p:sp>
-        <p:nvSpPr>
-          <p:cNvPr id="5" name="Rectangle 4"/>
-          <p:cNvSpPr/>
-          <p:nvPr/>
-        </p:nvSpPr>
-        <p:spPr>
-          <a:xfrm>
-            <a:off x="640080" y="5943600"/>
-            <a:ext cx="10908792" cy="594360"/>
-          </a:xfrm>
-          <a:prstGeom prst="rect">
-            <a:avLst/>
-          </a:prstGeom>
-          <a:solidFill>
-            <a:srgbClr val="EEF1F6"/>
-          </a:solidFill>
-          <a:ln>
-            <a:noFill/>
-          </a:ln>
-        </p:spPr>
-        <p:style>
-          <a:lnRef idx="1">
-            <a:schemeClr val="accent1"/>
-          </a:lnRef>
-          <a:fillRef idx="3">
-            <a:schemeClr val="accent1"/>
-          </a:fillRef>
-          <a:effectRef idx="2">
-            <a:schemeClr val="accent1"/>
-          </a:effectRef>
-          <a:fontRef idx="minor">
-            <a:schemeClr val="lt1"/>
-          </a:fontRef>
-        </p:style>
-        <p:txBody>
-          <a:bodyPr rtlCol="0" anchor="ctr"/>
-          <a:lstStyle/>
-          <a:p>
-            <a:pPr algn="ctr"/>
-          </a:p>
-        </p:txBody>
-      </p:sp>
-      <p:sp>
-        <p:nvSpPr>
-          <p:cNvPr id="6" name="TextBox 5"/>
-          <p:cNvSpPr txBox="1"/>
-          <p:nvPr/>
-        </p:nvSpPr>
-        <p:spPr>
-          <a:xfrm>
-            <a:off x="640080" y="5943600"/>
-            <a:ext cx="10908792" cy="594360"/>
-          </a:xfrm>
-          <a:prstGeom prst="rect">
-            <a:avLst/>
-          </a:prstGeom>
-          <a:noFill/>
-        </p:spPr>
-        <p:txBody>
-          <a:bodyPr wrap="square" lIns="0" rIns="0" tIns="0" bIns="0" anchor="ctr">
-            <a:spAutoFit/>
-          </a:bodyPr>
-          <a:lstStyle/>
-          <a:p>
-            <a:pPr algn="ctr">
-              <a:lnSpc>
-                <a:spcPct val="115000"/>
-              </a:lnSpc>
-            </a:pPr>
-            <a:r>
-              <a:rPr sz="1600" b="1" i="0">
-                <a:solidFill>
-                  <a:srgbClr val="122A52"/>
-                </a:solidFill>
-                <a:latin typeface="Helvetica"/>
-              </a:rPr>
-              <a:t>Resultat: én helper, brugt 3 steder. Deterministisk.</a:t>
-            </a:r>
-          </a:p>
-        </p:txBody>
-      </p:sp>
-      <p:sp>
-        <p:nvSpPr>
-          <p:cNvPr id="7" name="Rectangle 6"/>
-          <p:cNvSpPr/>
-          <p:nvPr/>
-        </p:nvSpPr>
-        <p:spPr>
-          <a:xfrm>
-            <a:off x="0" y="0"/>
-            <a:ext cx="12191695" cy="164592"/>
-          </a:xfrm>
-          <a:prstGeom prst="rect">
-            <a:avLst/>
-          </a:prstGeom>
-          <a:solidFill>
-            <a:srgbClr val="122A52"/>
-          </a:solidFill>
-          <a:ln>
-            <a:noFill/>
-          </a:ln>
-        </p:spPr>
-        <p:style>
-          <a:lnRef idx="1">
-            <a:schemeClr val="accent1"/>
-          </a:lnRef>
-          <a:fillRef idx="3">
-            <a:schemeClr val="accent1"/>
-          </a:fillRef>
-          <a:effectRef idx="2">
-            <a:schemeClr val="accent1"/>
-          </a:effectRef>
-          <a:fontRef idx="minor">
-            <a:schemeClr val="lt1"/>
-          </a:fontRef>
-        </p:style>
-        <p:txBody>
-          <a:bodyPr rtlCol="0" anchor="ctr"/>
-          <a:lstStyle/>
-          <a:p>
-            <a:pPr algn="ctr"/>
-          </a:p>
-        </p:txBody>
-      </p:sp>
-      <p:sp>
-        <p:nvSpPr>
-          <p:cNvPr id="8" name="Rectangle 7"/>
-          <p:cNvSpPr/>
-          <p:nvPr/>
-        </p:nvSpPr>
-        <p:spPr>
-          <a:xfrm>
-            <a:off x="0" y="6693408"/>
-            <a:ext cx="12191695" cy="164592"/>
-          </a:xfrm>
-          <a:prstGeom prst="rect">
-            <a:avLst/>
-          </a:prstGeom>
-          <a:solidFill>
-            <a:srgbClr val="122A52"/>
-          </a:solidFill>
-          <a:ln>
-            <a:noFill/>
-          </a:ln>
-        </p:spPr>
-        <p:style>
-          <a:lnRef idx="1">
-            <a:schemeClr val="accent1"/>
-          </a:lnRef>
-          <a:fillRef idx="3">
-            <a:schemeClr val="accent1"/>
-          </a:fillRef>
-          <a:effectRef idx="2">
-            <a:schemeClr val="accent1"/>
-          </a:effectRef>
-          <a:fontRef idx="minor">
-            <a:schemeClr val="lt1"/>
-          </a:fontRef>
-        </p:style>
-        <p:txBody>
-          <a:bodyPr rtlCol="0" anchor="ctr"/>
-          <a:lstStyle/>
-          <a:p>
-            <a:pPr algn="ctr"/>
-          </a:p>
-        </p:txBody>
-      </p:sp>
-      <p:sp>
-        <p:nvSpPr>
-          <p:cNvPr id="9" name="TextBox 8"/>
-          <p:cNvSpPr txBox="1"/>
-          <p:nvPr/>
-        </p:nvSpPr>
-        <p:spPr>
-          <a:xfrm>
-            <a:off x="365760" y="6400800"/>
-            <a:ext cx="1828800" cy="274320"/>
-          </a:xfrm>
-          <a:prstGeom prst="rect">
-            <a:avLst/>
-          </a:prstGeom>
-          <a:noFill/>
-        </p:spPr>
-        <p:txBody>
-          <a:bodyPr wrap="square" lIns="0" rIns="0" tIns="0" bIns="0" anchor="t">
-            <a:spAutoFit/>
-          </a:bodyPr>
-          <a:lstStyle/>
-          <a:p>
-            <a:pPr algn="l">
-              <a:lnSpc>
-                <a:spcPct val="115000"/>
-              </a:lnSpc>
-            </a:pPr>
-            <a:r>
-              <a:rPr sz="1000" b="0" i="0">
-                <a:solidFill>
-                  <a:srgbClr val="556B8A"/>
-                </a:solidFill>
-                <a:latin typeface="Helvetica"/>
-              </a:rPr>
-              <a:t>11 |</a:t>
-            </a:r>
-          </a:p>
-        </p:txBody>
-      </p:sp>
       <p:pic>
         <p:nvPicPr>
-          <p:cNvPr id="10" name="Picture 9" descr="edc_logo.png"/>
+          <p:cNvPr id="3" name="Picture 2" descr="edc_logo.png"/>
           <p:cNvPicPr>
             <a:picLocks noChangeAspect="1"/>
           </p:cNvPicPr>
@@ -6490,14 +5654,174 @@
         </p:blipFill>
         <p:spPr>
           <a:xfrm>
-            <a:off x="11475720" y="6263640"/>
-            <a:ext cx="594360" cy="594360"/>
+            <a:off x="5364327" y="1645920"/>
+            <a:ext cx="1463040" cy="1463040"/>
           </a:xfrm>
           <a:prstGeom prst="rect">
             <a:avLst/>
           </a:prstGeom>
         </p:spPr>
       </p:pic>
+      <p:sp>
+        <p:nvSpPr>
+          <p:cNvPr id="4" name="TextBox 3"/>
+          <p:cNvSpPr txBox="1"/>
+          <p:nvPr/>
+        </p:nvSpPr>
+        <p:spPr>
+          <a:xfrm>
+            <a:off x="0" y="3657600"/>
+            <a:ext cx="12191695" cy="548640"/>
+          </a:xfrm>
+          <a:prstGeom prst="rect">
+            <a:avLst/>
+          </a:prstGeom>
+          <a:noFill/>
+        </p:spPr>
+        <p:txBody>
+          <a:bodyPr wrap="square" lIns="0" rIns="0" tIns="0" bIns="0" anchor="t">
+            <a:spAutoFit/>
+          </a:bodyPr>
+          <a:lstStyle/>
+          <a:p>
+            <a:pPr algn="ctr">
+              <a:lnSpc>
+                <a:spcPct val="115000"/>
+              </a:lnSpc>
+            </a:pPr>
+            <a:r>
+              <a:rPr sz="2200" b="0" i="0">
+                <a:solidFill>
+                  <a:srgbClr val="F5B81C"/>
+                </a:solidFill>
+                <a:latin typeface="Menlo"/>
+              </a:rPr>
+              <a:t>Punkt 3</a:t>
+            </a:r>
+          </a:p>
+        </p:txBody>
+      </p:sp>
+      <p:sp>
+        <p:nvSpPr>
+          <p:cNvPr id="5" name="TextBox 4"/>
+          <p:cNvSpPr txBox="1"/>
+          <p:nvPr/>
+        </p:nvSpPr>
+        <p:spPr>
+          <a:xfrm>
+            <a:off x="0" y="4297680"/>
+            <a:ext cx="12191695" cy="914400"/>
+          </a:xfrm>
+          <a:prstGeom prst="rect">
+            <a:avLst/>
+          </a:prstGeom>
+          <a:noFill/>
+        </p:spPr>
+        <p:txBody>
+          <a:bodyPr wrap="square" lIns="0" rIns="0" tIns="0" bIns="0" anchor="t">
+            <a:spAutoFit/>
+          </a:bodyPr>
+          <a:lstStyle/>
+          <a:p>
+            <a:pPr algn="ctr">
+              <a:lnSpc>
+                <a:spcPct val="115000"/>
+              </a:lnSpc>
+            </a:pPr>
+            <a:r>
+              <a:rPr sz="4400" b="1" i="0">
+                <a:solidFill>
+                  <a:srgbClr val="FFFFFF"/>
+                </a:solidFill>
+                <a:latin typeface="Helvetica"/>
+              </a:rPr>
+              <a:t>Hands-on</a:t>
+            </a:r>
+          </a:p>
+        </p:txBody>
+      </p:sp>
+      <p:sp>
+        <p:nvSpPr>
+          <p:cNvPr id="6" name="TextBox 5"/>
+          <p:cNvSpPr txBox="1"/>
+          <p:nvPr/>
+        </p:nvSpPr>
+        <p:spPr>
+          <a:xfrm>
+            <a:off x="0" y="5029200"/>
+            <a:ext cx="12191695" cy="548640"/>
+          </a:xfrm>
+          <a:prstGeom prst="rect">
+            <a:avLst/>
+          </a:prstGeom>
+          <a:noFill/>
+        </p:spPr>
+        <p:txBody>
+          <a:bodyPr wrap="square" lIns="0" rIns="0" tIns="0" bIns="0" anchor="t">
+            <a:spAutoFit/>
+          </a:bodyPr>
+          <a:lstStyle/>
+          <a:p>
+            <a:pPr algn="ctr">
+              <a:lnSpc>
+                <a:spcPct val="115000"/>
+              </a:lnSpc>
+            </a:pPr>
+            <a:r>
+              <a:rPr sz="1800" b="0" i="0">
+                <a:solidFill>
+                  <a:srgbClr val="C8D4E8"/>
+                </a:solidFill>
+                <a:latin typeface="Helvetica"/>
+              </a:rPr>
+              <a:t>20 minutter · solo på din egen maskine</a:t>
+            </a:r>
+          </a:p>
+        </p:txBody>
+      </p:sp>
+      <p:sp>
+        <p:nvSpPr>
+          <p:cNvPr id="7" name="Rectangle 6"/>
+          <p:cNvSpPr/>
+          <p:nvPr/>
+        </p:nvSpPr>
+        <p:spPr>
+          <a:xfrm>
+            <a:off x="0" y="6693408"/>
+            <a:ext cx="12191695" cy="164592"/>
+          </a:xfrm>
+          <a:prstGeom prst="rect">
+            <a:avLst/>
+          </a:prstGeom>
+          <a:solidFill>
+            <a:srgbClr val="F5B81C"/>
+          </a:solidFill>
+          <a:ln>
+            <a:noFill/>
+          </a:ln>
+        </p:spPr>
+        <p:style>
+          <a:lnRef idx="1">
+            <a:schemeClr val="accent1"/>
+          </a:lnRef>
+          <a:fillRef idx="3">
+            <a:schemeClr val="accent1"/>
+          </a:fillRef>
+          <a:effectRef idx="2">
+            <a:schemeClr val="accent1"/>
+          </a:effectRef>
+          <a:fontRef idx="minor">
+            <a:schemeClr val="lt1"/>
+          </a:fontRef>
+        </p:style>
+        <p:txBody>
+          <a:bodyPr rtlCol="0" anchor="ctr"/>
+          <a:lstStyle/>
+          <a:p>
+            <a:pPr algn="ctr"/>
+          </a:p>
+        </p:txBody>
+      </p:sp>
     </p:spTree>
   </p:cSld>
   <p:clrMapOvr>
@@ -6593,7 +5917,7 @@
                 </a:solidFill>
                 <a:latin typeface="Helvetica"/>
               </a:rPr>
-              <a:t>Pointen</a:t>
+              <a:t>Hands-on</a:t>
             </a:r>
             <a:r>
               <a:rPr sz="3400" b="0">
@@ -6602,142 +5926,21 @@
                 </a:solidFill>
                 <a:latin typeface="Helvetica"/>
               </a:rPr>
-              <a:t> | Begge fixes virker visuelt — kun den ene efterlader sund kode</a:t>
-            </a:r>
-          </a:p>
-        </p:txBody>
-      </p:sp>
-      <p:sp>
-        <p:nvSpPr>
-          <p:cNvPr id="4" name="Rectangle 3"/>
-          <p:cNvSpPr/>
+              <a:t> | Prøv begge prompt-typer på samme opgave</a:t>
+            </a:r>
+          </a:p>
+        </p:txBody>
+      </p:sp>
+      <p:sp>
+        <p:nvSpPr>
+          <p:cNvPr id="4" name="TextBox 3"/>
+          <p:cNvSpPr txBox="1"/>
           <p:nvPr/>
         </p:nvSpPr>
         <p:spPr>
           <a:xfrm>
             <a:off x="640080" y="2011680"/>
-            <a:ext cx="5349240" cy="3657600"/>
-          </a:xfrm>
-          <a:prstGeom prst="rect">
-            <a:avLst/>
-          </a:prstGeom>
-          <a:solidFill>
-            <a:srgbClr val="FADCDC"/>
-          </a:solidFill>
-          <a:ln>
-            <a:noFill/>
-          </a:ln>
-        </p:spPr>
-        <p:style>
-          <a:lnRef idx="1">
-            <a:schemeClr val="accent1"/>
-          </a:lnRef>
-          <a:fillRef idx="3">
-            <a:schemeClr val="accent1"/>
-          </a:fillRef>
-          <a:effectRef idx="2">
-            <a:schemeClr val="accent1"/>
-          </a:effectRef>
-          <a:fontRef idx="minor">
-            <a:schemeClr val="lt1"/>
-          </a:fontRef>
-        </p:style>
-        <p:txBody>
-          <a:bodyPr rtlCol="0" anchor="ctr"/>
-          <a:lstStyle/>
-          <a:p>
-            <a:pPr algn="ctr"/>
-          </a:p>
-        </p:txBody>
-      </p:sp>
-      <p:sp>
-        <p:nvSpPr>
-          <p:cNvPr id="5" name="TextBox 4"/>
-          <p:cNvSpPr txBox="1"/>
-          <p:nvPr/>
-        </p:nvSpPr>
-        <p:spPr>
-          <a:xfrm>
-            <a:off x="1005840" y="2286000"/>
-            <a:ext cx="4617720" cy="365760"/>
-          </a:xfrm>
-          <a:prstGeom prst="rect">
-            <a:avLst/>
-          </a:prstGeom>
-          <a:noFill/>
-        </p:spPr>
-        <p:txBody>
-          <a:bodyPr wrap="square" lIns="0" rIns="0" tIns="0" bIns="0" anchor="t">
-            <a:spAutoFit/>
-          </a:bodyPr>
-          <a:lstStyle/>
-          <a:p>
-            <a:pPr algn="l">
-              <a:lnSpc>
-                <a:spcPct val="115000"/>
-              </a:lnSpc>
-            </a:pPr>
-            <a:r>
-              <a:rPr sz="1400" b="1" i="0">
-                <a:solidFill>
-                  <a:srgbClr val="8B1F1F"/>
-                </a:solidFill>
-                <a:latin typeface="Helvetica"/>
-              </a:rPr>
-              <a:t>DÅRLIG PROMPT</a:t>
-            </a:r>
-          </a:p>
-        </p:txBody>
-      </p:sp>
-      <p:sp>
-        <p:nvSpPr>
-          <p:cNvPr id="6" name="TextBox 5"/>
-          <p:cNvSpPr txBox="1"/>
-          <p:nvPr/>
-        </p:nvSpPr>
-        <p:spPr>
-          <a:xfrm>
-            <a:off x="1005840" y="2788920"/>
-            <a:ext cx="4617720" cy="822960"/>
-          </a:xfrm>
-          <a:prstGeom prst="rect">
-            <a:avLst/>
-          </a:prstGeom>
-          <a:noFill/>
-        </p:spPr>
-        <p:txBody>
-          <a:bodyPr wrap="square" lIns="0" rIns="0" tIns="0" bIns="0" anchor="t">
-            <a:spAutoFit/>
-          </a:bodyPr>
-          <a:lstStyle/>
-          <a:p>
-            <a:pPr algn="l">
-              <a:lnSpc>
-                <a:spcPct val="115000"/>
-              </a:lnSpc>
-            </a:pPr>
-            <a:r>
-              <a:rPr sz="2200" b="1" i="0">
-                <a:solidFill>
-                  <a:srgbClr val="122A52"/>
-                </a:solidFill>
-                <a:latin typeface="Helvetica"/>
-              </a:rPr>
-              <a:t>3 inline-kopier af samme logik</a:t>
-            </a:r>
-          </a:p>
-        </p:txBody>
-      </p:sp>
-      <p:sp>
-        <p:nvSpPr>
-          <p:cNvPr id="7" name="TextBox 6"/>
-          <p:cNvSpPr txBox="1"/>
-          <p:nvPr/>
-        </p:nvSpPr>
-        <p:spPr>
-          <a:xfrm>
-            <a:off x="1005840" y="3840480"/>
-            <a:ext cx="4617720" cy="1828800"/>
+            <a:ext cx="10972800" cy="4114800"/>
           </a:xfrm>
           <a:prstGeom prst="rect">
             <a:avLst/>
@@ -6752,320 +5955,275 @@
           <a:p>
             <a:pPr algn="l">
               <a:lnSpc>
-                <a:spcPct val="150000"/>
+                <a:spcPct val="160000"/>
               </a:lnSpc>
               <a:spcAft>
                 <a:spcPts val="1000"/>
               </a:spcAft>
             </a:pPr>
             <a:r>
-              <a:rPr sz="1500" b="1">
-                <a:solidFill>
-                  <a:srgbClr val="8B1F1F"/>
+              <a:rPr sz="1800" b="1">
+                <a:solidFill>
+                  <a:srgbClr val="122A52"/>
                 </a:solidFill>
                 <a:latin typeface="Helvetica"/>
               </a:rPr>
               <a:t>■   </a:t>
             </a:r>
             <a:r>
-              <a:rPr sz="1500" b="0">
+              <a:rPr sz="1800" b="1">
                 <a:solidFill>
                   <a:srgbClr val="122A52"/>
                 </a:solidFill>
                 <a:latin typeface="Helvetica"/>
               </a:rPr>
-              <a:t>DRY brudt — ændring kræver 3 filer</a:t>
+              <a:t>git clone</a:t>
+            </a:r>
+            <a:r>
+              <a:rPr sz="1800" b="0">
+                <a:solidFill>
+                  <a:srgbClr val="122A52"/>
+                </a:solidFill>
+                <a:latin typeface="Helvetica"/>
+              </a:rPr>
+              <a:t> + </a:t>
+            </a:r>
+            <a:r>
+              <a:rPr sz="1800" b="1">
+                <a:solidFill>
+                  <a:srgbClr val="122A52"/>
+                </a:solidFill>
+                <a:latin typeface="Helvetica"/>
+              </a:rPr>
+              <a:t>npm install</a:t>
+            </a:r>
+            <a:r>
+              <a:rPr sz="1800" b="0">
+                <a:solidFill>
+                  <a:srgbClr val="122A52"/>
+                </a:solidFill>
+                <a:latin typeface="Helvetica"/>
+              </a:rPr>
+              <a:t> + </a:t>
+            </a:r>
+            <a:r>
+              <a:rPr sz="1800" b="1">
+                <a:solidFill>
+                  <a:srgbClr val="122A52"/>
+                </a:solidFill>
+                <a:latin typeface="Helvetica"/>
+              </a:rPr>
+              <a:t>claude</a:t>
+            </a:r>
+            <a:r>
+              <a:rPr sz="1800" b="0">
+                <a:solidFill>
+                  <a:srgbClr val="122A52"/>
+                </a:solidFill>
+                <a:latin typeface="Helvetica"/>
+              </a:rPr>
+              <a:t> i `demo/`-mappen</a:t>
             </a:r>
           </a:p>
           <a:p>
             <a:pPr algn="l">
               <a:lnSpc>
-                <a:spcPct val="150000"/>
+                <a:spcPct val="160000"/>
               </a:lnSpc>
               <a:spcAft>
                 <a:spcPts val="1000"/>
               </a:spcAft>
             </a:pPr>
             <a:r>
-              <a:rPr sz="1500" b="1">
-                <a:solidFill>
-                  <a:srgbClr val="8B1F1F"/>
+              <a:rPr sz="1800" b="1">
+                <a:solidFill>
+                  <a:srgbClr val="122A52"/>
                 </a:solidFill>
                 <a:latin typeface="Helvetica"/>
               </a:rPr>
               <a:t>■   </a:t>
             </a:r>
             <a:r>
-              <a:rPr sz="1500" b="0">
+              <a:rPr sz="1800" b="0">
                 <a:solidFill>
                   <a:srgbClr val="122A52"/>
                 </a:solidFill>
                 <a:latin typeface="Helvetica"/>
               </a:rPr>
-              <a:t>Forskelligt resultat hver kørsel</a:t>
+              <a:t>Vælg én opgave fra demoen (pris-bug, performance, eller favorit-knap)</a:t>
             </a:r>
           </a:p>
           <a:p>
             <a:pPr algn="l">
               <a:lnSpc>
-                <a:spcPct val="150000"/>
+                <a:spcPct val="160000"/>
               </a:lnSpc>
               <a:spcAft>
                 <a:spcPts val="1000"/>
               </a:spcAft>
             </a:pPr>
             <a:r>
-              <a:rPr sz="1500" b="1">
-                <a:solidFill>
-                  <a:srgbClr val="8B1F1F"/>
+              <a:rPr sz="1800" b="1">
+                <a:solidFill>
+                  <a:srgbClr val="122A52"/>
                 </a:solidFill>
                 <a:latin typeface="Helvetica"/>
               </a:rPr>
               <a:t>■   </a:t>
             </a:r>
             <a:r>
-              <a:rPr sz="1500" b="0">
+              <a:rPr sz="1800" b="0">
                 <a:solidFill>
                   <a:srgbClr val="122A52"/>
                 </a:solidFill>
                 <a:latin typeface="Helvetica"/>
               </a:rPr>
-              <a:t>Nogle gange ufuldstændig fix</a:t>
-            </a:r>
-          </a:p>
-        </p:txBody>
-      </p:sp>
-      <p:sp>
-        <p:nvSpPr>
-          <p:cNvPr id="8" name="Rectangle 7"/>
-          <p:cNvSpPr/>
-          <p:nvPr/>
-        </p:nvSpPr>
-        <p:spPr>
-          <a:xfrm>
-            <a:off x="6263640" y="2011680"/>
-            <a:ext cx="5349240" cy="3657600"/>
-          </a:xfrm>
-          <a:prstGeom prst="rect">
-            <a:avLst/>
-          </a:prstGeom>
-          <a:solidFill>
-            <a:srgbClr val="D7ECDD"/>
-          </a:solidFill>
-          <a:ln>
-            <a:noFill/>
-          </a:ln>
-        </p:spPr>
-        <p:style>
-          <a:lnRef idx="1">
-            <a:schemeClr val="accent1"/>
-          </a:lnRef>
-          <a:fillRef idx="3">
-            <a:schemeClr val="accent1"/>
-          </a:fillRef>
-          <a:effectRef idx="2">
-            <a:schemeClr val="accent1"/>
-          </a:effectRef>
-          <a:fontRef idx="minor">
-            <a:schemeClr val="lt1"/>
-          </a:fontRef>
-        </p:style>
-        <p:txBody>
-          <a:bodyPr rtlCol="0" anchor="ctr"/>
-          <a:lstStyle/>
-          <a:p>
-            <a:pPr algn="ctr"/>
-          </a:p>
-        </p:txBody>
-      </p:sp>
-      <p:sp>
-        <p:nvSpPr>
-          <p:cNvPr id="9" name="TextBox 8"/>
-          <p:cNvSpPr txBox="1"/>
-          <p:nvPr/>
-        </p:nvSpPr>
-        <p:spPr>
-          <a:xfrm>
-            <a:off x="6629400" y="2286000"/>
-            <a:ext cx="4617720" cy="365760"/>
-          </a:xfrm>
-          <a:prstGeom prst="rect">
-            <a:avLst/>
-          </a:prstGeom>
-          <a:noFill/>
-        </p:spPr>
-        <p:txBody>
-          <a:bodyPr wrap="square" lIns="0" rIns="0" tIns="0" bIns="0" anchor="t">
-            <a:spAutoFit/>
-          </a:bodyPr>
-          <a:lstStyle/>
+              <a:t>Skriv først en </a:t>
+            </a:r>
+            <a:r>
+              <a:rPr sz="1800" b="1">
+                <a:solidFill>
+                  <a:srgbClr val="122A52"/>
+                </a:solidFill>
+                <a:latin typeface="Helvetica"/>
+              </a:rPr>
+              <a:t>hurtig prompt</a:t>
+            </a:r>
+            <a:r>
+              <a:rPr sz="1800" b="0">
+                <a:solidFill>
+                  <a:srgbClr val="122A52"/>
+                </a:solidFill>
+                <a:latin typeface="Helvetica"/>
+              </a:rPr>
+              <a:t> — som du ville skrive på en travl dag</a:t>
+            </a:r>
+          </a:p>
           <a:p>
             <a:pPr algn="l">
               <a:lnSpc>
-                <a:spcPct val="115000"/>
-              </a:lnSpc>
-            </a:pPr>
-            <a:r>
-              <a:rPr sz="1400" b="1" i="0">
-                <a:solidFill>
-                  <a:srgbClr val="14532D"/>
-                </a:solidFill>
-                <a:latin typeface="Helvetica"/>
-              </a:rPr>
-              <a:t>GOD PROMPT</a:t>
-            </a:r>
-          </a:p>
-        </p:txBody>
-      </p:sp>
-      <p:sp>
-        <p:nvSpPr>
-          <p:cNvPr id="10" name="TextBox 9"/>
-          <p:cNvSpPr txBox="1"/>
-          <p:nvPr/>
-        </p:nvSpPr>
-        <p:spPr>
-          <a:xfrm>
-            <a:off x="6629400" y="2788920"/>
-            <a:ext cx="4617720" cy="822960"/>
-          </a:xfrm>
-          <a:prstGeom prst="rect">
-            <a:avLst/>
-          </a:prstGeom>
-          <a:noFill/>
-        </p:spPr>
-        <p:txBody>
-          <a:bodyPr wrap="square" lIns="0" rIns="0" tIns="0" bIns="0" anchor="t">
-            <a:spAutoFit/>
-          </a:bodyPr>
-          <a:lstStyle/>
-          <a:p>
-            <a:pPr algn="l">
-              <a:lnSpc>
-                <a:spcPct val="115000"/>
-              </a:lnSpc>
-            </a:pPr>
-            <a:r>
-              <a:rPr sz="2200" b="1" i="0">
-                <a:solidFill>
-                  <a:srgbClr val="122A52"/>
-                </a:solidFill>
-                <a:latin typeface="Helvetica"/>
-              </a:rPr>
-              <a:t>1 helper, brugt 3 steder</a:t>
-            </a:r>
-          </a:p>
-        </p:txBody>
-      </p:sp>
-      <p:sp>
-        <p:nvSpPr>
-          <p:cNvPr id="11" name="TextBox 10"/>
-          <p:cNvSpPr txBox="1"/>
-          <p:nvPr/>
-        </p:nvSpPr>
-        <p:spPr>
-          <a:xfrm>
-            <a:off x="6629400" y="3840480"/>
-            <a:ext cx="4617720" cy="1828800"/>
-          </a:xfrm>
-          <a:prstGeom prst="rect">
-            <a:avLst/>
-          </a:prstGeom>
-          <a:noFill/>
-        </p:spPr>
-        <p:txBody>
-          <a:bodyPr wrap="square" lIns="0" rIns="0" tIns="0" bIns="0">
-            <a:spAutoFit/>
-          </a:bodyPr>
-          <a:lstStyle/>
-          <a:p>
-            <a:pPr algn="l">
-              <a:lnSpc>
-                <a:spcPct val="150000"/>
+                <a:spcPct val="160000"/>
               </a:lnSpc>
               <a:spcAft>
                 <a:spcPts val="1000"/>
               </a:spcAft>
             </a:pPr>
             <a:r>
-              <a:rPr sz="1500" b="1">
-                <a:solidFill>
-                  <a:srgbClr val="14532D"/>
+              <a:rPr sz="1800" b="1">
+                <a:solidFill>
+                  <a:srgbClr val="122A52"/>
                 </a:solidFill>
                 <a:latin typeface="Helvetica"/>
               </a:rPr>
               <a:t>■   </a:t>
             </a:r>
             <a:r>
-              <a:rPr sz="1500" b="0">
+              <a:rPr sz="1800" b="1">
                 <a:solidFill>
                   <a:srgbClr val="122A52"/>
                 </a:solidFill>
                 <a:latin typeface="Helvetica"/>
               </a:rPr>
-              <a:t>Ét sted at ændre fremover</a:t>
+              <a:t>git checkout .</a:t>
+            </a:r>
+            <a:r>
+              <a:rPr sz="1800" b="0">
+                <a:solidFill>
+                  <a:srgbClr val="122A52"/>
+                </a:solidFill>
+                <a:latin typeface="Helvetica"/>
+              </a:rPr>
+              <a:t> og </a:t>
+            </a:r>
+            <a:r>
+              <a:rPr sz="1800" b="1">
+                <a:solidFill>
+                  <a:srgbClr val="122A52"/>
+                </a:solidFill>
+                <a:latin typeface="Helvetica"/>
+              </a:rPr>
+              <a:t>/clear</a:t>
+            </a:r>
+            <a:r>
+              <a:rPr sz="1800" b="0">
+                <a:solidFill>
+                  <a:srgbClr val="122A52"/>
+                </a:solidFill>
+                <a:latin typeface="Helvetica"/>
+              </a:rPr>
+              <a:t> for at rulle tilbage</a:t>
             </a:r>
           </a:p>
           <a:p>
             <a:pPr algn="l">
               <a:lnSpc>
-                <a:spcPct val="150000"/>
+                <a:spcPct val="160000"/>
               </a:lnSpc>
               <a:spcAft>
                 <a:spcPts val="1000"/>
               </a:spcAft>
             </a:pPr>
             <a:r>
-              <a:rPr sz="1500" b="1">
-                <a:solidFill>
-                  <a:srgbClr val="14532D"/>
+              <a:rPr sz="1800" b="1">
+                <a:solidFill>
+                  <a:srgbClr val="122A52"/>
                 </a:solidFill>
                 <a:latin typeface="Helvetica"/>
               </a:rPr>
               <a:t>■   </a:t>
             </a:r>
             <a:r>
-              <a:rPr sz="1500" b="0">
+              <a:rPr sz="1800" b="0">
                 <a:solidFill>
                   <a:srgbClr val="122A52"/>
                 </a:solidFill>
                 <a:latin typeface="Helvetica"/>
               </a:rPr>
-              <a:t>Deterministisk — samme resultat hver gang</a:t>
+              <a:t>Skriv så en prompt med </a:t>
+            </a:r>
+            <a:r>
+              <a:rPr sz="1800" b="1">
+                <a:solidFill>
+                  <a:srgbClr val="122A52"/>
+                </a:solidFill>
+                <a:latin typeface="Helvetica"/>
+              </a:rPr>
+              <a:t>alle 4 byggeklodser</a:t>
             </a:r>
           </a:p>
           <a:p>
             <a:pPr algn="l">
               <a:lnSpc>
-                <a:spcPct val="150000"/>
+                <a:spcPct val="160000"/>
               </a:lnSpc>
               <a:spcAft>
                 <a:spcPts val="1000"/>
               </a:spcAft>
             </a:pPr>
             <a:r>
-              <a:rPr sz="1500" b="1">
-                <a:solidFill>
-                  <a:srgbClr val="14532D"/>
+              <a:rPr sz="1800" b="1">
+                <a:solidFill>
+                  <a:srgbClr val="122A52"/>
                 </a:solidFill>
                 <a:latin typeface="Helvetica"/>
               </a:rPr>
               <a:t>■   </a:t>
             </a:r>
             <a:r>
-              <a:rPr sz="1500" b="0">
+              <a:rPr sz="1800" b="0">
                 <a:solidFill>
                   <a:srgbClr val="122A52"/>
                 </a:solidFill>
                 <a:latin typeface="Helvetica"/>
               </a:rPr>
-              <a:t>Helperen kan genbruges</a:t>
-            </a:r>
-          </a:p>
-        </p:txBody>
-      </p:sp>
-      <p:sp>
-        <p:nvSpPr>
-          <p:cNvPr id="12" name="Rectangle 11"/>
+              <a:t>Sammenlign: hvad var forskellen? Hvilken ville du committe?</a:t>
+            </a:r>
+          </a:p>
+        </p:txBody>
+      </p:sp>
+      <p:sp>
+        <p:nvSpPr>
+          <p:cNvPr id="5" name="Rectangle 4"/>
           <p:cNvSpPr/>
           <p:nvPr/>
         </p:nvSpPr>
@@ -7108,7 +6266,7 @@
       </p:sp>
       <p:sp>
         <p:nvSpPr>
-          <p:cNvPr id="13" name="Rectangle 12"/>
+          <p:cNvPr id="6" name="Rectangle 5"/>
           <p:cNvSpPr/>
           <p:nvPr/>
         </p:nvSpPr>
@@ -7151,7 +6309,7 @@
       </p:sp>
       <p:sp>
         <p:nvSpPr>
-          <p:cNvPr id="14" name="TextBox 13"/>
+          <p:cNvPr id="7" name="TextBox 6"/>
           <p:cNvSpPr txBox="1"/>
           <p:nvPr/>
         </p:nvSpPr>
@@ -7190,7 +6348,7 @@
       </p:sp>
       <p:pic>
         <p:nvPicPr>
-          <p:cNvPr id="15" name="Picture 14" descr="edc_logo.png"/>
+          <p:cNvPr id="8" name="Picture 7" descr="edc_logo.png"/>
           <p:cNvPicPr>
             <a:picLocks noChangeAspect="1"/>
           </p:cNvPicPr>
@@ -7245,1319 +6403,6 @@
             <a:avLst/>
           </a:prstGeom>
           <a:solidFill>
-            <a:srgbClr val="FFFFFF"/>
-          </a:solidFill>
-          <a:ln>
-            <a:noFill/>
-          </a:ln>
-        </p:spPr>
-        <p:style>
-          <a:lnRef idx="1">
-            <a:schemeClr val="accent1"/>
-          </a:lnRef>
-          <a:fillRef idx="3">
-            <a:schemeClr val="accent1"/>
-          </a:fillRef>
-          <a:effectRef idx="2">
-            <a:schemeClr val="accent1"/>
-          </a:effectRef>
-          <a:fontRef idx="minor">
-            <a:schemeClr val="lt1"/>
-          </a:fontRef>
-        </p:style>
-        <p:txBody>
-          <a:bodyPr rtlCol="0" anchor="ctr"/>
-          <a:lstStyle/>
-          <a:p>
-            <a:pPr algn="ctr"/>
-          </a:p>
-        </p:txBody>
-      </p:sp>
-      <p:sp>
-        <p:nvSpPr>
-          <p:cNvPr id="3" name="TextBox 2"/>
-          <p:cNvSpPr txBox="1"/>
-          <p:nvPr/>
-        </p:nvSpPr>
-        <p:spPr>
-          <a:xfrm>
-            <a:off x="548640" y="457200"/>
-            <a:ext cx="11155680" cy="914400"/>
-          </a:xfrm>
-          <a:prstGeom prst="rect">
-            <a:avLst/>
-          </a:prstGeom>
-          <a:noFill/>
-        </p:spPr>
-        <p:txBody>
-          <a:bodyPr wrap="square" lIns="0" tIns="0" bIns="0" rIns="0">
-            <a:spAutoFit/>
-          </a:bodyPr>
-          <a:lstStyle/>
-          <a:p>
-            <a:pPr algn="l">
-              <a:lnSpc>
-                <a:spcPct val="110000"/>
-              </a:lnSpc>
-            </a:pPr>
-            <a:r>
-              <a:rPr sz="3400" b="1">
-                <a:solidFill>
-                  <a:srgbClr val="122A52"/>
-                </a:solidFill>
-                <a:latin typeface="Helvetica"/>
-              </a:rPr>
-              <a:t>Vigtigt forbehold</a:t>
-            </a:r>
-            <a:r>
-              <a:rPr sz="3400" b="0">
-                <a:solidFill>
-                  <a:srgbClr val="122A52"/>
-                </a:solidFill>
-                <a:latin typeface="Helvetica"/>
-              </a:rPr>
-              <a:t> | Demoen er lille — virkeligheden er stor</a:t>
-            </a:r>
-          </a:p>
-        </p:txBody>
-      </p:sp>
-      <p:sp>
-        <p:nvSpPr>
-          <p:cNvPr id="4" name="5-Point Star 3"/>
-          <p:cNvSpPr/>
-          <p:nvPr/>
-        </p:nvSpPr>
-        <p:spPr>
-          <a:xfrm>
-            <a:off x="731520" y="1920240"/>
-            <a:ext cx="822960" cy="822960"/>
-          </a:xfrm>
-          <a:prstGeom prst="star5">
-            <a:avLst/>
-          </a:prstGeom>
-          <a:solidFill>
-            <a:srgbClr val="122A52"/>
-          </a:solidFill>
-          <a:ln>
-            <a:noFill/>
-          </a:ln>
-        </p:spPr>
-        <p:style>
-          <a:lnRef idx="1">
-            <a:schemeClr val="accent1"/>
-          </a:lnRef>
-          <a:fillRef idx="3">
-            <a:schemeClr val="accent1"/>
-          </a:fillRef>
-          <a:effectRef idx="2">
-            <a:schemeClr val="accent1"/>
-          </a:effectRef>
-          <a:fontRef idx="minor">
-            <a:schemeClr val="lt1"/>
-          </a:fontRef>
-        </p:style>
-        <p:txBody>
-          <a:bodyPr rtlCol="0" anchor="ctr"/>
-          <a:lstStyle/>
-          <a:p>
-            <a:pPr algn="ctr"/>
-          </a:p>
-        </p:txBody>
-      </p:sp>
-      <p:sp>
-        <p:nvSpPr>
-          <p:cNvPr id="5" name="TextBox 4"/>
-          <p:cNvSpPr txBox="1"/>
-          <p:nvPr/>
-        </p:nvSpPr>
-        <p:spPr>
-          <a:xfrm>
-            <a:off x="1920240" y="1965960"/>
-            <a:ext cx="9692640" cy="822960"/>
-          </a:xfrm>
-          <a:prstGeom prst="rect">
-            <a:avLst/>
-          </a:prstGeom>
-          <a:noFill/>
-        </p:spPr>
-        <p:txBody>
-          <a:bodyPr wrap="square" lIns="0" rIns="0" tIns="0" bIns="0" anchor="t">
-            <a:spAutoFit/>
-          </a:bodyPr>
-          <a:lstStyle/>
-          <a:p>
-            <a:pPr algn="l">
-              <a:lnSpc>
-                <a:spcPct val="130000"/>
-              </a:lnSpc>
-            </a:pPr>
-            <a:r>
-              <a:rPr sz="2000" b="1">
-                <a:solidFill>
-                  <a:srgbClr val="122A52"/>
-                </a:solidFill>
-                <a:latin typeface="Helvetica"/>
-              </a:rPr>
-              <a:t>Forskellen ser subtil ud her.</a:t>
-            </a:r>
-            <a:r>
-              <a:rPr sz="2000" b="0">
-                <a:solidFill>
-                  <a:srgbClr val="122A52"/>
-                </a:solidFill>
-                <a:latin typeface="Helvetica"/>
-              </a:rPr>
-              <a:t> På jeres rigtige projekter eksploderer den.</a:t>
-            </a:r>
-          </a:p>
-        </p:txBody>
-      </p:sp>
-      <p:sp>
-        <p:nvSpPr>
-          <p:cNvPr id="6" name="TextBox 5"/>
-          <p:cNvSpPr txBox="1"/>
-          <p:nvPr/>
-        </p:nvSpPr>
-        <p:spPr>
-          <a:xfrm>
-            <a:off x="731520" y="3200400"/>
-            <a:ext cx="10789920" cy="3200400"/>
-          </a:xfrm>
-          <a:prstGeom prst="rect">
-            <a:avLst/>
-          </a:prstGeom>
-          <a:noFill/>
-        </p:spPr>
-        <p:txBody>
-          <a:bodyPr wrap="square" lIns="0" rIns="0" tIns="0" bIns="0">
-            <a:spAutoFit/>
-          </a:bodyPr>
-          <a:lstStyle/>
-          <a:p>
-            <a:pPr algn="l">
-              <a:lnSpc>
-                <a:spcPct val="160000"/>
-              </a:lnSpc>
-              <a:spcAft>
-                <a:spcPts val="1000"/>
-              </a:spcAft>
-            </a:pPr>
-            <a:r>
-              <a:rPr sz="1500" b="1">
-                <a:solidFill>
-                  <a:srgbClr val="122A52"/>
-                </a:solidFill>
-                <a:latin typeface="Helvetica"/>
-              </a:rPr>
-              <a:t>■   </a:t>
-            </a:r>
-            <a:r>
-              <a:rPr sz="1500" b="1">
-                <a:solidFill>
-                  <a:srgbClr val="122A52"/>
-                </a:solidFill>
-                <a:latin typeface="Helvetica"/>
-              </a:rPr>
-              <a:t>Her:</a:t>
-            </a:r>
-            <a:r>
-              <a:rPr sz="1500" b="0">
-                <a:solidFill>
-                  <a:srgbClr val="122A52"/>
-                </a:solidFill>
-                <a:latin typeface="Helvetica"/>
-              </a:rPr>
-              <a:t> 5 filer, ét tydeligt symptom, Opus 4.7 — Claude finder *et* fix uanset hvor vag prompten er</a:t>
-            </a:r>
-          </a:p>
-          <a:p>
-            <a:pPr algn="l">
-              <a:lnSpc>
-                <a:spcPct val="160000"/>
-              </a:lnSpc>
-              <a:spcAft>
-                <a:spcPts val="1000"/>
-              </a:spcAft>
-            </a:pPr>
-            <a:r>
-              <a:rPr sz="1500" b="1">
-                <a:solidFill>
-                  <a:srgbClr val="122A52"/>
-                </a:solidFill>
-                <a:latin typeface="Helvetica"/>
-              </a:rPr>
-              <a:t>■   </a:t>
-            </a:r>
-            <a:r>
-              <a:rPr sz="1500" b="1">
-                <a:solidFill>
-                  <a:srgbClr val="122A52"/>
-                </a:solidFill>
-                <a:latin typeface="Helvetica"/>
-              </a:rPr>
-              <a:t>På jeres codebases:</a:t>
-            </a:r>
-            <a:r>
-              <a:rPr sz="1500" b="0">
-                <a:solidFill>
-                  <a:srgbClr val="122A52"/>
-                </a:solidFill>
-                <a:latin typeface="Helvetica"/>
-              </a:rPr>
-              <a:t> 100k+ linjer, 10+ års historik, DTO'er, mappere, migrations, uskrevne konventioner</a:t>
-            </a:r>
-          </a:p>
-          <a:p>
-            <a:pPr algn="l">
-              <a:lnSpc>
-                <a:spcPct val="160000"/>
-              </a:lnSpc>
-              <a:spcAft>
-                <a:spcPts val="1000"/>
-              </a:spcAft>
-            </a:pPr>
-            <a:r>
-              <a:rPr sz="1500" b="1">
-                <a:solidFill>
-                  <a:srgbClr val="122A52"/>
-                </a:solidFill>
-                <a:latin typeface="Helvetica"/>
-              </a:rPr>
-              <a:t>■   </a:t>
-            </a:r>
-            <a:r>
-              <a:rPr sz="1500" b="1">
-                <a:solidFill>
-                  <a:srgbClr val="122A52"/>
-                </a:solidFill>
-                <a:latin typeface="Helvetica"/>
-              </a:rPr>
-              <a:t>Konsekvens af vag prompt:</a:t>
-            </a:r>
-            <a:r>
-              <a:rPr sz="1500" b="0">
-                <a:solidFill>
-                  <a:srgbClr val="122A52"/>
-                </a:solidFill>
-                <a:latin typeface="Helvetica"/>
-              </a:rPr>
-              <a:t> forkert fil · glemt halvdel af kæden · konfliktende abstraktion · brudt konvention</a:t>
-            </a:r>
-          </a:p>
-          <a:p>
-            <a:pPr algn="l">
-              <a:lnSpc>
-                <a:spcPct val="160000"/>
-              </a:lnSpc>
-              <a:spcAft>
-                <a:spcPts val="1000"/>
-              </a:spcAft>
-            </a:pPr>
-            <a:r>
-              <a:rPr sz="1500" b="1">
-                <a:solidFill>
-                  <a:srgbClr val="122A52"/>
-                </a:solidFill>
-                <a:latin typeface="Helvetica"/>
-              </a:rPr>
-              <a:t>■   </a:t>
-            </a:r>
-            <a:r>
-              <a:rPr sz="1500" b="1">
-                <a:solidFill>
-                  <a:srgbClr val="122A52"/>
-                </a:solidFill>
-                <a:latin typeface="Helvetica"/>
-              </a:rPr>
-              <a:t>Vi træner mønsteret HER</a:t>
-            </a:r>
-            <a:r>
-              <a:rPr sz="1500" b="0">
-                <a:solidFill>
-                  <a:srgbClr val="122A52"/>
-                </a:solidFill>
-                <a:latin typeface="Helvetica"/>
-              </a:rPr>
-              <a:t> — så det sidder i fingrene mandag morgen i en rigtig PR</a:t>
-            </a:r>
-          </a:p>
-        </p:txBody>
-      </p:sp>
-      <p:sp>
-        <p:nvSpPr>
-          <p:cNvPr id="7" name="Rectangle 6"/>
-          <p:cNvSpPr/>
-          <p:nvPr/>
-        </p:nvSpPr>
-        <p:spPr>
-          <a:xfrm>
-            <a:off x="0" y="0"/>
-            <a:ext cx="12191695" cy="164592"/>
-          </a:xfrm>
-          <a:prstGeom prst="rect">
-            <a:avLst/>
-          </a:prstGeom>
-          <a:solidFill>
-            <a:srgbClr val="122A52"/>
-          </a:solidFill>
-          <a:ln>
-            <a:noFill/>
-          </a:ln>
-        </p:spPr>
-        <p:style>
-          <a:lnRef idx="1">
-            <a:schemeClr val="accent1"/>
-          </a:lnRef>
-          <a:fillRef idx="3">
-            <a:schemeClr val="accent1"/>
-          </a:fillRef>
-          <a:effectRef idx="2">
-            <a:schemeClr val="accent1"/>
-          </a:effectRef>
-          <a:fontRef idx="minor">
-            <a:schemeClr val="lt1"/>
-          </a:fontRef>
-        </p:style>
-        <p:txBody>
-          <a:bodyPr rtlCol="0" anchor="ctr"/>
-          <a:lstStyle/>
-          <a:p>
-            <a:pPr algn="ctr"/>
-          </a:p>
-        </p:txBody>
-      </p:sp>
-      <p:sp>
-        <p:nvSpPr>
-          <p:cNvPr id="8" name="Rectangle 7"/>
-          <p:cNvSpPr/>
-          <p:nvPr/>
-        </p:nvSpPr>
-        <p:spPr>
-          <a:xfrm>
-            <a:off x="0" y="6693408"/>
-            <a:ext cx="12191695" cy="164592"/>
-          </a:xfrm>
-          <a:prstGeom prst="rect">
-            <a:avLst/>
-          </a:prstGeom>
-          <a:solidFill>
-            <a:srgbClr val="122A52"/>
-          </a:solidFill>
-          <a:ln>
-            <a:noFill/>
-          </a:ln>
-        </p:spPr>
-        <p:style>
-          <a:lnRef idx="1">
-            <a:schemeClr val="accent1"/>
-          </a:lnRef>
-          <a:fillRef idx="3">
-            <a:schemeClr val="accent1"/>
-          </a:fillRef>
-          <a:effectRef idx="2">
-            <a:schemeClr val="accent1"/>
-          </a:effectRef>
-          <a:fontRef idx="minor">
-            <a:schemeClr val="lt1"/>
-          </a:fontRef>
-        </p:style>
-        <p:txBody>
-          <a:bodyPr rtlCol="0" anchor="ctr"/>
-          <a:lstStyle/>
-          <a:p>
-            <a:pPr algn="ctr"/>
-          </a:p>
-        </p:txBody>
-      </p:sp>
-      <p:sp>
-        <p:nvSpPr>
-          <p:cNvPr id="9" name="TextBox 8"/>
-          <p:cNvSpPr txBox="1"/>
-          <p:nvPr/>
-        </p:nvSpPr>
-        <p:spPr>
-          <a:xfrm>
-            <a:off x="365760" y="6400800"/>
-            <a:ext cx="1828800" cy="274320"/>
-          </a:xfrm>
-          <a:prstGeom prst="rect">
-            <a:avLst/>
-          </a:prstGeom>
-          <a:noFill/>
-        </p:spPr>
-        <p:txBody>
-          <a:bodyPr wrap="square" lIns="0" rIns="0" tIns="0" bIns="0" anchor="t">
-            <a:spAutoFit/>
-          </a:bodyPr>
-          <a:lstStyle/>
-          <a:p>
-            <a:pPr algn="l">
-              <a:lnSpc>
-                <a:spcPct val="115000"/>
-              </a:lnSpc>
-            </a:pPr>
-            <a:r>
-              <a:rPr sz="1000" b="0" i="0">
-                <a:solidFill>
-                  <a:srgbClr val="556B8A"/>
-                </a:solidFill>
-                <a:latin typeface="Helvetica"/>
-              </a:rPr>
-              <a:t>13 |</a:t>
-            </a:r>
-          </a:p>
-        </p:txBody>
-      </p:sp>
-      <p:pic>
-        <p:nvPicPr>
-          <p:cNvPr id="10" name="Picture 9" descr="edc_logo.png"/>
-          <p:cNvPicPr>
-            <a:picLocks noChangeAspect="1"/>
-          </p:cNvPicPr>
-          <p:nvPr/>
-        </p:nvPicPr>
-        <p:blipFill>
-          <a:blip r:embed="rId2"/>
-          <a:stretch>
-            <a:fillRect/>
-          </a:stretch>
-        </p:blipFill>
-        <p:spPr>
-          <a:xfrm>
-            <a:off x="11475720" y="6263640"/>
-            <a:ext cx="594360" cy="594360"/>
-          </a:xfrm>
-          <a:prstGeom prst="rect">
-            <a:avLst/>
-          </a:prstGeom>
-        </p:spPr>
-      </p:pic>
-    </p:spTree>
-  </p:cSld>
-  <p:clrMapOvr>
-    <a:masterClrMapping/>
-  </p:clrMapOvr>
-</p:sld>
-</file>
-
-<file path=ppt/slides/slide14.xml><?xml version="1.0" encoding="utf-8"?>
-<p:sld xmlns:a="http://schemas.openxmlformats.org/drawingml/2006/main" xmlns:p="http://schemas.openxmlformats.org/presentationml/2006/main" xmlns:r="http://schemas.openxmlformats.org/officeDocument/2006/relationships">
-  <p:cSld>
-    <p:spTree>
-      <p:nvGrpSpPr>
-        <p:cNvPr id="1" name=""/>
-        <p:cNvGrpSpPr/>
-        <p:nvPr/>
-      </p:nvGrpSpPr>
-      <p:grpSpPr/>
-      <p:sp>
-        <p:nvSpPr>
-          <p:cNvPr id="2" name="Rectangle 1"/>
-          <p:cNvSpPr/>
-          <p:nvPr/>
-        </p:nvSpPr>
-        <p:spPr>
-          <a:xfrm>
-            <a:off x="0" y="0"/>
-            <a:ext cx="12191695" cy="6858000"/>
-          </a:xfrm>
-          <a:prstGeom prst="rect">
-            <a:avLst/>
-          </a:prstGeom>
-          <a:solidFill>
-            <a:srgbClr val="122A52"/>
-          </a:solidFill>
-          <a:ln>
-            <a:noFill/>
-          </a:ln>
-        </p:spPr>
-        <p:style>
-          <a:lnRef idx="1">
-            <a:schemeClr val="accent1"/>
-          </a:lnRef>
-          <a:fillRef idx="3">
-            <a:schemeClr val="accent1"/>
-          </a:fillRef>
-          <a:effectRef idx="2">
-            <a:schemeClr val="accent1"/>
-          </a:effectRef>
-          <a:fontRef idx="minor">
-            <a:schemeClr val="lt1"/>
-          </a:fontRef>
-        </p:style>
-        <p:txBody>
-          <a:bodyPr rtlCol="0" anchor="ctr"/>
-          <a:lstStyle/>
-          <a:p>
-            <a:pPr algn="ctr"/>
-          </a:p>
-        </p:txBody>
-      </p:sp>
-      <p:pic>
-        <p:nvPicPr>
-          <p:cNvPr id="3" name="Picture 2" descr="edc_logo.png"/>
-          <p:cNvPicPr>
-            <a:picLocks noChangeAspect="1"/>
-          </p:cNvPicPr>
-          <p:nvPr/>
-        </p:nvPicPr>
-        <p:blipFill>
-          <a:blip r:embed="rId2"/>
-          <a:stretch>
-            <a:fillRect/>
-          </a:stretch>
-        </p:blipFill>
-        <p:spPr>
-          <a:xfrm>
-            <a:off x="5364327" y="1645920"/>
-            <a:ext cx="1463040" cy="1463040"/>
-          </a:xfrm>
-          <a:prstGeom prst="rect">
-            <a:avLst/>
-          </a:prstGeom>
-        </p:spPr>
-      </p:pic>
-      <p:sp>
-        <p:nvSpPr>
-          <p:cNvPr id="4" name="TextBox 3"/>
-          <p:cNvSpPr txBox="1"/>
-          <p:nvPr/>
-        </p:nvSpPr>
-        <p:spPr>
-          <a:xfrm>
-            <a:off x="0" y="3657600"/>
-            <a:ext cx="12191695" cy="548640"/>
-          </a:xfrm>
-          <a:prstGeom prst="rect">
-            <a:avLst/>
-          </a:prstGeom>
-          <a:noFill/>
-        </p:spPr>
-        <p:txBody>
-          <a:bodyPr wrap="square" lIns="0" rIns="0" tIns="0" bIns="0" anchor="t">
-            <a:spAutoFit/>
-          </a:bodyPr>
-          <a:lstStyle/>
-          <a:p>
-            <a:pPr algn="ctr">
-              <a:lnSpc>
-                <a:spcPct val="115000"/>
-              </a:lnSpc>
-            </a:pPr>
-            <a:r>
-              <a:rPr sz="2200" b="0" i="0">
-                <a:solidFill>
-                  <a:srgbClr val="F5B81C"/>
-                </a:solidFill>
-                <a:latin typeface="Menlo"/>
-              </a:rPr>
-              <a:t>Punkt 3</a:t>
-            </a:r>
-          </a:p>
-        </p:txBody>
-      </p:sp>
-      <p:sp>
-        <p:nvSpPr>
-          <p:cNvPr id="5" name="TextBox 4"/>
-          <p:cNvSpPr txBox="1"/>
-          <p:nvPr/>
-        </p:nvSpPr>
-        <p:spPr>
-          <a:xfrm>
-            <a:off x="0" y="4297680"/>
-            <a:ext cx="12191695" cy="914400"/>
-          </a:xfrm>
-          <a:prstGeom prst="rect">
-            <a:avLst/>
-          </a:prstGeom>
-          <a:noFill/>
-        </p:spPr>
-        <p:txBody>
-          <a:bodyPr wrap="square" lIns="0" rIns="0" tIns="0" bIns="0" anchor="t">
-            <a:spAutoFit/>
-          </a:bodyPr>
-          <a:lstStyle/>
-          <a:p>
-            <a:pPr algn="ctr">
-              <a:lnSpc>
-                <a:spcPct val="115000"/>
-              </a:lnSpc>
-            </a:pPr>
-            <a:r>
-              <a:rPr sz="4400" b="1" i="0">
-                <a:solidFill>
-                  <a:srgbClr val="FFFFFF"/>
-                </a:solidFill>
-                <a:latin typeface="Helvetica"/>
-              </a:rPr>
-              <a:t>Hands-on</a:t>
-            </a:r>
-          </a:p>
-        </p:txBody>
-      </p:sp>
-      <p:sp>
-        <p:nvSpPr>
-          <p:cNvPr id="6" name="TextBox 5"/>
-          <p:cNvSpPr txBox="1"/>
-          <p:nvPr/>
-        </p:nvSpPr>
-        <p:spPr>
-          <a:xfrm>
-            <a:off x="0" y="5029200"/>
-            <a:ext cx="12191695" cy="548640"/>
-          </a:xfrm>
-          <a:prstGeom prst="rect">
-            <a:avLst/>
-          </a:prstGeom>
-          <a:noFill/>
-        </p:spPr>
-        <p:txBody>
-          <a:bodyPr wrap="square" lIns="0" rIns="0" tIns="0" bIns="0" anchor="t">
-            <a:spAutoFit/>
-          </a:bodyPr>
-          <a:lstStyle/>
-          <a:p>
-            <a:pPr algn="ctr">
-              <a:lnSpc>
-                <a:spcPct val="115000"/>
-              </a:lnSpc>
-            </a:pPr>
-            <a:r>
-              <a:rPr sz="1800" b="0" i="0">
-                <a:solidFill>
-                  <a:srgbClr val="C8D4E8"/>
-                </a:solidFill>
-                <a:latin typeface="Helvetica"/>
-              </a:rPr>
-              <a:t>20 minutter · solo på din egen maskine</a:t>
-            </a:r>
-          </a:p>
-        </p:txBody>
-      </p:sp>
-      <p:sp>
-        <p:nvSpPr>
-          <p:cNvPr id="7" name="Rectangle 6"/>
-          <p:cNvSpPr/>
-          <p:nvPr/>
-        </p:nvSpPr>
-        <p:spPr>
-          <a:xfrm>
-            <a:off x="0" y="6693408"/>
-            <a:ext cx="12191695" cy="164592"/>
-          </a:xfrm>
-          <a:prstGeom prst="rect">
-            <a:avLst/>
-          </a:prstGeom>
-          <a:solidFill>
-            <a:srgbClr val="F5B81C"/>
-          </a:solidFill>
-          <a:ln>
-            <a:noFill/>
-          </a:ln>
-        </p:spPr>
-        <p:style>
-          <a:lnRef idx="1">
-            <a:schemeClr val="accent1"/>
-          </a:lnRef>
-          <a:fillRef idx="3">
-            <a:schemeClr val="accent1"/>
-          </a:fillRef>
-          <a:effectRef idx="2">
-            <a:schemeClr val="accent1"/>
-          </a:effectRef>
-          <a:fontRef idx="minor">
-            <a:schemeClr val="lt1"/>
-          </a:fontRef>
-        </p:style>
-        <p:txBody>
-          <a:bodyPr rtlCol="0" anchor="ctr"/>
-          <a:lstStyle/>
-          <a:p>
-            <a:pPr algn="ctr"/>
-          </a:p>
-        </p:txBody>
-      </p:sp>
-    </p:spTree>
-  </p:cSld>
-  <p:clrMapOvr>
-    <a:masterClrMapping/>
-  </p:clrMapOvr>
-</p:sld>
-</file>
-
-<file path=ppt/slides/slide15.xml><?xml version="1.0" encoding="utf-8"?>
-<p:sld xmlns:a="http://schemas.openxmlformats.org/drawingml/2006/main" xmlns:p="http://schemas.openxmlformats.org/presentationml/2006/main" xmlns:r="http://schemas.openxmlformats.org/officeDocument/2006/relationships">
-  <p:cSld>
-    <p:spTree>
-      <p:nvGrpSpPr>
-        <p:cNvPr id="1" name=""/>
-        <p:cNvGrpSpPr/>
-        <p:nvPr/>
-      </p:nvGrpSpPr>
-      <p:grpSpPr/>
-      <p:sp>
-        <p:nvSpPr>
-          <p:cNvPr id="2" name="Rectangle 1"/>
-          <p:cNvSpPr/>
-          <p:nvPr/>
-        </p:nvSpPr>
-        <p:spPr>
-          <a:xfrm>
-            <a:off x="0" y="0"/>
-            <a:ext cx="12191695" cy="6858000"/>
-          </a:xfrm>
-          <a:prstGeom prst="rect">
-            <a:avLst/>
-          </a:prstGeom>
-          <a:solidFill>
-            <a:srgbClr val="FFFFFF"/>
-          </a:solidFill>
-          <a:ln>
-            <a:noFill/>
-          </a:ln>
-        </p:spPr>
-        <p:style>
-          <a:lnRef idx="1">
-            <a:schemeClr val="accent1"/>
-          </a:lnRef>
-          <a:fillRef idx="3">
-            <a:schemeClr val="accent1"/>
-          </a:fillRef>
-          <a:effectRef idx="2">
-            <a:schemeClr val="accent1"/>
-          </a:effectRef>
-          <a:fontRef idx="minor">
-            <a:schemeClr val="lt1"/>
-          </a:fontRef>
-        </p:style>
-        <p:txBody>
-          <a:bodyPr rtlCol="0" anchor="ctr"/>
-          <a:lstStyle/>
-          <a:p>
-            <a:pPr algn="ctr"/>
-          </a:p>
-        </p:txBody>
-      </p:sp>
-      <p:sp>
-        <p:nvSpPr>
-          <p:cNvPr id="3" name="TextBox 2"/>
-          <p:cNvSpPr txBox="1"/>
-          <p:nvPr/>
-        </p:nvSpPr>
-        <p:spPr>
-          <a:xfrm>
-            <a:off x="548640" y="457200"/>
-            <a:ext cx="11155680" cy="914400"/>
-          </a:xfrm>
-          <a:prstGeom prst="rect">
-            <a:avLst/>
-          </a:prstGeom>
-          <a:noFill/>
-        </p:spPr>
-        <p:txBody>
-          <a:bodyPr wrap="square" lIns="0" tIns="0" bIns="0" rIns="0">
-            <a:spAutoFit/>
-          </a:bodyPr>
-          <a:lstStyle/>
-          <a:p>
-            <a:pPr algn="l">
-              <a:lnSpc>
-                <a:spcPct val="110000"/>
-              </a:lnSpc>
-            </a:pPr>
-            <a:r>
-              <a:rPr sz="3400" b="1">
-                <a:solidFill>
-                  <a:srgbClr val="122A52"/>
-                </a:solidFill>
-                <a:latin typeface="Helvetica"/>
-              </a:rPr>
-              <a:t>Hands-on</a:t>
-            </a:r>
-            <a:r>
-              <a:rPr sz="3400" b="0">
-                <a:solidFill>
-                  <a:srgbClr val="122A52"/>
-                </a:solidFill>
-                <a:latin typeface="Helvetica"/>
-              </a:rPr>
-              <a:t> | Prøv begge prompt-typer på samme opgave</a:t>
-            </a:r>
-          </a:p>
-        </p:txBody>
-      </p:sp>
-      <p:sp>
-        <p:nvSpPr>
-          <p:cNvPr id="4" name="TextBox 3"/>
-          <p:cNvSpPr txBox="1"/>
-          <p:nvPr/>
-        </p:nvSpPr>
-        <p:spPr>
-          <a:xfrm>
-            <a:off x="640080" y="2011680"/>
-            <a:ext cx="10972800" cy="4114800"/>
-          </a:xfrm>
-          <a:prstGeom prst="rect">
-            <a:avLst/>
-          </a:prstGeom>
-          <a:noFill/>
-        </p:spPr>
-        <p:txBody>
-          <a:bodyPr wrap="square" lIns="0" rIns="0" tIns="0" bIns="0">
-            <a:spAutoFit/>
-          </a:bodyPr>
-          <a:lstStyle/>
-          <a:p>
-            <a:pPr algn="l">
-              <a:lnSpc>
-                <a:spcPct val="160000"/>
-              </a:lnSpc>
-              <a:spcAft>
-                <a:spcPts val="1000"/>
-              </a:spcAft>
-            </a:pPr>
-            <a:r>
-              <a:rPr sz="1800" b="1">
-                <a:solidFill>
-                  <a:srgbClr val="122A52"/>
-                </a:solidFill>
-                <a:latin typeface="Helvetica"/>
-              </a:rPr>
-              <a:t>■   </a:t>
-            </a:r>
-            <a:r>
-              <a:rPr sz="1800" b="1">
-                <a:solidFill>
-                  <a:srgbClr val="122A52"/>
-                </a:solidFill>
-                <a:latin typeface="Helvetica"/>
-              </a:rPr>
-              <a:t>git clone</a:t>
-            </a:r>
-            <a:r>
-              <a:rPr sz="1800" b="0">
-                <a:solidFill>
-                  <a:srgbClr val="122A52"/>
-                </a:solidFill>
-                <a:latin typeface="Helvetica"/>
-              </a:rPr>
-              <a:t> + </a:t>
-            </a:r>
-            <a:r>
-              <a:rPr sz="1800" b="1">
-                <a:solidFill>
-                  <a:srgbClr val="122A52"/>
-                </a:solidFill>
-                <a:latin typeface="Helvetica"/>
-              </a:rPr>
-              <a:t>npm install</a:t>
-            </a:r>
-            <a:r>
-              <a:rPr sz="1800" b="0">
-                <a:solidFill>
-                  <a:srgbClr val="122A52"/>
-                </a:solidFill>
-                <a:latin typeface="Helvetica"/>
-              </a:rPr>
-              <a:t> + </a:t>
-            </a:r>
-            <a:r>
-              <a:rPr sz="1800" b="1">
-                <a:solidFill>
-                  <a:srgbClr val="122A52"/>
-                </a:solidFill>
-                <a:latin typeface="Helvetica"/>
-              </a:rPr>
-              <a:t>claude</a:t>
-            </a:r>
-            <a:r>
-              <a:rPr sz="1800" b="0">
-                <a:solidFill>
-                  <a:srgbClr val="122A52"/>
-                </a:solidFill>
-                <a:latin typeface="Helvetica"/>
-              </a:rPr>
-              <a:t> i `demo/`-mappen</a:t>
-            </a:r>
-          </a:p>
-          <a:p>
-            <a:pPr algn="l">
-              <a:lnSpc>
-                <a:spcPct val="160000"/>
-              </a:lnSpc>
-              <a:spcAft>
-                <a:spcPts val="1000"/>
-              </a:spcAft>
-            </a:pPr>
-            <a:r>
-              <a:rPr sz="1800" b="1">
-                <a:solidFill>
-                  <a:srgbClr val="122A52"/>
-                </a:solidFill>
-                <a:latin typeface="Helvetica"/>
-              </a:rPr>
-              <a:t>■   </a:t>
-            </a:r>
-            <a:r>
-              <a:rPr sz="1800" b="0">
-                <a:solidFill>
-                  <a:srgbClr val="122A52"/>
-                </a:solidFill>
-                <a:latin typeface="Helvetica"/>
-              </a:rPr>
-              <a:t>Vælg én opgave fra demoen (pris-bug, performance, eller favorit-knap)</a:t>
-            </a:r>
-          </a:p>
-          <a:p>
-            <a:pPr algn="l">
-              <a:lnSpc>
-                <a:spcPct val="160000"/>
-              </a:lnSpc>
-              <a:spcAft>
-                <a:spcPts val="1000"/>
-              </a:spcAft>
-            </a:pPr>
-            <a:r>
-              <a:rPr sz="1800" b="1">
-                <a:solidFill>
-                  <a:srgbClr val="122A52"/>
-                </a:solidFill>
-                <a:latin typeface="Helvetica"/>
-              </a:rPr>
-              <a:t>■   </a:t>
-            </a:r>
-            <a:r>
-              <a:rPr sz="1800" b="0">
-                <a:solidFill>
-                  <a:srgbClr val="122A52"/>
-                </a:solidFill>
-                <a:latin typeface="Helvetica"/>
-              </a:rPr>
-              <a:t>Skriv først en </a:t>
-            </a:r>
-            <a:r>
-              <a:rPr sz="1800" b="1">
-                <a:solidFill>
-                  <a:srgbClr val="122A52"/>
-                </a:solidFill>
-                <a:latin typeface="Helvetica"/>
-              </a:rPr>
-              <a:t>hurtig prompt</a:t>
-            </a:r>
-            <a:r>
-              <a:rPr sz="1800" b="0">
-                <a:solidFill>
-                  <a:srgbClr val="122A52"/>
-                </a:solidFill>
-                <a:latin typeface="Helvetica"/>
-              </a:rPr>
-              <a:t> — som du ville skrive på en travl dag</a:t>
-            </a:r>
-          </a:p>
-          <a:p>
-            <a:pPr algn="l">
-              <a:lnSpc>
-                <a:spcPct val="160000"/>
-              </a:lnSpc>
-              <a:spcAft>
-                <a:spcPts val="1000"/>
-              </a:spcAft>
-            </a:pPr>
-            <a:r>
-              <a:rPr sz="1800" b="1">
-                <a:solidFill>
-                  <a:srgbClr val="122A52"/>
-                </a:solidFill>
-                <a:latin typeface="Helvetica"/>
-              </a:rPr>
-              <a:t>■   </a:t>
-            </a:r>
-            <a:r>
-              <a:rPr sz="1800" b="1">
-                <a:solidFill>
-                  <a:srgbClr val="122A52"/>
-                </a:solidFill>
-                <a:latin typeface="Helvetica"/>
-              </a:rPr>
-              <a:t>git checkout .</a:t>
-            </a:r>
-            <a:r>
-              <a:rPr sz="1800" b="0">
-                <a:solidFill>
-                  <a:srgbClr val="122A52"/>
-                </a:solidFill>
-                <a:latin typeface="Helvetica"/>
-              </a:rPr>
-              <a:t> og </a:t>
-            </a:r>
-            <a:r>
-              <a:rPr sz="1800" b="1">
-                <a:solidFill>
-                  <a:srgbClr val="122A52"/>
-                </a:solidFill>
-                <a:latin typeface="Helvetica"/>
-              </a:rPr>
-              <a:t>/clear</a:t>
-            </a:r>
-            <a:r>
-              <a:rPr sz="1800" b="0">
-                <a:solidFill>
-                  <a:srgbClr val="122A52"/>
-                </a:solidFill>
-                <a:latin typeface="Helvetica"/>
-              </a:rPr>
-              <a:t> for at rulle tilbage</a:t>
-            </a:r>
-          </a:p>
-          <a:p>
-            <a:pPr algn="l">
-              <a:lnSpc>
-                <a:spcPct val="160000"/>
-              </a:lnSpc>
-              <a:spcAft>
-                <a:spcPts val="1000"/>
-              </a:spcAft>
-            </a:pPr>
-            <a:r>
-              <a:rPr sz="1800" b="1">
-                <a:solidFill>
-                  <a:srgbClr val="122A52"/>
-                </a:solidFill>
-                <a:latin typeface="Helvetica"/>
-              </a:rPr>
-              <a:t>■   </a:t>
-            </a:r>
-            <a:r>
-              <a:rPr sz="1800" b="0">
-                <a:solidFill>
-                  <a:srgbClr val="122A52"/>
-                </a:solidFill>
-                <a:latin typeface="Helvetica"/>
-              </a:rPr>
-              <a:t>Skriv så en prompt med </a:t>
-            </a:r>
-            <a:r>
-              <a:rPr sz="1800" b="1">
-                <a:solidFill>
-                  <a:srgbClr val="122A52"/>
-                </a:solidFill>
-                <a:latin typeface="Helvetica"/>
-              </a:rPr>
-              <a:t>alle 4 byggeklodser</a:t>
-            </a:r>
-          </a:p>
-          <a:p>
-            <a:pPr algn="l">
-              <a:lnSpc>
-                <a:spcPct val="160000"/>
-              </a:lnSpc>
-              <a:spcAft>
-                <a:spcPts val="1000"/>
-              </a:spcAft>
-            </a:pPr>
-            <a:r>
-              <a:rPr sz="1800" b="1">
-                <a:solidFill>
-                  <a:srgbClr val="122A52"/>
-                </a:solidFill>
-                <a:latin typeface="Helvetica"/>
-              </a:rPr>
-              <a:t>■   </a:t>
-            </a:r>
-            <a:r>
-              <a:rPr sz="1800" b="0">
-                <a:solidFill>
-                  <a:srgbClr val="122A52"/>
-                </a:solidFill>
-                <a:latin typeface="Helvetica"/>
-              </a:rPr>
-              <a:t>Sammenlign: hvad var forskellen? Hvilken ville du committe?</a:t>
-            </a:r>
-          </a:p>
-        </p:txBody>
-      </p:sp>
-      <p:sp>
-        <p:nvSpPr>
-          <p:cNvPr id="5" name="Rectangle 4"/>
-          <p:cNvSpPr/>
-          <p:nvPr/>
-        </p:nvSpPr>
-        <p:spPr>
-          <a:xfrm>
-            <a:off x="0" y="0"/>
-            <a:ext cx="12191695" cy="164592"/>
-          </a:xfrm>
-          <a:prstGeom prst="rect">
-            <a:avLst/>
-          </a:prstGeom>
-          <a:solidFill>
-            <a:srgbClr val="122A52"/>
-          </a:solidFill>
-          <a:ln>
-            <a:noFill/>
-          </a:ln>
-        </p:spPr>
-        <p:style>
-          <a:lnRef idx="1">
-            <a:schemeClr val="accent1"/>
-          </a:lnRef>
-          <a:fillRef idx="3">
-            <a:schemeClr val="accent1"/>
-          </a:fillRef>
-          <a:effectRef idx="2">
-            <a:schemeClr val="accent1"/>
-          </a:effectRef>
-          <a:fontRef idx="minor">
-            <a:schemeClr val="lt1"/>
-          </a:fontRef>
-        </p:style>
-        <p:txBody>
-          <a:bodyPr rtlCol="0" anchor="ctr"/>
-          <a:lstStyle/>
-          <a:p>
-            <a:pPr algn="ctr"/>
-          </a:p>
-        </p:txBody>
-      </p:sp>
-      <p:sp>
-        <p:nvSpPr>
-          <p:cNvPr id="6" name="Rectangle 5"/>
-          <p:cNvSpPr/>
-          <p:nvPr/>
-        </p:nvSpPr>
-        <p:spPr>
-          <a:xfrm>
-            <a:off x="0" y="6693408"/>
-            <a:ext cx="12191695" cy="164592"/>
-          </a:xfrm>
-          <a:prstGeom prst="rect">
-            <a:avLst/>
-          </a:prstGeom>
-          <a:solidFill>
-            <a:srgbClr val="122A52"/>
-          </a:solidFill>
-          <a:ln>
-            <a:noFill/>
-          </a:ln>
-        </p:spPr>
-        <p:style>
-          <a:lnRef idx="1">
-            <a:schemeClr val="accent1"/>
-          </a:lnRef>
-          <a:fillRef idx="3">
-            <a:schemeClr val="accent1"/>
-          </a:fillRef>
-          <a:effectRef idx="2">
-            <a:schemeClr val="accent1"/>
-          </a:effectRef>
-          <a:fontRef idx="minor">
-            <a:schemeClr val="lt1"/>
-          </a:fontRef>
-        </p:style>
-        <p:txBody>
-          <a:bodyPr rtlCol="0" anchor="ctr"/>
-          <a:lstStyle/>
-          <a:p>
-            <a:pPr algn="ctr"/>
-          </a:p>
-        </p:txBody>
-      </p:sp>
-      <p:sp>
-        <p:nvSpPr>
-          <p:cNvPr id="7" name="TextBox 6"/>
-          <p:cNvSpPr txBox="1"/>
-          <p:nvPr/>
-        </p:nvSpPr>
-        <p:spPr>
-          <a:xfrm>
-            <a:off x="365760" y="6400800"/>
-            <a:ext cx="1828800" cy="274320"/>
-          </a:xfrm>
-          <a:prstGeom prst="rect">
-            <a:avLst/>
-          </a:prstGeom>
-          <a:noFill/>
-        </p:spPr>
-        <p:txBody>
-          <a:bodyPr wrap="square" lIns="0" rIns="0" tIns="0" bIns="0" anchor="t">
-            <a:spAutoFit/>
-          </a:bodyPr>
-          <a:lstStyle/>
-          <a:p>
-            <a:pPr algn="l">
-              <a:lnSpc>
-                <a:spcPct val="115000"/>
-              </a:lnSpc>
-            </a:pPr>
-            <a:r>
-              <a:rPr sz="1000" b="0" i="0">
-                <a:solidFill>
-                  <a:srgbClr val="556B8A"/>
-                </a:solidFill>
-                <a:latin typeface="Helvetica"/>
-              </a:rPr>
-              <a:t>15 |</a:t>
-            </a:r>
-          </a:p>
-        </p:txBody>
-      </p:sp>
-      <p:pic>
-        <p:nvPicPr>
-          <p:cNvPr id="8" name="Picture 7" descr="edc_logo.png"/>
-          <p:cNvPicPr>
-            <a:picLocks noChangeAspect="1"/>
-          </p:cNvPicPr>
-          <p:nvPr/>
-        </p:nvPicPr>
-        <p:blipFill>
-          <a:blip r:embed="rId2"/>
-          <a:stretch>
-            <a:fillRect/>
-          </a:stretch>
-        </p:blipFill>
-        <p:spPr>
-          <a:xfrm>
-            <a:off x="11475720" y="6263640"/>
-            <a:ext cx="594360" cy="594360"/>
-          </a:xfrm>
-          <a:prstGeom prst="rect">
-            <a:avLst/>
-          </a:prstGeom>
-        </p:spPr>
-      </p:pic>
-    </p:spTree>
-  </p:cSld>
-  <p:clrMapOvr>
-    <a:masterClrMapping/>
-  </p:clrMapOvr>
-</p:sld>
-</file>
-
-<file path=ppt/slides/slide16.xml><?xml version="1.0" encoding="utf-8"?>
-<p:sld xmlns:a="http://schemas.openxmlformats.org/drawingml/2006/main" xmlns:p="http://schemas.openxmlformats.org/presentationml/2006/main" xmlns:r="http://schemas.openxmlformats.org/officeDocument/2006/relationships">
-  <p:cSld>
-    <p:spTree>
-      <p:nvGrpSpPr>
-        <p:cNvPr id="1" name=""/>
-        <p:cNvGrpSpPr/>
-        <p:nvPr/>
-      </p:nvGrpSpPr>
-      <p:grpSpPr/>
-      <p:sp>
-        <p:nvSpPr>
-          <p:cNvPr id="2" name="Rectangle 1"/>
-          <p:cNvSpPr/>
-          <p:nvPr/>
-        </p:nvSpPr>
-        <p:spPr>
-          <a:xfrm>
-            <a:off x="0" y="0"/>
-            <a:ext cx="12191695" cy="6858000"/>
-          </a:xfrm>
-          <a:prstGeom prst="rect">
-            <a:avLst/>
-          </a:prstGeom>
-          <a:solidFill>
             <a:srgbClr val="122A52"/>
           </a:solidFill>
           <a:ln>
@@ -13031,39 +10876,15 @@
           </a:p>
         </p:txBody>
       </p:sp>
-      <p:pic>
-        <p:nvPicPr>
-          <p:cNvPr id="3" name="Picture 2" descr="edc_logo.png"/>
-          <p:cNvPicPr>
-            <a:picLocks noChangeAspect="1"/>
-          </p:cNvPicPr>
-          <p:nvPr/>
-        </p:nvPicPr>
-        <p:blipFill>
-          <a:blip r:embed="rId2"/>
-          <a:stretch>
-            <a:fillRect/>
-          </a:stretch>
-        </p:blipFill>
-        <p:spPr>
-          <a:xfrm>
-            <a:off x="5364327" y="1645920"/>
-            <a:ext cx="1463040" cy="1463040"/>
-          </a:xfrm>
-          <a:prstGeom prst="rect">
-            <a:avLst/>
-          </a:prstGeom>
-        </p:spPr>
-      </p:pic>
-      <p:sp>
-        <p:nvSpPr>
-          <p:cNvPr id="4" name="TextBox 3"/>
+      <p:sp>
+        <p:nvSpPr>
+          <p:cNvPr id="3" name="TextBox 2"/>
           <p:cNvSpPr txBox="1"/>
           <p:nvPr/>
         </p:nvSpPr>
         <p:spPr>
           <a:xfrm>
-            <a:off x="0" y="3657600"/>
+            <a:off x="0" y="1280160"/>
             <a:ext cx="12191695" cy="548640"/>
           </a:xfrm>
           <a:prstGeom prst="rect">
@@ -13096,14 +10917,14 @@
       </p:sp>
       <p:sp>
         <p:nvSpPr>
-          <p:cNvPr id="5" name="TextBox 4"/>
+          <p:cNvPr id="4" name="TextBox 3"/>
           <p:cNvSpPr txBox="1"/>
           <p:nvPr/>
         </p:nvSpPr>
         <p:spPr>
           <a:xfrm>
-            <a:off x="0" y="4297680"/>
-            <a:ext cx="12191695" cy="914400"/>
+            <a:off x="0" y="1920240"/>
+            <a:ext cx="12191695" cy="1097280"/>
           </a:xfrm>
           <a:prstGeom prst="rect">
             <a:avLst/>
@@ -13122,7 +10943,7 @@
               </a:lnSpc>
             </a:pPr>
             <a:r>
-              <a:rPr sz="4400" b="1" i="0">
+              <a:rPr sz="5400" b="1" i="0">
                 <a:solidFill>
                   <a:srgbClr val="FFFFFF"/>
                 </a:solidFill>
@@ -13135,13 +10956,13 @@
       </p:sp>
       <p:sp>
         <p:nvSpPr>
-          <p:cNvPr id="6" name="TextBox 5"/>
+          <p:cNvPr id="5" name="TextBox 4"/>
           <p:cNvSpPr txBox="1"/>
           <p:nvPr/>
         </p:nvSpPr>
         <p:spPr>
           <a:xfrm>
-            <a:off x="0" y="5029200"/>
+            <a:off x="0" y="2926080"/>
             <a:ext cx="12191695" cy="548640"/>
           </a:xfrm>
           <a:prstGeom prst="rect">
@@ -13161,7 +10982,7 @@
               </a:lnSpc>
             </a:pPr>
             <a:r>
-              <a:rPr sz="1800" b="0" i="0">
+              <a:rPr sz="2000" b="0" i="0">
                 <a:solidFill>
                   <a:srgbClr val="C8D4E8"/>
                 </a:solidFill>
@@ -13174,7 +10995,169 @@
       </p:sp>
       <p:sp>
         <p:nvSpPr>
-          <p:cNvPr id="7" name="Rectangle 6"/>
+          <p:cNvPr id="6" name="Rounded Rectangle 5"/>
+          <p:cNvSpPr/>
+          <p:nvPr/>
+        </p:nvSpPr>
+        <p:spPr>
+          <a:xfrm>
+            <a:off x="2895447" y="4206240"/>
+            <a:ext cx="6400800" cy="1280160"/>
+          </a:xfrm>
+          <a:prstGeom prst="roundRect">
+            <a:avLst>
+              <a:gd name="adj" fmla="val 15000"/>
+            </a:avLst>
+          </a:prstGeom>
+          <a:solidFill>
+            <a:srgbClr val="F5B81C"/>
+          </a:solidFill>
+          <a:ln>
+            <a:noFill/>
+          </a:ln>
+        </p:spPr>
+        <p:style>
+          <a:lnRef idx="1">
+            <a:schemeClr val="accent1"/>
+          </a:lnRef>
+          <a:fillRef idx="3">
+            <a:schemeClr val="accent1"/>
+          </a:fillRef>
+          <a:effectRef idx="2">
+            <a:schemeClr val="accent1"/>
+          </a:effectRef>
+          <a:fontRef idx="minor">
+            <a:schemeClr val="lt1"/>
+          </a:fontRef>
+        </p:style>
+        <p:txBody>
+          <a:bodyPr rtlCol="0" anchor="ctr"/>
+          <a:lstStyle/>
+          <a:p>
+            <a:pPr algn="ctr"/>
+          </a:p>
+        </p:txBody>
+      </p:sp>
+      <p:sp>
+        <p:nvSpPr>
+          <p:cNvPr id="7" name="TextBox 6"/>
+          <p:cNvSpPr txBox="1"/>
+          <p:nvPr/>
+        </p:nvSpPr>
+        <p:spPr>
+          <a:xfrm>
+            <a:off x="2895447" y="4297680"/>
+            <a:ext cx="6400800" cy="457200"/>
+          </a:xfrm>
+          <a:prstGeom prst="rect">
+            <a:avLst/>
+          </a:prstGeom>
+          <a:noFill/>
+        </p:spPr>
+        <p:txBody>
+          <a:bodyPr wrap="square" lIns="0" rIns="0" tIns="0" bIns="0" anchor="t">
+            <a:spAutoFit/>
+          </a:bodyPr>
+          <a:lstStyle/>
+          <a:p>
+            <a:pPr algn="ctr">
+              <a:lnSpc>
+                <a:spcPct val="115000"/>
+              </a:lnSpc>
+            </a:pPr>
+            <a:r>
+              <a:rPr sz="1400" b="1" i="0">
+                <a:solidFill>
+                  <a:srgbClr val="122A52"/>
+                </a:solidFill>
+                <a:latin typeface="Menlo"/>
+              </a:rPr>
+              <a:t>KOPIER PROMPTS FRA</a:t>
+            </a:r>
+          </a:p>
+        </p:txBody>
+      </p:sp>
+      <p:sp>
+        <p:nvSpPr>
+          <p:cNvPr id="8" name="TextBox 7"/>
+          <p:cNvSpPr txBox="1"/>
+          <p:nvPr/>
+        </p:nvSpPr>
+        <p:spPr>
+          <a:xfrm>
+            <a:off x="2895447" y="4709160"/>
+            <a:ext cx="6400800" cy="731520"/>
+          </a:xfrm>
+          <a:prstGeom prst="rect">
+            <a:avLst/>
+          </a:prstGeom>
+          <a:noFill/>
+        </p:spPr>
+        <p:txBody>
+          <a:bodyPr wrap="square" lIns="0" rIns="0" tIns="0" bIns="0" anchor="t">
+            <a:spAutoFit/>
+          </a:bodyPr>
+          <a:lstStyle/>
+          <a:p>
+            <a:pPr algn="ctr">
+              <a:lnSpc>
+                <a:spcPct val="115000"/>
+              </a:lnSpc>
+            </a:pPr>
+            <a:r>
+              <a:rPr sz="4400" b="1" i="0">
+                <a:solidFill>
+                  <a:srgbClr val="122A52"/>
+                </a:solidFill>
+                <a:latin typeface="Menlo"/>
+              </a:rPr>
+              <a:t>/prompts</a:t>
+            </a:r>
+          </a:p>
+        </p:txBody>
+      </p:sp>
+      <p:sp>
+        <p:nvSpPr>
+          <p:cNvPr id="9" name="TextBox 8"/>
+          <p:cNvSpPr txBox="1"/>
+          <p:nvPr/>
+        </p:nvSpPr>
+        <p:spPr>
+          <a:xfrm>
+            <a:off x="0" y="5852160"/>
+            <a:ext cx="12191695" cy="457200"/>
+          </a:xfrm>
+          <a:prstGeom prst="rect">
+            <a:avLst/>
+          </a:prstGeom>
+          <a:noFill/>
+        </p:spPr>
+        <p:txBody>
+          <a:bodyPr wrap="square" lIns="0" rIns="0" tIns="0" bIns="0" anchor="t">
+            <a:spAutoFit/>
+          </a:bodyPr>
+          <a:lstStyle/>
+          <a:p>
+            <a:pPr algn="ctr">
+              <a:lnSpc>
+                <a:spcPct val="115000"/>
+              </a:lnSpc>
+            </a:pPr>
+            <a:r>
+              <a:rPr sz="1500" b="0" i="1">
+                <a:solidFill>
+                  <a:srgbClr val="C8D4E8"/>
+                </a:solidFill>
+                <a:latin typeface="Helvetica"/>
+              </a:rPr>
+              <a:t>Skærmen er min — kig med på terminal og /demo</a:t>
+            </a:r>
+          </a:p>
+        </p:txBody>
+      </p:sp>
+      <p:sp>
+        <p:nvSpPr>
+          <p:cNvPr id="10" name="Rectangle 9"/>
           <p:cNvSpPr/>
           <p:nvPr/>
         </p:nvSpPr>
@@ -13310,7 +11293,7 @@
                 </a:solidFill>
                 <a:latin typeface="Helvetica"/>
               </a:rPr>
-              <a:t>Bug'en på /demo</a:t>
+              <a:t>Pointen</a:t>
             </a:r>
             <a:r>
               <a:rPr sz="3400" b="0">
@@ -13319,7 +11302,7 @@
                 </a:solidFill>
                 <a:latin typeface="Helvetica"/>
               </a:rPr>
-              <a:t> | Priser i USD med cents på en dansk side</a:t>
+              <a:t> | Begge fixes virker visuelt — kun den ene efterlader sund kode</a:t>
             </a:r>
           </a:p>
         </p:txBody>
@@ -13332,8 +11315,8 @@
         </p:nvSpPr>
         <p:spPr>
           <a:xfrm>
-            <a:off x="640080" y="2103120"/>
-            <a:ext cx="5349240" cy="3383280"/>
+            <a:off x="640080" y="2011680"/>
+            <a:ext cx="5349240" cy="3657600"/>
           </a:xfrm>
           <a:prstGeom prst="rect">
             <a:avLst/>
@@ -13375,7 +11358,7 @@
         </p:nvSpPr>
         <p:spPr>
           <a:xfrm>
-            <a:off x="1005840" y="2377440"/>
+            <a:off x="1005840" y="2286000"/>
             <a:ext cx="4617720" cy="365760"/>
           </a:xfrm>
           <a:prstGeom prst="rect">
@@ -13401,7 +11384,7 @@
                 </a:solidFill>
                 <a:latin typeface="Helvetica"/>
               </a:rPr>
-              <a:t>NU (BUG)</a:t>
+              <a:t>DÅRLIG PROMPT</a:t>
             </a:r>
           </a:p>
         </p:txBody>
@@ -13414,8 +11397,8 @@
         </p:nvSpPr>
         <p:spPr>
           <a:xfrm>
-            <a:off x="1005840" y="2971800"/>
-            <a:ext cx="4617720" cy="2286000"/>
+            <a:off x="1005840" y="2788920"/>
+            <a:ext cx="4617720" cy="822960"/>
           </a:xfrm>
           <a:prstGeom prst="rect">
             <a:avLst/>
@@ -13430,33 +11413,138 @@
           <a:p>
             <a:pPr algn="l">
               <a:lnSpc>
-                <a:spcPct val="130000"/>
+                <a:spcPct val="115000"/>
               </a:lnSpc>
             </a:pPr>
             <a:r>
-              <a:rPr sz="3000" b="1" i="0">
+              <a:rPr sz="2200" b="1" i="0">
+                <a:solidFill>
+                  <a:srgbClr val="122A52"/>
+                </a:solidFill>
+                <a:latin typeface="Helvetica"/>
+              </a:rPr>
+              <a:t>3 inline-kopier af samme logik</a:t>
+            </a:r>
+          </a:p>
+        </p:txBody>
+      </p:sp>
+      <p:sp>
+        <p:nvSpPr>
+          <p:cNvPr id="7" name="TextBox 6"/>
+          <p:cNvSpPr txBox="1"/>
+          <p:nvPr/>
+        </p:nvSpPr>
+        <p:spPr>
+          <a:xfrm>
+            <a:off x="1005840" y="3840480"/>
+            <a:ext cx="4617720" cy="1828800"/>
+          </a:xfrm>
+          <a:prstGeom prst="rect">
+            <a:avLst/>
+          </a:prstGeom>
+          <a:noFill/>
+        </p:spPr>
+        <p:txBody>
+          <a:bodyPr wrap="square" lIns="0" rIns="0" tIns="0" bIns="0">
+            <a:spAutoFit/>
+          </a:bodyPr>
+          <a:lstStyle/>
+          <a:p>
+            <a:pPr algn="l">
+              <a:lnSpc>
+                <a:spcPct val="150000"/>
+              </a:lnSpc>
+              <a:spcAft>
+                <a:spcPts val="1000"/>
+              </a:spcAft>
+            </a:pPr>
+            <a:r>
+              <a:rPr sz="1500" b="1">
                 <a:solidFill>
                   <a:srgbClr val="8B1F1F"/>
                 </a:solidFill>
-                <a:latin typeface="Menlo"/>
-              </a:rPr>
-              <a:t>$8,500,000.00
-$4,250,000.00
-$6,900,000.00</a:t>
-            </a:r>
-          </a:p>
-        </p:txBody>
-      </p:sp>
-      <p:sp>
-        <p:nvSpPr>
-          <p:cNvPr id="7" name="Rectangle 6"/>
+                <a:latin typeface="Helvetica"/>
+              </a:rPr>
+              <a:t>■   </a:t>
+            </a:r>
+            <a:r>
+              <a:rPr sz="1500" b="0">
+                <a:solidFill>
+                  <a:srgbClr val="122A52"/>
+                </a:solidFill>
+                <a:latin typeface="Helvetica"/>
+              </a:rPr>
+              <a:t>DRY brudt — ændring kræver 3 filer</a:t>
+            </a:r>
+          </a:p>
+          <a:p>
+            <a:pPr algn="l">
+              <a:lnSpc>
+                <a:spcPct val="150000"/>
+              </a:lnSpc>
+              <a:spcAft>
+                <a:spcPts val="1000"/>
+              </a:spcAft>
+            </a:pPr>
+            <a:r>
+              <a:rPr sz="1500" b="1">
+                <a:solidFill>
+                  <a:srgbClr val="8B1F1F"/>
+                </a:solidFill>
+                <a:latin typeface="Helvetica"/>
+              </a:rPr>
+              <a:t>■   </a:t>
+            </a:r>
+            <a:r>
+              <a:rPr sz="1500" b="0">
+                <a:solidFill>
+                  <a:srgbClr val="122A52"/>
+                </a:solidFill>
+                <a:latin typeface="Helvetica"/>
+              </a:rPr>
+              <a:t>Forskelligt resultat hver kørsel</a:t>
+            </a:r>
+          </a:p>
+          <a:p>
+            <a:pPr algn="l">
+              <a:lnSpc>
+                <a:spcPct val="150000"/>
+              </a:lnSpc>
+              <a:spcAft>
+                <a:spcPts val="1000"/>
+              </a:spcAft>
+            </a:pPr>
+            <a:r>
+              <a:rPr sz="1500" b="1">
+                <a:solidFill>
+                  <a:srgbClr val="8B1F1F"/>
+                </a:solidFill>
+                <a:latin typeface="Helvetica"/>
+              </a:rPr>
+              <a:t>■   </a:t>
+            </a:r>
+            <a:r>
+              <a:rPr sz="1500" b="0">
+                <a:solidFill>
+                  <a:srgbClr val="122A52"/>
+                </a:solidFill>
+                <a:latin typeface="Helvetica"/>
+              </a:rPr>
+              <a:t>Nogle gange ufuldstændig fix</a:t>
+            </a:r>
+          </a:p>
+        </p:txBody>
+      </p:sp>
+      <p:sp>
+        <p:nvSpPr>
+          <p:cNvPr id="8" name="Rectangle 7"/>
           <p:cNvSpPr/>
           <p:nvPr/>
         </p:nvSpPr>
         <p:spPr>
           <a:xfrm>
-            <a:off x="6263640" y="2103120"/>
-            <a:ext cx="5349240" cy="3383280"/>
+            <a:off x="6263640" y="2011680"/>
+            <a:ext cx="5349240" cy="3657600"/>
           </a:xfrm>
           <a:prstGeom prst="rect">
             <a:avLst/>
@@ -13492,13 +11580,13 @@
       </p:sp>
       <p:sp>
         <p:nvSpPr>
-          <p:cNvPr id="8" name="TextBox 7"/>
+          <p:cNvPr id="9" name="TextBox 8"/>
           <p:cNvSpPr txBox="1"/>
           <p:nvPr/>
         </p:nvSpPr>
         <p:spPr>
           <a:xfrm>
-            <a:off x="6629400" y="2377440"/>
+            <a:off x="6629400" y="2286000"/>
             <a:ext cx="4617720" cy="365760"/>
           </a:xfrm>
           <a:prstGeom prst="rect">
@@ -13524,21 +11612,21 @@
                 </a:solidFill>
                 <a:latin typeface="Helvetica"/>
               </a:rPr>
-              <a:t>ØNSKET</a:t>
-            </a:r>
-          </a:p>
-        </p:txBody>
-      </p:sp>
-      <p:sp>
-        <p:nvSpPr>
-          <p:cNvPr id="9" name="TextBox 8"/>
+              <a:t>GOD PROMPT</a:t>
+            </a:r>
+          </a:p>
+        </p:txBody>
+      </p:sp>
+      <p:sp>
+        <p:nvSpPr>
+          <p:cNvPr id="10" name="TextBox 9"/>
           <p:cNvSpPr txBox="1"/>
           <p:nvPr/>
         </p:nvSpPr>
         <p:spPr>
           <a:xfrm>
-            <a:off x="6629400" y="2971800"/>
-            <a:ext cx="4617720" cy="2286000"/>
+            <a:off x="6629400" y="2788920"/>
+            <a:ext cx="4617720" cy="822960"/>
           </a:xfrm>
           <a:prstGeom prst="rect">
             <a:avLst/>
@@ -13552,66 +11640,132 @@
           <a:lstStyle/>
           <a:p>
             <a:pPr algn="l">
-              <a:lnSpc>
-                <a:spcPct val="130000"/>
-              </a:lnSpc>
-            </a:pPr>
-            <a:r>
-              <a:rPr sz="3000" b="1" i="0">
-                <a:solidFill>
-                  <a:srgbClr val="14532D"/>
-                </a:solidFill>
-                <a:latin typeface="Menlo"/>
-              </a:rPr>
-              <a:t>8.500.000 kr.
-4.250.000 kr.
-6.900.000 kr.</a:t>
-            </a:r>
-          </a:p>
-        </p:txBody>
-      </p:sp>
-      <p:sp>
-        <p:nvSpPr>
-          <p:cNvPr id="10" name="TextBox 9"/>
-          <p:cNvSpPr txBox="1"/>
-          <p:nvPr/>
-        </p:nvSpPr>
-        <p:spPr>
-          <a:xfrm>
-            <a:off x="640080" y="5715000"/>
-            <a:ext cx="10972800" cy="457200"/>
-          </a:xfrm>
-          <a:prstGeom prst="rect">
-            <a:avLst/>
-          </a:prstGeom>
-          <a:noFill/>
-        </p:spPr>
-        <p:txBody>
-          <a:bodyPr wrap="square" lIns="0" rIns="0" tIns="0" bIns="0" anchor="t">
-            <a:spAutoFit/>
-          </a:bodyPr>
-          <a:lstStyle/>
-          <a:p>
-            <a:pPr algn="ctr">
               <a:lnSpc>
                 <a:spcPct val="115000"/>
               </a:lnSpc>
             </a:pPr>
             <a:r>
-              <a:rPr sz="1400" b="0" i="1">
-                <a:solidFill>
-                  <a:srgbClr val="556B8A"/>
-                </a:solidFill>
-                <a:latin typeface="Helvetica"/>
-              </a:rPr>
-              <a:t>Pris-formateringen ligger inline 3 steder uden helper — typisk consequence af "hurtigt fix".</a:t>
-            </a:r>
-          </a:p>
-        </p:txBody>
-      </p:sp>
-      <p:sp>
-        <p:nvSpPr>
-          <p:cNvPr id="11" name="Rectangle 10"/>
+              <a:rPr sz="2200" b="1" i="0">
+                <a:solidFill>
+                  <a:srgbClr val="122A52"/>
+                </a:solidFill>
+                <a:latin typeface="Helvetica"/>
+              </a:rPr>
+              <a:t>1 helper, brugt 3 steder</a:t>
+            </a:r>
+          </a:p>
+        </p:txBody>
+      </p:sp>
+      <p:sp>
+        <p:nvSpPr>
+          <p:cNvPr id="11" name="TextBox 10"/>
+          <p:cNvSpPr txBox="1"/>
+          <p:nvPr/>
+        </p:nvSpPr>
+        <p:spPr>
+          <a:xfrm>
+            <a:off x="6629400" y="3840480"/>
+            <a:ext cx="4617720" cy="1828800"/>
+          </a:xfrm>
+          <a:prstGeom prst="rect">
+            <a:avLst/>
+          </a:prstGeom>
+          <a:noFill/>
+        </p:spPr>
+        <p:txBody>
+          <a:bodyPr wrap="square" lIns="0" rIns="0" tIns="0" bIns="0">
+            <a:spAutoFit/>
+          </a:bodyPr>
+          <a:lstStyle/>
+          <a:p>
+            <a:pPr algn="l">
+              <a:lnSpc>
+                <a:spcPct val="150000"/>
+              </a:lnSpc>
+              <a:spcAft>
+                <a:spcPts val="1000"/>
+              </a:spcAft>
+            </a:pPr>
+            <a:r>
+              <a:rPr sz="1500" b="1">
+                <a:solidFill>
+                  <a:srgbClr val="14532D"/>
+                </a:solidFill>
+                <a:latin typeface="Helvetica"/>
+              </a:rPr>
+              <a:t>■   </a:t>
+            </a:r>
+            <a:r>
+              <a:rPr sz="1500" b="0">
+                <a:solidFill>
+                  <a:srgbClr val="122A52"/>
+                </a:solidFill>
+                <a:latin typeface="Helvetica"/>
+              </a:rPr>
+              <a:t>Ét sted at ændre fremover</a:t>
+            </a:r>
+          </a:p>
+          <a:p>
+            <a:pPr algn="l">
+              <a:lnSpc>
+                <a:spcPct val="150000"/>
+              </a:lnSpc>
+              <a:spcAft>
+                <a:spcPts val="1000"/>
+              </a:spcAft>
+            </a:pPr>
+            <a:r>
+              <a:rPr sz="1500" b="1">
+                <a:solidFill>
+                  <a:srgbClr val="14532D"/>
+                </a:solidFill>
+                <a:latin typeface="Helvetica"/>
+              </a:rPr>
+              <a:t>■   </a:t>
+            </a:r>
+            <a:r>
+              <a:rPr sz="1500" b="0">
+                <a:solidFill>
+                  <a:srgbClr val="122A52"/>
+                </a:solidFill>
+                <a:latin typeface="Helvetica"/>
+              </a:rPr>
+              <a:t>Deterministisk — samme resultat hver gang</a:t>
+            </a:r>
+          </a:p>
+          <a:p>
+            <a:pPr algn="l">
+              <a:lnSpc>
+                <a:spcPct val="150000"/>
+              </a:lnSpc>
+              <a:spcAft>
+                <a:spcPts val="1000"/>
+              </a:spcAft>
+            </a:pPr>
+            <a:r>
+              <a:rPr sz="1500" b="1">
+                <a:solidFill>
+                  <a:srgbClr val="14532D"/>
+                </a:solidFill>
+                <a:latin typeface="Helvetica"/>
+              </a:rPr>
+              <a:t>■   </a:t>
+            </a:r>
+            <a:r>
+              <a:rPr sz="1500" b="0">
+                <a:solidFill>
+                  <a:srgbClr val="122A52"/>
+                </a:solidFill>
+                <a:latin typeface="Helvetica"/>
+              </a:rPr>
+              <a:t>Helperen kan genbruges</a:t>
+            </a:r>
+          </a:p>
+        </p:txBody>
+      </p:sp>
+      <p:sp>
+        <p:nvSpPr>
+          <p:cNvPr id="12" name="Rectangle 11"/>
           <p:cNvSpPr/>
           <p:nvPr/>
         </p:nvSpPr>
@@ -13654,7 +11808,7 @@
       </p:sp>
       <p:sp>
         <p:nvSpPr>
-          <p:cNvPr id="12" name="Rectangle 11"/>
+          <p:cNvPr id="13" name="Rectangle 12"/>
           <p:cNvSpPr/>
           <p:nvPr/>
         </p:nvSpPr>
@@ -13697,7 +11851,7 @@
       </p:sp>
       <p:sp>
         <p:nvSpPr>
-          <p:cNvPr id="13" name="TextBox 12"/>
+          <p:cNvPr id="14" name="TextBox 13"/>
           <p:cNvSpPr txBox="1"/>
           <p:nvPr/>
         </p:nvSpPr>
@@ -13736,7 +11890,7 @@
       </p:sp>
       <p:pic>
         <p:nvPicPr>
-          <p:cNvPr id="14" name="Picture 13" descr="edc_logo.png"/>
+          <p:cNvPr id="15" name="Picture 14" descr="edc_logo.png"/>
           <p:cNvPicPr>
             <a:picLocks noChangeAspect="1"/>
           </p:cNvPicPr>

</xml_diff>

<commit_message>
Slide 8: fjern /prompts-pille og skærm-deling note
Matias ved hvad han skal gøre under demoen — slidet behøver ikke
gentage det. Tilbage er en clean section-divider med Punkt 2 +
"Live demo" + undertitel, matchende EDC-stilen.

Speaker-noten har stadig hele demo-flowet hvis det skulle være.

Co-Authored-By: Claude Opus 4.7 (1M context) <noreply@anthropic.com>
</commit_message>
<xml_diff>
--- a/slides/session1.pptx
+++ b/slides/session1.pptx
@@ -10884,7 +10884,7 @@
         </p:nvSpPr>
         <p:spPr>
           <a:xfrm>
-            <a:off x="0" y="1280160"/>
+            <a:off x="0" y="2651760"/>
             <a:ext cx="12191695" cy="548640"/>
           </a:xfrm>
           <a:prstGeom prst="rect">
@@ -10923,7 +10923,7 @@
         </p:nvSpPr>
         <p:spPr>
           <a:xfrm>
-            <a:off x="0" y="1920240"/>
+            <a:off x="0" y="3291840"/>
             <a:ext cx="12191695" cy="1097280"/>
           </a:xfrm>
           <a:prstGeom prst="rect">
@@ -10962,7 +10962,7 @@
         </p:nvSpPr>
         <p:spPr>
           <a:xfrm>
-            <a:off x="0" y="2926080"/>
+            <a:off x="0" y="4297680"/>
             <a:ext cx="12191695" cy="548640"/>
           </a:xfrm>
           <a:prstGeom prst="rect">
@@ -10995,169 +10995,7 @@
       </p:sp>
       <p:sp>
         <p:nvSpPr>
-          <p:cNvPr id="6" name="Rounded Rectangle 5"/>
-          <p:cNvSpPr/>
-          <p:nvPr/>
-        </p:nvSpPr>
-        <p:spPr>
-          <a:xfrm>
-            <a:off x="2895447" y="4206240"/>
-            <a:ext cx="6400800" cy="1280160"/>
-          </a:xfrm>
-          <a:prstGeom prst="roundRect">
-            <a:avLst>
-              <a:gd name="adj" fmla="val 15000"/>
-            </a:avLst>
-          </a:prstGeom>
-          <a:solidFill>
-            <a:srgbClr val="F5B81C"/>
-          </a:solidFill>
-          <a:ln>
-            <a:noFill/>
-          </a:ln>
-        </p:spPr>
-        <p:style>
-          <a:lnRef idx="1">
-            <a:schemeClr val="accent1"/>
-          </a:lnRef>
-          <a:fillRef idx="3">
-            <a:schemeClr val="accent1"/>
-          </a:fillRef>
-          <a:effectRef idx="2">
-            <a:schemeClr val="accent1"/>
-          </a:effectRef>
-          <a:fontRef idx="minor">
-            <a:schemeClr val="lt1"/>
-          </a:fontRef>
-        </p:style>
-        <p:txBody>
-          <a:bodyPr rtlCol="0" anchor="ctr"/>
-          <a:lstStyle/>
-          <a:p>
-            <a:pPr algn="ctr"/>
-          </a:p>
-        </p:txBody>
-      </p:sp>
-      <p:sp>
-        <p:nvSpPr>
-          <p:cNvPr id="7" name="TextBox 6"/>
-          <p:cNvSpPr txBox="1"/>
-          <p:nvPr/>
-        </p:nvSpPr>
-        <p:spPr>
-          <a:xfrm>
-            <a:off x="2895447" y="4297680"/>
-            <a:ext cx="6400800" cy="457200"/>
-          </a:xfrm>
-          <a:prstGeom prst="rect">
-            <a:avLst/>
-          </a:prstGeom>
-          <a:noFill/>
-        </p:spPr>
-        <p:txBody>
-          <a:bodyPr wrap="square" lIns="0" rIns="0" tIns="0" bIns="0" anchor="t">
-            <a:spAutoFit/>
-          </a:bodyPr>
-          <a:lstStyle/>
-          <a:p>
-            <a:pPr algn="ctr">
-              <a:lnSpc>
-                <a:spcPct val="115000"/>
-              </a:lnSpc>
-            </a:pPr>
-            <a:r>
-              <a:rPr sz="1400" b="1" i="0">
-                <a:solidFill>
-                  <a:srgbClr val="122A52"/>
-                </a:solidFill>
-                <a:latin typeface="Menlo"/>
-              </a:rPr>
-              <a:t>KOPIER PROMPTS FRA</a:t>
-            </a:r>
-          </a:p>
-        </p:txBody>
-      </p:sp>
-      <p:sp>
-        <p:nvSpPr>
-          <p:cNvPr id="8" name="TextBox 7"/>
-          <p:cNvSpPr txBox="1"/>
-          <p:nvPr/>
-        </p:nvSpPr>
-        <p:spPr>
-          <a:xfrm>
-            <a:off x="2895447" y="4709160"/>
-            <a:ext cx="6400800" cy="731520"/>
-          </a:xfrm>
-          <a:prstGeom prst="rect">
-            <a:avLst/>
-          </a:prstGeom>
-          <a:noFill/>
-        </p:spPr>
-        <p:txBody>
-          <a:bodyPr wrap="square" lIns="0" rIns="0" tIns="0" bIns="0" anchor="t">
-            <a:spAutoFit/>
-          </a:bodyPr>
-          <a:lstStyle/>
-          <a:p>
-            <a:pPr algn="ctr">
-              <a:lnSpc>
-                <a:spcPct val="115000"/>
-              </a:lnSpc>
-            </a:pPr>
-            <a:r>
-              <a:rPr sz="4400" b="1" i="0">
-                <a:solidFill>
-                  <a:srgbClr val="122A52"/>
-                </a:solidFill>
-                <a:latin typeface="Menlo"/>
-              </a:rPr>
-              <a:t>/prompts</a:t>
-            </a:r>
-          </a:p>
-        </p:txBody>
-      </p:sp>
-      <p:sp>
-        <p:nvSpPr>
-          <p:cNvPr id="9" name="TextBox 8"/>
-          <p:cNvSpPr txBox="1"/>
-          <p:nvPr/>
-        </p:nvSpPr>
-        <p:spPr>
-          <a:xfrm>
-            <a:off x="0" y="5852160"/>
-            <a:ext cx="12191695" cy="457200"/>
-          </a:xfrm>
-          <a:prstGeom prst="rect">
-            <a:avLst/>
-          </a:prstGeom>
-          <a:noFill/>
-        </p:spPr>
-        <p:txBody>
-          <a:bodyPr wrap="square" lIns="0" rIns="0" tIns="0" bIns="0" anchor="t">
-            <a:spAutoFit/>
-          </a:bodyPr>
-          <a:lstStyle/>
-          <a:p>
-            <a:pPr algn="ctr">
-              <a:lnSpc>
-                <a:spcPct val="115000"/>
-              </a:lnSpc>
-            </a:pPr>
-            <a:r>
-              <a:rPr sz="1500" b="0" i="1">
-                <a:solidFill>
-                  <a:srgbClr val="C8D4E8"/>
-                </a:solidFill>
-                <a:latin typeface="Helvetica"/>
-              </a:rPr>
-              <a:t>Skærmen er min — kig med på terminal og /demo</a:t>
-            </a:r>
-          </a:p>
-        </p:txBody>
-      </p:sp>
-      <p:sp>
-        <p:nvSpPr>
-          <p:cNvPr id="10" name="Rectangle 9"/>
+          <p:cNvPr id="6" name="Rectangle 5"/>
           <p:cNvSpPr/>
           <p:nvPr/>
         </p:nvSpPr>

</xml_diff>

<commit_message>
Slide 10 + 12: fjern overflødige meta-bullets
- Slide 10 (Vigtigt forbehold): fjernet "Vi træner mønsteret HER"
  bullet — pointen siger sig selv via de andre 3, og du italesætter
  det fra speaker-noten
- Slide 12 (Hands-on): fjernet "Sammenlign: hvad var forskellen?
  Hvilken ville du committe?" bullet — du italesætter spørgsmålet
  i samlingen, behøver ikke stå på skærmen

Resterende bullets er nu lidt større og mere luftige.

Co-Authored-By: Claude Opus 4.7 (1M context) <noreply@anthropic.com>
</commit_message>
<xml_diff>
--- a/slides/session1.pptx
+++ b/slides/session1.pptx
@@ -5281,14 +5281,14 @@
           <a:p>
             <a:pPr algn="l">
               <a:lnSpc>
-                <a:spcPct val="160000"/>
+                <a:spcPct val="170000"/>
               </a:lnSpc>
               <a:spcAft>
                 <a:spcPts val="1000"/>
               </a:spcAft>
             </a:pPr>
             <a:r>
-              <a:rPr sz="1500" b="1">
+              <a:rPr sz="1600" b="1">
                 <a:solidFill>
                   <a:srgbClr val="122A52"/>
                 </a:solidFill>
@@ -5297,7 +5297,7 @@
               <a:t>■   </a:t>
             </a:r>
             <a:r>
-              <a:rPr sz="1500" b="1">
+              <a:rPr sz="1600" b="1">
                 <a:solidFill>
                   <a:srgbClr val="122A52"/>
                 </a:solidFill>
@@ -5306,7 +5306,7 @@
               <a:t>Her:</a:t>
             </a:r>
             <a:r>
-              <a:rPr sz="1500" b="0">
+              <a:rPr sz="1600" b="0">
                 <a:solidFill>
                   <a:srgbClr val="122A52"/>
                 </a:solidFill>
@@ -5318,14 +5318,14 @@
           <a:p>
             <a:pPr algn="l">
               <a:lnSpc>
-                <a:spcPct val="160000"/>
+                <a:spcPct val="170000"/>
               </a:lnSpc>
               <a:spcAft>
                 <a:spcPts val="1000"/>
               </a:spcAft>
             </a:pPr>
             <a:r>
-              <a:rPr sz="1500" b="1">
+              <a:rPr sz="1600" b="1">
                 <a:solidFill>
                   <a:srgbClr val="122A52"/>
                 </a:solidFill>
@@ -5334,7 +5334,7 @@
               <a:t>■   </a:t>
             </a:r>
             <a:r>
-              <a:rPr sz="1500" b="1">
+              <a:rPr sz="1600" b="1">
                 <a:solidFill>
                   <a:srgbClr val="122A52"/>
                 </a:solidFill>
@@ -5343,7 +5343,7 @@
               <a:t>På jeres codebases:</a:t>
             </a:r>
             <a:r>
-              <a:rPr sz="1500" b="0">
+              <a:rPr sz="1600" b="0">
                 <a:solidFill>
                   <a:srgbClr val="122A52"/>
                 </a:solidFill>
@@ -5355,14 +5355,14 @@
           <a:p>
             <a:pPr algn="l">
               <a:lnSpc>
-                <a:spcPct val="160000"/>
+                <a:spcPct val="170000"/>
               </a:lnSpc>
               <a:spcAft>
                 <a:spcPts val="1000"/>
               </a:spcAft>
             </a:pPr>
             <a:r>
-              <a:rPr sz="1500" b="1">
+              <a:rPr sz="1600" b="1">
                 <a:solidFill>
                   <a:srgbClr val="122A52"/>
                 </a:solidFill>
@@ -5371,7 +5371,7 @@
               <a:t>■   </a:t>
             </a:r>
             <a:r>
-              <a:rPr sz="1500" b="1">
+              <a:rPr sz="1600" b="1">
                 <a:solidFill>
                   <a:srgbClr val="122A52"/>
                 </a:solidFill>
@@ -5380,50 +5380,13 @@
               <a:t>Konsekvens af vag prompt:</a:t>
             </a:r>
             <a:r>
-              <a:rPr sz="1500" b="0">
+              <a:rPr sz="1600" b="0">
                 <a:solidFill>
                   <a:srgbClr val="122A52"/>
                 </a:solidFill>
                 <a:latin typeface="Helvetica"/>
               </a:rPr>
               <a:t> forkert fil · glemt halvdel af kæden · konfliktende abstraktion · brudt konvention</a:t>
-            </a:r>
-          </a:p>
-          <a:p>
-            <a:pPr algn="l">
-              <a:lnSpc>
-                <a:spcPct val="160000"/>
-              </a:lnSpc>
-              <a:spcAft>
-                <a:spcPts val="1000"/>
-              </a:spcAft>
-            </a:pPr>
-            <a:r>
-              <a:rPr sz="1500" b="1">
-                <a:solidFill>
-                  <a:srgbClr val="122A52"/>
-                </a:solidFill>
-                <a:latin typeface="Helvetica"/>
-              </a:rPr>
-              <a:t>■   </a:t>
-            </a:r>
-            <a:r>
-              <a:rPr sz="1500" b="1">
-                <a:solidFill>
-                  <a:srgbClr val="122A52"/>
-                </a:solidFill>
-                <a:latin typeface="Helvetica"/>
-              </a:rPr>
-              <a:t>Vi træner mønsteret HER</a:t>
-            </a:r>
-            <a:r>
-              <a:rPr sz="1500" b="0">
-                <a:solidFill>
-                  <a:srgbClr val="122A52"/>
-                </a:solidFill>
-                <a:latin typeface="Helvetica"/>
-              </a:rPr>
-              <a:t> — så det sidder i fingrene mandag morgen i en rigtig PR</a:t>
             </a:r>
           </a:p>
         </p:txBody>
@@ -5955,14 +5918,14 @@
           <a:p>
             <a:pPr algn="l">
               <a:lnSpc>
-                <a:spcPct val="160000"/>
+                <a:spcPct val="170000"/>
               </a:lnSpc>
               <a:spcAft>
                 <a:spcPts val="1000"/>
               </a:spcAft>
             </a:pPr>
             <a:r>
-              <a:rPr sz="1800" b="1">
+              <a:rPr sz="1900" b="1">
                 <a:solidFill>
                   <a:srgbClr val="122A52"/>
                 </a:solidFill>
@@ -5971,7 +5934,7 @@
               <a:t>■   </a:t>
             </a:r>
             <a:r>
-              <a:rPr sz="1800" b="1">
+              <a:rPr sz="1900" b="1">
                 <a:solidFill>
                   <a:srgbClr val="122A52"/>
                 </a:solidFill>
@@ -5980,7 +5943,7 @@
               <a:t>git clone</a:t>
             </a:r>
             <a:r>
-              <a:rPr sz="1800" b="0">
+              <a:rPr sz="1900" b="0">
                 <a:solidFill>
                   <a:srgbClr val="122A52"/>
                 </a:solidFill>
@@ -5989,7 +5952,7 @@
               <a:t> + </a:t>
             </a:r>
             <a:r>
-              <a:rPr sz="1800" b="1">
+              <a:rPr sz="1900" b="1">
                 <a:solidFill>
                   <a:srgbClr val="122A52"/>
                 </a:solidFill>
@@ -5998,7 +5961,7 @@
               <a:t>npm install</a:t>
             </a:r>
             <a:r>
-              <a:rPr sz="1800" b="0">
+              <a:rPr sz="1900" b="0">
                 <a:solidFill>
                   <a:srgbClr val="122A52"/>
                 </a:solidFill>
@@ -6007,7 +5970,7 @@
               <a:t> + </a:t>
             </a:r>
             <a:r>
-              <a:rPr sz="1800" b="1">
+              <a:rPr sz="1900" b="1">
                 <a:solidFill>
                   <a:srgbClr val="122A52"/>
                 </a:solidFill>
@@ -6016,7 +5979,7 @@
               <a:t>claude</a:t>
             </a:r>
             <a:r>
-              <a:rPr sz="1800" b="0">
+              <a:rPr sz="1900" b="0">
                 <a:solidFill>
                   <a:srgbClr val="122A52"/>
                 </a:solidFill>
@@ -6028,14 +5991,14 @@
           <a:p>
             <a:pPr algn="l">
               <a:lnSpc>
-                <a:spcPct val="160000"/>
+                <a:spcPct val="170000"/>
               </a:lnSpc>
               <a:spcAft>
                 <a:spcPts val="1000"/>
               </a:spcAft>
             </a:pPr>
             <a:r>
-              <a:rPr sz="1800" b="1">
+              <a:rPr sz="1900" b="1">
                 <a:solidFill>
                   <a:srgbClr val="122A52"/>
                 </a:solidFill>
@@ -6044,7 +6007,7 @@
               <a:t>■   </a:t>
             </a:r>
             <a:r>
-              <a:rPr sz="1800" b="0">
+              <a:rPr sz="1900" b="0">
                 <a:solidFill>
                   <a:srgbClr val="122A52"/>
                 </a:solidFill>
@@ -6056,14 +6019,14 @@
           <a:p>
             <a:pPr algn="l">
               <a:lnSpc>
-                <a:spcPct val="160000"/>
+                <a:spcPct val="170000"/>
               </a:lnSpc>
               <a:spcAft>
                 <a:spcPts val="1000"/>
               </a:spcAft>
             </a:pPr>
             <a:r>
-              <a:rPr sz="1800" b="1">
+              <a:rPr sz="1900" b="1">
                 <a:solidFill>
                   <a:srgbClr val="122A52"/>
                 </a:solidFill>
@@ -6072,7 +6035,7 @@
               <a:t>■   </a:t>
             </a:r>
             <a:r>
-              <a:rPr sz="1800" b="0">
+              <a:rPr sz="1900" b="0">
                 <a:solidFill>
                   <a:srgbClr val="122A52"/>
                 </a:solidFill>
@@ -6081,7 +6044,7 @@
               <a:t>Skriv først en </a:t>
             </a:r>
             <a:r>
-              <a:rPr sz="1800" b="1">
+              <a:rPr sz="1900" b="1">
                 <a:solidFill>
                   <a:srgbClr val="122A52"/>
                 </a:solidFill>
@@ -6090,7 +6053,7 @@
               <a:t>hurtig prompt</a:t>
             </a:r>
             <a:r>
-              <a:rPr sz="1800" b="0">
+              <a:rPr sz="1900" b="0">
                 <a:solidFill>
                   <a:srgbClr val="122A52"/>
                 </a:solidFill>
@@ -6102,14 +6065,14 @@
           <a:p>
             <a:pPr algn="l">
               <a:lnSpc>
-                <a:spcPct val="160000"/>
+                <a:spcPct val="170000"/>
               </a:lnSpc>
               <a:spcAft>
                 <a:spcPts val="1000"/>
               </a:spcAft>
             </a:pPr>
             <a:r>
-              <a:rPr sz="1800" b="1">
+              <a:rPr sz="1900" b="1">
                 <a:solidFill>
                   <a:srgbClr val="122A52"/>
                 </a:solidFill>
@@ -6118,7 +6081,7 @@
               <a:t>■   </a:t>
             </a:r>
             <a:r>
-              <a:rPr sz="1800" b="1">
+              <a:rPr sz="1900" b="1">
                 <a:solidFill>
                   <a:srgbClr val="122A52"/>
                 </a:solidFill>
@@ -6127,7 +6090,7 @@
               <a:t>git checkout .</a:t>
             </a:r>
             <a:r>
-              <a:rPr sz="1800" b="0">
+              <a:rPr sz="1900" b="0">
                 <a:solidFill>
                   <a:srgbClr val="122A52"/>
                 </a:solidFill>
@@ -6136,7 +6099,7 @@
               <a:t> og </a:t>
             </a:r>
             <a:r>
-              <a:rPr sz="1800" b="1">
+              <a:rPr sz="1900" b="1">
                 <a:solidFill>
                   <a:srgbClr val="122A52"/>
                 </a:solidFill>
@@ -6145,7 +6108,7 @@
               <a:t>/clear</a:t>
             </a:r>
             <a:r>
-              <a:rPr sz="1800" b="0">
+              <a:rPr sz="1900" b="0">
                 <a:solidFill>
                   <a:srgbClr val="122A52"/>
                 </a:solidFill>
@@ -6157,14 +6120,14 @@
           <a:p>
             <a:pPr algn="l">
               <a:lnSpc>
-                <a:spcPct val="160000"/>
+                <a:spcPct val="170000"/>
               </a:lnSpc>
               <a:spcAft>
                 <a:spcPts val="1000"/>
               </a:spcAft>
             </a:pPr>
             <a:r>
-              <a:rPr sz="1800" b="1">
+              <a:rPr sz="1900" b="1">
                 <a:solidFill>
                   <a:srgbClr val="122A52"/>
                 </a:solidFill>
@@ -6173,7 +6136,7 @@
               <a:t>■   </a:t>
             </a:r>
             <a:r>
-              <a:rPr sz="1800" b="0">
+              <a:rPr sz="1900" b="0">
                 <a:solidFill>
                   <a:srgbClr val="122A52"/>
                 </a:solidFill>
@@ -6182,41 +6145,13 @@
               <a:t>Skriv så en prompt med </a:t>
             </a:r>
             <a:r>
-              <a:rPr sz="1800" b="1">
+              <a:rPr sz="1900" b="1">
                 <a:solidFill>
                   <a:srgbClr val="122A52"/>
                 </a:solidFill>
                 <a:latin typeface="Helvetica"/>
               </a:rPr>
               <a:t>alle 4 byggeklodser</a:t>
-            </a:r>
-          </a:p>
-          <a:p>
-            <a:pPr algn="l">
-              <a:lnSpc>
-                <a:spcPct val="160000"/>
-              </a:lnSpc>
-              <a:spcAft>
-                <a:spcPts val="1000"/>
-              </a:spcAft>
-            </a:pPr>
-            <a:r>
-              <a:rPr sz="1800" b="1">
-                <a:solidFill>
-                  <a:srgbClr val="122A52"/>
-                </a:solidFill>
-                <a:latin typeface="Helvetica"/>
-              </a:rPr>
-              <a:t>■   </a:t>
-            </a:r>
-            <a:r>
-              <a:rPr sz="1800" b="0">
-                <a:solidFill>
-                  <a:srgbClr val="122A52"/>
-                </a:solidFill>
-                <a:latin typeface="Helvetica"/>
-              </a:rPr>
-              <a:t>Sammenlign: hvad var forskellen? Hvilken ville du committe?</a:t>
             </a:r>
           </a:p>
         </p:txBody>

</xml_diff>

<commit_message>
Fjern hands-on instruktioner og outro — 11 slides total
Matias forklarer hands-on verbalt og runder af mundtligt.
Hands-on dividerer bliver det sidste slide og står på projektoren
mens deltagerne arbejder.

Speaker-noten på Punkt 3 dækker nu hele afslutningen:
- Start (0:35): solo, 20 min, hvad de skal gøre
- Mens de arbejder: gå rundt, lyt efter aha
- 5 min tilbage: saml op, deling
- 0:55 afslutning: hjemmeopgave, bekræft næste præsentant, tak

Co-Authored-By: Claude Opus 4.7 (1M context) <noreply@anthropic.com>
</commit_message>
<xml_diff>
--- a/slides/session1.pptx
+++ b/slides/session1.pptx
@@ -16,8 +16,6 @@
     <p:sldId id="264" r:id="rId16"/>
     <p:sldId id="265" r:id="rId17"/>
     <p:sldId id="266" r:id="rId18"/>
-    <p:sldId id="267" r:id="rId19"/>
-    <p:sldId id="268" r:id="rId20"/>
   </p:sldIdLst>
   <p:sldSz cx="12191695" cy="6858000" type="screen4x3"/>
   <p:notesSz cx="6858000" cy="9144000"/>
@@ -715,243 +713,81 @@
           </a:p>
           <a:p>
             <a:r>
-              <a:t>Korte instrukser · 0:35 — start. De skal i gang.</a:t>
+              <a:t>Hands-on (0:35–0:55) + afslutning (0:55–1:00). Slidet bliver siddende mens deltagerne arbejder. Du forklarer hands-on verbalt, går rundt, samler op, og runder af — alt sammen uden at skifte slide.</a:t>
             </a:r>
           </a:p>
           <a:p/>
           <a:p>
             <a:r>
-              <a:t>─── SIG ───</a:t>
-            </a:r>
-          </a:p>
-          <a:p>
-            <a:r>
-              <a:t>"Nu jer."</a:t>
+              <a:t>─── SIG (start hands-on, 0:35) ───</a:t>
+            </a:r>
+          </a:p>
+          <a:p>
+            <a:r>
+              <a:t>"Nu jer. Solo på din egen maskine — du skal selv mærke forskellen i fingrene. I har 20 minutter."</a:t>
             </a:r>
           </a:p>
           <a:p/>
           <a:p>
             <a:r>
-              <a:t>"Solo på din egen maskine — du skal selv mærke forskellen i fingrene."</a:t>
+              <a:t>"Kør git clone fra README'en, npm install, og claude i demo-mappen. Vælg én opgave fra demoen — pris-bug, performance, eller favorit-knap."</a:t>
             </a:r>
           </a:p>
           <a:p/>
           <a:p>
             <a:r>
-              <a:t>"I har 20 minutter."</a:t>
-            </a:r>
-          </a:p>
-        </p:txBody>
-      </p:sp>
-      <p:sp>
-        <p:nvSpPr>
-          <p:cNvPr id="4" name="Slide Number Placeholder 3"/>
-          <p:cNvSpPr>
-            <a:spLocks noGrp="1"/>
-          </p:cNvSpPr>
-          <p:nvPr>
-            <p:ph type="sldNum" idx="5" sz="quarter"/>
-          </p:nvPr>
-        </p:nvSpPr>
-        <p:spPr/>
-      </p:sp>
-    </p:spTree>
-  </p:cSld>
-  <p:clrMapOvr>
-    <a:masterClrMapping/>
-  </p:clrMapOvr>
-</p:notes>
-</file>
-
-<file path=ppt/notesSlides/notesSlide12.xml><?xml version="1.0" encoding="utf-8"?>
-<p:notes xmlns:a="http://schemas.openxmlformats.org/drawingml/2006/main" xmlns:p="http://schemas.openxmlformats.org/presentationml/2006/main" xmlns:r="http://schemas.openxmlformats.org/officeDocument/2006/relationships">
-  <p:cSld>
-    <p:spTree>
-      <p:nvGrpSpPr>
-        <p:cNvPr id="1" name=""/>
-        <p:cNvGrpSpPr/>
-        <p:nvPr/>
-      </p:nvGrpSpPr>
-      <p:grpSpPr>
-        <a:xfrm>
-          <a:off x="0" y="0"/>
-          <a:ext cx="0" cy="0"/>
-          <a:chOff x="0" y="0"/>
-          <a:chExt cx="0" cy="0"/>
-        </a:xfrm>
-      </p:grpSpPr>
-      <p:sp>
-        <p:nvSpPr>
-          <p:cNvPr id="2" name="Slide Image Placeholder 1"/>
-          <p:cNvSpPr>
-            <a:spLocks noGrp="1"/>
-          </p:cNvSpPr>
-          <p:nvPr>
-            <p:ph type="sldImg" idx="2"/>
-          </p:nvPr>
-        </p:nvSpPr>
-        <p:spPr/>
-      </p:sp>
-      <p:sp>
-        <p:nvSpPr>
-          <p:cNvPr id="3" name="Notes Placeholder 2"/>
-          <p:cNvSpPr>
-            <a:spLocks noGrp="1"/>
-          </p:cNvSpPr>
-          <p:nvPr>
-            <p:ph type="body" idx="3" sz="quarter"/>
-          </p:nvPr>
-        </p:nvSpPr>
-        <p:spPr/>
-        <p:txBody>
-          <a:bodyPr/>
-          <a:lstStyle/>
-          <a:p>
-            <a:r>
-              <a:t>─── LÆS ───</a:t>
-            </a:r>
-          </a:p>
-          <a:p>
-            <a:r>
-              <a:t>Mens de arbejder · 0:35–0:55. Gå rundt. Hjælp dem der sidder fast. Lyt efter en god 'aha'-bemærkning du kan bede dem dele bagefter.</a:t>
+              <a:t>"Skriv først en hurtig prompt som I ville skrive på en travl dag. Så git checkout og /clear for at rulle tilbage. Så samme opgave med alle 4 byggeklodser."</a:t>
             </a:r>
           </a:p>
           <a:p/>
           <a:p>
             <a:r>
-              <a:t>─── SIG (i starten) ───</a:t>
-            </a:r>
-          </a:p>
-          <a:p>
-            <a:r>
-              <a:t>"Læs trinene på slidet: clone, npm install, claude i demo. Vælg én opgave fra demoen."</a:t>
+              <a:t>"Hvis du sidder fast, ræk hånden op — vi går rundt."</a:t>
             </a:r>
           </a:p>
           <a:p/>
           <a:p>
             <a:r>
-              <a:t>"Det vigtigste: prøv BEGGE prompts — ikke bare den gode. Læg mærke til forskellen."</a:t>
+              <a:t>─── GØR (mens de arbejder) ───</a:t>
+            </a:r>
+          </a:p>
+          <a:p>
+            <a:r>
+              <a:t>Gå rundt. Hjælp dem der sidder fast. Lyt efter en god 'aha'-bemærkning du kan bede dem dele bagefter.</a:t>
             </a:r>
           </a:p>
           <a:p/>
           <a:p>
             <a:r>
-              <a:t>"Hvis du sidder fast, ræk hånden op — vi går rundt."</a:t>
+              <a:t>─── SIG (med 5 min tilbage, ~0:50) ───</a:t>
+            </a:r>
+          </a:p>
+          <a:p>
+            <a:r>
+              <a:t>"Saml jer — én indsigt højt fra hver. Den der overraskede jer mest."</a:t>
             </a:r>
           </a:p>
           <a:p/>
           <a:p>
             <a:r>
-              <a:t>─── SIG (med 5 min tilbage) ───</a:t>
-            </a:r>
-          </a:p>
-          <a:p>
-            <a:r>
-              <a:t>"Saml jer — én indsigt højt fra hver. Den der overraskede jer mest."</a:t>
-            </a:r>
-          </a:p>
-        </p:txBody>
-      </p:sp>
-      <p:sp>
-        <p:nvSpPr>
-          <p:cNvPr id="4" name="Slide Number Placeholder 3"/>
-          <p:cNvSpPr>
-            <a:spLocks noGrp="1"/>
-          </p:cNvSpPr>
-          <p:nvPr>
-            <p:ph type="sldNum" idx="5" sz="quarter"/>
-          </p:nvPr>
-        </p:nvSpPr>
-        <p:spPr/>
-      </p:sp>
-    </p:spTree>
-  </p:cSld>
-  <p:clrMapOvr>
-    <a:masterClrMapping/>
-  </p:clrMapOvr>
-</p:notes>
-</file>
-
-<file path=ppt/notesSlides/notesSlide13.xml><?xml version="1.0" encoding="utf-8"?>
-<p:notes xmlns:a="http://schemas.openxmlformats.org/drawingml/2006/main" xmlns:p="http://schemas.openxmlformats.org/presentationml/2006/main" xmlns:r="http://schemas.openxmlformats.org/officeDocument/2006/relationships">
-  <p:cSld>
-    <p:spTree>
-      <p:nvGrpSpPr>
-        <p:cNvPr id="1" name=""/>
-        <p:cNvGrpSpPr/>
-        <p:nvPr/>
-      </p:nvGrpSpPr>
-      <p:grpSpPr>
-        <a:xfrm>
-          <a:off x="0" y="0"/>
-          <a:ext cx="0" cy="0"/>
-          <a:chOff x="0" y="0"/>
-          <a:chExt cx="0" cy="0"/>
-        </a:xfrm>
-      </p:grpSpPr>
-      <p:sp>
-        <p:nvSpPr>
-          <p:cNvPr id="2" name="Slide Image Placeholder 1"/>
-          <p:cNvSpPr>
-            <a:spLocks noGrp="1"/>
-          </p:cNvSpPr>
-          <p:nvPr>
-            <p:ph type="sldImg" idx="2"/>
-          </p:nvPr>
-        </p:nvSpPr>
-        <p:spPr/>
-      </p:sp>
-      <p:sp>
-        <p:nvSpPr>
-          <p:cNvPr id="3" name="Notes Placeholder 2"/>
-          <p:cNvSpPr>
-            <a:spLocks noGrp="1"/>
-          </p:cNvSpPr>
-          <p:nvPr>
-            <p:ph type="body" idx="3" sz="quarter"/>
-          </p:nvPr>
-        </p:nvSpPr>
-        <p:spPr/>
-        <p:txBody>
-          <a:bodyPr/>
-          <a:lstStyle/>
-          <a:p>
-            <a:r>
-              <a:t>─── LÆS ───</a:t>
-            </a:r>
-          </a:p>
-          <a:p>
-            <a:r>
-              <a:t>Afslutning · 0:55–1:00. Hjemmeopgave nem. Bekræft næste præsentant igen ved navn så de ved det er reelt.</a:t>
+              <a:t>─── SIG (afslutning, 0:55) ───</a:t>
+            </a:r>
+          </a:p>
+          <a:p>
+            <a:r>
+              <a:t>"Hjemmeopgaven er nem: brug Claude Code på mindst én rigtig opgave inden torsdag — i et af jeres rigtige projekter, ikke demoen."</a:t>
             </a:r>
           </a:p>
           <a:p/>
           <a:p>
             <a:r>
-              <a:t>─── SIG ───</a:t>
-            </a:r>
-          </a:p>
-          <a:p>
-            <a:r>
-              <a:t>"Hjemmeopgaven er nem. Brug Claude Code på MINDST én rigtig opgave inden torsdag — i et af jeres rigtige projekter, ikke demoen."</a:t>
+              <a:t>"Tag to prompts med til torsdag: én der virkede godt, og én der ikke gjorde. Vi starter session 2 med at dele dem."</a:t>
             </a:r>
           </a:p>
           <a:p/>
           <a:p>
             <a:r>
-              <a:t>"Tag to prompts med til torsdag: én der virkede godt, og én der ikke gjorde."</a:t>
-            </a:r>
-          </a:p>
-          <a:p/>
-          <a:p>
-            <a:r>
-              <a:t>"Vi starter session 2 med at dele dem. Vi lærer mest af de fejlede prompts."</a:t>
-            </a:r>
-          </a:p>
-          <a:p/>
-          <a:p>
-            <a:r>
-              <a:t>"[Navn] tager session 2 om Plan mode. Jeg sender slide-skabelon og pre-work-video senest mandag."</a:t>
+              <a:t>"[Navn] tager session 2 om Plan mode. Jeg sender slide-skabelon og pre-work-video senest dagen før."</a:t>
             </a:r>
           </a:p>
           <a:p/>
@@ -5745,932 +5581,6 @@
       <p:sp>
         <p:nvSpPr>
           <p:cNvPr id="7" name="Rectangle 6"/>
-          <p:cNvSpPr/>
-          <p:nvPr/>
-        </p:nvSpPr>
-        <p:spPr>
-          <a:xfrm>
-            <a:off x="0" y="6693408"/>
-            <a:ext cx="12191695" cy="164592"/>
-          </a:xfrm>
-          <a:prstGeom prst="rect">
-            <a:avLst/>
-          </a:prstGeom>
-          <a:solidFill>
-            <a:srgbClr val="F5B81C"/>
-          </a:solidFill>
-          <a:ln>
-            <a:noFill/>
-          </a:ln>
-        </p:spPr>
-        <p:style>
-          <a:lnRef idx="1">
-            <a:schemeClr val="accent1"/>
-          </a:lnRef>
-          <a:fillRef idx="3">
-            <a:schemeClr val="accent1"/>
-          </a:fillRef>
-          <a:effectRef idx="2">
-            <a:schemeClr val="accent1"/>
-          </a:effectRef>
-          <a:fontRef idx="minor">
-            <a:schemeClr val="lt1"/>
-          </a:fontRef>
-        </p:style>
-        <p:txBody>
-          <a:bodyPr rtlCol="0" anchor="ctr"/>
-          <a:lstStyle/>
-          <a:p>
-            <a:pPr algn="ctr"/>
-          </a:p>
-        </p:txBody>
-      </p:sp>
-    </p:spTree>
-  </p:cSld>
-  <p:clrMapOvr>
-    <a:masterClrMapping/>
-  </p:clrMapOvr>
-</p:sld>
-</file>
-
-<file path=ppt/slides/slide12.xml><?xml version="1.0" encoding="utf-8"?>
-<p:sld xmlns:a="http://schemas.openxmlformats.org/drawingml/2006/main" xmlns:p="http://schemas.openxmlformats.org/presentationml/2006/main" xmlns:r="http://schemas.openxmlformats.org/officeDocument/2006/relationships">
-  <p:cSld>
-    <p:spTree>
-      <p:nvGrpSpPr>
-        <p:cNvPr id="1" name=""/>
-        <p:cNvGrpSpPr/>
-        <p:nvPr/>
-      </p:nvGrpSpPr>
-      <p:grpSpPr/>
-      <p:sp>
-        <p:nvSpPr>
-          <p:cNvPr id="2" name="Rectangle 1"/>
-          <p:cNvSpPr/>
-          <p:nvPr/>
-        </p:nvSpPr>
-        <p:spPr>
-          <a:xfrm>
-            <a:off x="0" y="0"/>
-            <a:ext cx="12191695" cy="6858000"/>
-          </a:xfrm>
-          <a:prstGeom prst="rect">
-            <a:avLst/>
-          </a:prstGeom>
-          <a:solidFill>
-            <a:srgbClr val="FFFFFF"/>
-          </a:solidFill>
-          <a:ln>
-            <a:noFill/>
-          </a:ln>
-        </p:spPr>
-        <p:style>
-          <a:lnRef idx="1">
-            <a:schemeClr val="accent1"/>
-          </a:lnRef>
-          <a:fillRef idx="3">
-            <a:schemeClr val="accent1"/>
-          </a:fillRef>
-          <a:effectRef idx="2">
-            <a:schemeClr val="accent1"/>
-          </a:effectRef>
-          <a:fontRef idx="minor">
-            <a:schemeClr val="lt1"/>
-          </a:fontRef>
-        </p:style>
-        <p:txBody>
-          <a:bodyPr rtlCol="0" anchor="ctr"/>
-          <a:lstStyle/>
-          <a:p>
-            <a:pPr algn="ctr"/>
-          </a:p>
-        </p:txBody>
-      </p:sp>
-      <p:sp>
-        <p:nvSpPr>
-          <p:cNvPr id="3" name="TextBox 2"/>
-          <p:cNvSpPr txBox="1"/>
-          <p:nvPr/>
-        </p:nvSpPr>
-        <p:spPr>
-          <a:xfrm>
-            <a:off x="548640" y="457200"/>
-            <a:ext cx="11155680" cy="914400"/>
-          </a:xfrm>
-          <a:prstGeom prst="rect">
-            <a:avLst/>
-          </a:prstGeom>
-          <a:noFill/>
-        </p:spPr>
-        <p:txBody>
-          <a:bodyPr wrap="square" lIns="0" tIns="0" bIns="0" rIns="0">
-            <a:spAutoFit/>
-          </a:bodyPr>
-          <a:lstStyle/>
-          <a:p>
-            <a:pPr algn="l">
-              <a:lnSpc>
-                <a:spcPct val="110000"/>
-              </a:lnSpc>
-            </a:pPr>
-            <a:r>
-              <a:rPr sz="3400" b="1">
-                <a:solidFill>
-                  <a:srgbClr val="122A52"/>
-                </a:solidFill>
-                <a:latin typeface="Helvetica"/>
-              </a:rPr>
-              <a:t>Hands-on</a:t>
-            </a:r>
-            <a:r>
-              <a:rPr sz="3400" b="0">
-                <a:solidFill>
-                  <a:srgbClr val="122A52"/>
-                </a:solidFill>
-                <a:latin typeface="Helvetica"/>
-              </a:rPr>
-              <a:t> | Prøv begge prompt-typer på samme opgave</a:t>
-            </a:r>
-          </a:p>
-        </p:txBody>
-      </p:sp>
-      <p:sp>
-        <p:nvSpPr>
-          <p:cNvPr id="4" name="TextBox 3"/>
-          <p:cNvSpPr txBox="1"/>
-          <p:nvPr/>
-        </p:nvSpPr>
-        <p:spPr>
-          <a:xfrm>
-            <a:off x="640080" y="2011680"/>
-            <a:ext cx="10972800" cy="4114800"/>
-          </a:xfrm>
-          <a:prstGeom prst="rect">
-            <a:avLst/>
-          </a:prstGeom>
-          <a:noFill/>
-        </p:spPr>
-        <p:txBody>
-          <a:bodyPr wrap="square" lIns="0" rIns="0" tIns="0" bIns="0">
-            <a:spAutoFit/>
-          </a:bodyPr>
-          <a:lstStyle/>
-          <a:p>
-            <a:pPr algn="l">
-              <a:lnSpc>
-                <a:spcPct val="170000"/>
-              </a:lnSpc>
-              <a:spcAft>
-                <a:spcPts val="1000"/>
-              </a:spcAft>
-            </a:pPr>
-            <a:r>
-              <a:rPr sz="1900" b="1">
-                <a:solidFill>
-                  <a:srgbClr val="122A52"/>
-                </a:solidFill>
-                <a:latin typeface="Helvetica"/>
-              </a:rPr>
-              <a:t>■   </a:t>
-            </a:r>
-            <a:r>
-              <a:rPr sz="1900" b="1">
-                <a:solidFill>
-                  <a:srgbClr val="122A52"/>
-                </a:solidFill>
-                <a:latin typeface="Helvetica"/>
-              </a:rPr>
-              <a:t>git clone</a:t>
-            </a:r>
-            <a:r>
-              <a:rPr sz="1900" b="0">
-                <a:solidFill>
-                  <a:srgbClr val="122A52"/>
-                </a:solidFill>
-                <a:latin typeface="Helvetica"/>
-              </a:rPr>
-              <a:t> + </a:t>
-            </a:r>
-            <a:r>
-              <a:rPr sz="1900" b="1">
-                <a:solidFill>
-                  <a:srgbClr val="122A52"/>
-                </a:solidFill>
-                <a:latin typeface="Helvetica"/>
-              </a:rPr>
-              <a:t>npm install</a:t>
-            </a:r>
-            <a:r>
-              <a:rPr sz="1900" b="0">
-                <a:solidFill>
-                  <a:srgbClr val="122A52"/>
-                </a:solidFill>
-                <a:latin typeface="Helvetica"/>
-              </a:rPr>
-              <a:t> + </a:t>
-            </a:r>
-            <a:r>
-              <a:rPr sz="1900" b="1">
-                <a:solidFill>
-                  <a:srgbClr val="122A52"/>
-                </a:solidFill>
-                <a:latin typeface="Helvetica"/>
-              </a:rPr>
-              <a:t>claude</a:t>
-            </a:r>
-            <a:r>
-              <a:rPr sz="1900" b="0">
-                <a:solidFill>
-                  <a:srgbClr val="122A52"/>
-                </a:solidFill>
-                <a:latin typeface="Helvetica"/>
-              </a:rPr>
-              <a:t> i `demo/`-mappen</a:t>
-            </a:r>
-          </a:p>
-          <a:p>
-            <a:pPr algn="l">
-              <a:lnSpc>
-                <a:spcPct val="170000"/>
-              </a:lnSpc>
-              <a:spcAft>
-                <a:spcPts val="1000"/>
-              </a:spcAft>
-            </a:pPr>
-            <a:r>
-              <a:rPr sz="1900" b="1">
-                <a:solidFill>
-                  <a:srgbClr val="122A52"/>
-                </a:solidFill>
-                <a:latin typeface="Helvetica"/>
-              </a:rPr>
-              <a:t>■   </a:t>
-            </a:r>
-            <a:r>
-              <a:rPr sz="1900" b="0">
-                <a:solidFill>
-                  <a:srgbClr val="122A52"/>
-                </a:solidFill>
-                <a:latin typeface="Helvetica"/>
-              </a:rPr>
-              <a:t>Vælg én opgave fra demoen (pris-bug, performance, eller favorit-knap)</a:t>
-            </a:r>
-          </a:p>
-          <a:p>
-            <a:pPr algn="l">
-              <a:lnSpc>
-                <a:spcPct val="170000"/>
-              </a:lnSpc>
-              <a:spcAft>
-                <a:spcPts val="1000"/>
-              </a:spcAft>
-            </a:pPr>
-            <a:r>
-              <a:rPr sz="1900" b="1">
-                <a:solidFill>
-                  <a:srgbClr val="122A52"/>
-                </a:solidFill>
-                <a:latin typeface="Helvetica"/>
-              </a:rPr>
-              <a:t>■   </a:t>
-            </a:r>
-            <a:r>
-              <a:rPr sz="1900" b="0">
-                <a:solidFill>
-                  <a:srgbClr val="122A52"/>
-                </a:solidFill>
-                <a:latin typeface="Helvetica"/>
-              </a:rPr>
-              <a:t>Skriv først en </a:t>
-            </a:r>
-            <a:r>
-              <a:rPr sz="1900" b="1">
-                <a:solidFill>
-                  <a:srgbClr val="122A52"/>
-                </a:solidFill>
-                <a:latin typeface="Helvetica"/>
-              </a:rPr>
-              <a:t>hurtig prompt</a:t>
-            </a:r>
-            <a:r>
-              <a:rPr sz="1900" b="0">
-                <a:solidFill>
-                  <a:srgbClr val="122A52"/>
-                </a:solidFill>
-                <a:latin typeface="Helvetica"/>
-              </a:rPr>
-              <a:t> — som du ville skrive på en travl dag</a:t>
-            </a:r>
-          </a:p>
-          <a:p>
-            <a:pPr algn="l">
-              <a:lnSpc>
-                <a:spcPct val="170000"/>
-              </a:lnSpc>
-              <a:spcAft>
-                <a:spcPts val="1000"/>
-              </a:spcAft>
-            </a:pPr>
-            <a:r>
-              <a:rPr sz="1900" b="1">
-                <a:solidFill>
-                  <a:srgbClr val="122A52"/>
-                </a:solidFill>
-                <a:latin typeface="Helvetica"/>
-              </a:rPr>
-              <a:t>■   </a:t>
-            </a:r>
-            <a:r>
-              <a:rPr sz="1900" b="1">
-                <a:solidFill>
-                  <a:srgbClr val="122A52"/>
-                </a:solidFill>
-                <a:latin typeface="Helvetica"/>
-              </a:rPr>
-              <a:t>git checkout .</a:t>
-            </a:r>
-            <a:r>
-              <a:rPr sz="1900" b="0">
-                <a:solidFill>
-                  <a:srgbClr val="122A52"/>
-                </a:solidFill>
-                <a:latin typeface="Helvetica"/>
-              </a:rPr>
-              <a:t> og </a:t>
-            </a:r>
-            <a:r>
-              <a:rPr sz="1900" b="1">
-                <a:solidFill>
-                  <a:srgbClr val="122A52"/>
-                </a:solidFill>
-                <a:latin typeface="Helvetica"/>
-              </a:rPr>
-              <a:t>/clear</a:t>
-            </a:r>
-            <a:r>
-              <a:rPr sz="1900" b="0">
-                <a:solidFill>
-                  <a:srgbClr val="122A52"/>
-                </a:solidFill>
-                <a:latin typeface="Helvetica"/>
-              </a:rPr>
-              <a:t> for at rulle tilbage</a:t>
-            </a:r>
-          </a:p>
-          <a:p>
-            <a:pPr algn="l">
-              <a:lnSpc>
-                <a:spcPct val="170000"/>
-              </a:lnSpc>
-              <a:spcAft>
-                <a:spcPts val="1000"/>
-              </a:spcAft>
-            </a:pPr>
-            <a:r>
-              <a:rPr sz="1900" b="1">
-                <a:solidFill>
-                  <a:srgbClr val="122A52"/>
-                </a:solidFill>
-                <a:latin typeface="Helvetica"/>
-              </a:rPr>
-              <a:t>■   </a:t>
-            </a:r>
-            <a:r>
-              <a:rPr sz="1900" b="0">
-                <a:solidFill>
-                  <a:srgbClr val="122A52"/>
-                </a:solidFill>
-                <a:latin typeface="Helvetica"/>
-              </a:rPr>
-              <a:t>Skriv så en prompt med </a:t>
-            </a:r>
-            <a:r>
-              <a:rPr sz="1900" b="1">
-                <a:solidFill>
-                  <a:srgbClr val="122A52"/>
-                </a:solidFill>
-                <a:latin typeface="Helvetica"/>
-              </a:rPr>
-              <a:t>alle 4 byggeklodser</a:t>
-            </a:r>
-          </a:p>
-        </p:txBody>
-      </p:sp>
-      <p:sp>
-        <p:nvSpPr>
-          <p:cNvPr id="5" name="Rectangle 4"/>
-          <p:cNvSpPr/>
-          <p:nvPr/>
-        </p:nvSpPr>
-        <p:spPr>
-          <a:xfrm>
-            <a:off x="0" y="0"/>
-            <a:ext cx="12191695" cy="164592"/>
-          </a:xfrm>
-          <a:prstGeom prst="rect">
-            <a:avLst/>
-          </a:prstGeom>
-          <a:solidFill>
-            <a:srgbClr val="122A52"/>
-          </a:solidFill>
-          <a:ln>
-            <a:noFill/>
-          </a:ln>
-        </p:spPr>
-        <p:style>
-          <a:lnRef idx="1">
-            <a:schemeClr val="accent1"/>
-          </a:lnRef>
-          <a:fillRef idx="3">
-            <a:schemeClr val="accent1"/>
-          </a:fillRef>
-          <a:effectRef idx="2">
-            <a:schemeClr val="accent1"/>
-          </a:effectRef>
-          <a:fontRef idx="minor">
-            <a:schemeClr val="lt1"/>
-          </a:fontRef>
-        </p:style>
-        <p:txBody>
-          <a:bodyPr rtlCol="0" anchor="ctr"/>
-          <a:lstStyle/>
-          <a:p>
-            <a:pPr algn="ctr"/>
-          </a:p>
-        </p:txBody>
-      </p:sp>
-      <p:sp>
-        <p:nvSpPr>
-          <p:cNvPr id="6" name="Rectangle 5"/>
-          <p:cNvSpPr/>
-          <p:nvPr/>
-        </p:nvSpPr>
-        <p:spPr>
-          <a:xfrm>
-            <a:off x="0" y="6693408"/>
-            <a:ext cx="12191695" cy="164592"/>
-          </a:xfrm>
-          <a:prstGeom prst="rect">
-            <a:avLst/>
-          </a:prstGeom>
-          <a:solidFill>
-            <a:srgbClr val="122A52"/>
-          </a:solidFill>
-          <a:ln>
-            <a:noFill/>
-          </a:ln>
-        </p:spPr>
-        <p:style>
-          <a:lnRef idx="1">
-            <a:schemeClr val="accent1"/>
-          </a:lnRef>
-          <a:fillRef idx="3">
-            <a:schemeClr val="accent1"/>
-          </a:fillRef>
-          <a:effectRef idx="2">
-            <a:schemeClr val="accent1"/>
-          </a:effectRef>
-          <a:fontRef idx="minor">
-            <a:schemeClr val="lt1"/>
-          </a:fontRef>
-        </p:style>
-        <p:txBody>
-          <a:bodyPr rtlCol="0" anchor="ctr"/>
-          <a:lstStyle/>
-          <a:p>
-            <a:pPr algn="ctr"/>
-          </a:p>
-        </p:txBody>
-      </p:sp>
-      <p:sp>
-        <p:nvSpPr>
-          <p:cNvPr id="7" name="TextBox 6"/>
-          <p:cNvSpPr txBox="1"/>
-          <p:nvPr/>
-        </p:nvSpPr>
-        <p:spPr>
-          <a:xfrm>
-            <a:off x="365760" y="6400800"/>
-            <a:ext cx="1828800" cy="274320"/>
-          </a:xfrm>
-          <a:prstGeom prst="rect">
-            <a:avLst/>
-          </a:prstGeom>
-          <a:noFill/>
-        </p:spPr>
-        <p:txBody>
-          <a:bodyPr wrap="square" lIns="0" rIns="0" tIns="0" bIns="0" anchor="t">
-            <a:spAutoFit/>
-          </a:bodyPr>
-          <a:lstStyle/>
-          <a:p>
-            <a:pPr algn="l">
-              <a:lnSpc>
-                <a:spcPct val="115000"/>
-              </a:lnSpc>
-            </a:pPr>
-            <a:r>
-              <a:rPr sz="1000" b="0" i="0">
-                <a:solidFill>
-                  <a:srgbClr val="556B8A"/>
-                </a:solidFill>
-                <a:latin typeface="Helvetica"/>
-              </a:rPr>
-              <a:t>12 |</a:t>
-            </a:r>
-          </a:p>
-        </p:txBody>
-      </p:sp>
-      <p:pic>
-        <p:nvPicPr>
-          <p:cNvPr id="8" name="Picture 7" descr="edc_logo.png"/>
-          <p:cNvPicPr>
-            <a:picLocks noChangeAspect="1"/>
-          </p:cNvPicPr>
-          <p:nvPr/>
-        </p:nvPicPr>
-        <p:blipFill>
-          <a:blip r:embed="rId2"/>
-          <a:stretch>
-            <a:fillRect/>
-          </a:stretch>
-        </p:blipFill>
-        <p:spPr>
-          <a:xfrm>
-            <a:off x="11475720" y="6263640"/>
-            <a:ext cx="594360" cy="594360"/>
-          </a:xfrm>
-          <a:prstGeom prst="rect">
-            <a:avLst/>
-          </a:prstGeom>
-        </p:spPr>
-      </p:pic>
-    </p:spTree>
-  </p:cSld>
-  <p:clrMapOvr>
-    <a:masterClrMapping/>
-  </p:clrMapOvr>
-</p:sld>
-</file>
-
-<file path=ppt/slides/slide13.xml><?xml version="1.0" encoding="utf-8"?>
-<p:sld xmlns:a="http://schemas.openxmlformats.org/drawingml/2006/main" xmlns:p="http://schemas.openxmlformats.org/presentationml/2006/main" xmlns:r="http://schemas.openxmlformats.org/officeDocument/2006/relationships">
-  <p:cSld>
-    <p:spTree>
-      <p:nvGrpSpPr>
-        <p:cNvPr id="1" name=""/>
-        <p:cNvGrpSpPr/>
-        <p:nvPr/>
-      </p:nvGrpSpPr>
-      <p:grpSpPr/>
-      <p:sp>
-        <p:nvSpPr>
-          <p:cNvPr id="2" name="Rectangle 1"/>
-          <p:cNvSpPr/>
-          <p:nvPr/>
-        </p:nvSpPr>
-        <p:spPr>
-          <a:xfrm>
-            <a:off x="0" y="0"/>
-            <a:ext cx="12191695" cy="6858000"/>
-          </a:xfrm>
-          <a:prstGeom prst="rect">
-            <a:avLst/>
-          </a:prstGeom>
-          <a:solidFill>
-            <a:srgbClr val="122A52"/>
-          </a:solidFill>
-          <a:ln>
-            <a:noFill/>
-          </a:ln>
-        </p:spPr>
-        <p:style>
-          <a:lnRef idx="1">
-            <a:schemeClr val="accent1"/>
-          </a:lnRef>
-          <a:fillRef idx="3">
-            <a:schemeClr val="accent1"/>
-          </a:fillRef>
-          <a:effectRef idx="2">
-            <a:schemeClr val="accent1"/>
-          </a:effectRef>
-          <a:fontRef idx="minor">
-            <a:schemeClr val="lt1"/>
-          </a:fontRef>
-        </p:style>
-        <p:txBody>
-          <a:bodyPr rtlCol="0" anchor="ctr"/>
-          <a:lstStyle/>
-          <a:p>
-            <a:pPr algn="ctr"/>
-          </a:p>
-        </p:txBody>
-      </p:sp>
-      <p:pic>
-        <p:nvPicPr>
-          <p:cNvPr id="3" name="Picture 2" descr="edc_logo.png"/>
-          <p:cNvPicPr>
-            <a:picLocks noChangeAspect="1"/>
-          </p:cNvPicPr>
-          <p:nvPr/>
-        </p:nvPicPr>
-        <p:blipFill>
-          <a:blip r:embed="rId2"/>
-          <a:stretch>
-            <a:fillRect/>
-          </a:stretch>
-        </p:blipFill>
-        <p:spPr>
-          <a:xfrm>
-            <a:off x="5547207" y="640080"/>
-            <a:ext cx="1097280" cy="1097280"/>
-          </a:xfrm>
-          <a:prstGeom prst="rect">
-            <a:avLst/>
-          </a:prstGeom>
-        </p:spPr>
-      </p:pic>
-      <p:sp>
-        <p:nvSpPr>
-          <p:cNvPr id="4" name="TextBox 3"/>
-          <p:cNvSpPr txBox="1"/>
-          <p:nvPr/>
-        </p:nvSpPr>
-        <p:spPr>
-          <a:xfrm>
-            <a:off x="0" y="1920240"/>
-            <a:ext cx="12191695" cy="548640"/>
-          </a:xfrm>
-          <a:prstGeom prst="rect">
-            <a:avLst/>
-          </a:prstGeom>
-          <a:noFill/>
-        </p:spPr>
-        <p:txBody>
-          <a:bodyPr wrap="square" lIns="0" rIns="0" tIns="0" bIns="0" anchor="t">
-            <a:spAutoFit/>
-          </a:bodyPr>
-          <a:lstStyle/>
-          <a:p>
-            <a:pPr algn="ctr">
-              <a:lnSpc>
-                <a:spcPct val="115000"/>
-              </a:lnSpc>
-            </a:pPr>
-            <a:r>
-              <a:rPr sz="1800" b="0" i="0">
-                <a:solidFill>
-                  <a:srgbClr val="F5B81C"/>
-                </a:solidFill>
-                <a:latin typeface="Menlo"/>
-              </a:rPr>
-              <a:t>Hjemmeopgave inden torsdag</a:t>
-            </a:r>
-          </a:p>
-        </p:txBody>
-      </p:sp>
-      <p:sp>
-        <p:nvSpPr>
-          <p:cNvPr id="5" name="TextBox 4"/>
-          <p:cNvSpPr txBox="1"/>
-          <p:nvPr/>
-        </p:nvSpPr>
-        <p:spPr>
-          <a:xfrm>
-            <a:off x="0" y="2468880"/>
-            <a:ext cx="12191695" cy="914400"/>
-          </a:xfrm>
-          <a:prstGeom prst="rect">
-            <a:avLst/>
-          </a:prstGeom>
-          <a:noFill/>
-        </p:spPr>
-        <p:txBody>
-          <a:bodyPr wrap="square" lIns="0" rIns="0" tIns="0" bIns="0" anchor="t">
-            <a:spAutoFit/>
-          </a:bodyPr>
-          <a:lstStyle/>
-          <a:p>
-            <a:pPr algn="ctr">
-              <a:lnSpc>
-                <a:spcPct val="115000"/>
-              </a:lnSpc>
-            </a:pPr>
-            <a:r>
-              <a:rPr sz="4400" b="1" i="0">
-                <a:solidFill>
-                  <a:srgbClr val="FFFFFF"/>
-                </a:solidFill>
-                <a:latin typeface="Helvetica"/>
-              </a:rPr>
-              <a:t>Brug Claude Code</a:t>
-            </a:r>
-          </a:p>
-        </p:txBody>
-      </p:sp>
-      <p:sp>
-        <p:nvSpPr>
-          <p:cNvPr id="6" name="TextBox 5"/>
-          <p:cNvSpPr txBox="1"/>
-          <p:nvPr/>
-        </p:nvSpPr>
-        <p:spPr>
-          <a:xfrm>
-            <a:off x="0" y="3200400"/>
-            <a:ext cx="12191695" cy="640080"/>
-          </a:xfrm>
-          <a:prstGeom prst="rect">
-            <a:avLst/>
-          </a:prstGeom>
-          <a:noFill/>
-        </p:spPr>
-        <p:txBody>
-          <a:bodyPr wrap="square" lIns="0" rIns="0" tIns="0" bIns="0" anchor="t">
-            <a:spAutoFit/>
-          </a:bodyPr>
-          <a:lstStyle/>
-          <a:p>
-            <a:pPr algn="ctr">
-              <a:lnSpc>
-                <a:spcPct val="115000"/>
-              </a:lnSpc>
-            </a:pPr>
-            <a:r>
-              <a:rPr sz="2800" b="0" i="0">
-                <a:solidFill>
-                  <a:srgbClr val="C8D4E8"/>
-                </a:solidFill>
-                <a:latin typeface="Helvetica"/>
-              </a:rPr>
-              <a:t>på mindst én rigtig opgave</a:t>
-            </a:r>
-          </a:p>
-        </p:txBody>
-      </p:sp>
-      <p:sp>
-        <p:nvSpPr>
-          <p:cNvPr id="7" name="Rectangle 6"/>
-          <p:cNvSpPr/>
-          <p:nvPr/>
-        </p:nvSpPr>
-        <p:spPr>
-          <a:xfrm>
-            <a:off x="1828800" y="4297680"/>
-            <a:ext cx="8531352" cy="1828800"/>
-          </a:xfrm>
-          <a:prstGeom prst="rect">
-            <a:avLst/>
-          </a:prstGeom>
-          <a:solidFill>
-            <a:srgbClr val="1B366B"/>
-          </a:solidFill>
-          <a:ln>
-            <a:noFill/>
-          </a:ln>
-        </p:spPr>
-        <p:style>
-          <a:lnRef idx="1">
-            <a:schemeClr val="accent1"/>
-          </a:lnRef>
-          <a:fillRef idx="3">
-            <a:schemeClr val="accent1"/>
-          </a:fillRef>
-          <a:effectRef idx="2">
-            <a:schemeClr val="accent1"/>
-          </a:effectRef>
-          <a:fontRef idx="minor">
-            <a:schemeClr val="lt1"/>
-          </a:fontRef>
-        </p:style>
-        <p:txBody>
-          <a:bodyPr rtlCol="0" anchor="ctr"/>
-          <a:lstStyle/>
-          <a:p>
-            <a:pPr algn="ctr"/>
-          </a:p>
-        </p:txBody>
-      </p:sp>
-      <p:sp>
-        <p:nvSpPr>
-          <p:cNvPr id="8" name="TextBox 7"/>
-          <p:cNvSpPr txBox="1"/>
-          <p:nvPr/>
-        </p:nvSpPr>
-        <p:spPr>
-          <a:xfrm>
-            <a:off x="2194560" y="4434840"/>
-            <a:ext cx="7772400" cy="457200"/>
-          </a:xfrm>
-          <a:prstGeom prst="rect">
-            <a:avLst/>
-          </a:prstGeom>
-          <a:noFill/>
-        </p:spPr>
-        <p:txBody>
-          <a:bodyPr wrap="square" lIns="0" rIns="0" tIns="0" bIns="0" anchor="t">
-            <a:spAutoFit/>
-          </a:bodyPr>
-          <a:lstStyle/>
-          <a:p>
-            <a:pPr algn="l">
-              <a:lnSpc>
-                <a:spcPct val="115000"/>
-              </a:lnSpc>
-            </a:pPr>
-            <a:r>
-              <a:rPr sz="1600" b="1" i="0">
-                <a:solidFill>
-                  <a:srgbClr val="F5B81C"/>
-                </a:solidFill>
-                <a:latin typeface="Menlo"/>
-              </a:rPr>
-              <a:t>Tag med til torsdag:</a:t>
-            </a:r>
-          </a:p>
-        </p:txBody>
-      </p:sp>
-      <p:sp>
-        <p:nvSpPr>
-          <p:cNvPr id="9" name="TextBox 8"/>
-          <p:cNvSpPr txBox="1"/>
-          <p:nvPr/>
-        </p:nvSpPr>
-        <p:spPr>
-          <a:xfrm>
-            <a:off x="2194560" y="4937760"/>
-            <a:ext cx="7772400" cy="1188720"/>
-          </a:xfrm>
-          <a:prstGeom prst="rect">
-            <a:avLst/>
-          </a:prstGeom>
-          <a:noFill/>
-        </p:spPr>
-        <p:txBody>
-          <a:bodyPr wrap="square" lIns="0" rIns="0" tIns="0" bIns="0">
-            <a:spAutoFit/>
-          </a:bodyPr>
-          <a:lstStyle/>
-          <a:p>
-            <a:pPr algn="l">
-              <a:lnSpc>
-                <a:spcPct val="140000"/>
-              </a:lnSpc>
-              <a:spcAft>
-                <a:spcPts val="1000"/>
-              </a:spcAft>
-            </a:pPr>
-            <a:r>
-              <a:rPr sz="1800" b="1">
-                <a:solidFill>
-                  <a:srgbClr val="F5B81C"/>
-                </a:solidFill>
-                <a:latin typeface="Helvetica"/>
-              </a:rPr>
-              <a:t>■   </a:t>
-            </a:r>
-            <a:r>
-              <a:rPr sz="1800" b="0">
-                <a:solidFill>
-                  <a:srgbClr val="FFFFFF"/>
-                </a:solidFill>
-                <a:latin typeface="Helvetica"/>
-              </a:rPr>
-              <a:t>Én prompt der virkede godt</a:t>
-            </a:r>
-          </a:p>
-          <a:p>
-            <a:pPr algn="l">
-              <a:lnSpc>
-                <a:spcPct val="140000"/>
-              </a:lnSpc>
-              <a:spcAft>
-                <a:spcPts val="1000"/>
-              </a:spcAft>
-            </a:pPr>
-            <a:r>
-              <a:rPr sz="1800" b="1">
-                <a:solidFill>
-                  <a:srgbClr val="F5B81C"/>
-                </a:solidFill>
-                <a:latin typeface="Helvetica"/>
-              </a:rPr>
-              <a:t>■   </a:t>
-            </a:r>
-            <a:r>
-              <a:rPr sz="1800" b="0">
-                <a:solidFill>
-                  <a:srgbClr val="FFFFFF"/>
-                </a:solidFill>
-                <a:latin typeface="Helvetica"/>
-              </a:rPr>
-              <a:t>Én der ikke gjorde — vi lærer mest af de fejlede</a:t>
-            </a:r>
-          </a:p>
-        </p:txBody>
-      </p:sp>
-      <p:sp>
-        <p:nvSpPr>
-          <p:cNvPr id="10" name="Rectangle 9"/>
           <p:cNvSpPr/>
           <p:nvPr/>
         </p:nvSpPr>

</xml_diff>

<commit_message>
Slide 11 (Hands-on): vis strukturen + eksempel hele tiden
Sidste slide bliver stående 20+ min mens deltagerne arbejder.
Lavet om fra section divider til content slide med:
- Mini-version af de 4 byggeklodser (kompakt, 4 bokse)
- Konkret eksempel-prompt der annoteret med [1] [2] [3] [4]
  så de kan se hvilken byggeklods der er hvad
- Eksempel: findByCity("Hellerup") på propertyService.ts —
  realistisk opgave de selv kunne lave

Deltagerne kan nu kigge op fra deres laptop og se strukturen
+ et konkret eksempel hele tiden.

Co-Authored-By: Claude Opus 4.7 (1M context) <noreply@anthropic.com>
</commit_message>
<xml_diff>
--- a/slides/session1.pptx
+++ b/slides/session1.pptx
@@ -5409,6 +5409,140 @@
             <a:avLst/>
           </a:prstGeom>
           <a:solidFill>
+            <a:srgbClr val="FFFFFF"/>
+          </a:solidFill>
+          <a:ln>
+            <a:noFill/>
+          </a:ln>
+        </p:spPr>
+        <p:style>
+          <a:lnRef idx="1">
+            <a:schemeClr val="accent1"/>
+          </a:lnRef>
+          <a:fillRef idx="3">
+            <a:schemeClr val="accent1"/>
+          </a:fillRef>
+          <a:effectRef idx="2">
+            <a:schemeClr val="accent1"/>
+          </a:effectRef>
+          <a:fontRef idx="minor">
+            <a:schemeClr val="lt1"/>
+          </a:fontRef>
+        </p:style>
+        <p:txBody>
+          <a:bodyPr rtlCol="0" anchor="ctr"/>
+          <a:lstStyle/>
+          <a:p>
+            <a:pPr algn="ctr"/>
+          </a:p>
+        </p:txBody>
+      </p:sp>
+      <p:sp>
+        <p:nvSpPr>
+          <p:cNvPr id="3" name="TextBox 2"/>
+          <p:cNvSpPr txBox="1"/>
+          <p:nvPr/>
+        </p:nvSpPr>
+        <p:spPr>
+          <a:xfrm>
+            <a:off x="548640" y="457200"/>
+            <a:ext cx="11155680" cy="914400"/>
+          </a:xfrm>
+          <a:prstGeom prst="rect">
+            <a:avLst/>
+          </a:prstGeom>
+          <a:noFill/>
+        </p:spPr>
+        <p:txBody>
+          <a:bodyPr wrap="square" lIns="0" tIns="0" bIns="0" rIns="0">
+            <a:spAutoFit/>
+          </a:bodyPr>
+          <a:lstStyle/>
+          <a:p>
+            <a:pPr algn="l">
+              <a:lnSpc>
+                <a:spcPct val="110000"/>
+              </a:lnSpc>
+            </a:pPr>
+            <a:r>
+              <a:rPr sz="3400" b="1">
+                <a:solidFill>
+                  <a:srgbClr val="122A52"/>
+                </a:solidFill>
+                <a:latin typeface="Helvetica"/>
+              </a:rPr>
+              <a:t>Hands-on</a:t>
+            </a:r>
+            <a:r>
+              <a:rPr sz="3400" b="0">
+                <a:solidFill>
+                  <a:srgbClr val="122A52"/>
+                </a:solidFill>
+                <a:latin typeface="Helvetica"/>
+              </a:rPr>
+              <a:t> | Solo · 20 min — brug strukturen og prøv begge prompt-typer</a:t>
+            </a:r>
+          </a:p>
+        </p:txBody>
+      </p:sp>
+      <p:sp>
+        <p:nvSpPr>
+          <p:cNvPr id="4" name="Rectangle 3"/>
+          <p:cNvSpPr/>
+          <p:nvPr/>
+        </p:nvSpPr>
+        <p:spPr>
+          <a:xfrm>
+            <a:off x="594360" y="1828800"/>
+            <a:ext cx="2697480" cy="1417320"/>
+          </a:xfrm>
+          <a:prstGeom prst="rect">
+            <a:avLst/>
+          </a:prstGeom>
+          <a:solidFill>
+            <a:srgbClr val="EEF1F6"/>
+          </a:solidFill>
+          <a:ln>
+            <a:noFill/>
+          </a:ln>
+        </p:spPr>
+        <p:style>
+          <a:lnRef idx="1">
+            <a:schemeClr val="accent1"/>
+          </a:lnRef>
+          <a:fillRef idx="3">
+            <a:schemeClr val="accent1"/>
+          </a:fillRef>
+          <a:effectRef idx="2">
+            <a:schemeClr val="accent1"/>
+          </a:effectRef>
+          <a:fontRef idx="minor">
+            <a:schemeClr val="lt1"/>
+          </a:fontRef>
+        </p:style>
+        <p:txBody>
+          <a:bodyPr rtlCol="0" anchor="ctr"/>
+          <a:lstStyle/>
+          <a:p>
+            <a:pPr algn="ctr"/>
+          </a:p>
+        </p:txBody>
+      </p:sp>
+      <p:sp>
+        <p:nvSpPr>
+          <p:cNvPr id="5" name="Oval 4"/>
+          <p:cNvSpPr/>
+          <p:nvPr/>
+        </p:nvSpPr>
+        <p:spPr>
+          <a:xfrm>
+            <a:off x="822960" y="2057400"/>
+            <a:ext cx="384048" cy="384048"/>
+          </a:xfrm>
+          <a:prstGeom prst="ellipse">
+            <a:avLst/>
+          </a:prstGeom>
+          <a:solidFill>
             <a:srgbClr val="122A52"/>
           </a:solidFill>
           <a:ln>
@@ -5430,16 +5564,1009 @@
           </a:fontRef>
         </p:style>
         <p:txBody>
+          <a:bodyPr rtlCol="0" anchor="ctr" lIns="0" rIns="0" tIns="0" bIns="0"/>
+          <a:lstStyle/>
+          <a:p>
+            <a:pPr algn="ctr"/>
+            <a:r>
+              <a:rPr sz="1300" b="1">
+                <a:solidFill>
+                  <a:srgbClr val="FFFFFF"/>
+                </a:solidFill>
+                <a:latin typeface="Helvetica"/>
+              </a:rPr>
+              <a:t>1</a:t>
+            </a:r>
+          </a:p>
+        </p:txBody>
+      </p:sp>
+      <p:sp>
+        <p:nvSpPr>
+          <p:cNvPr id="6" name="TextBox 5"/>
+          <p:cNvSpPr txBox="1"/>
+          <p:nvPr/>
+        </p:nvSpPr>
+        <p:spPr>
+          <a:xfrm>
+            <a:off x="1307592" y="2075688"/>
+            <a:ext cx="1783080" cy="365760"/>
+          </a:xfrm>
+          <a:prstGeom prst="rect">
+            <a:avLst/>
+          </a:prstGeom>
+          <a:noFill/>
+        </p:spPr>
+        <p:txBody>
+          <a:bodyPr wrap="square" lIns="0" rIns="0" tIns="0" bIns="0" anchor="t">
+            <a:spAutoFit/>
+          </a:bodyPr>
+          <a:lstStyle/>
+          <a:p>
+            <a:pPr algn="l">
+              <a:lnSpc>
+                <a:spcPct val="115000"/>
+              </a:lnSpc>
+            </a:pPr>
+            <a:r>
+              <a:rPr sz="1400" b="1" i="0">
+                <a:solidFill>
+                  <a:srgbClr val="122A52"/>
+                </a:solidFill>
+                <a:latin typeface="Helvetica"/>
+              </a:rPr>
+              <a:t>Kontekst</a:t>
+            </a:r>
+          </a:p>
+        </p:txBody>
+      </p:sp>
+      <p:sp>
+        <p:nvSpPr>
+          <p:cNvPr id="7" name="TextBox 6"/>
+          <p:cNvSpPr txBox="1"/>
+          <p:nvPr/>
+        </p:nvSpPr>
+        <p:spPr>
+          <a:xfrm>
+            <a:off x="822960" y="2606040"/>
+            <a:ext cx="2240280" cy="640080"/>
+          </a:xfrm>
+          <a:prstGeom prst="rect">
+            <a:avLst/>
+          </a:prstGeom>
+          <a:noFill/>
+        </p:spPr>
+        <p:txBody>
+          <a:bodyPr wrap="square" lIns="0" rIns="0" tIns="0" bIns="0" anchor="t">
+            <a:spAutoFit/>
+          </a:bodyPr>
+          <a:lstStyle/>
+          <a:p>
+            <a:pPr algn="l">
+              <a:lnSpc>
+                <a:spcPct val="130000"/>
+              </a:lnSpc>
+            </a:pPr>
+            <a:r>
+              <a:rPr sz="1100" b="0" i="0">
+                <a:solidFill>
+                  <a:srgbClr val="122A52"/>
+                </a:solidFill>
+                <a:latin typeface="Helvetica"/>
+              </a:rPr>
+              <a:t>Hvilke filer
+skal Claude læse?</a:t>
+            </a:r>
+          </a:p>
+        </p:txBody>
+      </p:sp>
+      <p:sp>
+        <p:nvSpPr>
+          <p:cNvPr id="8" name="Rectangle 7"/>
+          <p:cNvSpPr/>
+          <p:nvPr/>
+        </p:nvSpPr>
+        <p:spPr>
+          <a:xfrm>
+            <a:off x="3410712" y="1828800"/>
+            <a:ext cx="2697480" cy="1417320"/>
+          </a:xfrm>
+          <a:prstGeom prst="rect">
+            <a:avLst/>
+          </a:prstGeom>
+          <a:solidFill>
+            <a:srgbClr val="EEF1F6"/>
+          </a:solidFill>
+          <a:ln>
+            <a:noFill/>
+          </a:ln>
+        </p:spPr>
+        <p:style>
+          <a:lnRef idx="1">
+            <a:schemeClr val="accent1"/>
+          </a:lnRef>
+          <a:fillRef idx="3">
+            <a:schemeClr val="accent1"/>
+          </a:fillRef>
+          <a:effectRef idx="2">
+            <a:schemeClr val="accent1"/>
+          </a:effectRef>
+          <a:fontRef idx="minor">
+            <a:schemeClr val="lt1"/>
+          </a:fontRef>
+        </p:style>
+        <p:txBody>
           <a:bodyPr rtlCol="0" anchor="ctr"/>
           <a:lstStyle/>
           <a:p>
             <a:pPr algn="ctr"/>
+          </a:p>
+        </p:txBody>
+      </p:sp>
+      <p:sp>
+        <p:nvSpPr>
+          <p:cNvPr id="9" name="Oval 8"/>
+          <p:cNvSpPr/>
+          <p:nvPr/>
+        </p:nvSpPr>
+        <p:spPr>
+          <a:xfrm>
+            <a:off x="3639312" y="2057400"/>
+            <a:ext cx="384048" cy="384048"/>
+          </a:xfrm>
+          <a:prstGeom prst="ellipse">
+            <a:avLst/>
+          </a:prstGeom>
+          <a:solidFill>
+            <a:srgbClr val="122A52"/>
+          </a:solidFill>
+          <a:ln>
+            <a:noFill/>
+          </a:ln>
+        </p:spPr>
+        <p:style>
+          <a:lnRef idx="1">
+            <a:schemeClr val="accent1"/>
+          </a:lnRef>
+          <a:fillRef idx="3">
+            <a:schemeClr val="accent1"/>
+          </a:fillRef>
+          <a:effectRef idx="2">
+            <a:schemeClr val="accent1"/>
+          </a:effectRef>
+          <a:fontRef idx="minor">
+            <a:schemeClr val="lt1"/>
+          </a:fontRef>
+        </p:style>
+        <p:txBody>
+          <a:bodyPr rtlCol="0" anchor="ctr" lIns="0" rIns="0" tIns="0" bIns="0"/>
+          <a:lstStyle/>
+          <a:p>
+            <a:pPr algn="ctr"/>
+            <a:r>
+              <a:rPr sz="1300" b="1">
+                <a:solidFill>
+                  <a:srgbClr val="FFFFFF"/>
+                </a:solidFill>
+                <a:latin typeface="Helvetica"/>
+              </a:rPr>
+              <a:t>2</a:t>
+            </a:r>
+          </a:p>
+        </p:txBody>
+      </p:sp>
+      <p:sp>
+        <p:nvSpPr>
+          <p:cNvPr id="10" name="TextBox 9"/>
+          <p:cNvSpPr txBox="1"/>
+          <p:nvPr/>
+        </p:nvSpPr>
+        <p:spPr>
+          <a:xfrm>
+            <a:off x="4123944" y="2075688"/>
+            <a:ext cx="1783080" cy="365760"/>
+          </a:xfrm>
+          <a:prstGeom prst="rect">
+            <a:avLst/>
+          </a:prstGeom>
+          <a:noFill/>
+        </p:spPr>
+        <p:txBody>
+          <a:bodyPr wrap="square" lIns="0" rIns="0" tIns="0" bIns="0" anchor="t">
+            <a:spAutoFit/>
+          </a:bodyPr>
+          <a:lstStyle/>
+          <a:p>
+            <a:pPr algn="l">
+              <a:lnSpc>
+                <a:spcPct val="115000"/>
+              </a:lnSpc>
+            </a:pPr>
+            <a:r>
+              <a:rPr sz="1400" b="1" i="0">
+                <a:solidFill>
+                  <a:srgbClr val="122A52"/>
+                </a:solidFill>
+                <a:latin typeface="Helvetica"/>
+              </a:rPr>
+              <a:t>Opgave</a:t>
+            </a:r>
+          </a:p>
+        </p:txBody>
+      </p:sp>
+      <p:sp>
+        <p:nvSpPr>
+          <p:cNvPr id="11" name="TextBox 10"/>
+          <p:cNvSpPr txBox="1"/>
+          <p:nvPr/>
+        </p:nvSpPr>
+        <p:spPr>
+          <a:xfrm>
+            <a:off x="3639312" y="2606040"/>
+            <a:ext cx="2240280" cy="640080"/>
+          </a:xfrm>
+          <a:prstGeom prst="rect">
+            <a:avLst/>
+          </a:prstGeom>
+          <a:noFill/>
+        </p:spPr>
+        <p:txBody>
+          <a:bodyPr wrap="square" lIns="0" rIns="0" tIns="0" bIns="0" anchor="t">
+            <a:spAutoFit/>
+          </a:bodyPr>
+          <a:lstStyle/>
+          <a:p>
+            <a:pPr algn="l">
+              <a:lnSpc>
+                <a:spcPct val="130000"/>
+              </a:lnSpc>
+            </a:pPr>
+            <a:r>
+              <a:rPr sz="1100" b="0" i="0">
+                <a:solidFill>
+                  <a:srgbClr val="122A52"/>
+                </a:solidFill>
+                <a:latin typeface="Helvetica"/>
+              </a:rPr>
+              <a:t>Hvad vil du
+have gjort?</a:t>
+            </a:r>
+          </a:p>
+        </p:txBody>
+      </p:sp>
+      <p:sp>
+        <p:nvSpPr>
+          <p:cNvPr id="12" name="Rectangle 11"/>
+          <p:cNvSpPr/>
+          <p:nvPr/>
+        </p:nvSpPr>
+        <p:spPr>
+          <a:xfrm>
+            <a:off x="6227064" y="1828800"/>
+            <a:ext cx="2697480" cy="1417320"/>
+          </a:xfrm>
+          <a:prstGeom prst="rect">
+            <a:avLst/>
+          </a:prstGeom>
+          <a:solidFill>
+            <a:srgbClr val="EEF1F6"/>
+          </a:solidFill>
+          <a:ln>
+            <a:noFill/>
+          </a:ln>
+        </p:spPr>
+        <p:style>
+          <a:lnRef idx="1">
+            <a:schemeClr val="accent1"/>
+          </a:lnRef>
+          <a:fillRef idx="3">
+            <a:schemeClr val="accent1"/>
+          </a:fillRef>
+          <a:effectRef idx="2">
+            <a:schemeClr val="accent1"/>
+          </a:effectRef>
+          <a:fontRef idx="minor">
+            <a:schemeClr val="lt1"/>
+          </a:fontRef>
+        </p:style>
+        <p:txBody>
+          <a:bodyPr rtlCol="0" anchor="ctr"/>
+          <a:lstStyle/>
+          <a:p>
+            <a:pPr algn="ctr"/>
+          </a:p>
+        </p:txBody>
+      </p:sp>
+      <p:sp>
+        <p:nvSpPr>
+          <p:cNvPr id="13" name="Oval 12"/>
+          <p:cNvSpPr/>
+          <p:nvPr/>
+        </p:nvSpPr>
+        <p:spPr>
+          <a:xfrm>
+            <a:off x="6455664" y="2057400"/>
+            <a:ext cx="384048" cy="384048"/>
+          </a:xfrm>
+          <a:prstGeom prst="ellipse">
+            <a:avLst/>
+          </a:prstGeom>
+          <a:solidFill>
+            <a:srgbClr val="122A52"/>
+          </a:solidFill>
+          <a:ln>
+            <a:noFill/>
+          </a:ln>
+        </p:spPr>
+        <p:style>
+          <a:lnRef idx="1">
+            <a:schemeClr val="accent1"/>
+          </a:lnRef>
+          <a:fillRef idx="3">
+            <a:schemeClr val="accent1"/>
+          </a:fillRef>
+          <a:effectRef idx="2">
+            <a:schemeClr val="accent1"/>
+          </a:effectRef>
+          <a:fontRef idx="minor">
+            <a:schemeClr val="lt1"/>
+          </a:fontRef>
+        </p:style>
+        <p:txBody>
+          <a:bodyPr rtlCol="0" anchor="ctr" lIns="0" rIns="0" tIns="0" bIns="0"/>
+          <a:lstStyle/>
+          <a:p>
+            <a:pPr algn="ctr"/>
+            <a:r>
+              <a:rPr sz="1300" b="1">
+                <a:solidFill>
+                  <a:srgbClr val="FFFFFF"/>
+                </a:solidFill>
+                <a:latin typeface="Helvetica"/>
+              </a:rPr>
+              <a:t>3</a:t>
+            </a:r>
+          </a:p>
+        </p:txBody>
+      </p:sp>
+      <p:sp>
+        <p:nvSpPr>
+          <p:cNvPr id="14" name="TextBox 13"/>
+          <p:cNvSpPr txBox="1"/>
+          <p:nvPr/>
+        </p:nvSpPr>
+        <p:spPr>
+          <a:xfrm>
+            <a:off x="6940296" y="2075688"/>
+            <a:ext cx="1783080" cy="365760"/>
+          </a:xfrm>
+          <a:prstGeom prst="rect">
+            <a:avLst/>
+          </a:prstGeom>
+          <a:noFill/>
+        </p:spPr>
+        <p:txBody>
+          <a:bodyPr wrap="square" lIns="0" rIns="0" tIns="0" bIns="0" anchor="t">
+            <a:spAutoFit/>
+          </a:bodyPr>
+          <a:lstStyle/>
+          <a:p>
+            <a:pPr algn="l">
+              <a:lnSpc>
+                <a:spcPct val="115000"/>
+              </a:lnSpc>
+            </a:pPr>
+            <a:r>
+              <a:rPr sz="1400" b="1" i="0">
+                <a:solidFill>
+                  <a:srgbClr val="122A52"/>
+                </a:solidFill>
+                <a:latin typeface="Helvetica"/>
+              </a:rPr>
+              <a:t>Begrænsninger</a:t>
+            </a:r>
+          </a:p>
+        </p:txBody>
+      </p:sp>
+      <p:sp>
+        <p:nvSpPr>
+          <p:cNvPr id="15" name="TextBox 14"/>
+          <p:cNvSpPr txBox="1"/>
+          <p:nvPr/>
+        </p:nvSpPr>
+        <p:spPr>
+          <a:xfrm>
+            <a:off x="6455664" y="2606040"/>
+            <a:ext cx="2240280" cy="640080"/>
+          </a:xfrm>
+          <a:prstGeom prst="rect">
+            <a:avLst/>
+          </a:prstGeom>
+          <a:noFill/>
+        </p:spPr>
+        <p:txBody>
+          <a:bodyPr wrap="square" lIns="0" rIns="0" tIns="0" bIns="0" anchor="t">
+            <a:spAutoFit/>
+          </a:bodyPr>
+          <a:lstStyle/>
+          <a:p>
+            <a:pPr algn="l">
+              <a:lnSpc>
+                <a:spcPct val="130000"/>
+              </a:lnSpc>
+            </a:pPr>
+            <a:r>
+              <a:rPr sz="1100" b="0" i="0">
+                <a:solidFill>
+                  <a:srgbClr val="122A52"/>
+                </a:solidFill>
+                <a:latin typeface="Helvetica"/>
+              </a:rPr>
+              <a:t>Hvad må Claude
+IKKE røre?</a:t>
+            </a:r>
+          </a:p>
+        </p:txBody>
+      </p:sp>
+      <p:sp>
+        <p:nvSpPr>
+          <p:cNvPr id="16" name="Rectangle 15"/>
+          <p:cNvSpPr/>
+          <p:nvPr/>
+        </p:nvSpPr>
+        <p:spPr>
+          <a:xfrm>
+            <a:off x="9043416" y="1828800"/>
+            <a:ext cx="2697480" cy="1417320"/>
+          </a:xfrm>
+          <a:prstGeom prst="rect">
+            <a:avLst/>
+          </a:prstGeom>
+          <a:solidFill>
+            <a:srgbClr val="EEF1F6"/>
+          </a:solidFill>
+          <a:ln>
+            <a:noFill/>
+          </a:ln>
+        </p:spPr>
+        <p:style>
+          <a:lnRef idx="1">
+            <a:schemeClr val="accent1"/>
+          </a:lnRef>
+          <a:fillRef idx="3">
+            <a:schemeClr val="accent1"/>
+          </a:fillRef>
+          <a:effectRef idx="2">
+            <a:schemeClr val="accent1"/>
+          </a:effectRef>
+          <a:fontRef idx="minor">
+            <a:schemeClr val="lt1"/>
+          </a:fontRef>
+        </p:style>
+        <p:txBody>
+          <a:bodyPr rtlCol="0" anchor="ctr"/>
+          <a:lstStyle/>
+          <a:p>
+            <a:pPr algn="ctr"/>
+          </a:p>
+        </p:txBody>
+      </p:sp>
+      <p:sp>
+        <p:nvSpPr>
+          <p:cNvPr id="17" name="Oval 16"/>
+          <p:cNvSpPr/>
+          <p:nvPr/>
+        </p:nvSpPr>
+        <p:spPr>
+          <a:xfrm>
+            <a:off x="9272016" y="2057400"/>
+            <a:ext cx="384048" cy="384048"/>
+          </a:xfrm>
+          <a:prstGeom prst="ellipse">
+            <a:avLst/>
+          </a:prstGeom>
+          <a:solidFill>
+            <a:srgbClr val="122A52"/>
+          </a:solidFill>
+          <a:ln>
+            <a:noFill/>
+          </a:ln>
+        </p:spPr>
+        <p:style>
+          <a:lnRef idx="1">
+            <a:schemeClr val="accent1"/>
+          </a:lnRef>
+          <a:fillRef idx="3">
+            <a:schemeClr val="accent1"/>
+          </a:fillRef>
+          <a:effectRef idx="2">
+            <a:schemeClr val="accent1"/>
+          </a:effectRef>
+          <a:fontRef idx="minor">
+            <a:schemeClr val="lt1"/>
+          </a:fontRef>
+        </p:style>
+        <p:txBody>
+          <a:bodyPr rtlCol="0" anchor="ctr" lIns="0" rIns="0" tIns="0" bIns="0"/>
+          <a:lstStyle/>
+          <a:p>
+            <a:pPr algn="ctr"/>
+            <a:r>
+              <a:rPr sz="1300" b="1">
+                <a:solidFill>
+                  <a:srgbClr val="FFFFFF"/>
+                </a:solidFill>
+                <a:latin typeface="Helvetica"/>
+              </a:rPr>
+              <a:t>4</a:t>
+            </a:r>
+          </a:p>
+        </p:txBody>
+      </p:sp>
+      <p:sp>
+        <p:nvSpPr>
+          <p:cNvPr id="18" name="TextBox 17"/>
+          <p:cNvSpPr txBox="1"/>
+          <p:nvPr/>
+        </p:nvSpPr>
+        <p:spPr>
+          <a:xfrm>
+            <a:off x="9756648" y="2075688"/>
+            <a:ext cx="1783080" cy="365760"/>
+          </a:xfrm>
+          <a:prstGeom prst="rect">
+            <a:avLst/>
+          </a:prstGeom>
+          <a:noFill/>
+        </p:spPr>
+        <p:txBody>
+          <a:bodyPr wrap="square" lIns="0" rIns="0" tIns="0" bIns="0" anchor="t">
+            <a:spAutoFit/>
+          </a:bodyPr>
+          <a:lstStyle/>
+          <a:p>
+            <a:pPr algn="l">
+              <a:lnSpc>
+                <a:spcPct val="115000"/>
+              </a:lnSpc>
+            </a:pPr>
+            <a:r>
+              <a:rPr sz="1400" b="1" i="0">
+                <a:solidFill>
+                  <a:srgbClr val="122A52"/>
+                </a:solidFill>
+                <a:latin typeface="Helvetica"/>
+              </a:rPr>
+              <a:t>Forventet output</a:t>
+            </a:r>
+          </a:p>
+        </p:txBody>
+      </p:sp>
+      <p:sp>
+        <p:nvSpPr>
+          <p:cNvPr id="19" name="TextBox 18"/>
+          <p:cNvSpPr txBox="1"/>
+          <p:nvPr/>
+        </p:nvSpPr>
+        <p:spPr>
+          <a:xfrm>
+            <a:off x="9272016" y="2606040"/>
+            <a:ext cx="2240280" cy="640080"/>
+          </a:xfrm>
+          <a:prstGeom prst="rect">
+            <a:avLst/>
+          </a:prstGeom>
+          <a:noFill/>
+        </p:spPr>
+        <p:txBody>
+          <a:bodyPr wrap="square" lIns="0" rIns="0" tIns="0" bIns="0" anchor="t">
+            <a:spAutoFit/>
+          </a:bodyPr>
+          <a:lstStyle/>
+          <a:p>
+            <a:pPr algn="l">
+              <a:lnSpc>
+                <a:spcPct val="130000"/>
+              </a:lnSpc>
+            </a:pPr>
+            <a:r>
+              <a:rPr sz="1100" b="0" i="0">
+                <a:solidFill>
+                  <a:srgbClr val="122A52"/>
+                </a:solidFill>
+                <a:latin typeface="Helvetica"/>
+              </a:rPr>
+              <a:t>Hvad ser "done"
+ud som?</a:t>
+            </a:r>
+          </a:p>
+        </p:txBody>
+      </p:sp>
+      <p:sp>
+        <p:nvSpPr>
+          <p:cNvPr id="20" name="TextBox 19"/>
+          <p:cNvSpPr txBox="1"/>
+          <p:nvPr/>
+        </p:nvSpPr>
+        <p:spPr>
+          <a:xfrm>
+            <a:off x="594360" y="3520440"/>
+            <a:ext cx="10972800" cy="365760"/>
+          </a:xfrm>
+          <a:prstGeom prst="rect">
+            <a:avLst/>
+          </a:prstGeom>
+          <a:noFill/>
+        </p:spPr>
+        <p:txBody>
+          <a:bodyPr wrap="square" lIns="0" rIns="0" tIns="0" bIns="0" anchor="t">
+            <a:spAutoFit/>
+          </a:bodyPr>
+          <a:lstStyle/>
+          <a:p>
+            <a:pPr algn="l">
+              <a:lnSpc>
+                <a:spcPct val="115000"/>
+              </a:lnSpc>
+            </a:pPr>
+            <a:r>
+              <a:rPr sz="1300" b="1" i="0">
+                <a:solidFill>
+                  <a:srgbClr val="F5B81C"/>
+                </a:solidFill>
+                <a:latin typeface="Menlo"/>
+              </a:rPr>
+              <a:t>EKSEMPEL — sådan kunne en god prompt se ud:</a:t>
+            </a:r>
+          </a:p>
+        </p:txBody>
+      </p:sp>
+      <p:sp>
+        <p:nvSpPr>
+          <p:cNvPr id="21" name="Rounded Rectangle 20"/>
+          <p:cNvSpPr/>
+          <p:nvPr/>
+        </p:nvSpPr>
+        <p:spPr>
+          <a:xfrm>
+            <a:off x="594360" y="3931920"/>
+            <a:ext cx="11018520" cy="2331720"/>
+          </a:xfrm>
+          <a:prstGeom prst="roundRect">
+            <a:avLst>
+              <a:gd name="adj" fmla="val 4000"/>
+            </a:avLst>
+          </a:prstGeom>
+          <a:solidFill>
+            <a:srgbClr val="0F1F3D"/>
+          </a:solidFill>
+          <a:ln>
+            <a:noFill/>
+          </a:ln>
+        </p:spPr>
+        <p:style>
+          <a:lnRef idx="1">
+            <a:schemeClr val="accent1"/>
+          </a:lnRef>
+          <a:fillRef idx="3">
+            <a:schemeClr val="accent1"/>
+          </a:fillRef>
+          <a:effectRef idx="2">
+            <a:schemeClr val="accent1"/>
+          </a:effectRef>
+          <a:fontRef idx="minor">
+            <a:schemeClr val="lt1"/>
+          </a:fontRef>
+        </p:style>
+        <p:txBody>
+          <a:bodyPr rtlCol="0" anchor="ctr"/>
+          <a:lstStyle/>
+          <a:p>
+            <a:pPr algn="ctr"/>
+          </a:p>
+        </p:txBody>
+      </p:sp>
+      <p:sp>
+        <p:nvSpPr>
+          <p:cNvPr id="22" name="TextBox 21"/>
+          <p:cNvSpPr txBox="1"/>
+          <p:nvPr/>
+        </p:nvSpPr>
+        <p:spPr>
+          <a:xfrm>
+            <a:off x="868680" y="4069080"/>
+            <a:ext cx="10469880" cy="2103120"/>
+          </a:xfrm>
+          <a:prstGeom prst="rect">
+            <a:avLst/>
+          </a:prstGeom>
+          <a:noFill/>
+        </p:spPr>
+        <p:txBody>
+          <a:bodyPr wrap="square" lIns="0" rIns="0" tIns="0" bIns="0">
+            <a:spAutoFit/>
+          </a:bodyPr>
+          <a:lstStyle/>
+          <a:p>
+            <a:pPr>
+              <a:lnSpc>
+                <a:spcPct val="140000"/>
+              </a:lnSpc>
+              <a:spcAft>
+                <a:spcPts val="800"/>
+              </a:spcAft>
+            </a:pPr>
+            <a:r>
+              <a:rPr sz="1300" b="1">
+                <a:solidFill>
+                  <a:srgbClr val="F5B81C"/>
+                </a:solidFill>
+                <a:latin typeface="Menlo"/>
+              </a:rPr>
+              <a:t>[1] </a:t>
+            </a:r>
+            <a:r>
+              <a:rPr sz="1300">
+                <a:solidFill>
+                  <a:srgbClr val="E2E8F0"/>
+                </a:solidFill>
+                <a:latin typeface="Menlo"/>
+              </a:rPr>
+              <a:t>Læs lib/propertyService.ts.</a:t>
+            </a:r>
+          </a:p>
+          <a:p>
+            <a:pPr>
+              <a:lnSpc>
+                <a:spcPct val="140000"/>
+              </a:lnSpc>
+              <a:spcAft>
+                <a:spcPts val="800"/>
+              </a:spcAft>
+            </a:pPr>
+            <a:r>
+              <a:rPr sz="1300" b="1">
+                <a:solidFill>
+                  <a:srgbClr val="F5B81C"/>
+                </a:solidFill>
+                <a:latin typeface="Menlo"/>
+              </a:rPr>
+              <a:t>[2] </a:t>
+            </a:r>
+            <a:r>
+              <a:rPr sz="1300">
+                <a:solidFill>
+                  <a:srgbClr val="E2E8F0"/>
+                </a:solidFill>
+                <a:latin typeface="Menlo"/>
+              </a:rPr>
+              <a:t>Tilføj findByCity(city: string) der returnerer alle boliger i en given by.</a:t>
+            </a:r>
+          </a:p>
+          <a:p>
+            <a:pPr>
+              <a:lnSpc>
+                <a:spcPct val="140000"/>
+              </a:lnSpc>
+              <a:spcAft>
+                <a:spcPts val="800"/>
+              </a:spcAft>
+            </a:pPr>
+            <a:r>
+              <a:rPr sz="1300" b="1">
+                <a:solidFill>
+                  <a:srgbClr val="F5B81C"/>
+                </a:solidFill>
+                <a:latin typeface="Menlo"/>
+              </a:rPr>
+              <a:t>[3] </a:t>
+            </a:r>
+            <a:r>
+              <a:rPr sz="1300">
+                <a:solidFill>
+                  <a:srgbClr val="E2E8F0"/>
+                </a:solidFill>
+                <a:latin typeface="Menlo"/>
+              </a:rPr>
+              <a:t>Rør ikke getAll eller findById. Ingen commit.</a:t>
+            </a:r>
+          </a:p>
+          <a:p>
+            <a:pPr>
+              <a:lnSpc>
+                <a:spcPct val="140000"/>
+              </a:lnSpc>
+              <a:spcAft>
+                <a:spcPts val="800"/>
+              </a:spcAft>
+            </a:pPr>
+            <a:r>
+              <a:rPr sz="1300" b="1">
+                <a:solidFill>
+                  <a:srgbClr val="F5B81C"/>
+                </a:solidFill>
+                <a:latin typeface="Menlo"/>
+              </a:rPr>
+              <a:t>[4] </a:t>
+            </a:r>
+            <a:r>
+              <a:rPr sz="1300">
+                <a:solidFill>
+                  <a:srgbClr val="E2E8F0"/>
+                </a:solidFill>
+                <a:latin typeface="Menlo"/>
+              </a:rPr>
+              <a:t>Forventet: findByCity("Hellerup") returnerer 1 bolig.</a:t>
+            </a:r>
+          </a:p>
+        </p:txBody>
+      </p:sp>
+      <p:sp>
+        <p:nvSpPr>
+          <p:cNvPr id="23" name="TextBox 22"/>
+          <p:cNvSpPr txBox="1"/>
+          <p:nvPr/>
+        </p:nvSpPr>
+        <p:spPr>
+          <a:xfrm>
+            <a:off x="594360" y="6400800"/>
+            <a:ext cx="10972800" cy="274320"/>
+          </a:xfrm>
+          <a:prstGeom prst="rect">
+            <a:avLst/>
+          </a:prstGeom>
+          <a:noFill/>
+        </p:spPr>
+        <p:txBody>
+          <a:bodyPr wrap="square" lIns="0" rIns="0" tIns="0" bIns="0" anchor="t">
+            <a:spAutoFit/>
+          </a:bodyPr>
+          <a:lstStyle/>
+          <a:p>
+            <a:pPr algn="ctr">
+              <a:lnSpc>
+                <a:spcPct val="115000"/>
+              </a:lnSpc>
+            </a:pPr>
+            <a:r>
+              <a:rPr sz="1100" b="0" i="1">
+                <a:solidFill>
+                  <a:srgbClr val="556B8A"/>
+                </a:solidFill>
+                <a:latin typeface="Helvetica"/>
+              </a:rPr>
+              <a:t>Skriv først en hurtig prompt — så git checkout . + /clear — så samme opgave med strukturen.</a:t>
+            </a:r>
+          </a:p>
+        </p:txBody>
+      </p:sp>
+      <p:sp>
+        <p:nvSpPr>
+          <p:cNvPr id="24" name="Rectangle 23"/>
+          <p:cNvSpPr/>
+          <p:nvPr/>
+        </p:nvSpPr>
+        <p:spPr>
+          <a:xfrm>
+            <a:off x="0" y="0"/>
+            <a:ext cx="12191695" cy="164592"/>
+          </a:xfrm>
+          <a:prstGeom prst="rect">
+            <a:avLst/>
+          </a:prstGeom>
+          <a:solidFill>
+            <a:srgbClr val="122A52"/>
+          </a:solidFill>
+          <a:ln>
+            <a:noFill/>
+          </a:ln>
+        </p:spPr>
+        <p:style>
+          <a:lnRef idx="1">
+            <a:schemeClr val="accent1"/>
+          </a:lnRef>
+          <a:fillRef idx="3">
+            <a:schemeClr val="accent1"/>
+          </a:fillRef>
+          <a:effectRef idx="2">
+            <a:schemeClr val="accent1"/>
+          </a:effectRef>
+          <a:fontRef idx="minor">
+            <a:schemeClr val="lt1"/>
+          </a:fontRef>
+        </p:style>
+        <p:txBody>
+          <a:bodyPr rtlCol="0" anchor="ctr"/>
+          <a:lstStyle/>
+          <a:p>
+            <a:pPr algn="ctr"/>
+          </a:p>
+        </p:txBody>
+      </p:sp>
+      <p:sp>
+        <p:nvSpPr>
+          <p:cNvPr id="25" name="Rectangle 24"/>
+          <p:cNvSpPr/>
+          <p:nvPr/>
+        </p:nvSpPr>
+        <p:spPr>
+          <a:xfrm>
+            <a:off x="0" y="6693408"/>
+            <a:ext cx="12191695" cy="164592"/>
+          </a:xfrm>
+          <a:prstGeom prst="rect">
+            <a:avLst/>
+          </a:prstGeom>
+          <a:solidFill>
+            <a:srgbClr val="122A52"/>
+          </a:solidFill>
+          <a:ln>
+            <a:noFill/>
+          </a:ln>
+        </p:spPr>
+        <p:style>
+          <a:lnRef idx="1">
+            <a:schemeClr val="accent1"/>
+          </a:lnRef>
+          <a:fillRef idx="3">
+            <a:schemeClr val="accent1"/>
+          </a:fillRef>
+          <a:effectRef idx="2">
+            <a:schemeClr val="accent1"/>
+          </a:effectRef>
+          <a:fontRef idx="minor">
+            <a:schemeClr val="lt1"/>
+          </a:fontRef>
+        </p:style>
+        <p:txBody>
+          <a:bodyPr rtlCol="0" anchor="ctr"/>
+          <a:lstStyle/>
+          <a:p>
+            <a:pPr algn="ctr"/>
+          </a:p>
+        </p:txBody>
+      </p:sp>
+      <p:sp>
+        <p:nvSpPr>
+          <p:cNvPr id="26" name="TextBox 25"/>
+          <p:cNvSpPr txBox="1"/>
+          <p:nvPr/>
+        </p:nvSpPr>
+        <p:spPr>
+          <a:xfrm>
+            <a:off x="365760" y="6400800"/>
+            <a:ext cx="1828800" cy="274320"/>
+          </a:xfrm>
+          <a:prstGeom prst="rect">
+            <a:avLst/>
+          </a:prstGeom>
+          <a:noFill/>
+        </p:spPr>
+        <p:txBody>
+          <a:bodyPr wrap="square" lIns="0" rIns="0" tIns="0" bIns="0" anchor="t">
+            <a:spAutoFit/>
+          </a:bodyPr>
+          <a:lstStyle/>
+          <a:p>
+            <a:pPr algn="l">
+              <a:lnSpc>
+                <a:spcPct val="115000"/>
+              </a:lnSpc>
+            </a:pPr>
+            <a:r>
+              <a:rPr sz="1000" b="0" i="0">
+                <a:solidFill>
+                  <a:srgbClr val="556B8A"/>
+                </a:solidFill>
+                <a:latin typeface="Helvetica"/>
+              </a:rPr>
+              <a:t>11 |</a:t>
+            </a:r>
           </a:p>
         </p:txBody>
       </p:sp>
       <p:pic>
         <p:nvPicPr>
-          <p:cNvPr id="3" name="Picture 2" descr="edc_logo.png"/>
+          <p:cNvPr id="27" name="Picture 26" descr="edc_logo.png"/>
           <p:cNvPicPr>
             <a:picLocks noChangeAspect="1"/>
           </p:cNvPicPr>
@@ -5453,174 +6580,14 @@
         </p:blipFill>
         <p:spPr>
           <a:xfrm>
-            <a:off x="5364327" y="1645920"/>
-            <a:ext cx="1463040" cy="1463040"/>
+            <a:off x="11475720" y="6263640"/>
+            <a:ext cx="594360" cy="594360"/>
           </a:xfrm>
           <a:prstGeom prst="rect">
             <a:avLst/>
           </a:prstGeom>
         </p:spPr>
       </p:pic>
-      <p:sp>
-        <p:nvSpPr>
-          <p:cNvPr id="4" name="TextBox 3"/>
-          <p:cNvSpPr txBox="1"/>
-          <p:nvPr/>
-        </p:nvSpPr>
-        <p:spPr>
-          <a:xfrm>
-            <a:off x="0" y="3657600"/>
-            <a:ext cx="12191695" cy="548640"/>
-          </a:xfrm>
-          <a:prstGeom prst="rect">
-            <a:avLst/>
-          </a:prstGeom>
-          <a:noFill/>
-        </p:spPr>
-        <p:txBody>
-          <a:bodyPr wrap="square" lIns="0" rIns="0" tIns="0" bIns="0" anchor="t">
-            <a:spAutoFit/>
-          </a:bodyPr>
-          <a:lstStyle/>
-          <a:p>
-            <a:pPr algn="ctr">
-              <a:lnSpc>
-                <a:spcPct val="115000"/>
-              </a:lnSpc>
-            </a:pPr>
-            <a:r>
-              <a:rPr sz="2200" b="0" i="0">
-                <a:solidFill>
-                  <a:srgbClr val="F5B81C"/>
-                </a:solidFill>
-                <a:latin typeface="Menlo"/>
-              </a:rPr>
-              <a:t>Punkt 3</a:t>
-            </a:r>
-          </a:p>
-        </p:txBody>
-      </p:sp>
-      <p:sp>
-        <p:nvSpPr>
-          <p:cNvPr id="5" name="TextBox 4"/>
-          <p:cNvSpPr txBox="1"/>
-          <p:nvPr/>
-        </p:nvSpPr>
-        <p:spPr>
-          <a:xfrm>
-            <a:off x="0" y="4297680"/>
-            <a:ext cx="12191695" cy="914400"/>
-          </a:xfrm>
-          <a:prstGeom prst="rect">
-            <a:avLst/>
-          </a:prstGeom>
-          <a:noFill/>
-        </p:spPr>
-        <p:txBody>
-          <a:bodyPr wrap="square" lIns="0" rIns="0" tIns="0" bIns="0" anchor="t">
-            <a:spAutoFit/>
-          </a:bodyPr>
-          <a:lstStyle/>
-          <a:p>
-            <a:pPr algn="ctr">
-              <a:lnSpc>
-                <a:spcPct val="115000"/>
-              </a:lnSpc>
-            </a:pPr>
-            <a:r>
-              <a:rPr sz="4400" b="1" i="0">
-                <a:solidFill>
-                  <a:srgbClr val="FFFFFF"/>
-                </a:solidFill>
-                <a:latin typeface="Helvetica"/>
-              </a:rPr>
-              <a:t>Hands-on</a:t>
-            </a:r>
-          </a:p>
-        </p:txBody>
-      </p:sp>
-      <p:sp>
-        <p:nvSpPr>
-          <p:cNvPr id="6" name="TextBox 5"/>
-          <p:cNvSpPr txBox="1"/>
-          <p:nvPr/>
-        </p:nvSpPr>
-        <p:spPr>
-          <a:xfrm>
-            <a:off x="0" y="5029200"/>
-            <a:ext cx="12191695" cy="548640"/>
-          </a:xfrm>
-          <a:prstGeom prst="rect">
-            <a:avLst/>
-          </a:prstGeom>
-          <a:noFill/>
-        </p:spPr>
-        <p:txBody>
-          <a:bodyPr wrap="square" lIns="0" rIns="0" tIns="0" bIns="0" anchor="t">
-            <a:spAutoFit/>
-          </a:bodyPr>
-          <a:lstStyle/>
-          <a:p>
-            <a:pPr algn="ctr">
-              <a:lnSpc>
-                <a:spcPct val="115000"/>
-              </a:lnSpc>
-            </a:pPr>
-            <a:r>
-              <a:rPr sz="1800" b="0" i="0">
-                <a:solidFill>
-                  <a:srgbClr val="C8D4E8"/>
-                </a:solidFill>
-                <a:latin typeface="Helvetica"/>
-              </a:rPr>
-              <a:t>20 minutter · solo på din egen maskine</a:t>
-            </a:r>
-          </a:p>
-        </p:txBody>
-      </p:sp>
-      <p:sp>
-        <p:nvSpPr>
-          <p:cNvPr id="7" name="Rectangle 6"/>
-          <p:cNvSpPr/>
-          <p:nvPr/>
-        </p:nvSpPr>
-        <p:spPr>
-          <a:xfrm>
-            <a:off x="0" y="6693408"/>
-            <a:ext cx="12191695" cy="164592"/>
-          </a:xfrm>
-          <a:prstGeom prst="rect">
-            <a:avLst/>
-          </a:prstGeom>
-          <a:solidFill>
-            <a:srgbClr val="F5B81C"/>
-          </a:solidFill>
-          <a:ln>
-            <a:noFill/>
-          </a:ln>
-        </p:spPr>
-        <p:style>
-          <a:lnRef idx="1">
-            <a:schemeClr val="accent1"/>
-          </a:lnRef>
-          <a:fillRef idx="3">
-            <a:schemeClr val="accent1"/>
-          </a:fillRef>
-          <a:effectRef idx="2">
-            <a:schemeClr val="accent1"/>
-          </a:effectRef>
-          <a:fontRef idx="minor">
-            <a:schemeClr val="lt1"/>
-          </a:fontRef>
-        </p:style>
-        <p:txBody>
-          <a:bodyPr rtlCol="0" anchor="ctr"/>
-          <a:lstStyle/>
-          <a:p>
-            <a:pPr algn="ctr"/>
-          </a:p>
-        </p:txBody>
-      </p:sp>
     </p:spTree>
   </p:cSld>
   <p:clrMapOvr>

</xml_diff>

<commit_message>
Cover: tilføj sjove Claude IRL-screenshots
To screenshots fra rigtige Claude-sessioner som icebreaker mens
folk finder pladser:

1. Claude undskylder for at finde på en VS Code-setting
   ("I made that up. There is no claude-code.dangerouslySkipPermissions
   VS Code setting. Sorry about the bad info.")

2. Claude graver 224 sekunder og finder en NullReferenceException
   i en VSTO/WPF-kontekst — rigtigt detektivarbejde med PowerShell-fix

Captions framer kontrasten:
- "Når Claude finder på ting:" + apology
- "...og når Claude graver 224 sekunder for at finde en rigtig bug:"
  + bug-find

Det matcher dagens tema: Claude er ikke perfekt, men hvis du ved
hvordan du prompter, leverer den.

Co-Authored-By: Claude Opus 4.7 (1M context) <noreply@anthropic.com>
</commit_message>
<xml_diff>
--- a/slides/session1.pptx
+++ b/slides/session1.pptx
@@ -4741,8 +4741,8 @@
         </p:nvSpPr>
         <p:spPr>
           <a:xfrm>
-            <a:off x="0" y="2651760"/>
-            <a:ext cx="12191695" cy="548640"/>
+            <a:off x="0" y="457200"/>
+            <a:ext cx="12191695" cy="457200"/>
           </a:xfrm>
           <a:prstGeom prst="rect">
             <a:avLst/>
@@ -4761,7 +4761,7 @@
               </a:lnSpc>
             </a:pPr>
             <a:r>
-              <a:rPr sz="2200" b="0" i="0">
+              <a:rPr sz="1800" b="0" i="0">
                 <a:solidFill>
                   <a:srgbClr val="F5B81C"/>
                 </a:solidFill>
@@ -4780,8 +4780,8 @@
         </p:nvSpPr>
         <p:spPr>
           <a:xfrm>
-            <a:off x="0" y="3291840"/>
-            <a:ext cx="12191695" cy="1097280"/>
+            <a:off x="0" y="914400"/>
+            <a:ext cx="12191695" cy="914400"/>
           </a:xfrm>
           <a:prstGeom prst="rect">
             <a:avLst/>
@@ -4800,7 +4800,7 @@
               </a:lnSpc>
             </a:pPr>
             <a:r>
-              <a:rPr sz="5400" b="1" i="0">
+              <a:rPr sz="4400" b="1" i="0">
                 <a:solidFill>
                   <a:srgbClr val="FFFFFF"/>
                 </a:solidFill>
@@ -4819,8 +4819,8 @@
         </p:nvSpPr>
         <p:spPr>
           <a:xfrm>
-            <a:off x="0" y="4297680"/>
-            <a:ext cx="12191695" cy="548640"/>
+            <a:off x="0" y="1828800"/>
+            <a:ext cx="12191695" cy="365760"/>
           </a:xfrm>
           <a:prstGeom prst="rect">
             <a:avLst/>
@@ -4839,20 +4839,146 @@
               </a:lnSpc>
             </a:pPr>
             <a:r>
-              <a:rPr sz="2000" b="0" i="0">
+              <a:rPr sz="1400" b="0" i="1">
                 <a:solidFill>
                   <a:srgbClr val="C8D4E8"/>
                 </a:solidFill>
                 <a:latin typeface="Helvetica"/>
               </a:rPr>
-              <a:t>Kickoff og fundamentet · EDC × Claude Code</a:t>
-            </a:r>
-          </a:p>
-        </p:txBody>
-      </p:sp>
-      <p:sp>
-        <p:nvSpPr>
-          <p:cNvPr id="6" name="Rectangle 5"/>
+              <a:t>Mens I finder pladser — lidt Claude IRL</a:t>
+            </a:r>
+          </a:p>
+        </p:txBody>
+      </p:sp>
+      <p:sp>
+        <p:nvSpPr>
+          <p:cNvPr id="6" name="TextBox 5"/>
+          <p:cNvSpPr txBox="1"/>
+          <p:nvPr/>
+        </p:nvSpPr>
+        <p:spPr>
+          <a:xfrm>
+            <a:off x="0" y="2468880"/>
+            <a:ext cx="12191695" cy="320040"/>
+          </a:xfrm>
+          <a:prstGeom prst="rect">
+            <a:avLst/>
+          </a:prstGeom>
+          <a:noFill/>
+        </p:spPr>
+        <p:txBody>
+          <a:bodyPr wrap="square" lIns="0" rIns="0" tIns="0" bIns="0" anchor="t">
+            <a:spAutoFit/>
+          </a:bodyPr>
+          <a:lstStyle/>
+          <a:p>
+            <a:pPr algn="ctr">
+              <a:lnSpc>
+                <a:spcPct val="115000"/>
+              </a:lnSpc>
+            </a:pPr>
+            <a:r>
+              <a:rPr sz="1300" b="1" i="0">
+                <a:solidFill>
+                  <a:srgbClr val="F5B81C"/>
+                </a:solidFill>
+                <a:latin typeface="Menlo"/>
+              </a:rPr>
+              <a:t>Når Claude finder på ting:</a:t>
+            </a:r>
+          </a:p>
+        </p:txBody>
+      </p:sp>
+      <p:pic>
+        <p:nvPicPr>
+          <p:cNvPr id="7" name="Picture 6" descr="claude_apology.png"/>
+          <p:cNvPicPr>
+            <a:picLocks noChangeAspect="1"/>
+          </p:cNvPicPr>
+          <p:nvPr/>
+        </p:nvPicPr>
+        <p:blipFill>
+          <a:blip r:embed="rId2"/>
+          <a:stretch>
+            <a:fillRect/>
+          </a:stretch>
+        </p:blipFill>
+        <p:spPr>
+          <a:xfrm>
+            <a:off x="1523847" y="2788920"/>
+            <a:ext cx="9144000" cy="196596"/>
+          </a:xfrm>
+          <a:prstGeom prst="rect">
+            <a:avLst/>
+          </a:prstGeom>
+        </p:spPr>
+      </p:pic>
+      <p:sp>
+        <p:nvSpPr>
+          <p:cNvPr id="8" name="TextBox 7"/>
+          <p:cNvSpPr txBox="1"/>
+          <p:nvPr/>
+        </p:nvSpPr>
+        <p:spPr>
+          <a:xfrm>
+            <a:off x="0" y="3246120"/>
+            <a:ext cx="12191695" cy="320040"/>
+          </a:xfrm>
+          <a:prstGeom prst="rect">
+            <a:avLst/>
+          </a:prstGeom>
+          <a:noFill/>
+        </p:spPr>
+        <p:txBody>
+          <a:bodyPr wrap="square" lIns="0" rIns="0" tIns="0" bIns="0" anchor="t">
+            <a:spAutoFit/>
+          </a:bodyPr>
+          <a:lstStyle/>
+          <a:p>
+            <a:pPr algn="ctr">
+              <a:lnSpc>
+                <a:spcPct val="115000"/>
+              </a:lnSpc>
+            </a:pPr>
+            <a:r>
+              <a:rPr sz="1300" b="1" i="0">
+                <a:solidFill>
+                  <a:srgbClr val="F5B81C"/>
+                </a:solidFill>
+                <a:latin typeface="Menlo"/>
+              </a:rPr>
+              <a:t>...og når Claude graver 224 sekunder for at finde en rigtig bug:</a:t>
+            </a:r>
+          </a:p>
+        </p:txBody>
+      </p:sp>
+      <p:pic>
+        <p:nvPicPr>
+          <p:cNvPr id="9" name="Picture 8" descr="claude_bug_find.png"/>
+          <p:cNvPicPr>
+            <a:picLocks noChangeAspect="1"/>
+          </p:cNvPicPr>
+          <p:nvPr/>
+        </p:nvPicPr>
+        <p:blipFill>
+          <a:blip r:embed="rId3"/>
+          <a:stretch>
+            <a:fillRect/>
+          </a:stretch>
+        </p:blipFill>
+        <p:spPr>
+          <a:xfrm>
+            <a:off x="4952847" y="3611880"/>
+            <a:ext cx="2286000" cy="3026664"/>
+          </a:xfrm>
+          <a:prstGeom prst="rect">
+            <a:avLst/>
+          </a:prstGeom>
+        </p:spPr>
+      </p:pic>
+      <p:sp>
+        <p:nvSpPr>
+          <p:cNvPr id="10" name="Rectangle 9"/>
           <p:cNvSpPr/>
           <p:nvPr/>
         </p:nvSpPr>

</xml_diff>

<commit_message>
Cover: fjern caption-linjer og forstør billederne
- Fjernet "Når Claude finder på ting:" og "...og når Claude graver
  224 sekunder for at finde en rigtig bug:" overskrifterne
- Apology-billedet udvidet fra 10" til 12" bredt — teksten er nu
  meget mere læsbar
- Bug-find-billedet udvidet fra 2.5" × 3.31" til 3.3" × 4.37" —
  fylder næsten hele den nederste halvdel af slidet

Co-Authored-By: Claude Opus 4.7 (1M context) <noreply@anthropic.com>
</commit_message>
<xml_diff>
--- a/slides/session1.pptx
+++ b/slides/session1.pptx
@@ -4741,8 +4741,8 @@
         </p:nvSpPr>
         <p:spPr>
           <a:xfrm>
-            <a:off x="0" y="457200"/>
-            <a:ext cx="12191695" cy="457200"/>
+            <a:off x="0" y="365760"/>
+            <a:ext cx="12191695" cy="365760"/>
           </a:xfrm>
           <a:prstGeom prst="rect">
             <a:avLst/>
@@ -4761,7 +4761,7 @@
               </a:lnSpc>
             </a:pPr>
             <a:r>
-              <a:rPr sz="1800" b="0" i="0">
+              <a:rPr sz="1600" b="0" i="0">
                 <a:solidFill>
                   <a:srgbClr val="F5B81C"/>
                 </a:solidFill>
@@ -4780,8 +4780,8 @@
         </p:nvSpPr>
         <p:spPr>
           <a:xfrm>
-            <a:off x="0" y="914400"/>
-            <a:ext cx="12191695" cy="914400"/>
+            <a:off x="0" y="777240"/>
+            <a:ext cx="12191695" cy="822960"/>
           </a:xfrm>
           <a:prstGeom prst="rect">
             <a:avLst/>
@@ -4800,7 +4800,7 @@
               </a:lnSpc>
             </a:pPr>
             <a:r>
-              <a:rPr sz="4400" b="1" i="0">
+              <a:rPr sz="4200" b="1" i="0">
                 <a:solidFill>
                   <a:srgbClr val="FFFFFF"/>
                 </a:solidFill>
@@ -4819,8 +4819,8 @@
         </p:nvSpPr>
         <p:spPr>
           <a:xfrm>
-            <a:off x="0" y="1828800"/>
-            <a:ext cx="12191695" cy="365760"/>
+            <a:off x="0" y="1691640"/>
+            <a:ext cx="12191695" cy="320040"/>
           </a:xfrm>
           <a:prstGeom prst="rect">
             <a:avLst/>
@@ -4850,48 +4850,9 @@
           </a:p>
         </p:txBody>
       </p:sp>
-      <p:sp>
-        <p:nvSpPr>
-          <p:cNvPr id="6" name="TextBox 5"/>
-          <p:cNvSpPr txBox="1"/>
-          <p:nvPr/>
-        </p:nvSpPr>
-        <p:spPr>
-          <a:xfrm>
-            <a:off x="0" y="2468880"/>
-            <a:ext cx="12191695" cy="320040"/>
-          </a:xfrm>
-          <a:prstGeom prst="rect">
-            <a:avLst/>
-          </a:prstGeom>
-          <a:noFill/>
-        </p:spPr>
-        <p:txBody>
-          <a:bodyPr wrap="square" lIns="0" rIns="0" tIns="0" bIns="0" anchor="t">
-            <a:spAutoFit/>
-          </a:bodyPr>
-          <a:lstStyle/>
-          <a:p>
-            <a:pPr algn="ctr">
-              <a:lnSpc>
-                <a:spcPct val="115000"/>
-              </a:lnSpc>
-            </a:pPr>
-            <a:r>
-              <a:rPr sz="1300" b="1" i="0">
-                <a:solidFill>
-                  <a:srgbClr val="F5B81C"/>
-                </a:solidFill>
-                <a:latin typeface="Menlo"/>
-              </a:rPr>
-              <a:t>Når Claude finder på ting:</a:t>
-            </a:r>
-          </a:p>
-        </p:txBody>
-      </p:sp>
       <p:pic>
         <p:nvPicPr>
-          <p:cNvPr id="7" name="Picture 6" descr="claude_apology.png"/>
+          <p:cNvPr id="6" name="Picture 5" descr="claude_apology.png"/>
           <p:cNvPicPr>
             <a:picLocks noChangeAspect="1"/>
           </p:cNvPicPr>
@@ -4905,56 +4866,17 @@
         </p:blipFill>
         <p:spPr>
           <a:xfrm>
-            <a:off x="1523847" y="2788920"/>
-            <a:ext cx="9144000" cy="196596"/>
+            <a:off x="609447" y="2286000"/>
+            <a:ext cx="10972800" cy="235915"/>
           </a:xfrm>
           <a:prstGeom prst="rect">
             <a:avLst/>
           </a:prstGeom>
         </p:spPr>
       </p:pic>
-      <p:sp>
-        <p:nvSpPr>
-          <p:cNvPr id="8" name="TextBox 7"/>
-          <p:cNvSpPr txBox="1"/>
-          <p:nvPr/>
-        </p:nvSpPr>
-        <p:spPr>
-          <a:xfrm>
-            <a:off x="0" y="3246120"/>
-            <a:ext cx="12191695" cy="320040"/>
-          </a:xfrm>
-          <a:prstGeom prst="rect">
-            <a:avLst/>
-          </a:prstGeom>
-          <a:noFill/>
-        </p:spPr>
-        <p:txBody>
-          <a:bodyPr wrap="square" lIns="0" rIns="0" tIns="0" bIns="0" anchor="t">
-            <a:spAutoFit/>
-          </a:bodyPr>
-          <a:lstStyle/>
-          <a:p>
-            <a:pPr algn="ctr">
-              <a:lnSpc>
-                <a:spcPct val="115000"/>
-              </a:lnSpc>
-            </a:pPr>
-            <a:r>
-              <a:rPr sz="1300" b="1" i="0">
-                <a:solidFill>
-                  <a:srgbClr val="F5B81C"/>
-                </a:solidFill>
-                <a:latin typeface="Menlo"/>
-              </a:rPr>
-              <a:t>...og når Claude graver 224 sekunder for at finde en rigtig bug:</a:t>
-            </a:r>
-          </a:p>
-        </p:txBody>
-      </p:sp>
       <p:pic>
         <p:nvPicPr>
-          <p:cNvPr id="9" name="Picture 8" descr="claude_bug_find.png"/>
+          <p:cNvPr id="7" name="Picture 6" descr="claude_bug_find.png"/>
           <p:cNvPicPr>
             <a:picLocks noChangeAspect="1"/>
           </p:cNvPicPr>
@@ -4968,8 +4890,8 @@
         </p:blipFill>
         <p:spPr>
           <a:xfrm>
-            <a:off x="4952847" y="3611880"/>
-            <a:ext cx="2286000" cy="3026664"/>
+            <a:off x="4587087" y="2651760"/>
+            <a:ext cx="3017520" cy="3995928"/>
           </a:xfrm>
           <a:prstGeom prst="rect">
             <a:avLst/>
@@ -4978,7 +4900,7 @@
       </p:pic>
       <p:sp>
         <p:nvSpPr>
-          <p:cNvPr id="10" name="Rectangle 9"/>
+          <p:cNvPr id="8" name="Rectangle 7"/>
           <p:cNvSpPr/>
           <p:nvPr/>
         </p:nvSpPr>

</xml_diff>

<commit_message>
Tilføj jazz-baggrundsmusik til cover-slide
atlasaudio-jazz-519632.mp3 (4.5MB) embedded i slide 1 med autoplay
og loop. Spiller mens folk finder pladser, stopper når Matias klikker
videre til slide 2.

Co-Authored-By: Claude Opus 4.7 (1M context) <noreply@anthropic.com>
</commit_message>
<xml_diff>
--- a/slides/session1.pptx
+++ b/slides/session1.pptx
@@ -4941,11 +4941,114 @@
           </a:p>
         </p:txBody>
       </p:sp>
+      <p:pic>
+        <p:nvPicPr>
+          <p:cNvPr id="9" name="music.mp3">
+            <a:hlinkClick r:id="" action="ppaction://media"/>
+          </p:cNvPr>
+          <p:cNvPicPr>
+            <a:picLocks noChangeAspect="1"/>
+          </p:cNvPicPr>
+          <p:nvPr>
+            <a:videoFile r:link="rId5"/>
+            <p:extLst>
+              <p:ext uri="{DAA4B4D4-6D71-4841-9C94-3DE7FCFB9230}">
+                <p14:media xmlns:p14="http://schemas.microsoft.com/office/powerpoint/2010/main" r:embed="rId4"/>
+              </p:ext>
+            </p:extLst>
+          </p:nvPr>
+        </p:nvPicPr>
+        <p:blipFill>
+          <a:blip r:embed="rId6"/>
+          <a:stretch>
+            <a:fillRect/>
+          </a:stretch>
+        </p:blipFill>
+        <p:spPr>
+          <a:xfrm>
+            <a:off x="-457200" y="-457200"/>
+            <a:ext cx="365760" cy="365760"/>
+          </a:xfrm>
+          <a:prstGeom prst="rect">
+            <a:avLst/>
+          </a:prstGeom>
+        </p:spPr>
+      </p:pic>
     </p:spTree>
   </p:cSld>
   <p:clrMapOvr>
     <a:masterClrMapping/>
   </p:clrMapOvr>
+  <p:timing>
+    <p:tnLst>
+      <p:par>
+        <p:cTn id="1" dur="indefinite" restart="never" nodeType="tmRoot">
+          <p:childTnLst>
+            <p:seq concurrent="1" nextAc="seek">
+              <p:cTn id="2" dur="indefinite" nodeType="mainSeq">
+                <p:childTnLst>
+                  <p:par>
+                    <p:cTn id="3" fill="hold">
+                      <p:stCondLst>
+                        <p:cond delay="indefinite"/>
+                      </p:stCondLst>
+                      <p:childTnLst>
+                        <p:par>
+                          <p:cTn id="4" fill="hold">
+                            <p:stCondLst>
+                              <p:cond delay="0"/>
+                            </p:stCondLst>
+                            <p:childTnLst>
+                              <p:par>
+                                <p:cTn id="5" presetID="1" presetClass="mediacall" presetSubtype="0" fill="hold" nodeType="afterEffect">
+                                  <p:stCondLst>
+                                    <p:cond delay="0"/>
+                                  </p:stCondLst>
+                                  <p:childTnLst>
+                                    <p:cmd type="call" cmd="playFrom(0.0)">
+                                      <p:cBhvr>
+                                        <p:cTn id="6" dur="indefinite"/>
+                                        <p:tgtEl>
+                                          <p:spTgt spid="9"/>
+                                        </p:tgtEl>
+                                      </p:cBhvr>
+                                    </p:cmd>
+                                  </p:childTnLst>
+                                </p:cTn>
+                              </p:par>
+                            </p:childTnLst>
+                          </p:cTn>
+                        </p:par>
+                      </p:childTnLst>
+                    </p:cTn>
+                    <p:nextCondLst>
+                      <p:cond evt="onNext" delay="0">
+                        <p:tgtEl>
+                          <p:sldTgt/>
+                        </p:tgtEl>
+                      </p:cond>
+                    </p:nextCondLst>
+                  </p:par>
+                </p:childTnLst>
+              </p:cTn>
+            </p:seq>
+            <p:audio>
+              <p:cMediaNode vol="80000">
+                <p:cTn id="7" repeatCount="indefinite" fill="hold" display="0">
+                  <p:stCondLst>
+                    <p:cond delay="indefinite"/>
+                  </p:stCondLst>
+                </p:cTn>
+                <p:tgtEl>
+                  <p:spTgt spid="9"/>
+                </p:tgtEl>
+              </p:cMediaNode>
+            </p:audio>
+          </p:childTnLst>
+        </p:cTn>
+      </p:par>
+    </p:tnLst>
+  </p:timing>
 </p:sld>
 </file>
 

</xml_diff>

<commit_message>
Slide 5 (Dagens kerne): tilføj "Den første prompt er den vigtigste"
Ny navy callout-blok nederst med gul "OG VIGTIGST AF ALT" eyebrow
og hvid hovedtekst. Pointen: når Claude først er i gang i en
forkert retning, er det svært at rette kursen. Bedre at bruge
30 sek ekstra på prompten end 10 min på at rydde op bagefter.

Speaker-noten er udvidet med pause + uddybning af pointen.

Co-Authored-By: Claude Opus 4.7 (1M context) <noreply@anthropic.com>
</commit_message>
<xml_diff>
--- a/slides/session1.pptx
+++ b/slides/session1.pptx
@@ -1178,7 +1178,7 @@
           </a:p>
           <a:p>
             <a:r>
-              <a:t>Saml i ÉN sætning · 0:13–0:15. Sig den langsomt. Det er hele dagen i én linje.</a:t>
+              <a:t>Saml i ÉN sætning · 0:13–0:15. Sig de tre linjer langsomt. Den sidste — "den første prompt er den vigtigste" — er nøgle-pointen: når Claude først er i gang med en svag retning, er det svært at rette kursen. Bedre at bruge 30 sek ekstra på prompten end 10 min på at rydde op.</a:t>
             </a:r>
           </a:p>
           <a:p/>
@@ -1201,7 +1201,19 @@
           <a:p/>
           <a:p>
             <a:r>
-              <a:t>"Forskellen er hvor præcist du beskriver opgaven for Claude. Det er det vi træner i dag."</a:t>
+              <a:t>"Forskellen er hvor præcist du beskriver opgaven for Claude."</a:t>
+            </a:r>
+          </a:p>
+          <a:p/>
+          <a:p>
+            <a:r>
+              <a:t>[Pause. Peg på det navy-felt nederst.]</a:t>
+            </a:r>
+          </a:p>
+          <a:p/>
+          <a:p>
+            <a:r>
+              <a:t>"Og den vigtigste prompt er den første. Når Claude er i gang i en forkert retning, er det svært at rette kursen. Bedre at bruge 30 sekunder ekstra på den første prompt end 10 minutter på at rydde op bagefter."</a:t>
             </a:r>
           </a:p>
         </p:txBody>
@@ -8844,8 +8856,8 @@
         </p:nvSpPr>
         <p:spPr>
           <a:xfrm>
-            <a:off x="548640" y="2468880"/>
-            <a:ext cx="11155680" cy="822960"/>
+            <a:off x="548640" y="2011680"/>
+            <a:ext cx="11155680" cy="777240"/>
           </a:xfrm>
           <a:prstGeom prst="rect">
             <a:avLst/>
@@ -8864,7 +8876,7 @@
               </a:lnSpc>
             </a:pPr>
             <a:r>
-              <a:rPr sz="3400" b="1" i="0">
+              <a:rPr sz="3200" b="1" i="0">
                 <a:solidFill>
                   <a:srgbClr val="556B8A"/>
                 </a:solidFill>
@@ -8883,8 +8895,8 @@
         </p:nvSpPr>
         <p:spPr>
           <a:xfrm>
-            <a:off x="548640" y="3383280"/>
-            <a:ext cx="11155680" cy="822960"/>
+            <a:off x="548640" y="2788920"/>
+            <a:ext cx="11155680" cy="777240"/>
           </a:xfrm>
           <a:prstGeom prst="rect">
             <a:avLst/>
@@ -8903,7 +8915,7 @@
               </a:lnSpc>
             </a:pPr>
             <a:r>
-              <a:rPr sz="3400" b="1" i="0">
+              <a:rPr sz="3200" b="1" i="0">
                 <a:solidFill>
                   <a:srgbClr val="122A52"/>
                 </a:solidFill>
@@ -8922,8 +8934,8 @@
         </p:nvSpPr>
         <p:spPr>
           <a:xfrm>
-            <a:off x="548640" y="5029200"/>
-            <a:ext cx="11091672" cy="914400"/>
+            <a:off x="548640" y="3977639"/>
+            <a:ext cx="11091672" cy="822960"/>
           </a:xfrm>
           <a:prstGeom prst="rect">
             <a:avLst/>
@@ -8965,8 +8977,8 @@
         </p:nvSpPr>
         <p:spPr>
           <a:xfrm>
-            <a:off x="548640" y="5029200"/>
-            <a:ext cx="11091672" cy="914400"/>
+            <a:off x="548640" y="3977639"/>
+            <a:ext cx="11091672" cy="822960"/>
           </a:xfrm>
           <a:prstGeom prst="rect">
             <a:avLst/>
@@ -8985,7 +8997,7 @@
               </a:lnSpc>
             </a:pPr>
             <a:r>
-              <a:rPr sz="2200" b="0" i="0">
+              <a:rPr sz="2000" b="0" i="0">
                 <a:solidFill>
                   <a:srgbClr val="122A52"/>
                 </a:solidFill>
@@ -9004,8 +9016,8 @@
         </p:nvSpPr>
         <p:spPr>
           <a:xfrm>
-            <a:off x="0" y="0"/>
-            <a:ext cx="12191695" cy="164592"/>
+            <a:off x="548640" y="4983480"/>
+            <a:ext cx="11091672" cy="1143000"/>
           </a:xfrm>
           <a:prstGeom prst="rect">
             <a:avLst/>
@@ -9041,13 +9053,91 @@
       </p:sp>
       <p:sp>
         <p:nvSpPr>
-          <p:cNvPr id="9" name="Rectangle 8"/>
+          <p:cNvPr id="9" name="TextBox 8"/>
+          <p:cNvSpPr txBox="1"/>
+          <p:nvPr/>
+        </p:nvSpPr>
+        <p:spPr>
+          <a:xfrm>
+            <a:off x="548640" y="5120640"/>
+            <a:ext cx="11091672" cy="320040"/>
+          </a:xfrm>
+          <a:prstGeom prst="rect">
+            <a:avLst/>
+          </a:prstGeom>
+          <a:noFill/>
+        </p:spPr>
+        <p:txBody>
+          <a:bodyPr wrap="square" lIns="0" rIns="0" tIns="0" bIns="0" anchor="t">
+            <a:spAutoFit/>
+          </a:bodyPr>
+          <a:lstStyle/>
+          <a:p>
+            <a:pPr algn="ctr">
+              <a:lnSpc>
+                <a:spcPct val="115000"/>
+              </a:lnSpc>
+            </a:pPr>
+            <a:r>
+              <a:rPr sz="1200" b="1" i="0">
+                <a:solidFill>
+                  <a:srgbClr val="F5B81C"/>
+                </a:solidFill>
+                <a:latin typeface="Menlo"/>
+              </a:rPr>
+              <a:t>OG VIGTIGST AF ALT</a:t>
+            </a:r>
+          </a:p>
+        </p:txBody>
+      </p:sp>
+      <p:sp>
+        <p:nvSpPr>
+          <p:cNvPr id="10" name="TextBox 9"/>
+          <p:cNvSpPr txBox="1"/>
+          <p:nvPr/>
+        </p:nvSpPr>
+        <p:spPr>
+          <a:xfrm>
+            <a:off x="548640" y="5440680"/>
+            <a:ext cx="11091672" cy="640080"/>
+          </a:xfrm>
+          <a:prstGeom prst="rect">
+            <a:avLst/>
+          </a:prstGeom>
+          <a:noFill/>
+        </p:spPr>
+        <p:txBody>
+          <a:bodyPr wrap="square" lIns="0" rIns="0" tIns="0" bIns="0" anchor="t">
+            <a:spAutoFit/>
+          </a:bodyPr>
+          <a:lstStyle/>
+          <a:p>
+            <a:pPr algn="ctr">
+              <a:lnSpc>
+                <a:spcPct val="115000"/>
+              </a:lnSpc>
+            </a:pPr>
+            <a:r>
+              <a:rPr sz="2600" b="1" i="0">
+                <a:solidFill>
+                  <a:srgbClr val="FFFFFF"/>
+                </a:solidFill>
+                <a:latin typeface="Helvetica"/>
+              </a:rPr>
+              <a:t>Den første prompt er den vigtigste.</a:t>
+            </a:r>
+          </a:p>
+        </p:txBody>
+      </p:sp>
+      <p:sp>
+        <p:nvSpPr>
+          <p:cNvPr id="11" name="Rectangle 10"/>
           <p:cNvSpPr/>
           <p:nvPr/>
         </p:nvSpPr>
         <p:spPr>
           <a:xfrm>
-            <a:off x="0" y="6693408"/>
+            <a:off x="0" y="0"/>
             <a:ext cx="12191695" cy="164592"/>
           </a:xfrm>
           <a:prstGeom prst="rect">
@@ -9084,7 +9174,50 @@
       </p:sp>
       <p:sp>
         <p:nvSpPr>
-          <p:cNvPr id="10" name="TextBox 9"/>
+          <p:cNvPr id="12" name="Rectangle 11"/>
+          <p:cNvSpPr/>
+          <p:nvPr/>
+        </p:nvSpPr>
+        <p:spPr>
+          <a:xfrm>
+            <a:off x="0" y="6693408"/>
+            <a:ext cx="12191695" cy="164592"/>
+          </a:xfrm>
+          <a:prstGeom prst="rect">
+            <a:avLst/>
+          </a:prstGeom>
+          <a:solidFill>
+            <a:srgbClr val="122A52"/>
+          </a:solidFill>
+          <a:ln>
+            <a:noFill/>
+          </a:ln>
+        </p:spPr>
+        <p:style>
+          <a:lnRef idx="1">
+            <a:schemeClr val="accent1"/>
+          </a:lnRef>
+          <a:fillRef idx="3">
+            <a:schemeClr val="accent1"/>
+          </a:fillRef>
+          <a:effectRef idx="2">
+            <a:schemeClr val="accent1"/>
+          </a:effectRef>
+          <a:fontRef idx="minor">
+            <a:schemeClr val="lt1"/>
+          </a:fontRef>
+        </p:style>
+        <p:txBody>
+          <a:bodyPr rtlCol="0" anchor="ctr"/>
+          <a:lstStyle/>
+          <a:p>
+            <a:pPr algn="ctr"/>
+          </a:p>
+        </p:txBody>
+      </p:sp>
+      <p:sp>
+        <p:nvSpPr>
+          <p:cNvPr id="13" name="TextBox 12"/>
           <p:cNvSpPr txBox="1"/>
           <p:nvPr/>
         </p:nvSpPr>
@@ -9123,7 +9256,7 @@
       </p:sp>
       <p:pic>
         <p:nvPicPr>
-          <p:cNvPr id="11" name="Picture 10" descr="edc_logo.png"/>
+          <p:cNvPr id="14" name="Picture 13" descr="edc_logo.png"/>
           <p:cNvPicPr>
             <a:picLocks noChangeAspect="1"/>
           </p:cNvPicPr>

</xml_diff>

<commit_message>
slides: opdater session1 og tilføj notes-PDF til reMarkable
Co-Authored-By: Claude Opus 4.7 (1M context) <noreply@anthropic.com>
</commit_message>
<xml_diff>
--- a/slides/session1.pptx
+++ b/slides/session1.pptx
@@ -4,20 +4,23 @@
   <p:sldMasterIdLst>
     <p:sldMasterId id="2147483648" r:id="rId1"/>
   </p:sldMasterIdLst>
+  <p:notesMasterIdLst>
+    <p:notesMasterId r:id="rId13"/>
+  </p:notesMasterIdLst>
   <p:sldIdLst>
-    <p:sldId id="256" r:id="rId7"/>
-    <p:sldId id="257" r:id="rId9"/>
-    <p:sldId id="258" r:id="rId10"/>
-    <p:sldId id="259" r:id="rId11"/>
-    <p:sldId id="260" r:id="rId12"/>
-    <p:sldId id="261" r:id="rId13"/>
-    <p:sldId id="262" r:id="rId14"/>
-    <p:sldId id="263" r:id="rId15"/>
-    <p:sldId id="264" r:id="rId16"/>
-    <p:sldId id="265" r:id="rId17"/>
-    <p:sldId id="266" r:id="rId18"/>
+    <p:sldId id="256" r:id="rId2"/>
+    <p:sldId id="257" r:id="rId3"/>
+    <p:sldId id="258" r:id="rId4"/>
+    <p:sldId id="259" r:id="rId5"/>
+    <p:sldId id="260" r:id="rId6"/>
+    <p:sldId id="261" r:id="rId7"/>
+    <p:sldId id="262" r:id="rId8"/>
+    <p:sldId id="263" r:id="rId9"/>
+    <p:sldId id="264" r:id="rId10"/>
+    <p:sldId id="265" r:id="rId11"/>
+    <p:sldId id="266" r:id="rId12"/>
   </p:sldIdLst>
-  <p:sldSz cx="12191695" cy="6858000" type="screen4x3"/>
+  <p:sldSz cx="12192000" cy="6858000"/>
   <p:notesSz cx="6858000" cy="9144000"/>
   <p:defaultTextStyle>
     <a:defPPr>
@@ -114,11 +117,27 @@
       </a:defRPr>
     </a:lvl9pPr>
   </p:defaultTextStyle>
+  <p:extLst>
+    <p:ext uri="{EFAFB233-063F-42B5-8137-9DF3F51BA10A}">
+      <p15:sldGuideLst xmlns:p15="http://schemas.microsoft.com/office/powerpoint/2012/main">
+        <p15:guide id="1" orient="horz" pos="2160">
+          <p15:clr>
+            <a:srgbClr val="A4A3A4"/>
+          </p15:clr>
+        </p15:guide>
+        <p15:guide id="2" pos="2880">
+          <p15:clr>
+            <a:srgbClr val="A4A3A4"/>
+          </p15:clr>
+        </p15:guide>
+      </p15:sldGuideLst>
+    </p:ext>
+  </p:extLst>
 </p:presentation>
 </file>
 
 <file path=ppt/notesMasters/notesMaster1.xml><?xml version="1.0" encoding="utf-8"?>
-<p:notesMaster xmlns:a="http://schemas.openxmlformats.org/drawingml/2006/main" xmlns:p="http://schemas.openxmlformats.org/presentationml/2006/main" xmlns:r="http://schemas.openxmlformats.org/officeDocument/2006/relationships">
+<p:notesMaster xmlns:a="http://schemas.openxmlformats.org/drawingml/2006/main" xmlns:r="http://schemas.openxmlformats.org/officeDocument/2006/relationships" xmlns:p="http://schemas.openxmlformats.org/presentationml/2006/main">
   <p:cSld>
     <p:bg>
       <p:bgRef idx="1001">
@@ -139,241 +158,16 @@
           <a:chExt cx="0" cy="0"/>
         </a:xfrm>
       </p:grpSpPr>
-      <p:sp>
-        <p:nvSpPr>
-          <p:cNvPr id="2" name="Header Placeholder 1"/>
-          <p:cNvSpPr>
-            <a:spLocks noGrp="1"/>
-          </p:cNvSpPr>
-          <p:nvPr>
-            <p:ph type="hdr" sz="quarter"/>
-          </p:nvPr>
-        </p:nvSpPr>
-        <p:spPr>
-          <a:xfrm>
-            <a:off x="0" y="0"/>
-            <a:ext cx="2971800" cy="457200"/>
-          </a:xfrm>
-          <a:prstGeom prst="rect">
-            <a:avLst/>
-          </a:prstGeom>
-        </p:spPr>
-        <p:txBody>
-          <a:bodyPr vert="horz" lIns="91440" tIns="45720" rIns="91440" bIns="45720" rtlCol="0"/>
-          <a:lstStyle>
-            <a:lvl1pPr algn="l">
-              <a:defRPr sz="1200"/>
-            </a:lvl1pPr>
-          </a:lstStyle>
-          <a:p>
-            <a:endParaRPr lang="en-US"/>
-          </a:p>
-        </p:txBody>
-      </p:sp>
-      <p:sp>
-        <p:nvSpPr>
-          <p:cNvPr id="3" name="Date Placeholder 2"/>
-          <p:cNvSpPr>
-            <a:spLocks noGrp="1"/>
-          </p:cNvSpPr>
-          <p:nvPr>
-            <p:ph type="dt" idx="1"/>
-          </p:nvPr>
-        </p:nvSpPr>
-        <p:spPr>
-          <a:xfrm>
-            <a:off x="3884613" y="0"/>
-            <a:ext cx="2971800" cy="457200"/>
-          </a:xfrm>
-          <a:prstGeom prst="rect">
-            <a:avLst/>
-          </a:prstGeom>
-        </p:spPr>
-        <p:txBody>
-          <a:bodyPr vert="horz" lIns="91440" tIns="45720" rIns="91440" bIns="45720" rtlCol="0"/>
-          <a:lstStyle>
-            <a:lvl1pPr algn="r">
-              <a:defRPr sz="1200"/>
-            </a:lvl1pPr>
-          </a:lstStyle>
-          <a:p>
-            <a:fld id="{0F89C1C7-3DCD-1040-A9CF-14679D8B5DDD}" type="datetimeFigureOut">
-              <a:rPr lang="en-US" smtClean="0"/>
-              <a:t>10/17/16</a:t>
-            </a:fld>
-            <a:endParaRPr lang="en-US"/>
-          </a:p>
-        </p:txBody>
-      </p:sp>
-      <p:sp>
-        <p:nvSpPr>
-          <p:cNvPr id="4" name="Slide Image Placeholder 3"/>
-          <p:cNvSpPr>
-            <a:spLocks noGrp="1" noRot="1" noChangeAspect="1"/>
-          </p:cNvSpPr>
-          <p:nvPr>
-            <p:ph type="sldImg" idx="2"/>
-          </p:nvPr>
-        </p:nvSpPr>
-        <p:spPr>
-          <a:xfrm>
-            <a:off x="1143000" y="685800"/>
-            <a:ext cx="4572000" cy="3429000"/>
-          </a:xfrm>
-          <a:prstGeom prst="rect">
-            <a:avLst/>
-          </a:prstGeom>
-          <a:noFill/>
-          <a:ln w="12700">
-            <a:solidFill>
-              <a:prstClr val="black"/>
-            </a:solidFill>
-          </a:ln>
-        </p:spPr>
-        <p:txBody>
-          <a:bodyPr vert="horz" lIns="91440" tIns="45720" rIns="91440" bIns="45720" rtlCol="0" anchor="ctr"/>
-          <a:lstStyle/>
-          <a:p>
-            <a:endParaRPr lang="en-US"/>
-          </a:p>
-        </p:txBody>
-      </p:sp>
-      <p:sp>
-        <p:nvSpPr>
-          <p:cNvPr id="5" name="Notes Placeholder 4"/>
-          <p:cNvSpPr>
-            <a:spLocks noGrp="1"/>
-          </p:cNvSpPr>
-          <p:nvPr>
-            <p:ph type="body" sz="quarter" idx="3"/>
-          </p:nvPr>
-        </p:nvSpPr>
-        <p:spPr>
-          <a:xfrm>
-            <a:off x="685800" y="4343400"/>
-            <a:ext cx="5486400" cy="4114800"/>
-          </a:xfrm>
-          <a:prstGeom prst="rect">
-            <a:avLst/>
-          </a:prstGeom>
-        </p:spPr>
-        <p:txBody>
-          <a:bodyPr vert="horz" lIns="91440" tIns="45720" rIns="91440" bIns="45720" rtlCol="0"/>
-          <a:lstStyle/>
-          <a:p>
-            <a:pPr lvl="0"/>
-            <a:r>
-              <a:rPr lang="en-US" smtClean="0"/>
-              <a:t>Click to edit Master text styles</a:t>
-            </a:r>
-          </a:p>
-          <a:p>
-            <a:pPr lvl="1"/>
-            <a:r>
-              <a:rPr lang="en-US" smtClean="0"/>
-              <a:t>Second level</a:t>
-            </a:r>
-          </a:p>
-          <a:p>
-            <a:pPr lvl="2"/>
-            <a:r>
-              <a:rPr lang="en-US" smtClean="0"/>
-              <a:t>Third level</a:t>
-            </a:r>
-          </a:p>
-          <a:p>
-            <a:pPr lvl="3"/>
-            <a:r>
-              <a:rPr lang="en-US" smtClean="0"/>
-              <a:t>Fourth level</a:t>
-            </a:r>
-          </a:p>
-          <a:p>
-            <a:pPr lvl="4"/>
-            <a:r>
-              <a:rPr lang="en-US" smtClean="0"/>
-              <a:t>Fifth level</a:t>
-            </a:r>
-            <a:endParaRPr lang="en-US"/>
-          </a:p>
-        </p:txBody>
-      </p:sp>
-      <p:sp>
-        <p:nvSpPr>
-          <p:cNvPr id="6" name="Footer Placeholder 5"/>
-          <p:cNvSpPr>
-            <a:spLocks noGrp="1"/>
-          </p:cNvSpPr>
-          <p:nvPr>
-            <p:ph type="ftr" sz="quarter" idx="4"/>
-          </p:nvPr>
-        </p:nvSpPr>
-        <p:spPr>
-          <a:xfrm>
-            <a:off x="0" y="8685213"/>
-            <a:ext cx="2971800" cy="457200"/>
-          </a:xfrm>
-          <a:prstGeom prst="rect">
-            <a:avLst/>
-          </a:prstGeom>
-        </p:spPr>
-        <p:txBody>
-          <a:bodyPr vert="horz" lIns="91440" tIns="45720" rIns="91440" bIns="45720" rtlCol="0" anchor="b"/>
-          <a:lstStyle>
-            <a:lvl1pPr algn="l">
-              <a:defRPr sz="1200"/>
-            </a:lvl1pPr>
-          </a:lstStyle>
-          <a:p>
-            <a:endParaRPr lang="en-US"/>
-          </a:p>
-        </p:txBody>
-      </p:sp>
-      <p:sp>
-        <p:nvSpPr>
-          <p:cNvPr id="7" name="Slide Number Placeholder 6"/>
-          <p:cNvSpPr>
-            <a:spLocks noGrp="1"/>
-          </p:cNvSpPr>
-          <p:nvPr>
-            <p:ph type="sldNum" sz="quarter" idx="5"/>
-          </p:nvPr>
-        </p:nvSpPr>
-        <p:spPr>
-          <a:xfrm>
-            <a:off x="3884613" y="8685213"/>
-            <a:ext cx="2971800" cy="457200"/>
-          </a:xfrm>
-          <a:prstGeom prst="rect">
-            <a:avLst/>
-          </a:prstGeom>
-        </p:spPr>
-        <p:txBody>
-          <a:bodyPr vert="horz" lIns="91440" tIns="45720" rIns="91440" bIns="45720" rtlCol="0" anchor="b"/>
-          <a:lstStyle>
-            <a:lvl1pPr algn="r">
-              <a:defRPr sz="1200"/>
-            </a:lvl1pPr>
-          </a:lstStyle>
-          <a:p>
-            <a:fld id="{BB5E49A5-4136-284D-997B-48E1D791AD67}" type="slidenum">
-              <a:rPr lang="en-US" smtClean="0"/>
-              <a:t>‹#›</a:t>
-            </a:fld>
-            <a:endParaRPr lang="en-US"/>
-          </a:p>
-        </p:txBody>
-      </p:sp>
     </p:spTree>
     <p:extLst>
       <p:ext uri="{BB962C8B-B14F-4D97-AF65-F5344CB8AC3E}">
-        <p14:creationId xmlns:p14="http://schemas.microsoft.com/office/powerpoint/2010/main" val="2623252185"/>
+        <p14:creationId xmlns:p14="http://schemas.microsoft.com/office/powerpoint/2010/main" val="3854556064"/>
       </p:ext>
     </p:extLst>
   </p:cSld>
   <p:clrMap bg1="lt1" tx1="dk1" bg2="lt2" tx2="dk2" accent1="accent1" accent2="accent2" accent3="accent3" accent4="accent4" accent5="accent5" accent6="accent6" hlink="hlink" folHlink="folHlink"/>
   <p:notesStyle>
-    <a:lvl1pPr marL="0" algn="l" defTabSz="457200" rtl="0" eaLnBrk="1" latinLnBrk="0" hangingPunct="1">
+    <a:lvl1pPr marL="0" algn="l" defTabSz="914400" rtl="0" eaLnBrk="1" latinLnBrk="0" hangingPunct="1">
       <a:defRPr sz="1200" kern="1200">
         <a:solidFill>
           <a:schemeClr val="tx1"/>
@@ -383,7 +177,7 @@
         <a:cs typeface="+mn-cs"/>
       </a:defRPr>
     </a:lvl1pPr>
-    <a:lvl2pPr marL="457200" algn="l" defTabSz="457200" rtl="0" eaLnBrk="1" latinLnBrk="0" hangingPunct="1">
+    <a:lvl2pPr marL="457200" algn="l" defTabSz="914400" rtl="0" eaLnBrk="1" latinLnBrk="0" hangingPunct="1">
       <a:defRPr sz="1200" kern="1200">
         <a:solidFill>
           <a:schemeClr val="tx1"/>
@@ -393,7 +187,7 @@
         <a:cs typeface="+mn-cs"/>
       </a:defRPr>
     </a:lvl2pPr>
-    <a:lvl3pPr marL="914400" algn="l" defTabSz="457200" rtl="0" eaLnBrk="1" latinLnBrk="0" hangingPunct="1">
+    <a:lvl3pPr marL="914400" algn="l" defTabSz="914400" rtl="0" eaLnBrk="1" latinLnBrk="0" hangingPunct="1">
       <a:defRPr sz="1200" kern="1200">
         <a:solidFill>
           <a:schemeClr val="tx1"/>
@@ -403,7 +197,7 @@
         <a:cs typeface="+mn-cs"/>
       </a:defRPr>
     </a:lvl3pPr>
-    <a:lvl4pPr marL="1371600" algn="l" defTabSz="457200" rtl="0" eaLnBrk="1" latinLnBrk="0" hangingPunct="1">
+    <a:lvl4pPr marL="1371600" algn="l" defTabSz="914400" rtl="0" eaLnBrk="1" latinLnBrk="0" hangingPunct="1">
       <a:defRPr sz="1200" kern="1200">
         <a:solidFill>
           <a:schemeClr val="tx1"/>
@@ -413,7 +207,7 @@
         <a:cs typeface="+mn-cs"/>
       </a:defRPr>
     </a:lvl4pPr>
-    <a:lvl5pPr marL="1828800" algn="l" defTabSz="457200" rtl="0" eaLnBrk="1" latinLnBrk="0" hangingPunct="1">
+    <a:lvl5pPr marL="1828800" algn="l" defTabSz="914400" rtl="0" eaLnBrk="1" latinLnBrk="0" hangingPunct="1">
       <a:defRPr sz="1200" kern="1200">
         <a:solidFill>
           <a:schemeClr val="tx1"/>
@@ -423,7 +217,7 @@
         <a:cs typeface="+mn-cs"/>
       </a:defRPr>
     </a:lvl5pPr>
-    <a:lvl6pPr marL="2286000" algn="l" defTabSz="457200" rtl="0" eaLnBrk="1" latinLnBrk="0" hangingPunct="1">
+    <a:lvl6pPr marL="2286000" algn="l" defTabSz="914400" rtl="0" eaLnBrk="1" latinLnBrk="0" hangingPunct="1">
       <a:defRPr sz="1200" kern="1200">
         <a:solidFill>
           <a:schemeClr val="tx1"/>
@@ -433,7 +227,7 @@
         <a:cs typeface="+mn-cs"/>
       </a:defRPr>
     </a:lvl6pPr>
-    <a:lvl7pPr marL="2743200" algn="l" defTabSz="457200" rtl="0" eaLnBrk="1" latinLnBrk="0" hangingPunct="1">
+    <a:lvl7pPr marL="2743200" algn="l" defTabSz="914400" rtl="0" eaLnBrk="1" latinLnBrk="0" hangingPunct="1">
       <a:defRPr sz="1200" kern="1200">
         <a:solidFill>
           <a:schemeClr val="tx1"/>
@@ -443,7 +237,7 @@
         <a:cs typeface="+mn-cs"/>
       </a:defRPr>
     </a:lvl7pPr>
-    <a:lvl8pPr marL="3200400" algn="l" defTabSz="457200" rtl="0" eaLnBrk="1" latinLnBrk="0" hangingPunct="1">
+    <a:lvl8pPr marL="3200400" algn="l" defTabSz="914400" rtl="0" eaLnBrk="1" latinLnBrk="0" hangingPunct="1">
       <a:defRPr sz="1200" kern="1200">
         <a:solidFill>
           <a:schemeClr val="tx1"/>
@@ -453,7 +247,7 @@
         <a:cs typeface="+mn-cs"/>
       </a:defRPr>
     </a:lvl8pPr>
-    <a:lvl9pPr marL="3657600" algn="l" defTabSz="457200" rtl="0" eaLnBrk="1" latinLnBrk="0" hangingPunct="1">
+    <a:lvl9pPr marL="3657600" algn="l" defTabSz="914400" rtl="0" eaLnBrk="1" latinLnBrk="0" hangingPunct="1">
       <a:defRPr sz="1200" kern="1200">
         <a:solidFill>
           <a:schemeClr val="tx1"/>
@@ -468,7 +262,7 @@
 </file>
 
 <file path=ppt/notesSlides/notesSlide1.xml><?xml version="1.0" encoding="utf-8"?>
-<p:notes xmlns:a="http://schemas.openxmlformats.org/drawingml/2006/main" xmlns:p="http://schemas.openxmlformats.org/presentationml/2006/main" xmlns:r="http://schemas.openxmlformats.org/officeDocument/2006/relationships">
+<p:notes xmlns:a="http://schemas.openxmlformats.org/drawingml/2006/main" xmlns:r="http://schemas.openxmlformats.org/officeDocument/2006/relationships" xmlns:p="http://schemas.openxmlformats.org/presentationml/2006/main">
   <p:cSld>
     <p:spTree>
       <p:nvGrpSpPr>
@@ -488,7 +282,7 @@
         <p:nvSpPr>
           <p:cNvPr id="2" name="Slide Image Placeholder 1"/>
           <p:cNvSpPr>
-            <a:spLocks noGrp="1"/>
+            <a:spLocks noGrp="1" noRot="1" noChangeAspect="1"/>
           </p:cNvSpPr>
           <p:nvPr>
             <p:ph type="sldImg" idx="2"/>
@@ -503,7 +297,7 @@
             <a:spLocks noGrp="1"/>
           </p:cNvSpPr>
           <p:nvPr>
-            <p:ph type="body" idx="3" sz="quarter"/>
+            <p:ph type="body" sz="quarter" idx="3"/>
           </p:nvPr>
         </p:nvSpPr>
         <p:spPr/>
@@ -520,7 +314,9 @@
               <a:t>Velkomst · 0:00–0:05. Første øjeblik — bare rammesæt. Vent ikke for længe; kom videre.</a:t>
             </a:r>
           </a:p>
-          <a:p/>
+          <a:p>
+            <a:endParaRPr/>
+          </a:p>
           <a:p>
             <a:r>
               <a:t>─── SIG ───</a:t>
@@ -531,7 +327,9 @@
               <a:t>"Velkommen. Jeg er Matias, og det her er Michael. Vi er facilitatorer for de næste 5 uger."</a:t>
             </a:r>
           </a:p>
-          <a:p/>
+          <a:p>
+            <a:endParaRPr/>
+          </a:p>
           <a:p>
             <a:r>
               <a:t>"Det her er ikke et kursus hvor I lytter til os. Det er en træningslejr hvor I lærer ved at gøre — og fra session 2 også ved at undervise jeres kollegaer."</a:t>
@@ -546,7 +344,7 @@
             <a:spLocks noGrp="1"/>
           </p:cNvSpPr>
           <p:nvPr>
-            <p:ph type="sldNum" idx="5" sz="quarter"/>
+            <p:ph type="sldNum" sz="quarter" idx="5"/>
           </p:nvPr>
         </p:nvSpPr>
         <p:spPr/>
@@ -560,7 +358,7 @@
 </file>
 
 <file path=ppt/notesSlides/notesSlide10.xml><?xml version="1.0" encoding="utf-8"?>
-<p:notes xmlns:a="http://schemas.openxmlformats.org/drawingml/2006/main" xmlns:p="http://schemas.openxmlformats.org/presentationml/2006/main" xmlns:r="http://schemas.openxmlformats.org/officeDocument/2006/relationships">
+<p:notes xmlns:a="http://schemas.openxmlformats.org/drawingml/2006/main" xmlns:r="http://schemas.openxmlformats.org/officeDocument/2006/relationships" xmlns:p="http://schemas.openxmlformats.org/presentationml/2006/main">
   <p:cSld>
     <p:spTree>
       <p:nvGrpSpPr>
@@ -580,7 +378,7 @@
         <p:nvSpPr>
           <p:cNvPr id="2" name="Slide Image Placeholder 1"/>
           <p:cNvSpPr>
-            <a:spLocks noGrp="1"/>
+            <a:spLocks noGrp="1" noRot="1" noChangeAspect="1"/>
           </p:cNvSpPr>
           <p:nvPr>
             <p:ph type="sldImg" idx="2"/>
@@ -595,7 +393,7 @@
             <a:spLocks noGrp="1"/>
           </p:cNvSpPr>
           <p:nvPr>
-            <p:ph type="body" idx="3" sz="quarter"/>
+            <p:ph type="body" sz="quarter" idx="3"/>
           </p:nvPr>
         </p:nvSpPr>
         <p:spPr/>
@@ -612,7 +410,9 @@
               <a:t>Forsikring · 0:33–0:35. Det her slide er forsikring mod den deltager der siger "jamen den dårlige fungerede jo fint". Anerkend det direkte — det er ærligt.</a:t>
             </a:r>
           </a:p>
-          <a:p/>
+          <a:p>
+            <a:endParaRPr/>
+          </a:p>
           <a:p>
             <a:r>
               <a:t>─── SIG ───</a:t>
@@ -623,19 +423,25 @@
               <a:t>"I har ret. På denne lille demo med Opus 4.7 er forskellen subtil — Claude er smart nok til at finde et fix der virker, selv når prompten er vag."</a:t>
             </a:r>
           </a:p>
-          <a:p/>
+          <a:p>
+            <a:endParaRPr/>
+          </a:p>
           <a:p>
             <a:r>
               <a:t>"Men i jeres rigtige projekter — 100k+ linjer, DTO'er, mappere, migrations, konventioner der ikke er skrevet ned — eksploderer det."</a:t>
             </a:r>
           </a:p>
-          <a:p/>
+          <a:p>
+            <a:endParaRPr/>
+          </a:p>
           <a:p>
             <a:r>
               <a:t>"En vag prompt rammer den forkerte fil, glemmer halvdelen af kæden, eller introducerer et abstraktionslag der konflikter med jeres eksisterende."</a:t>
             </a:r>
           </a:p>
-          <a:p/>
+          <a:p>
+            <a:endParaRPr/>
+          </a:p>
           <a:p>
             <a:r>
               <a:t>"Vi træner mønsteret her hvor det er sikkert at fejle — så det sidder i fingrene når I er midt i en rigtig PR mandag morgen."</a:t>
@@ -650,7 +456,7 @@
             <a:spLocks noGrp="1"/>
           </p:cNvSpPr>
           <p:nvPr>
-            <p:ph type="sldNum" idx="5" sz="quarter"/>
+            <p:ph type="sldNum" sz="quarter" idx="5"/>
           </p:nvPr>
         </p:nvSpPr>
         <p:spPr/>
@@ -664,7 +470,7 @@
 </file>
 
 <file path=ppt/notesSlides/notesSlide11.xml><?xml version="1.0" encoding="utf-8"?>
-<p:notes xmlns:a="http://schemas.openxmlformats.org/drawingml/2006/main" xmlns:p="http://schemas.openxmlformats.org/presentationml/2006/main" xmlns:r="http://schemas.openxmlformats.org/officeDocument/2006/relationships">
+<p:notes xmlns:a="http://schemas.openxmlformats.org/drawingml/2006/main" xmlns:r="http://schemas.openxmlformats.org/officeDocument/2006/relationships" xmlns:p="http://schemas.openxmlformats.org/presentationml/2006/main">
   <p:cSld>
     <p:spTree>
       <p:nvGrpSpPr>
@@ -684,7 +490,7 @@
         <p:nvSpPr>
           <p:cNvPr id="2" name="Slide Image Placeholder 1"/>
           <p:cNvSpPr>
-            <a:spLocks noGrp="1"/>
+            <a:spLocks noGrp="1" noRot="1" noChangeAspect="1"/>
           </p:cNvSpPr>
           <p:nvPr>
             <p:ph type="sldImg" idx="2"/>
@@ -699,7 +505,7 @@
             <a:spLocks noGrp="1"/>
           </p:cNvSpPr>
           <p:nvPr>
-            <p:ph type="body" idx="3" sz="quarter"/>
+            <p:ph type="body" sz="quarter" idx="3"/>
           </p:nvPr>
         </p:nvSpPr>
         <p:spPr/>
@@ -716,7 +522,9 @@
               <a:t>Hands-on (0:35–0:55) + afslutning (0:55–1:00). Slidet bliver siddende mens deltagerne arbejder. Du forklarer hands-on verbalt, går rundt, samler op, og runder af — alt sammen uden at skifte slide.</a:t>
             </a:r>
           </a:p>
-          <a:p/>
+          <a:p>
+            <a:endParaRPr/>
+          </a:p>
           <a:p>
             <a:r>
               <a:t>─── SIG (start hands-on, 0:35) ───</a:t>
@@ -727,25 +535,33 @@
               <a:t>"Nu jer. Solo på din egen maskine — du skal selv mærke forskellen i fingrene. I har 20 minutter."</a:t>
             </a:r>
           </a:p>
-          <a:p/>
+          <a:p>
+            <a:endParaRPr/>
+          </a:p>
           <a:p>
             <a:r>
               <a:t>"Kør git clone fra README'en, npm install, og claude i demo-mappen. Vælg én opgave fra demoen — pris-bug, performance, eller favorit-knap."</a:t>
             </a:r>
           </a:p>
-          <a:p/>
+          <a:p>
+            <a:endParaRPr/>
+          </a:p>
           <a:p>
             <a:r>
               <a:t>"Skriv først en hurtig prompt som I ville skrive på en travl dag. Så git checkout og /clear for at rulle tilbage. Så samme opgave med alle 4 byggeklodser."</a:t>
             </a:r>
           </a:p>
-          <a:p/>
+          <a:p>
+            <a:endParaRPr/>
+          </a:p>
           <a:p>
             <a:r>
               <a:t>"Hvis du sidder fast, ræk hånden op — vi går rundt."</a:t>
             </a:r>
           </a:p>
-          <a:p/>
+          <a:p>
+            <a:endParaRPr/>
+          </a:p>
           <a:p>
             <a:r>
               <a:t>─── GØR (mens de arbejder) ───</a:t>
@@ -756,7 +572,9 @@
               <a:t>Gå rundt. Hjælp dem der sidder fast. Lyt efter en god 'aha'-bemærkning du kan bede dem dele bagefter.</a:t>
             </a:r>
           </a:p>
-          <a:p/>
+          <a:p>
+            <a:endParaRPr/>
+          </a:p>
           <a:p>
             <a:r>
               <a:t>─── SIG (med 5 min tilbage, ~0:50) ───</a:t>
@@ -767,7 +585,9 @@
               <a:t>"Saml jer — én indsigt højt fra hver. Den der overraskede jer mest."</a:t>
             </a:r>
           </a:p>
-          <a:p/>
+          <a:p>
+            <a:endParaRPr/>
+          </a:p>
           <a:p>
             <a:r>
               <a:t>─── SIG (afslutning, 0:55) ───</a:t>
@@ -778,19 +598,25 @@
               <a:t>"Hjemmeopgaven er nem: brug Claude Code på mindst én rigtig opgave inden torsdag — i et af jeres rigtige projekter, ikke demoen."</a:t>
             </a:r>
           </a:p>
-          <a:p/>
+          <a:p>
+            <a:endParaRPr/>
+          </a:p>
           <a:p>
             <a:r>
               <a:t>"Tag to prompts med til torsdag: én der virkede godt, og én der ikke gjorde. Vi starter session 2 med at dele dem."</a:t>
             </a:r>
           </a:p>
-          <a:p/>
+          <a:p>
+            <a:endParaRPr/>
+          </a:p>
           <a:p>
             <a:r>
               <a:t>"[Navn] tager session 2 om Plan mode. Jeg sender slide-skabelon og pre-work-video senest dagen før."</a:t>
             </a:r>
           </a:p>
-          <a:p/>
+          <a:p>
+            <a:endParaRPr/>
+          </a:p>
           <a:p>
             <a:r>
               <a:t>"Tak for i dag."</a:t>
@@ -805,7 +631,7 @@
             <a:spLocks noGrp="1"/>
           </p:cNvSpPr>
           <p:nvPr>
-            <p:ph type="sldNum" idx="5" sz="quarter"/>
+            <p:ph type="sldNum" sz="quarter" idx="5"/>
           </p:nvPr>
         </p:nvSpPr>
         <p:spPr/>
@@ -819,7 +645,7 @@
 </file>
 
 <file path=ppt/notesSlides/notesSlide2.xml><?xml version="1.0" encoding="utf-8"?>
-<p:notes xmlns:a="http://schemas.openxmlformats.org/drawingml/2006/main" xmlns:p="http://schemas.openxmlformats.org/presentationml/2006/main" xmlns:r="http://schemas.openxmlformats.org/officeDocument/2006/relationships">
+<p:notes xmlns:a="http://schemas.openxmlformats.org/drawingml/2006/main" xmlns:r="http://schemas.openxmlformats.org/officeDocument/2006/relationships" xmlns:p="http://schemas.openxmlformats.org/presentationml/2006/main">
   <p:cSld>
     <p:spTree>
       <p:nvGrpSpPr>
@@ -839,7 +665,7 @@
         <p:nvSpPr>
           <p:cNvPr id="2" name="Slide Image Placeholder 1"/>
           <p:cNvSpPr>
-            <a:spLocks noGrp="1"/>
+            <a:spLocks noGrp="1" noRot="1" noChangeAspect="1"/>
           </p:cNvSpPr>
           <p:nvPr>
             <p:ph type="sldImg" idx="2"/>
@@ -854,7 +680,7 @@
             <a:spLocks noGrp="1"/>
           </p:cNvSpPr>
           <p:nvPr>
-            <p:ph type="body" idx="3" sz="quarter"/>
+            <p:ph type="body" sz="quarter" idx="3"/>
           </p:nvPr>
         </p:nvSpPr>
         <p:spPr/>
@@ -871,7 +697,9 @@
               <a:t>Hurtigt overblik · 0:05–0:07. Peg på de fremhævede (blå) felter — det er de tre hoveddele. Ingen pause på en time, men det går stærkt.</a:t>
             </a:r>
           </a:p>
-          <a:p/>
+          <a:p>
+            <a:endParaRPr/>
+          </a:p>
           <a:p>
             <a:r>
               <a:t>─── SIG ───</a:t>
@@ -882,13 +710,17 @@
               <a:t>"Lige om lidt fortæller jeg lidt om hvordan de næste 5 uger ser ud."</a:t>
             </a:r>
           </a:p>
-          <a:p/>
+          <a:p>
+            <a:endParaRPr/>
+          </a:p>
           <a:p>
             <a:r>
               <a:t>"Så går vi i terminalen og laver en live demo."</a:t>
             </a:r>
           </a:p>
-          <a:p/>
+          <a:p>
+            <a:endParaRPr/>
+          </a:p>
           <a:p>
             <a:r>
               <a:t>"Og så er det jer der skal kode — solo på jeres egen maskine."</a:t>
@@ -903,7 +735,7 @@
             <a:spLocks noGrp="1"/>
           </p:cNvSpPr>
           <p:nvPr>
-            <p:ph type="sldNum" idx="5" sz="quarter"/>
+            <p:ph type="sldNum" sz="quarter" idx="5"/>
           </p:nvPr>
         </p:nvSpPr>
         <p:spPr/>
@@ -917,7 +749,7 @@
 </file>
 
 <file path=ppt/notesSlides/notesSlide3.xml><?xml version="1.0" encoding="utf-8"?>
-<p:notes xmlns:a="http://schemas.openxmlformats.org/drawingml/2006/main" xmlns:p="http://schemas.openxmlformats.org/presentationml/2006/main" xmlns:r="http://schemas.openxmlformats.org/officeDocument/2006/relationships">
+<p:notes xmlns:a="http://schemas.openxmlformats.org/drawingml/2006/main" xmlns:r="http://schemas.openxmlformats.org/officeDocument/2006/relationships" xmlns:p="http://schemas.openxmlformats.org/presentationml/2006/main">
   <p:cSld>
     <p:spTree>
       <p:nvGrpSpPr>
@@ -937,7 +769,7 @@
         <p:nvSpPr>
           <p:cNvPr id="2" name="Slide Image Placeholder 1"/>
           <p:cNvSpPr>
-            <a:spLocks noGrp="1"/>
+            <a:spLocks noGrp="1" noRot="1" noChangeAspect="1"/>
           </p:cNvSpPr>
           <p:nvPr>
             <p:ph type="sldImg" idx="2"/>
@@ -952,7 +784,7 @@
             <a:spLocks noGrp="1"/>
           </p:cNvSpPr>
           <p:nvPr>
-            <p:ph type="body" idx="3" sz="quarter"/>
+            <p:ph type="body" sz="quarter" idx="3"/>
           </p:nvPr>
         </p:nvSpPr>
         <p:spPr/>
@@ -969,7 +801,9 @@
               <a:t>Vigtigste pointe i dag · 0:07–0:10. Hvis de bare lytter, lærer de ingenting. Hvis de underviser hinanden, sidder det fast.</a:t>
             </a:r>
           </a:p>
-          <a:p/>
+          <a:p>
+            <a:endParaRPr/>
+          </a:p>
           <a:p>
             <a:r>
               <a:t>─── SIG ───</a:t>
@@ -980,13 +814,17 @@
               <a:t>"Det her er den vigtigste pointe i dag: Michael og jeg er facilitatorer, ikke eksperter."</a:t>
             </a:r>
           </a:p>
-          <a:p/>
+          <a:p>
+            <a:endParaRPr/>
+          </a:p>
           <a:p>
             <a:r>
               <a:t>"Jeg ved ikke nødvendigvis mere end jer om Claude Code om 5 uger. Det her er et hold der lærer sammen."</a:t>
             </a:r>
           </a:p>
-          <a:p/>
+          <a:p>
+            <a:endParaRPr/>
+          </a:p>
           <a:p>
             <a:r>
               <a:t>"Fra session 2 er det én af jer der præsenterer dagens emne. Vi hjælper med slides ugen før, så ingen står alene med det."</a:t>
@@ -1001,7 +839,7 @@
             <a:spLocks noGrp="1"/>
           </p:cNvSpPr>
           <p:nvPr>
-            <p:ph type="sldNum" idx="5" sz="quarter"/>
+            <p:ph type="sldNum" sz="quarter" idx="5"/>
           </p:nvPr>
         </p:nvSpPr>
         <p:spPr/>
@@ -1015,7 +853,7 @@
 </file>
 
 <file path=ppt/notesSlides/notesSlide4.xml><?xml version="1.0" encoding="utf-8"?>
-<p:notes xmlns:a="http://schemas.openxmlformats.org/drawingml/2006/main" xmlns:p="http://schemas.openxmlformats.org/presentationml/2006/main" xmlns:r="http://schemas.openxmlformats.org/officeDocument/2006/relationships">
+<p:notes xmlns:a="http://schemas.openxmlformats.org/drawingml/2006/main" xmlns:r="http://schemas.openxmlformats.org/officeDocument/2006/relationships" xmlns:p="http://schemas.openxmlformats.org/presentationml/2006/main">
   <p:cSld>
     <p:spTree>
       <p:nvGrpSpPr>
@@ -1035,7 +873,7 @@
         <p:nvSpPr>
           <p:cNvPr id="2" name="Slide Image Placeholder 1"/>
           <p:cNvSpPr>
-            <a:spLocks noGrp="1"/>
+            <a:spLocks noGrp="1" noRot="1" noChangeAspect="1"/>
           </p:cNvSpPr>
           <p:nvPr>
             <p:ph type="sldImg" idx="2"/>
@@ -1050,7 +888,7 @@
             <a:spLocks noGrp="1"/>
           </p:cNvSpPr>
           <p:nvPr>
-            <p:ph type="body" idx="3" sz="quarter"/>
+            <p:ph type="body" sz="quarter" idx="3"/>
           </p:nvPr>
         </p:nvSpPr>
         <p:spPr/>
@@ -1067,7 +905,9 @@
               <a:t>Akavet øjeblik · 0:10–0:13. Stil spørgsmålet og hold mund. Lad stilheden virke. Hvis ingen melder sig efter 10 sek: vælg én du ved godt har lyst — eller én der ser frisk ud.</a:t>
             </a:r>
           </a:p>
-          <a:p/>
+          <a:p>
+            <a:endParaRPr/>
+          </a:p>
           <a:p>
             <a:r>
               <a:t>─── SIG ───</a:t>
@@ -1078,13 +918,17 @@
               <a:t>"Hvem vil tage session 2 om Plan mode? Det er torsdag, jeg sender slide-skabelon og pre-work-video senest dagen før."</a:t>
             </a:r>
           </a:p>
-          <a:p/>
+          <a:p>
+            <a:endParaRPr/>
+          </a:p>
           <a:p>
             <a:r>
               <a:t>[Vent. Tæl til 10 i hovedet.]</a:t>
             </a:r>
           </a:p>
-          <a:p/>
+          <a:p>
+            <a:endParaRPr/>
+          </a:p>
           <a:p>
             <a:r>
               <a:t>Hvis ingen melder sig:</a:t>
@@ -1095,7 +939,9 @@
               <a:t>"[Navn] — vil du tage den?"</a:t>
             </a:r>
           </a:p>
-          <a:p/>
+          <a:p>
+            <a:endParaRPr/>
+          </a:p>
           <a:p>
             <a:r>
               <a:t>─── GØR ───</a:t>
@@ -1115,7 +961,7 @@
             <a:spLocks noGrp="1"/>
           </p:cNvSpPr>
           <p:nvPr>
-            <p:ph type="sldNum" idx="5" sz="quarter"/>
+            <p:ph type="sldNum" sz="quarter" idx="5"/>
           </p:nvPr>
         </p:nvSpPr>
         <p:spPr/>
@@ -1129,7 +975,7 @@
 </file>
 
 <file path=ppt/notesSlides/notesSlide5.xml><?xml version="1.0" encoding="utf-8"?>
-<p:notes xmlns:a="http://schemas.openxmlformats.org/drawingml/2006/main" xmlns:p="http://schemas.openxmlformats.org/presentationml/2006/main" xmlns:r="http://schemas.openxmlformats.org/officeDocument/2006/relationships">
+<p:notes xmlns:a="http://schemas.openxmlformats.org/drawingml/2006/main" xmlns:r="http://schemas.openxmlformats.org/officeDocument/2006/relationships" xmlns:p="http://schemas.openxmlformats.org/presentationml/2006/main">
   <p:cSld>
     <p:spTree>
       <p:nvGrpSpPr>
@@ -1149,7 +995,7 @@
         <p:nvSpPr>
           <p:cNvPr id="2" name="Slide Image Placeholder 1"/>
           <p:cNvSpPr>
-            <a:spLocks noGrp="1"/>
+            <a:spLocks noGrp="1" noRot="1" noChangeAspect="1"/>
           </p:cNvSpPr>
           <p:nvPr>
             <p:ph type="sldImg" idx="2"/>
@@ -1164,7 +1010,7 @@
             <a:spLocks noGrp="1"/>
           </p:cNvSpPr>
           <p:nvPr>
-            <p:ph type="body" idx="3" sz="quarter"/>
+            <p:ph type="body" sz="quarter" idx="3"/>
           </p:nvPr>
         </p:nvSpPr>
         <p:spPr/>
@@ -1181,7 +1027,9 @@
               <a:t>Saml i ÉN sætning · 0:13–0:15. Sig de tre linjer langsomt. Den sidste — "den første prompt er den vigtigste" — er nøgle-pointen: når Claude først er i gang med en svag retning, er det svært at rette kursen. Bedre at bruge 30 sek ekstra på prompten end 10 min på at rydde op.</a:t>
             </a:r>
           </a:p>
-          <a:p/>
+          <a:p>
+            <a:endParaRPr/>
+          </a:p>
           <a:p>
             <a:r>
               <a:t>─── SIG ───</a:t>
@@ -1192,25 +1040,33 @@
               <a:t>"En dårlig prompt giver generisk kode."</a:t>
             </a:r>
           </a:p>
-          <a:p/>
+          <a:p>
+            <a:endParaRPr/>
+          </a:p>
           <a:p>
             <a:r>
               <a:t>"En god prompt giver produktionsklar kode."</a:t>
             </a:r>
           </a:p>
-          <a:p/>
+          <a:p>
+            <a:endParaRPr/>
+          </a:p>
           <a:p>
             <a:r>
               <a:t>"Forskellen er hvor præcist du beskriver opgaven for Claude."</a:t>
             </a:r>
           </a:p>
-          <a:p/>
+          <a:p>
+            <a:endParaRPr/>
+          </a:p>
           <a:p>
             <a:r>
               <a:t>[Pause. Peg på det navy-felt nederst.]</a:t>
             </a:r>
           </a:p>
-          <a:p/>
+          <a:p>
+            <a:endParaRPr/>
+          </a:p>
           <a:p>
             <a:r>
               <a:t>"Og den vigtigste prompt er den første. Når Claude er i gang i en forkert retning, er det svært at rette kursen. Bedre at bruge 30 sekunder ekstra på den første prompt end 10 minutter på at rydde op bagefter."</a:t>
@@ -1225,7 +1081,7 @@
             <a:spLocks noGrp="1"/>
           </p:cNvSpPr>
           <p:nvPr>
-            <p:ph type="sldNum" idx="5" sz="quarter"/>
+            <p:ph type="sldNum" sz="quarter" idx="5"/>
           </p:nvPr>
         </p:nvSpPr>
         <p:spPr/>
@@ -1239,7 +1095,7 @@
 </file>
 
 <file path=ppt/notesSlides/notesSlide6.xml><?xml version="1.0" encoding="utf-8"?>
-<p:notes xmlns:a="http://schemas.openxmlformats.org/drawingml/2006/main" xmlns:p="http://schemas.openxmlformats.org/presentationml/2006/main" xmlns:r="http://schemas.openxmlformats.org/officeDocument/2006/relationships">
+<p:notes xmlns:a="http://schemas.openxmlformats.org/drawingml/2006/main" xmlns:r="http://schemas.openxmlformats.org/officeDocument/2006/relationships" xmlns:p="http://schemas.openxmlformats.org/presentationml/2006/main">
   <p:cSld>
     <p:spTree>
       <p:nvGrpSpPr>
@@ -1259,7 +1115,7 @@
         <p:nvSpPr>
           <p:cNvPr id="2" name="Slide Image Placeholder 1"/>
           <p:cNvSpPr>
-            <a:spLocks noGrp="1"/>
+            <a:spLocks noGrp="1" noRot="1" noChangeAspect="1"/>
           </p:cNvSpPr>
           <p:nvPr>
             <p:ph type="sldImg" idx="2"/>
@@ -1274,7 +1130,7 @@
             <a:spLocks noGrp="1"/>
           </p:cNvSpPr>
           <p:nvPr>
-            <p:ph type="body" idx="3" sz="quarter"/>
+            <p:ph type="body" sz="quarter" idx="3"/>
           </p:nvPr>
         </p:nvSpPr>
         <p:spPr/>
@@ -1291,7 +1147,9 @@
               <a:t>Mønsteret · 0:15–0:18. Det her skal de kunne udenad efter session 1. Læs dem op én af gangen og giv et lille eksempel for hver. Vigtigt: BEGRÆNSNINGER er markeret "når relevant" — det er ikke nødvendigt for hver prompt (fx ikke for "forklar denne fil"), men ved kode-ændringer er det guld værd.</a:t>
             </a:r>
           </a:p>
-          <a:p/>
+          <a:p>
+            <a:endParaRPr/>
+          </a:p>
           <a:p>
             <a:r>
               <a:t>─── SIG ───</a:t>
@@ -1302,31 +1160,41 @@
               <a:t>"Tænk i fire dele når du skriver en prompt:"</a:t>
             </a:r>
           </a:p>
-          <a:p/>
+          <a:p>
+            <a:endParaRPr/>
+          </a:p>
           <a:p>
             <a:r>
               <a:t>"1. Kontekst — fx: 'Læs lib/propertyService.ts og components/PropertyCard.tsx'."</a:t>
             </a:r>
           </a:p>
-          <a:p/>
+          <a:p>
+            <a:endParaRPr/>
+          </a:p>
           <a:p>
             <a:r>
               <a:t>"2. Opgave — konkret, fx: 'Lav en formatPrice-helper og brug den i begge filer'. Ikke 'der er noget med priserne...'."</a:t>
             </a:r>
           </a:p>
-          <a:p/>
+          <a:p>
+            <a:endParaRPr/>
+          </a:p>
           <a:p>
             <a:r>
               <a:t>"3. Begrænsninger — når relevant. Fx: 'Rør intet andet. Ingen commit.' Hvis du bare vil have Claude til at forklare en fil, kan du droppe det her."</a:t>
             </a:r>
           </a:p>
-          <a:p/>
+          <a:p>
+            <a:endParaRPr/>
+          </a:p>
           <a:p>
             <a:r>
               <a:t>"4. Forventet output — fx: 'Priser vises som 8.500.000 kr. alle 3 steder.'"</a:t>
             </a:r>
           </a:p>
-          <a:p/>
+          <a:p>
+            <a:endParaRPr/>
+          </a:p>
           <a:p>
             <a:r>
               <a:t>"Vi vender tilbage til mønsteret hver eneste session de næste 5 uger."</a:t>
@@ -1341,7 +1209,7 @@
             <a:spLocks noGrp="1"/>
           </p:cNvSpPr>
           <p:nvPr>
-            <p:ph type="sldNum" idx="5" sz="quarter"/>
+            <p:ph type="sldNum" sz="quarter" idx="5"/>
           </p:nvPr>
         </p:nvSpPr>
         <p:spPr/>
@@ -1355,7 +1223,7 @@
 </file>
 
 <file path=ppt/notesSlides/notesSlide7.xml><?xml version="1.0" encoding="utf-8"?>
-<p:notes xmlns:a="http://schemas.openxmlformats.org/drawingml/2006/main" xmlns:p="http://schemas.openxmlformats.org/presentationml/2006/main" xmlns:r="http://schemas.openxmlformats.org/officeDocument/2006/relationships">
+<p:notes xmlns:a="http://schemas.openxmlformats.org/drawingml/2006/main" xmlns:r="http://schemas.openxmlformats.org/officeDocument/2006/relationships" xmlns:p="http://schemas.openxmlformats.org/presentationml/2006/main">
   <p:cSld>
     <p:spTree>
       <p:nvGrpSpPr>
@@ -1375,7 +1243,7 @@
         <p:nvSpPr>
           <p:cNvPr id="2" name="Slide Image Placeholder 1"/>
           <p:cNvSpPr>
-            <a:spLocks noGrp="1"/>
+            <a:spLocks noGrp="1" noRot="1" noChangeAspect="1"/>
           </p:cNvSpPr>
           <p:nvPr>
             <p:ph type="sldImg" idx="2"/>
@@ -1390,7 +1258,7 @@
             <a:spLocks noGrp="1"/>
           </p:cNvSpPr>
           <p:nvPr>
-            <p:ph type="body" idx="3" sz="quarter"/>
+            <p:ph type="body" sz="quarter" idx="3"/>
           </p:nvPr>
         </p:nvSpPr>
         <p:spPr/>
@@ -1407,7 +1275,9 @@
               <a:t>Tryghed fra dag 1 · 0:18–0:20. Vi går i dybden i session 3, men de skal vide om det FRA i dag. Pointe: hvis de aldrig kan rulle tilbage, tør de aldrig prøve noget nyt.</a:t>
             </a:r>
           </a:p>
-          <a:p/>
+          <a:p>
+            <a:endParaRPr/>
+          </a:p>
           <a:p>
             <a:r>
               <a:t>─── SIG ───</a:t>
@@ -1418,19 +1288,25 @@
               <a:t>"Når Claude laver noget I fortryder — eller koden går i sort — så tryk Esc to gange."</a:t>
             </a:r>
           </a:p>
-          <a:p/>
+          <a:p>
+            <a:endParaRPr/>
+          </a:p>
           <a:p>
             <a:r>
               <a:t>"Der kommer en menu hvor I kan rulle tilbage til ethvert tidligere punkt i samtalen. Filerne, conversation, eller begge dele."</a:t>
             </a:r>
           </a:p>
-          <a:p/>
+          <a:p>
+            <a:endParaRPr/>
+          </a:p>
           <a:p>
             <a:r>
               <a:t>"Det er det her der gør det trygt at lade Claude prøve noget vildt."</a:t>
             </a:r>
           </a:p>
-          <a:p/>
+          <a:p>
+            <a:endParaRPr/>
+          </a:p>
           <a:p>
             <a:r>
               <a:t>"I må gerne bruge det fra første prompt I skriver i dag."</a:t>
@@ -1445,7 +1321,7 @@
             <a:spLocks noGrp="1"/>
           </p:cNvSpPr>
           <p:nvPr>
-            <p:ph type="sldNum" idx="5" sz="quarter"/>
+            <p:ph type="sldNum" sz="quarter" idx="5"/>
           </p:nvPr>
         </p:nvSpPr>
         <p:spPr/>
@@ -1459,7 +1335,7 @@
 </file>
 
 <file path=ppt/notesSlides/notesSlide8.xml><?xml version="1.0" encoding="utf-8"?>
-<p:notes xmlns:a="http://schemas.openxmlformats.org/drawingml/2006/main" xmlns:p="http://schemas.openxmlformats.org/presentationml/2006/main" xmlns:r="http://schemas.openxmlformats.org/officeDocument/2006/relationships">
+<p:notes xmlns:a="http://schemas.openxmlformats.org/drawingml/2006/main" xmlns:r="http://schemas.openxmlformats.org/officeDocument/2006/relationships" xmlns:p="http://schemas.openxmlformats.org/presentationml/2006/main">
   <p:cSld>
     <p:spTree>
       <p:nvGrpSpPr>
@@ -1479,7 +1355,7 @@
         <p:nvSpPr>
           <p:cNvPr id="2" name="Slide Image Placeholder 1"/>
           <p:cNvSpPr>
-            <a:spLocks noGrp="1"/>
+            <a:spLocks noGrp="1" noRot="1" noChangeAspect="1"/>
           </p:cNvSpPr>
           <p:nvPr>
             <p:ph type="sldImg" idx="2"/>
@@ -1494,7 +1370,7 @@
             <a:spLocks noGrp="1"/>
           </p:cNvSpPr>
           <p:nvPr>
-            <p:ph type="body" idx="3" sz="quarter"/>
+            <p:ph type="body" sz="quarter" idx="3"/>
           </p:nvPr>
         </p:nvSpPr>
         <p:spPr/>
@@ -1511,7 +1387,9 @@
               <a:t>Skift til DIN skærm · 0:15–0:35 (ca. 20 min). Slidet med /prompts står på projektoren mens du kører hele demoen på din egen skærm (terminal + /demo).</a:t>
             </a:r>
           </a:p>
-          <a:p/>
+          <a:p>
+            <a:endParaRPr/>
+          </a:p>
           <a:p>
             <a:r>
               <a:t>TJEKLISTE FØR DU SKIFTER:</a:t>
@@ -1537,7 +1415,9 @@
               <a:t>  □ claude --dangerously-skip-permissions kører i demo/-mappen</a:t>
             </a:r>
           </a:p>
-          <a:p/>
+          <a:p>
+            <a:endParaRPr/>
+          </a:p>
           <a:p>
             <a:r>
               <a:t>─── SIG ───</a:t>
@@ -1548,43 +1428,57 @@
               <a:t>"Nu deler jeg min skærm. I ser min terminal og /demo i browseren."</a:t>
             </a:r>
           </a:p>
-          <a:p/>
+          <a:p>
+            <a:endParaRPr/>
+          </a:p>
           <a:p>
             <a:r>
               <a:t>"Jeg har en /prompts-side åben hvor jeg kopierer prompts fra. Jeg gør det i denne rækkefølge:"</a:t>
             </a:r>
           </a:p>
-          <a:p/>
+          <a:p>
+            <a:endParaRPr/>
+          </a:p>
           <a:p>
             <a:r>
               <a:t>"1) Vis bug'en — scroll ned ad /demo, klik på en bolig, søg demo@edc.dk i favoritter."</a:t>
             </a:r>
           </a:p>
-          <a:p/>
+          <a:p>
+            <a:endParaRPr/>
+          </a:p>
           <a:p>
             <a:r>
               <a:t>"2) Kør den DÅRLIGE prompt — kopier fra /prompts, paste i Claude."</a:t>
             </a:r>
           </a:p>
-          <a:p/>
+          <a:p>
+            <a:endParaRPr/>
+          </a:p>
           <a:p>
             <a:r>
               <a:t>"3) git checkout . + /clear for at rulle tilbage."</a:t>
             </a:r>
           </a:p>
-          <a:p/>
+          <a:p>
+            <a:endParaRPr/>
+          </a:p>
           <a:p>
             <a:r>
               <a:t>"4) Kør den GODE prompt — samme opgave, men nu med kontekst."</a:t>
             </a:r>
           </a:p>
-          <a:p/>
+          <a:p>
+            <a:endParaRPr/>
+          </a:p>
           <a:p>
             <a:r>
               <a:t>"Kig med på begge ændringer — vi samler op bagefter."</a:t>
             </a:r>
           </a:p>
-          <a:p/>
+          <a:p>
+            <a:endParaRPr/>
+          </a:p>
           <a:p>
             <a:r>
               <a:t>─── GØR (mellem prompts) ───</a:t>
@@ -1604,7 +1498,7 @@
             <a:spLocks noGrp="1"/>
           </p:cNvSpPr>
           <p:nvPr>
-            <p:ph type="sldNum" idx="5" sz="quarter"/>
+            <p:ph type="sldNum" sz="quarter" idx="5"/>
           </p:nvPr>
         </p:nvSpPr>
         <p:spPr/>
@@ -1618,7 +1512,7 @@
 </file>
 
 <file path=ppt/notesSlides/notesSlide9.xml><?xml version="1.0" encoding="utf-8"?>
-<p:notes xmlns:a="http://schemas.openxmlformats.org/drawingml/2006/main" xmlns:p="http://schemas.openxmlformats.org/presentationml/2006/main" xmlns:r="http://schemas.openxmlformats.org/officeDocument/2006/relationships">
+<p:notes xmlns:a="http://schemas.openxmlformats.org/drawingml/2006/main" xmlns:r="http://schemas.openxmlformats.org/officeDocument/2006/relationships" xmlns:p="http://schemas.openxmlformats.org/presentationml/2006/main">
   <p:cSld>
     <p:spTree>
       <p:nvGrpSpPr>
@@ -1638,7 +1532,7 @@
         <p:nvSpPr>
           <p:cNvPr id="2" name="Slide Image Placeholder 1"/>
           <p:cNvSpPr>
-            <a:spLocks noGrp="1"/>
+            <a:spLocks noGrp="1" noRot="1" noChangeAspect="1"/>
           </p:cNvSpPr>
           <p:nvPr>
             <p:ph type="sldImg" idx="2"/>
@@ -1653,7 +1547,7 @@
             <a:spLocks noGrp="1"/>
           </p:cNvSpPr>
           <p:nvPr>
-            <p:ph type="body" idx="3" sz="quarter"/>
+            <p:ph type="body" sz="quarter" idx="3"/>
           </p:nvPr>
         </p:nvSpPr>
         <p:spPr/>
@@ -1670,7 +1564,9 @@
               <a:t>Sig det højt · 0:31–0:33. Det her er momentet hvor du SKAL sige det højt — ikke bare lade slidet tale. Det er hele dagen i én sætning.</a:t>
             </a:r>
           </a:p>
-          <a:p/>
+          <a:p>
+            <a:endParaRPr/>
+          </a:p>
           <a:p>
             <a:r>
               <a:t>─── SIG ───</a:t>
@@ -1681,19 +1577,25 @@
               <a:t>"Begge fixes virker visuelt — kr. står overalt. Men kig på koden:"</a:t>
             </a:r>
           </a:p>
-          <a:p/>
+          <a:p>
+            <a:endParaRPr/>
+          </a:p>
           <a:p>
             <a:r>
               <a:t>"Den dårlige duplikerede logikken 3 steder."</a:t>
             </a:r>
           </a:p>
-          <a:p/>
+          <a:p>
+            <a:endParaRPr/>
+          </a:p>
           <a:p>
             <a:r>
               <a:t>"Den gode lavede én helper, brugt 3 steder."</a:t>
             </a:r>
           </a:p>
-          <a:p/>
+          <a:p>
+            <a:endParaRPr/>
+          </a:p>
           <a:p>
             <a:r>
               <a:t>"Om 3 måneder, når en designer beder om at vise øre i favorit-listen, er det den forskel der bestemmer om I bruger 5 minutter eller 30."</a:t>
@@ -1708,7 +1610,7 @@
             <a:spLocks noGrp="1"/>
           </p:cNvSpPr>
           <p:nvPr>
-            <p:ph type="sldNum" idx="5" sz="quarter"/>
+            <p:ph type="sldNum" sz="quarter" idx="5"/>
           </p:nvPr>
         </p:nvSpPr>
         <p:spPr/>
@@ -1759,10 +1661,9 @@
           <a:lstStyle/>
           <a:p>
             <a:r>
-              <a:rPr lang="en-US" smtClean="0"/>
+              <a:rPr lang="en-US"/>
               <a:t>Click to edit Master title style</a:t>
             </a:r>
-            <a:endParaRPr lang="en-US"/>
           </a:p>
         </p:txBody>
       </p:sp>
@@ -1878,10 +1779,9 @@
           </a:lstStyle>
           <a:p>
             <a:r>
-              <a:rPr lang="en-US" smtClean="0"/>
+              <a:rPr lang="en-US"/>
               <a:t>Click to edit Master subtitle style</a:t>
             </a:r>
-            <a:endParaRPr lang="en-US"/>
           </a:p>
         </p:txBody>
       </p:sp>
@@ -1902,7 +1802,7 @@
           <a:p>
             <a:fld id="{5BCAD085-E8A6-8845-BD4E-CB4CCA059FC4}" type="datetimeFigureOut">
               <a:rPr lang="en-US" smtClean="0"/>
-              <a:t>1/27/13</a:t>
+              <a:t>5/5/26</a:t>
             </a:fld>
             <a:endParaRPr lang="en-US"/>
           </a:p>
@@ -1996,10 +1896,9 @@
           <a:lstStyle/>
           <a:p>
             <a:r>
-              <a:rPr lang="en-US" smtClean="0"/>
+              <a:rPr lang="en-US"/>
               <a:t>Click to edit Master title style</a:t>
             </a:r>
-            <a:endParaRPr lang="en-US"/>
           </a:p>
         </p:txBody>
       </p:sp>
@@ -2020,38 +1919,37 @@
           <a:p>
             <a:pPr lvl="0"/>
             <a:r>
-              <a:rPr lang="en-US" smtClean="0"/>
+              <a:rPr lang="en-US"/>
               <a:t>Click to edit Master text styles</a:t>
             </a:r>
           </a:p>
           <a:p>
             <a:pPr lvl="1"/>
             <a:r>
-              <a:rPr lang="en-US" smtClean="0"/>
+              <a:rPr lang="en-US"/>
               <a:t>Second level</a:t>
             </a:r>
           </a:p>
           <a:p>
             <a:pPr lvl="2"/>
             <a:r>
-              <a:rPr lang="en-US" smtClean="0"/>
+              <a:rPr lang="en-US"/>
               <a:t>Third level</a:t>
             </a:r>
           </a:p>
           <a:p>
             <a:pPr lvl="3"/>
             <a:r>
-              <a:rPr lang="en-US" smtClean="0"/>
+              <a:rPr lang="en-US"/>
               <a:t>Fourth level</a:t>
             </a:r>
           </a:p>
           <a:p>
             <a:pPr lvl="4"/>
             <a:r>
-              <a:rPr lang="en-US" smtClean="0"/>
+              <a:rPr lang="en-US"/>
               <a:t>Fifth level</a:t>
             </a:r>
-            <a:endParaRPr lang="en-US"/>
           </a:p>
         </p:txBody>
       </p:sp>
@@ -2072,7 +1970,7 @@
           <a:p>
             <a:fld id="{5BCAD085-E8A6-8845-BD4E-CB4CCA059FC4}" type="datetimeFigureOut">
               <a:rPr lang="en-US" smtClean="0"/>
-              <a:t>1/27/13</a:t>
+              <a:t>5/5/26</a:t>
             </a:fld>
             <a:endParaRPr lang="en-US"/>
           </a:p>
@@ -2171,10 +2069,9 @@
           <a:lstStyle/>
           <a:p>
             <a:r>
-              <a:rPr lang="en-US" smtClean="0"/>
+              <a:rPr lang="en-US"/>
               <a:t>Click to edit Master title style</a:t>
             </a:r>
-            <a:endParaRPr lang="en-US"/>
           </a:p>
         </p:txBody>
       </p:sp>
@@ -2200,38 +2097,37 @@
           <a:p>
             <a:pPr lvl="0"/>
             <a:r>
-              <a:rPr lang="en-US" smtClean="0"/>
+              <a:rPr lang="en-US"/>
               <a:t>Click to edit Master text styles</a:t>
             </a:r>
           </a:p>
           <a:p>
             <a:pPr lvl="1"/>
             <a:r>
-              <a:rPr lang="en-US" smtClean="0"/>
+              <a:rPr lang="en-US"/>
               <a:t>Second level</a:t>
             </a:r>
           </a:p>
           <a:p>
             <a:pPr lvl="2"/>
             <a:r>
-              <a:rPr lang="en-US" smtClean="0"/>
+              <a:rPr lang="en-US"/>
               <a:t>Third level</a:t>
             </a:r>
           </a:p>
           <a:p>
             <a:pPr lvl="3"/>
             <a:r>
-              <a:rPr lang="en-US" smtClean="0"/>
+              <a:rPr lang="en-US"/>
               <a:t>Fourth level</a:t>
             </a:r>
           </a:p>
           <a:p>
             <a:pPr lvl="4"/>
             <a:r>
-              <a:rPr lang="en-US" smtClean="0"/>
+              <a:rPr lang="en-US"/>
               <a:t>Fifth level</a:t>
             </a:r>
-            <a:endParaRPr lang="en-US"/>
           </a:p>
         </p:txBody>
       </p:sp>
@@ -2252,7 +2148,7 @@
           <a:p>
             <a:fld id="{5BCAD085-E8A6-8845-BD4E-CB4CCA059FC4}" type="datetimeFigureOut">
               <a:rPr lang="en-US" smtClean="0"/>
-              <a:t>1/27/13</a:t>
+              <a:t>5/5/26</a:t>
             </a:fld>
             <a:endParaRPr lang="en-US"/>
           </a:p>
@@ -2346,10 +2242,9 @@
           <a:lstStyle/>
           <a:p>
             <a:r>
-              <a:rPr lang="en-US" smtClean="0"/>
+              <a:rPr lang="en-US"/>
               <a:t>Click to edit Master title style</a:t>
             </a:r>
-            <a:endParaRPr lang="en-US"/>
           </a:p>
         </p:txBody>
       </p:sp>
@@ -2370,38 +2265,37 @@
           <a:p>
             <a:pPr lvl="0"/>
             <a:r>
-              <a:rPr lang="en-US" smtClean="0"/>
+              <a:rPr lang="en-US"/>
               <a:t>Click to edit Master text styles</a:t>
             </a:r>
           </a:p>
           <a:p>
             <a:pPr lvl="1"/>
             <a:r>
-              <a:rPr lang="en-US" smtClean="0"/>
+              <a:rPr lang="en-US"/>
               <a:t>Second level</a:t>
             </a:r>
           </a:p>
           <a:p>
             <a:pPr lvl="2"/>
             <a:r>
-              <a:rPr lang="en-US" smtClean="0"/>
+              <a:rPr lang="en-US"/>
               <a:t>Third level</a:t>
             </a:r>
           </a:p>
           <a:p>
             <a:pPr lvl="3"/>
             <a:r>
-              <a:rPr lang="en-US" smtClean="0"/>
+              <a:rPr lang="en-US"/>
               <a:t>Fourth level</a:t>
             </a:r>
           </a:p>
           <a:p>
             <a:pPr lvl="4"/>
             <a:r>
-              <a:rPr lang="en-US" smtClean="0"/>
+              <a:rPr lang="en-US"/>
               <a:t>Fifth level</a:t>
             </a:r>
-            <a:endParaRPr lang="en-US"/>
           </a:p>
         </p:txBody>
       </p:sp>
@@ -2422,7 +2316,7 @@
           <a:p>
             <a:fld id="{5BCAD085-E8A6-8845-BD4E-CB4CCA059FC4}" type="datetimeFigureOut">
               <a:rPr lang="en-US" smtClean="0"/>
-              <a:t>1/27/13</a:t>
+              <a:t>5/5/26</a:t>
             </a:fld>
             <a:endParaRPr lang="en-US"/>
           </a:p>
@@ -2525,10 +2419,9 @@
           </a:lstStyle>
           <a:p>
             <a:r>
-              <a:rPr lang="en-US" smtClean="0"/>
+              <a:rPr lang="en-US"/>
               <a:t>Click to edit Master title style</a:t>
             </a:r>
-            <a:endParaRPr lang="en-US"/>
           </a:p>
         </p:txBody>
       </p:sp>
@@ -2645,7 +2538,7 @@
           <a:p>
             <a:pPr lvl="0"/>
             <a:r>
-              <a:rPr lang="en-US" smtClean="0"/>
+              <a:rPr lang="en-US"/>
               <a:t>Click to edit Master text styles</a:t>
             </a:r>
           </a:p>
@@ -2668,7 +2561,7 @@
           <a:p>
             <a:fld id="{5BCAD085-E8A6-8845-BD4E-CB4CCA059FC4}" type="datetimeFigureOut">
               <a:rPr lang="en-US" smtClean="0"/>
-              <a:t>1/27/13</a:t>
+              <a:t>5/5/26</a:t>
             </a:fld>
             <a:endParaRPr lang="en-US"/>
           </a:p>
@@ -2762,10 +2655,9 @@
           <a:lstStyle/>
           <a:p>
             <a:r>
-              <a:rPr lang="en-US" smtClean="0"/>
+              <a:rPr lang="en-US"/>
               <a:t>Click to edit Master title style</a:t>
             </a:r>
-            <a:endParaRPr lang="en-US"/>
           </a:p>
         </p:txBody>
       </p:sp>
@@ -2819,38 +2711,37 @@
           <a:p>
             <a:pPr lvl="0"/>
             <a:r>
-              <a:rPr lang="en-US" smtClean="0"/>
+              <a:rPr lang="en-US"/>
               <a:t>Click to edit Master text styles</a:t>
             </a:r>
           </a:p>
           <a:p>
             <a:pPr lvl="1"/>
             <a:r>
-              <a:rPr lang="en-US" smtClean="0"/>
+              <a:rPr lang="en-US"/>
               <a:t>Second level</a:t>
             </a:r>
           </a:p>
           <a:p>
             <a:pPr lvl="2"/>
             <a:r>
-              <a:rPr lang="en-US" smtClean="0"/>
+              <a:rPr lang="en-US"/>
               <a:t>Third level</a:t>
             </a:r>
           </a:p>
           <a:p>
             <a:pPr lvl="3"/>
             <a:r>
-              <a:rPr lang="en-US" smtClean="0"/>
+              <a:rPr lang="en-US"/>
               <a:t>Fourth level</a:t>
             </a:r>
           </a:p>
           <a:p>
             <a:pPr lvl="4"/>
             <a:r>
-              <a:rPr lang="en-US" smtClean="0"/>
+              <a:rPr lang="en-US"/>
               <a:t>Fifth level</a:t>
             </a:r>
-            <a:endParaRPr lang="en-US"/>
           </a:p>
         </p:txBody>
       </p:sp>
@@ -2904,38 +2795,37 @@
           <a:p>
             <a:pPr lvl="0"/>
             <a:r>
-              <a:rPr lang="en-US" smtClean="0"/>
+              <a:rPr lang="en-US"/>
               <a:t>Click to edit Master text styles</a:t>
             </a:r>
           </a:p>
           <a:p>
             <a:pPr lvl="1"/>
             <a:r>
-              <a:rPr lang="en-US" smtClean="0"/>
+              <a:rPr lang="en-US"/>
               <a:t>Second level</a:t>
             </a:r>
           </a:p>
           <a:p>
             <a:pPr lvl="2"/>
             <a:r>
-              <a:rPr lang="en-US" smtClean="0"/>
+              <a:rPr lang="en-US"/>
               <a:t>Third level</a:t>
             </a:r>
           </a:p>
           <a:p>
             <a:pPr lvl="3"/>
             <a:r>
-              <a:rPr lang="en-US" smtClean="0"/>
+              <a:rPr lang="en-US"/>
               <a:t>Fourth level</a:t>
             </a:r>
           </a:p>
           <a:p>
             <a:pPr lvl="4"/>
             <a:r>
-              <a:rPr lang="en-US" smtClean="0"/>
+              <a:rPr lang="en-US"/>
               <a:t>Fifth level</a:t>
             </a:r>
-            <a:endParaRPr lang="en-US"/>
           </a:p>
         </p:txBody>
       </p:sp>
@@ -2956,7 +2846,7 @@
           <a:p>
             <a:fld id="{5BCAD085-E8A6-8845-BD4E-CB4CCA059FC4}" type="datetimeFigureOut">
               <a:rPr lang="en-US" smtClean="0"/>
-              <a:t>1/27/13</a:t>
+              <a:t>5/5/26</a:t>
             </a:fld>
             <a:endParaRPr lang="en-US"/>
           </a:p>
@@ -3054,10 +2944,9 @@
           </a:lstStyle>
           <a:p>
             <a:r>
-              <a:rPr lang="en-US" smtClean="0"/>
+              <a:rPr lang="en-US"/>
               <a:t>Click to edit Master title style</a:t>
             </a:r>
-            <a:endParaRPr lang="en-US"/>
           </a:p>
         </p:txBody>
       </p:sp>
@@ -3120,7 +3009,7 @@
           <a:p>
             <a:pPr lvl="0"/>
             <a:r>
-              <a:rPr lang="en-US" smtClean="0"/>
+              <a:rPr lang="en-US"/>
               <a:t>Click to edit Master text styles</a:t>
             </a:r>
           </a:p>
@@ -3176,38 +3065,37 @@
           <a:p>
             <a:pPr lvl="0"/>
             <a:r>
-              <a:rPr lang="en-US" smtClean="0"/>
+              <a:rPr lang="en-US"/>
               <a:t>Click to edit Master text styles</a:t>
             </a:r>
           </a:p>
           <a:p>
             <a:pPr lvl="1"/>
             <a:r>
-              <a:rPr lang="en-US" smtClean="0"/>
+              <a:rPr lang="en-US"/>
               <a:t>Second level</a:t>
             </a:r>
           </a:p>
           <a:p>
             <a:pPr lvl="2"/>
             <a:r>
-              <a:rPr lang="en-US" smtClean="0"/>
+              <a:rPr lang="en-US"/>
               <a:t>Third level</a:t>
             </a:r>
           </a:p>
           <a:p>
             <a:pPr lvl="3"/>
             <a:r>
-              <a:rPr lang="en-US" smtClean="0"/>
+              <a:rPr lang="en-US"/>
               <a:t>Fourth level</a:t>
             </a:r>
           </a:p>
           <a:p>
             <a:pPr lvl="4"/>
             <a:r>
-              <a:rPr lang="en-US" smtClean="0"/>
+              <a:rPr lang="en-US"/>
               <a:t>Fifth level</a:t>
             </a:r>
-            <a:endParaRPr lang="en-US"/>
           </a:p>
         </p:txBody>
       </p:sp>
@@ -3270,7 +3158,7 @@
           <a:p>
             <a:pPr lvl="0"/>
             <a:r>
-              <a:rPr lang="en-US" smtClean="0"/>
+              <a:rPr lang="en-US"/>
               <a:t>Click to edit Master text styles</a:t>
             </a:r>
           </a:p>
@@ -3326,38 +3214,37 @@
           <a:p>
             <a:pPr lvl="0"/>
             <a:r>
-              <a:rPr lang="en-US" smtClean="0"/>
+              <a:rPr lang="en-US"/>
               <a:t>Click to edit Master text styles</a:t>
             </a:r>
           </a:p>
           <a:p>
             <a:pPr lvl="1"/>
             <a:r>
-              <a:rPr lang="en-US" smtClean="0"/>
+              <a:rPr lang="en-US"/>
               <a:t>Second level</a:t>
             </a:r>
           </a:p>
           <a:p>
             <a:pPr lvl="2"/>
             <a:r>
-              <a:rPr lang="en-US" smtClean="0"/>
+              <a:rPr lang="en-US"/>
               <a:t>Third level</a:t>
             </a:r>
           </a:p>
           <a:p>
             <a:pPr lvl="3"/>
             <a:r>
-              <a:rPr lang="en-US" smtClean="0"/>
+              <a:rPr lang="en-US"/>
               <a:t>Fourth level</a:t>
             </a:r>
           </a:p>
           <a:p>
             <a:pPr lvl="4"/>
             <a:r>
-              <a:rPr lang="en-US" smtClean="0"/>
+              <a:rPr lang="en-US"/>
               <a:t>Fifth level</a:t>
             </a:r>
-            <a:endParaRPr lang="en-US"/>
           </a:p>
         </p:txBody>
       </p:sp>
@@ -3378,7 +3265,7 @@
           <a:p>
             <a:fld id="{5BCAD085-E8A6-8845-BD4E-CB4CCA059FC4}" type="datetimeFigureOut">
               <a:rPr lang="en-US" smtClean="0"/>
-              <a:t>1/27/13</a:t>
+              <a:t>5/5/26</a:t>
             </a:fld>
             <a:endParaRPr lang="en-US"/>
           </a:p>
@@ -3472,10 +3359,9 @@
           <a:lstStyle/>
           <a:p>
             <a:r>
-              <a:rPr lang="en-US" smtClean="0"/>
+              <a:rPr lang="en-US"/>
               <a:t>Click to edit Master title style</a:t>
             </a:r>
-            <a:endParaRPr lang="en-US"/>
           </a:p>
         </p:txBody>
       </p:sp>
@@ -3496,7 +3382,7 @@
           <a:p>
             <a:fld id="{5BCAD085-E8A6-8845-BD4E-CB4CCA059FC4}" type="datetimeFigureOut">
               <a:rPr lang="en-US" smtClean="0"/>
-              <a:t>1/27/13</a:t>
+              <a:t>5/5/26</a:t>
             </a:fld>
             <a:endParaRPr lang="en-US"/>
           </a:p>
@@ -3591,7 +3477,7 @@
           <a:p>
             <a:fld id="{5BCAD085-E8A6-8845-BD4E-CB4CCA059FC4}" type="datetimeFigureOut">
               <a:rPr lang="en-US" smtClean="0"/>
-              <a:t>1/27/13</a:t>
+              <a:t>5/5/26</a:t>
             </a:fld>
             <a:endParaRPr lang="en-US"/>
           </a:p>
@@ -3694,10 +3580,9 @@
           </a:lstStyle>
           <a:p>
             <a:r>
-              <a:rPr lang="en-US" smtClean="0"/>
+              <a:rPr lang="en-US"/>
               <a:t>Click to edit Master title style</a:t>
             </a:r>
-            <a:endParaRPr lang="en-US"/>
           </a:p>
         </p:txBody>
       </p:sp>
@@ -3751,38 +3636,37 @@
           <a:p>
             <a:pPr lvl="0"/>
             <a:r>
-              <a:rPr lang="en-US" smtClean="0"/>
+              <a:rPr lang="en-US"/>
               <a:t>Click to edit Master text styles</a:t>
             </a:r>
           </a:p>
           <a:p>
             <a:pPr lvl="1"/>
             <a:r>
-              <a:rPr lang="en-US" smtClean="0"/>
+              <a:rPr lang="en-US"/>
               <a:t>Second level</a:t>
             </a:r>
           </a:p>
           <a:p>
             <a:pPr lvl="2"/>
             <a:r>
-              <a:rPr lang="en-US" smtClean="0"/>
+              <a:rPr lang="en-US"/>
               <a:t>Third level</a:t>
             </a:r>
           </a:p>
           <a:p>
             <a:pPr lvl="3"/>
             <a:r>
-              <a:rPr lang="en-US" smtClean="0"/>
+              <a:rPr lang="en-US"/>
               <a:t>Fourth level</a:t>
             </a:r>
           </a:p>
           <a:p>
             <a:pPr lvl="4"/>
             <a:r>
-              <a:rPr lang="en-US" smtClean="0"/>
+              <a:rPr lang="en-US"/>
               <a:t>Fifth level</a:t>
             </a:r>
-            <a:endParaRPr lang="en-US"/>
           </a:p>
         </p:txBody>
       </p:sp>
@@ -3845,7 +3729,7 @@
           <a:p>
             <a:pPr lvl="0"/>
             <a:r>
-              <a:rPr lang="en-US" smtClean="0"/>
+              <a:rPr lang="en-US"/>
               <a:t>Click to edit Master text styles</a:t>
             </a:r>
           </a:p>
@@ -3868,7 +3752,7 @@
           <a:p>
             <a:fld id="{5BCAD085-E8A6-8845-BD4E-CB4CCA059FC4}" type="datetimeFigureOut">
               <a:rPr lang="en-US" smtClean="0"/>
-              <a:t>1/27/13</a:t>
+              <a:t>5/5/26</a:t>
             </a:fld>
             <a:endParaRPr lang="en-US"/>
           </a:p>
@@ -3971,10 +3855,9 @@
           </a:lstStyle>
           <a:p>
             <a:r>
-              <a:rPr lang="en-US" smtClean="0"/>
+              <a:rPr lang="en-US"/>
               <a:t>Click to edit Master title style</a:t>
             </a:r>
-            <a:endParaRPr lang="en-US"/>
           </a:p>
         </p:txBody>
       </p:sp>
@@ -4098,7 +3981,7 @@
           <a:p>
             <a:pPr lvl="0"/>
             <a:r>
-              <a:rPr lang="en-US" smtClean="0"/>
+              <a:rPr lang="en-US"/>
               <a:t>Click to edit Master text styles</a:t>
             </a:r>
           </a:p>
@@ -4121,7 +4004,7 @@
           <a:p>
             <a:fld id="{5BCAD085-E8A6-8845-BD4E-CB4CCA059FC4}" type="datetimeFigureOut">
               <a:rPr lang="en-US" smtClean="0"/>
-              <a:t>1/27/13</a:t>
+              <a:t>5/5/26</a:t>
             </a:fld>
             <a:endParaRPr lang="en-US"/>
           </a:p>
@@ -4230,10 +4113,9 @@
           <a:lstStyle/>
           <a:p>
             <a:r>
-              <a:rPr lang="en-US" smtClean="0"/>
+              <a:rPr lang="en-US"/>
               <a:t>Click to edit Master title style</a:t>
             </a:r>
-            <a:endParaRPr lang="en-US"/>
           </a:p>
         </p:txBody>
       </p:sp>
@@ -4264,38 +4146,37 @@
           <a:p>
             <a:pPr lvl="0"/>
             <a:r>
-              <a:rPr lang="en-US" smtClean="0"/>
+              <a:rPr lang="en-US"/>
               <a:t>Click to edit Master text styles</a:t>
             </a:r>
           </a:p>
           <a:p>
             <a:pPr lvl="1"/>
             <a:r>
-              <a:rPr lang="en-US" smtClean="0"/>
+              <a:rPr lang="en-US"/>
               <a:t>Second level</a:t>
             </a:r>
           </a:p>
           <a:p>
             <a:pPr lvl="2"/>
             <a:r>
-              <a:rPr lang="en-US" smtClean="0"/>
+              <a:rPr lang="en-US"/>
               <a:t>Third level</a:t>
             </a:r>
           </a:p>
           <a:p>
             <a:pPr lvl="3"/>
             <a:r>
-              <a:rPr lang="en-US" smtClean="0"/>
+              <a:rPr lang="en-US"/>
               <a:t>Fourth level</a:t>
             </a:r>
           </a:p>
           <a:p>
             <a:pPr lvl="4"/>
             <a:r>
-              <a:rPr lang="en-US" smtClean="0"/>
+              <a:rPr lang="en-US"/>
               <a:t>Fifth level</a:t>
             </a:r>
-            <a:endParaRPr lang="en-US"/>
           </a:p>
         </p:txBody>
       </p:sp>
@@ -4334,7 +4215,7 @@
           <a:p>
             <a:fld id="{5BCAD085-E8A6-8845-BD4E-CB4CCA059FC4}" type="datetimeFigureOut">
               <a:rPr lang="en-US" smtClean="0"/>
-              <a:t>1/27/13</a:t>
+              <a:t>5/5/26</a:t>
             </a:fld>
             <a:endParaRPr lang="en-US"/>
           </a:p>
@@ -4693,7 +4574,7 @@
 </file>
 
 <file path=ppt/slides/slide1.xml><?xml version="1.0" encoding="utf-8"?>
-<p:sld xmlns:a="http://schemas.openxmlformats.org/drawingml/2006/main" xmlns:p="http://schemas.openxmlformats.org/presentationml/2006/main" xmlns:r="http://schemas.openxmlformats.org/officeDocument/2006/relationships">
+<p:sld xmlns:a="http://schemas.openxmlformats.org/drawingml/2006/main" xmlns:r="http://schemas.openxmlformats.org/officeDocument/2006/relationships" xmlns:p="http://schemas.openxmlformats.org/presentationml/2006/main">
   <p:cSld>
     <p:spTree>
       <p:nvGrpSpPr>
@@ -4701,7 +4582,14 @@
         <p:cNvGrpSpPr/>
         <p:nvPr/>
       </p:nvGrpSpPr>
-      <p:grpSpPr/>
+      <p:grpSpPr>
+        <a:xfrm>
+          <a:off x="0" y="0"/>
+          <a:ext cx="0" cy="0"/>
+          <a:chOff x="0" y="0"/>
+          <a:chExt cx="0" cy="0"/>
+        </a:xfrm>
+      </p:grpSpPr>
       <p:sp>
         <p:nvSpPr>
           <p:cNvPr id="2" name="Rectangle 1"/>
@@ -4742,6 +4630,7 @@
           <a:lstStyle/>
           <a:p>
             <a:pPr algn="ctr"/>
+            <a:endParaRPr/>
           </a:p>
         </p:txBody>
       </p:sp>
@@ -4762,7 +4651,7 @@
           <a:noFill/>
         </p:spPr>
         <p:txBody>
-          <a:bodyPr wrap="square" lIns="0" rIns="0" tIns="0" bIns="0" anchor="t">
+          <a:bodyPr wrap="square" lIns="0" tIns="0" rIns="0" bIns="0" anchor="t">
             <a:spAutoFit/>
           </a:bodyPr>
           <a:lstStyle/>
@@ -4801,7 +4690,7 @@
           <a:noFill/>
         </p:spPr>
         <p:txBody>
-          <a:bodyPr wrap="square" lIns="0" rIns="0" tIns="0" bIns="0" anchor="t">
+          <a:bodyPr wrap="square" lIns="0" tIns="0" rIns="0" bIns="0" anchor="t">
             <a:spAutoFit/>
           </a:bodyPr>
           <a:lstStyle/>
@@ -4840,7 +4729,7 @@
           <a:noFill/>
         </p:spPr>
         <p:txBody>
-          <a:bodyPr wrap="square" lIns="0" rIns="0" tIns="0" bIns="0" anchor="t">
+          <a:bodyPr wrap="square" lIns="0" tIns="0" rIns="0" bIns="0" anchor="t">
             <a:spAutoFit/>
           </a:bodyPr>
           <a:lstStyle/>
@@ -4871,7 +4760,7 @@
           <p:nvPr/>
         </p:nvPicPr>
         <p:blipFill>
-          <a:blip r:embed="rId2"/>
+          <a:blip r:embed="rId5"/>
           <a:stretch>
             <a:fillRect/>
           </a:stretch>
@@ -4895,7 +4784,7 @@
           <p:nvPr/>
         </p:nvPicPr>
         <p:blipFill>
-          <a:blip r:embed="rId3"/>
+          <a:blip r:embed="rId6"/>
           <a:stretch>
             <a:fillRect/>
           </a:stretch>
@@ -4950,6 +4839,7 @@
           <a:lstStyle/>
           <a:p>
             <a:pPr algn="ctr"/>
+            <a:endParaRPr/>
           </a:p>
         </p:txBody>
       </p:sp>
@@ -4962,16 +4852,16 @@
             <a:picLocks noChangeAspect="1"/>
           </p:cNvPicPr>
           <p:nvPr>
-            <a:videoFile r:link="rId5"/>
+            <a:audioFile r:link="rId2"/>
             <p:extLst>
               <p:ext uri="{DAA4B4D4-6D71-4841-9C94-3DE7FCFB9230}">
-                <p14:media xmlns:p14="http://schemas.microsoft.com/office/powerpoint/2010/main" r:embed="rId4"/>
+                <p14:media xmlns:p14="http://schemas.microsoft.com/office/powerpoint/2010/main" r:embed="rId1"/>
               </p:ext>
             </p:extLst>
           </p:nvPr>
         </p:nvPicPr>
         <p:blipFill>
-          <a:blip r:embed="rId6"/>
+          <a:blip r:embed="rId7"/>
           <a:stretch>
             <a:fillRect/>
           </a:stretch>
@@ -5033,13 +4923,6 @@
                         </p:par>
                       </p:childTnLst>
                     </p:cTn>
-                    <p:nextCondLst>
-                      <p:cond evt="onNext" delay="0">
-                        <p:tgtEl>
-                          <p:sldTgt/>
-                        </p:tgtEl>
-                      </p:cond>
-                    </p:nextCondLst>
                   </p:par>
                 </p:childTnLst>
               </p:cTn>
@@ -5065,7 +4948,7 @@
 </file>
 
 <file path=ppt/slides/slide10.xml><?xml version="1.0" encoding="utf-8"?>
-<p:sld xmlns:a="http://schemas.openxmlformats.org/drawingml/2006/main" xmlns:p="http://schemas.openxmlformats.org/presentationml/2006/main" xmlns:r="http://schemas.openxmlformats.org/officeDocument/2006/relationships">
+<p:sld xmlns:a="http://schemas.openxmlformats.org/drawingml/2006/main" xmlns:r="http://schemas.openxmlformats.org/officeDocument/2006/relationships" xmlns:p="http://schemas.openxmlformats.org/presentationml/2006/main">
   <p:cSld>
     <p:spTree>
       <p:nvGrpSpPr>
@@ -5073,7 +4956,14 @@
         <p:cNvGrpSpPr/>
         <p:nvPr/>
       </p:nvGrpSpPr>
-      <p:grpSpPr/>
+      <p:grpSpPr>
+        <a:xfrm>
+          <a:off x="0" y="0"/>
+          <a:ext cx="0" cy="0"/>
+          <a:chOff x="0" y="0"/>
+          <a:chExt cx="0" cy="0"/>
+        </a:xfrm>
+      </p:grpSpPr>
       <p:sp>
         <p:nvSpPr>
           <p:cNvPr id="2" name="Rectangle 1"/>
@@ -5114,6 +5004,7 @@
           <a:lstStyle/>
           <a:p>
             <a:pPr algn="ctr"/>
+            <a:endParaRPr/>
           </a:p>
         </p:txBody>
       </p:sp>
@@ -5134,7 +5025,7 @@
           <a:noFill/>
         </p:spPr>
         <p:txBody>
-          <a:bodyPr wrap="square" lIns="0" tIns="0" bIns="0" rIns="0">
+          <a:bodyPr wrap="square" lIns="0" tIns="0" rIns="0" bIns="0">
             <a:spAutoFit/>
           </a:bodyPr>
           <a:lstStyle/>
@@ -5205,6 +5096,7 @@
           <a:lstStyle/>
           <a:p>
             <a:pPr algn="ctr"/>
+            <a:endParaRPr/>
           </a:p>
         </p:txBody>
       </p:sp>
@@ -5225,7 +5117,7 @@
           <a:noFill/>
         </p:spPr>
         <p:txBody>
-          <a:bodyPr wrap="square" lIns="0" rIns="0" tIns="0" bIns="0" anchor="t">
+          <a:bodyPr wrap="square" lIns="0" tIns="0" rIns="0" bIns="0" anchor="t">
             <a:spAutoFit/>
           </a:bodyPr>
           <a:lstStyle/>
@@ -5273,7 +5165,7 @@
           <a:noFill/>
         </p:spPr>
         <p:txBody>
-          <a:bodyPr wrap="square" lIns="0" rIns="0" tIns="0" bIns="0">
+          <a:bodyPr wrap="square" lIns="0" tIns="0" rIns="0" bIns="0">
             <a:spAutoFit/>
           </a:bodyPr>
           <a:lstStyle/>
@@ -5293,16 +5185,7 @@
                 </a:solidFill>
                 <a:latin typeface="Helvetica"/>
               </a:rPr>
-              <a:t>■   </a:t>
-            </a:r>
-            <a:r>
-              <a:rPr sz="1600" b="1">
-                <a:solidFill>
-                  <a:srgbClr val="122A52"/>
-                </a:solidFill>
-                <a:latin typeface="Helvetica"/>
-              </a:rPr>
-              <a:t>Her:</a:t>
+              <a:t>■   Her:</a:t>
             </a:r>
             <a:r>
               <a:rPr sz="1600" b="0">
@@ -5330,16 +5213,7 @@
                 </a:solidFill>
                 <a:latin typeface="Helvetica"/>
               </a:rPr>
-              <a:t>■   </a:t>
-            </a:r>
-            <a:r>
-              <a:rPr sz="1600" b="1">
-                <a:solidFill>
-                  <a:srgbClr val="122A52"/>
-                </a:solidFill>
-                <a:latin typeface="Helvetica"/>
-              </a:rPr>
-              <a:t>På jeres codebases:</a:t>
+              <a:t>■   På jeres codebases:</a:t>
             </a:r>
             <a:r>
               <a:rPr sz="1600" b="0">
@@ -5367,16 +5241,7 @@
                 </a:solidFill>
                 <a:latin typeface="Helvetica"/>
               </a:rPr>
-              <a:t>■   </a:t>
-            </a:r>
-            <a:r>
-              <a:rPr sz="1600" b="1">
-                <a:solidFill>
-                  <a:srgbClr val="122A52"/>
-                </a:solidFill>
-                <a:latin typeface="Helvetica"/>
-              </a:rPr>
-              <a:t>Konsekvens af vag prompt:</a:t>
+              <a:t>■   Konsekvens af vag prompt:</a:t>
             </a:r>
             <a:r>
               <a:rPr sz="1600" b="0">
@@ -5430,6 +5295,7 @@
           <a:lstStyle/>
           <a:p>
             <a:pPr algn="ctr"/>
+            <a:endParaRPr/>
           </a:p>
         </p:txBody>
       </p:sp>
@@ -5473,6 +5339,7 @@
           <a:lstStyle/>
           <a:p>
             <a:pPr algn="ctr"/>
+            <a:endParaRPr/>
           </a:p>
         </p:txBody>
       </p:sp>
@@ -5493,7 +5360,7 @@
           <a:noFill/>
         </p:spPr>
         <p:txBody>
-          <a:bodyPr wrap="square" lIns="0" rIns="0" tIns="0" bIns="0" anchor="t">
+          <a:bodyPr wrap="square" lIns="0" tIns="0" rIns="0" bIns="0" anchor="t">
             <a:spAutoFit/>
           </a:bodyPr>
           <a:lstStyle/>
@@ -5524,7 +5391,7 @@
           <p:nvPr/>
         </p:nvPicPr>
         <p:blipFill>
-          <a:blip r:embed="rId2"/>
+          <a:blip r:embed="rId3"/>
           <a:stretch>
             <a:fillRect/>
           </a:stretch>
@@ -5548,7 +5415,7 @@
 </file>
 
 <file path=ppt/slides/slide11.xml><?xml version="1.0" encoding="utf-8"?>
-<p:sld xmlns:a="http://schemas.openxmlformats.org/drawingml/2006/main" xmlns:p="http://schemas.openxmlformats.org/presentationml/2006/main" xmlns:r="http://schemas.openxmlformats.org/officeDocument/2006/relationships">
+<p:sld xmlns:a="http://schemas.openxmlformats.org/drawingml/2006/main" xmlns:r="http://schemas.openxmlformats.org/officeDocument/2006/relationships" xmlns:p="http://schemas.openxmlformats.org/presentationml/2006/main">
   <p:cSld>
     <p:spTree>
       <p:nvGrpSpPr>
@@ -5556,7 +5423,14 @@
         <p:cNvGrpSpPr/>
         <p:nvPr/>
       </p:nvGrpSpPr>
-      <p:grpSpPr/>
+      <p:grpSpPr>
+        <a:xfrm>
+          <a:off x="0" y="0"/>
+          <a:ext cx="0" cy="0"/>
+          <a:chOff x="0" y="0"/>
+          <a:chExt cx="0" cy="0"/>
+        </a:xfrm>
+      </p:grpSpPr>
       <p:sp>
         <p:nvSpPr>
           <p:cNvPr id="2" name="Rectangle 1"/>
@@ -5597,6 +5471,7 @@
           <a:lstStyle/>
           <a:p>
             <a:pPr algn="ctr"/>
+            <a:endParaRPr/>
           </a:p>
         </p:txBody>
       </p:sp>
@@ -5617,7 +5492,7 @@
           <a:noFill/>
         </p:spPr>
         <p:txBody>
-          <a:bodyPr wrap="square" lIns="0" tIns="0" bIns="0" rIns="0">
+          <a:bodyPr wrap="square" lIns="0" tIns="0" rIns="0" bIns="0">
             <a:spAutoFit/>
           </a:bodyPr>
           <a:lstStyle/>
@@ -5688,6 +5563,7 @@
           <a:lstStyle/>
           <a:p>
             <a:pPr algn="ctr"/>
+            <a:endParaRPr/>
           </a:p>
         </p:txBody>
       </p:sp>
@@ -5727,7 +5603,7 @@
           </a:fontRef>
         </p:style>
         <p:txBody>
-          <a:bodyPr rtlCol="0" anchor="ctr" lIns="0" rIns="0" tIns="0" bIns="0"/>
+          <a:bodyPr lIns="0" tIns="0" rIns="0" bIns="0" rtlCol="0" anchor="ctr"/>
           <a:lstStyle/>
           <a:p>
             <a:pPr algn="ctr"/>
@@ -5760,7 +5636,7 @@
           <a:noFill/>
         </p:spPr>
         <p:txBody>
-          <a:bodyPr wrap="square" lIns="0" rIns="0" tIns="0" bIns="0" anchor="t">
+          <a:bodyPr wrap="square" lIns="0" tIns="0" rIns="0" bIns="0" anchor="t">
             <a:spAutoFit/>
           </a:bodyPr>
           <a:lstStyle/>
@@ -5799,7 +5675,7 @@
           <a:noFill/>
         </p:spPr>
         <p:txBody>
-          <a:bodyPr wrap="square" lIns="0" rIns="0" tIns="0" bIns="0" anchor="t">
+          <a:bodyPr wrap="square" lIns="0" tIns="0" rIns="0" bIns="0" anchor="t">
             <a:spAutoFit/>
           </a:bodyPr>
           <a:lstStyle/>
@@ -5862,6 +5738,7 @@
           <a:lstStyle/>
           <a:p>
             <a:pPr algn="ctr"/>
+            <a:endParaRPr/>
           </a:p>
         </p:txBody>
       </p:sp>
@@ -5901,7 +5778,7 @@
           </a:fontRef>
         </p:style>
         <p:txBody>
-          <a:bodyPr rtlCol="0" anchor="ctr" lIns="0" rIns="0" tIns="0" bIns="0"/>
+          <a:bodyPr lIns="0" tIns="0" rIns="0" bIns="0" rtlCol="0" anchor="ctr"/>
           <a:lstStyle/>
           <a:p>
             <a:pPr algn="ctr"/>
@@ -5934,7 +5811,7 @@
           <a:noFill/>
         </p:spPr>
         <p:txBody>
-          <a:bodyPr wrap="square" lIns="0" rIns="0" tIns="0" bIns="0" anchor="t">
+          <a:bodyPr wrap="square" lIns="0" tIns="0" rIns="0" bIns="0" anchor="t">
             <a:spAutoFit/>
           </a:bodyPr>
           <a:lstStyle/>
@@ -5973,7 +5850,7 @@
           <a:noFill/>
         </p:spPr>
         <p:txBody>
-          <a:bodyPr wrap="square" lIns="0" rIns="0" tIns="0" bIns="0" anchor="t">
+          <a:bodyPr wrap="square" lIns="0" tIns="0" rIns="0" bIns="0" anchor="t">
             <a:spAutoFit/>
           </a:bodyPr>
           <a:lstStyle/>
@@ -6036,6 +5913,7 @@
           <a:lstStyle/>
           <a:p>
             <a:pPr algn="ctr"/>
+            <a:endParaRPr/>
           </a:p>
         </p:txBody>
       </p:sp>
@@ -6075,7 +5953,7 @@
           </a:fontRef>
         </p:style>
         <p:txBody>
-          <a:bodyPr rtlCol="0" anchor="ctr" lIns="0" rIns="0" tIns="0" bIns="0"/>
+          <a:bodyPr lIns="0" tIns="0" rIns="0" bIns="0" rtlCol="0" anchor="ctr"/>
           <a:lstStyle/>
           <a:p>
             <a:pPr algn="ctr"/>
@@ -6108,7 +5986,7 @@
           <a:noFill/>
         </p:spPr>
         <p:txBody>
-          <a:bodyPr wrap="square" lIns="0" rIns="0" tIns="0" bIns="0" anchor="t">
+          <a:bodyPr wrap="square" lIns="0" tIns="0" rIns="0" bIns="0" anchor="t">
             <a:spAutoFit/>
           </a:bodyPr>
           <a:lstStyle/>
@@ -6147,7 +6025,7 @@
           <a:noFill/>
         </p:spPr>
         <p:txBody>
-          <a:bodyPr wrap="square" lIns="0" rIns="0" tIns="0" bIns="0" anchor="t">
+          <a:bodyPr wrap="square" lIns="0" tIns="0" rIns="0" bIns="0" anchor="t">
             <a:spAutoFit/>
           </a:bodyPr>
           <a:lstStyle/>
@@ -6210,6 +6088,7 @@
           <a:lstStyle/>
           <a:p>
             <a:pPr algn="ctr"/>
+            <a:endParaRPr/>
           </a:p>
         </p:txBody>
       </p:sp>
@@ -6249,7 +6128,7 @@
           </a:fontRef>
         </p:style>
         <p:txBody>
-          <a:bodyPr rtlCol="0" anchor="ctr" lIns="0" rIns="0" tIns="0" bIns="0"/>
+          <a:bodyPr lIns="0" tIns="0" rIns="0" bIns="0" rtlCol="0" anchor="ctr"/>
           <a:lstStyle/>
           <a:p>
             <a:pPr algn="ctr"/>
@@ -6282,7 +6161,7 @@
           <a:noFill/>
         </p:spPr>
         <p:txBody>
-          <a:bodyPr wrap="square" lIns="0" rIns="0" tIns="0" bIns="0" anchor="t">
+          <a:bodyPr wrap="square" lIns="0" tIns="0" rIns="0" bIns="0" anchor="t">
             <a:spAutoFit/>
           </a:bodyPr>
           <a:lstStyle/>
@@ -6321,7 +6200,7 @@
           <a:noFill/>
         </p:spPr>
         <p:txBody>
-          <a:bodyPr wrap="square" lIns="0" rIns="0" tIns="0" bIns="0" anchor="t">
+          <a:bodyPr wrap="square" lIns="0" tIns="0" rIns="0" bIns="0" anchor="t">
             <a:spAutoFit/>
           </a:bodyPr>
           <a:lstStyle/>
@@ -6361,7 +6240,7 @@
           <a:noFill/>
         </p:spPr>
         <p:txBody>
-          <a:bodyPr wrap="square" lIns="0" rIns="0" tIns="0" bIns="0" anchor="t">
+          <a:bodyPr wrap="square" lIns="0" tIns="0" rIns="0" bIns="0" anchor="t">
             <a:spAutoFit/>
           </a:bodyPr>
           <a:lstStyle/>
@@ -6425,6 +6304,7 @@
           <a:lstStyle/>
           <a:p>
             <a:pPr algn="ctr"/>
+            <a:endParaRPr/>
           </a:p>
         </p:txBody>
       </p:sp>
@@ -6445,7 +6325,7 @@
           <a:noFill/>
         </p:spPr>
         <p:txBody>
-          <a:bodyPr wrap="square" lIns="0" rIns="0" tIns="0" bIns="0">
+          <a:bodyPr wrap="square" lIns="0" tIns="0" rIns="0" bIns="0">
             <a:spAutoFit/>
           </a:bodyPr>
           <a:lstStyle/>
@@ -6580,7 +6460,7 @@
           <a:noFill/>
         </p:spPr>
         <p:txBody>
-          <a:bodyPr wrap="square" lIns="0" rIns="0" tIns="0" bIns="0" anchor="t">
+          <a:bodyPr wrap="square" lIns="0" tIns="0" rIns="0" bIns="0" anchor="t">
             <a:spAutoFit/>
           </a:bodyPr>
           <a:lstStyle/>
@@ -6642,6 +6522,7 @@
           <a:lstStyle/>
           <a:p>
             <a:pPr algn="ctr"/>
+            <a:endParaRPr/>
           </a:p>
         </p:txBody>
       </p:sp>
@@ -6685,6 +6566,7 @@
           <a:lstStyle/>
           <a:p>
             <a:pPr algn="ctr"/>
+            <a:endParaRPr/>
           </a:p>
         </p:txBody>
       </p:sp>
@@ -6705,7 +6587,7 @@
           <a:noFill/>
         </p:spPr>
         <p:txBody>
-          <a:bodyPr wrap="square" lIns="0" rIns="0" tIns="0" bIns="0" anchor="t">
+          <a:bodyPr wrap="square" lIns="0" tIns="0" rIns="0" bIns="0" anchor="t">
             <a:spAutoFit/>
           </a:bodyPr>
           <a:lstStyle/>
@@ -6736,7 +6618,7 @@
           <p:nvPr/>
         </p:nvPicPr>
         <p:blipFill>
-          <a:blip r:embed="rId2"/>
+          <a:blip r:embed="rId3"/>
           <a:stretch>
             <a:fillRect/>
           </a:stretch>
@@ -6760,7 +6642,7 @@
 </file>
 
 <file path=ppt/slides/slide2.xml><?xml version="1.0" encoding="utf-8"?>
-<p:sld xmlns:a="http://schemas.openxmlformats.org/drawingml/2006/main" xmlns:p="http://schemas.openxmlformats.org/presentationml/2006/main" xmlns:r="http://schemas.openxmlformats.org/officeDocument/2006/relationships">
+<p:sld xmlns:a="http://schemas.openxmlformats.org/drawingml/2006/main" xmlns:r="http://schemas.openxmlformats.org/officeDocument/2006/relationships" xmlns:p="http://schemas.openxmlformats.org/presentationml/2006/main">
   <p:cSld>
     <p:spTree>
       <p:nvGrpSpPr>
@@ -6768,7 +6650,14 @@
         <p:cNvGrpSpPr/>
         <p:nvPr/>
       </p:nvGrpSpPr>
-      <p:grpSpPr/>
+      <p:grpSpPr>
+        <a:xfrm>
+          <a:off x="0" y="0"/>
+          <a:ext cx="0" cy="0"/>
+          <a:chOff x="0" y="0"/>
+          <a:chExt cx="0" cy="0"/>
+        </a:xfrm>
+      </p:grpSpPr>
       <p:sp>
         <p:nvSpPr>
           <p:cNvPr id="2" name="Rectangle 1"/>
@@ -6809,6 +6698,7 @@
           <a:lstStyle/>
           <a:p>
             <a:pPr algn="ctr"/>
+            <a:endParaRPr/>
           </a:p>
         </p:txBody>
       </p:sp>
@@ -6829,7 +6719,7 @@
           <a:noFill/>
         </p:spPr>
         <p:txBody>
-          <a:bodyPr wrap="square" lIns="0" rIns="0" tIns="0" bIns="0" anchor="t">
+          <a:bodyPr wrap="square" lIns="0" tIns="0" rIns="0" bIns="0" anchor="t">
             <a:spAutoFit/>
           </a:bodyPr>
           <a:lstStyle/>
@@ -6891,6 +6781,7 @@
           <a:lstStyle/>
           <a:p>
             <a:pPr algn="ctr"/>
+            <a:endParaRPr/>
           </a:p>
         </p:txBody>
       </p:sp>
@@ -6930,7 +6821,7 @@
           </a:fontRef>
         </p:style>
         <p:txBody>
-          <a:bodyPr rtlCol="0" anchor="ctr" lIns="182880" rIns="182880"/>
+          <a:bodyPr lIns="182880" rIns="182880" rtlCol="0" anchor="ctr"/>
           <a:lstStyle/>
           <a:p>
             <a:pPr algn="l"/>
@@ -6982,7 +6873,7 @@
           </a:fontRef>
         </p:style>
         <p:txBody>
-          <a:bodyPr rtlCol="0" anchor="ctr" lIns="228600" rIns="182880"/>
+          <a:bodyPr lIns="228600" rIns="182880" rtlCol="0" anchor="ctr"/>
           <a:lstStyle/>
           <a:p>
             <a:pPr algn="l"/>
@@ -7034,7 +6925,7 @@
           </a:fontRef>
         </p:style>
         <p:txBody>
-          <a:bodyPr rtlCol="0" anchor="ctr" lIns="182880" rIns="182880"/>
+          <a:bodyPr lIns="182880" rIns="182880" rtlCol="0" anchor="ctr"/>
           <a:lstStyle/>
           <a:p>
             <a:pPr algn="l"/>
@@ -7086,7 +6977,7 @@
           </a:fontRef>
         </p:style>
         <p:txBody>
-          <a:bodyPr rtlCol="0" anchor="ctr" lIns="228600" rIns="182880"/>
+          <a:bodyPr lIns="228600" rIns="182880" rtlCol="0" anchor="ctr"/>
           <a:lstStyle/>
           <a:p>
             <a:pPr algn="l"/>
@@ -7138,7 +7029,7 @@
           </a:fontRef>
         </p:style>
         <p:txBody>
-          <a:bodyPr rtlCol="0" anchor="ctr" lIns="182880" rIns="182880"/>
+          <a:bodyPr lIns="182880" rIns="182880" rtlCol="0" anchor="ctr"/>
           <a:lstStyle/>
           <a:p>
             <a:pPr algn="l"/>
@@ -7190,7 +7081,7 @@
           </a:fontRef>
         </p:style>
         <p:txBody>
-          <a:bodyPr rtlCol="0" anchor="ctr" lIns="228600" rIns="182880"/>
+          <a:bodyPr lIns="228600" rIns="182880" rtlCol="0" anchor="ctr"/>
           <a:lstStyle/>
           <a:p>
             <a:pPr algn="l"/>
@@ -7242,7 +7133,7 @@
           </a:fontRef>
         </p:style>
         <p:txBody>
-          <a:bodyPr rtlCol="0" anchor="ctr" lIns="182880" rIns="182880"/>
+          <a:bodyPr lIns="182880" rIns="182880" rtlCol="0" anchor="ctr"/>
           <a:lstStyle/>
           <a:p>
             <a:pPr algn="l"/>
@@ -7294,7 +7185,7 @@
           </a:fontRef>
         </p:style>
         <p:txBody>
-          <a:bodyPr rtlCol="0" anchor="ctr" lIns="228600" rIns="182880"/>
+          <a:bodyPr lIns="228600" rIns="182880" rtlCol="0" anchor="ctr"/>
           <a:lstStyle/>
           <a:p>
             <a:pPr algn="l"/>
@@ -7346,7 +7237,7 @@
           </a:fontRef>
         </p:style>
         <p:txBody>
-          <a:bodyPr rtlCol="0" anchor="ctr" lIns="182880" rIns="182880"/>
+          <a:bodyPr lIns="182880" rIns="182880" rtlCol="0" anchor="ctr"/>
           <a:lstStyle/>
           <a:p>
             <a:pPr algn="l"/>
@@ -7398,7 +7289,7 @@
           </a:fontRef>
         </p:style>
         <p:txBody>
-          <a:bodyPr rtlCol="0" anchor="ctr" lIns="228600" rIns="182880"/>
+          <a:bodyPr lIns="228600" rIns="182880" rtlCol="0" anchor="ctr"/>
           <a:lstStyle/>
           <a:p>
             <a:pPr algn="l"/>
@@ -7454,6 +7345,7 @@
           <a:lstStyle/>
           <a:p>
             <a:pPr algn="ctr"/>
+            <a:endParaRPr/>
           </a:p>
         </p:txBody>
       </p:sp>
@@ -7497,6 +7389,7 @@
           <a:lstStyle/>
           <a:p>
             <a:pPr algn="ctr"/>
+            <a:endParaRPr/>
           </a:p>
         </p:txBody>
       </p:sp>
@@ -7517,7 +7410,7 @@
           <a:noFill/>
         </p:spPr>
         <p:txBody>
-          <a:bodyPr wrap="square" lIns="0" rIns="0" tIns="0" bIns="0" anchor="t">
+          <a:bodyPr wrap="square" lIns="0" tIns="0" rIns="0" bIns="0" anchor="t">
             <a:spAutoFit/>
           </a:bodyPr>
           <a:lstStyle/>
@@ -7548,7 +7441,7 @@
           <p:nvPr/>
         </p:nvPicPr>
         <p:blipFill>
-          <a:blip r:embed="rId2"/>
+          <a:blip r:embed="rId3"/>
           <a:stretch>
             <a:fillRect/>
           </a:stretch>
@@ -7572,7 +7465,7 @@
 </file>
 
 <file path=ppt/slides/slide3.xml><?xml version="1.0" encoding="utf-8"?>
-<p:sld xmlns:a="http://schemas.openxmlformats.org/drawingml/2006/main" xmlns:p="http://schemas.openxmlformats.org/presentationml/2006/main" xmlns:r="http://schemas.openxmlformats.org/officeDocument/2006/relationships">
+<p:sld xmlns:a="http://schemas.openxmlformats.org/drawingml/2006/main" xmlns:r="http://schemas.openxmlformats.org/officeDocument/2006/relationships" xmlns:p="http://schemas.openxmlformats.org/presentationml/2006/main">
   <p:cSld>
     <p:spTree>
       <p:nvGrpSpPr>
@@ -7580,7 +7473,14 @@
         <p:cNvGrpSpPr/>
         <p:nvPr/>
       </p:nvGrpSpPr>
-      <p:grpSpPr/>
+      <p:grpSpPr>
+        <a:xfrm>
+          <a:off x="0" y="0"/>
+          <a:ext cx="0" cy="0"/>
+          <a:chOff x="0" y="0"/>
+          <a:chExt cx="0" cy="0"/>
+        </a:xfrm>
+      </p:grpSpPr>
       <p:sp>
         <p:nvSpPr>
           <p:cNvPr id="2" name="Rectangle 1"/>
@@ -7621,6 +7521,7 @@
           <a:lstStyle/>
           <a:p>
             <a:pPr algn="ctr"/>
+            <a:endParaRPr/>
           </a:p>
         </p:txBody>
       </p:sp>
@@ -7641,7 +7542,7 @@
           <a:noFill/>
         </p:spPr>
         <p:txBody>
-          <a:bodyPr wrap="square" lIns="0" tIns="0" bIns="0" rIns="0">
+          <a:bodyPr wrap="square" lIns="0" tIns="0" rIns="0" bIns="0">
             <a:spAutoFit/>
           </a:bodyPr>
           <a:lstStyle/>
@@ -7712,6 +7613,7 @@
           <a:lstStyle/>
           <a:p>
             <a:pPr algn="ctr"/>
+            <a:endParaRPr/>
           </a:p>
         </p:txBody>
       </p:sp>
@@ -7751,7 +7653,7 @@
           </a:fontRef>
         </p:style>
         <p:txBody>
-          <a:bodyPr rtlCol="0" anchor="ctr" lIns="0" rIns="0" tIns="0" bIns="0"/>
+          <a:bodyPr lIns="0" tIns="0" rIns="0" bIns="0" rtlCol="0" anchor="ctr"/>
           <a:lstStyle/>
           <a:p>
             <a:pPr algn="ctr"/>
@@ -7784,7 +7686,7 @@
           <a:noFill/>
         </p:spPr>
         <p:txBody>
-          <a:bodyPr wrap="square" lIns="0" rIns="0" tIns="0" bIns="0" anchor="t">
+          <a:bodyPr wrap="square" lIns="0" tIns="0" rIns="0" bIns="0" anchor="t">
             <a:spAutoFit/>
           </a:bodyPr>
           <a:lstStyle/>
@@ -7823,7 +7725,7 @@
           <a:noFill/>
         </p:spPr>
         <p:txBody>
-          <a:bodyPr wrap="square" lIns="0" rIns="0" tIns="0" bIns="0" anchor="t">
+          <a:bodyPr wrap="square" lIns="0" tIns="0" rIns="0" bIns="0" anchor="t">
             <a:spAutoFit/>
           </a:bodyPr>
           <a:lstStyle/>
@@ -7903,6 +7805,7 @@
           <a:lstStyle/>
           <a:p>
             <a:pPr algn="ctr"/>
+            <a:endParaRPr/>
           </a:p>
         </p:txBody>
       </p:sp>
@@ -7942,7 +7845,7 @@
           </a:fontRef>
         </p:style>
         <p:txBody>
-          <a:bodyPr rtlCol="0" anchor="ctr" lIns="0" rIns="0" tIns="0" bIns="0"/>
+          <a:bodyPr lIns="0" tIns="0" rIns="0" bIns="0" rtlCol="0" anchor="ctr"/>
           <a:lstStyle/>
           <a:p>
             <a:pPr algn="ctr"/>
@@ -7975,7 +7878,7 @@
           <a:noFill/>
         </p:spPr>
         <p:txBody>
-          <a:bodyPr wrap="square" lIns="0" rIns="0" tIns="0" bIns="0" anchor="t">
+          <a:bodyPr wrap="square" lIns="0" tIns="0" rIns="0" bIns="0" anchor="t">
             <a:spAutoFit/>
           </a:bodyPr>
           <a:lstStyle/>
@@ -8014,7 +7917,7 @@
           <a:noFill/>
         </p:spPr>
         <p:txBody>
-          <a:bodyPr wrap="square" lIns="0" rIns="0" tIns="0" bIns="0" anchor="t">
+          <a:bodyPr wrap="square" lIns="0" tIns="0" rIns="0" bIns="0" anchor="t">
             <a:spAutoFit/>
           </a:bodyPr>
           <a:lstStyle/>
@@ -8112,6 +8015,7 @@
           <a:lstStyle/>
           <a:p>
             <a:pPr algn="ctr"/>
+            <a:endParaRPr/>
           </a:p>
         </p:txBody>
       </p:sp>
@@ -8155,6 +8059,7 @@
           <a:lstStyle/>
           <a:p>
             <a:pPr algn="ctr"/>
+            <a:endParaRPr/>
           </a:p>
         </p:txBody>
       </p:sp>
@@ -8175,7 +8080,7 @@
           <a:noFill/>
         </p:spPr>
         <p:txBody>
-          <a:bodyPr wrap="square" lIns="0" rIns="0" tIns="0" bIns="0" anchor="t">
+          <a:bodyPr wrap="square" lIns="0" tIns="0" rIns="0" bIns="0" anchor="t">
             <a:spAutoFit/>
           </a:bodyPr>
           <a:lstStyle/>
@@ -8206,7 +8111,7 @@
           <p:nvPr/>
         </p:nvPicPr>
         <p:blipFill>
-          <a:blip r:embed="rId2"/>
+          <a:blip r:embed="rId3"/>
           <a:stretch>
             <a:fillRect/>
           </a:stretch>
@@ -8230,7 +8135,7 @@
 </file>
 
 <file path=ppt/slides/slide4.xml><?xml version="1.0" encoding="utf-8"?>
-<p:sld xmlns:a="http://schemas.openxmlformats.org/drawingml/2006/main" xmlns:p="http://schemas.openxmlformats.org/presentationml/2006/main" xmlns:r="http://schemas.openxmlformats.org/officeDocument/2006/relationships">
+<p:sld xmlns:a="http://schemas.openxmlformats.org/drawingml/2006/main" xmlns:r="http://schemas.openxmlformats.org/officeDocument/2006/relationships" xmlns:p="http://schemas.openxmlformats.org/presentationml/2006/main">
   <p:cSld>
     <p:spTree>
       <p:nvGrpSpPr>
@@ -8238,7 +8143,14 @@
         <p:cNvGrpSpPr/>
         <p:nvPr/>
       </p:nvGrpSpPr>
-      <p:grpSpPr/>
+      <p:grpSpPr>
+        <a:xfrm>
+          <a:off x="0" y="0"/>
+          <a:ext cx="0" cy="0"/>
+          <a:chOff x="0" y="0"/>
+          <a:chExt cx="0" cy="0"/>
+        </a:xfrm>
+      </p:grpSpPr>
       <p:sp>
         <p:nvSpPr>
           <p:cNvPr id="2" name="Rectangle 1"/>
@@ -8279,6 +8191,7 @@
           <a:lstStyle/>
           <a:p>
             <a:pPr algn="ctr"/>
+            <a:endParaRPr/>
           </a:p>
         </p:txBody>
       </p:sp>
@@ -8299,7 +8212,7 @@
           <a:noFill/>
         </p:spPr>
         <p:txBody>
-          <a:bodyPr wrap="square" lIns="0" tIns="0" bIns="0" rIns="0">
+          <a:bodyPr wrap="square" lIns="0" tIns="0" rIns="0" bIns="0">
             <a:spAutoFit/>
           </a:bodyPr>
           <a:lstStyle/>
@@ -8370,6 +8283,7 @@
           <a:lstStyle/>
           <a:p>
             <a:pPr algn="ctr"/>
+            <a:endParaRPr/>
           </a:p>
         </p:txBody>
       </p:sp>
@@ -8413,6 +8327,7 @@
           <a:lstStyle/>
           <a:p>
             <a:pPr algn="ctr"/>
+            <a:endParaRPr/>
           </a:p>
         </p:txBody>
       </p:sp>
@@ -8433,7 +8348,7 @@
           <a:noFill/>
         </p:spPr>
         <p:txBody>
-          <a:bodyPr wrap="square" lIns="0" rIns="0" tIns="0" bIns="0" anchor="t">
+          <a:bodyPr wrap="square" lIns="0" tIns="0" rIns="0" bIns="0" anchor="t">
             <a:spAutoFit/>
           </a:bodyPr>
           <a:lstStyle/>
@@ -8472,7 +8387,7 @@
           <a:noFill/>
         </p:spPr>
         <p:txBody>
-          <a:bodyPr wrap="square" lIns="0" rIns="0" tIns="0" bIns="0" anchor="t">
+          <a:bodyPr wrap="square" lIns="0" tIns="0" rIns="0" bIns="0" anchor="t">
             <a:spAutoFit/>
           </a:bodyPr>
           <a:lstStyle/>
@@ -8511,7 +8426,7 @@
           <a:noFill/>
         </p:spPr>
         <p:txBody>
-          <a:bodyPr wrap="square" lIns="0" rIns="0" tIns="0" bIns="0" anchor="t">
+          <a:bodyPr wrap="square" lIns="0" tIns="0" rIns="0" bIns="0" anchor="t">
             <a:spAutoFit/>
           </a:bodyPr>
           <a:lstStyle/>
@@ -8550,7 +8465,7 @@
           <a:noFill/>
         </p:spPr>
         <p:txBody>
-          <a:bodyPr wrap="square" lIns="0" rIns="0" tIns="0" bIns="0" anchor="t">
+          <a:bodyPr wrap="square" lIns="0" tIns="0" rIns="0" bIns="0" anchor="t">
             <a:spAutoFit/>
           </a:bodyPr>
           <a:lstStyle/>
@@ -8630,6 +8545,7 @@
           <a:lstStyle/>
           <a:p>
             <a:pPr algn="ctr"/>
+            <a:endParaRPr/>
           </a:p>
         </p:txBody>
       </p:sp>
@@ -8673,6 +8589,7 @@
           <a:lstStyle/>
           <a:p>
             <a:pPr algn="ctr"/>
+            <a:endParaRPr/>
           </a:p>
         </p:txBody>
       </p:sp>
@@ -8693,7 +8610,7 @@
           <a:noFill/>
         </p:spPr>
         <p:txBody>
-          <a:bodyPr wrap="square" lIns="0" rIns="0" tIns="0" bIns="0" anchor="t">
+          <a:bodyPr wrap="square" lIns="0" tIns="0" rIns="0" bIns="0" anchor="t">
             <a:spAutoFit/>
           </a:bodyPr>
           <a:lstStyle/>
@@ -8724,7 +8641,7 @@
           <p:nvPr/>
         </p:nvPicPr>
         <p:blipFill>
-          <a:blip r:embed="rId2"/>
+          <a:blip r:embed="rId3"/>
           <a:stretch>
             <a:fillRect/>
           </a:stretch>
@@ -8748,7 +8665,7 @@
 </file>
 
 <file path=ppt/slides/slide5.xml><?xml version="1.0" encoding="utf-8"?>
-<p:sld xmlns:a="http://schemas.openxmlformats.org/drawingml/2006/main" xmlns:p="http://schemas.openxmlformats.org/presentationml/2006/main" xmlns:r="http://schemas.openxmlformats.org/officeDocument/2006/relationships">
+<p:sld xmlns:a="http://schemas.openxmlformats.org/drawingml/2006/main" xmlns:r="http://schemas.openxmlformats.org/officeDocument/2006/relationships" xmlns:p="http://schemas.openxmlformats.org/presentationml/2006/main">
   <p:cSld>
     <p:spTree>
       <p:nvGrpSpPr>
@@ -8756,7 +8673,14 @@
         <p:cNvGrpSpPr/>
         <p:nvPr/>
       </p:nvGrpSpPr>
-      <p:grpSpPr/>
+      <p:grpSpPr>
+        <a:xfrm>
+          <a:off x="0" y="0"/>
+          <a:ext cx="0" cy="0"/>
+          <a:chOff x="0" y="0"/>
+          <a:chExt cx="0" cy="0"/>
+        </a:xfrm>
+      </p:grpSpPr>
       <p:sp>
         <p:nvSpPr>
           <p:cNvPr id="2" name="Rectangle 1"/>
@@ -8797,6 +8721,7 @@
           <a:lstStyle/>
           <a:p>
             <a:pPr algn="ctr"/>
+            <a:endParaRPr/>
           </a:p>
         </p:txBody>
       </p:sp>
@@ -8817,7 +8742,7 @@
           <a:noFill/>
         </p:spPr>
         <p:txBody>
-          <a:bodyPr wrap="square" lIns="0" tIns="0" bIns="0" rIns="0">
+          <a:bodyPr wrap="square" lIns="0" tIns="0" rIns="0" bIns="0">
             <a:spAutoFit/>
           </a:bodyPr>
           <a:lstStyle/>
@@ -8865,7 +8790,7 @@
           <a:noFill/>
         </p:spPr>
         <p:txBody>
-          <a:bodyPr wrap="square" lIns="0" rIns="0" tIns="0" bIns="0" anchor="t">
+          <a:bodyPr wrap="square" lIns="0" tIns="0" rIns="0" bIns="0" anchor="t">
             <a:spAutoFit/>
           </a:bodyPr>
           <a:lstStyle/>
@@ -8904,7 +8829,7 @@
           <a:noFill/>
         </p:spPr>
         <p:txBody>
-          <a:bodyPr wrap="square" lIns="0" rIns="0" tIns="0" bIns="0" anchor="t">
+          <a:bodyPr wrap="square" lIns="0" tIns="0" rIns="0" bIns="0" anchor="t">
             <a:spAutoFit/>
           </a:bodyPr>
           <a:lstStyle/>
@@ -8966,6 +8891,7 @@
           <a:lstStyle/>
           <a:p>
             <a:pPr algn="ctr"/>
+            <a:endParaRPr/>
           </a:p>
         </p:txBody>
       </p:sp>
@@ -8986,7 +8912,7 @@
           <a:noFill/>
         </p:spPr>
         <p:txBody>
-          <a:bodyPr wrap="square" lIns="0" rIns="0" tIns="0" bIns="0" anchor="ctr">
+          <a:bodyPr wrap="square" lIns="0" tIns="0" rIns="0" bIns="0" anchor="ctr">
             <a:spAutoFit/>
           </a:bodyPr>
           <a:lstStyle/>
@@ -9048,6 +8974,7 @@
           <a:lstStyle/>
           <a:p>
             <a:pPr algn="ctr"/>
+            <a:endParaRPr/>
           </a:p>
         </p:txBody>
       </p:sp>
@@ -9068,7 +8995,7 @@
           <a:noFill/>
         </p:spPr>
         <p:txBody>
-          <a:bodyPr wrap="square" lIns="0" rIns="0" tIns="0" bIns="0" anchor="t">
+          <a:bodyPr wrap="square" lIns="0" tIns="0" rIns="0" bIns="0" anchor="t">
             <a:spAutoFit/>
           </a:bodyPr>
           <a:lstStyle/>
@@ -9107,7 +9034,7 @@
           <a:noFill/>
         </p:spPr>
         <p:txBody>
-          <a:bodyPr wrap="square" lIns="0" rIns="0" tIns="0" bIns="0" anchor="t">
+          <a:bodyPr wrap="square" lIns="0" tIns="0" rIns="0" bIns="0" anchor="t">
             <a:spAutoFit/>
           </a:bodyPr>
           <a:lstStyle/>
@@ -9169,6 +9096,7 @@
           <a:lstStyle/>
           <a:p>
             <a:pPr algn="ctr"/>
+            <a:endParaRPr/>
           </a:p>
         </p:txBody>
       </p:sp>
@@ -9212,6 +9140,7 @@
           <a:lstStyle/>
           <a:p>
             <a:pPr algn="ctr"/>
+            <a:endParaRPr/>
           </a:p>
         </p:txBody>
       </p:sp>
@@ -9232,7 +9161,7 @@
           <a:noFill/>
         </p:spPr>
         <p:txBody>
-          <a:bodyPr wrap="square" lIns="0" rIns="0" tIns="0" bIns="0" anchor="t">
+          <a:bodyPr wrap="square" lIns="0" tIns="0" rIns="0" bIns="0" anchor="t">
             <a:spAutoFit/>
           </a:bodyPr>
           <a:lstStyle/>
@@ -9263,7 +9192,7 @@
           <p:nvPr/>
         </p:nvPicPr>
         <p:blipFill>
-          <a:blip r:embed="rId2"/>
+          <a:blip r:embed="rId3"/>
           <a:stretch>
             <a:fillRect/>
           </a:stretch>
@@ -9287,7 +9216,7 @@
 </file>
 
 <file path=ppt/slides/slide6.xml><?xml version="1.0" encoding="utf-8"?>
-<p:sld xmlns:a="http://schemas.openxmlformats.org/drawingml/2006/main" xmlns:p="http://schemas.openxmlformats.org/presentationml/2006/main" xmlns:r="http://schemas.openxmlformats.org/officeDocument/2006/relationships">
+<p:sld xmlns:a="http://schemas.openxmlformats.org/drawingml/2006/main" xmlns:r="http://schemas.openxmlformats.org/officeDocument/2006/relationships" xmlns:p="http://schemas.openxmlformats.org/presentationml/2006/main">
   <p:cSld>
     <p:spTree>
       <p:nvGrpSpPr>
@@ -9295,7 +9224,14 @@
         <p:cNvGrpSpPr/>
         <p:nvPr/>
       </p:nvGrpSpPr>
-      <p:grpSpPr/>
+      <p:grpSpPr>
+        <a:xfrm>
+          <a:off x="0" y="0"/>
+          <a:ext cx="0" cy="0"/>
+          <a:chOff x="0" y="0"/>
+          <a:chExt cx="0" cy="0"/>
+        </a:xfrm>
+      </p:grpSpPr>
       <p:sp>
         <p:nvSpPr>
           <p:cNvPr id="2" name="Rectangle 1"/>
@@ -9336,6 +9272,7 @@
           <a:lstStyle/>
           <a:p>
             <a:pPr algn="ctr"/>
+            <a:endParaRPr/>
           </a:p>
         </p:txBody>
       </p:sp>
@@ -9356,7 +9293,7 @@
           <a:noFill/>
         </p:spPr>
         <p:txBody>
-          <a:bodyPr wrap="square" lIns="0" tIns="0" bIns="0" rIns="0">
+          <a:bodyPr wrap="square" lIns="0" tIns="0" rIns="0" bIns="0">
             <a:spAutoFit/>
           </a:bodyPr>
           <a:lstStyle/>
@@ -9427,6 +9364,7 @@
           <a:lstStyle/>
           <a:p>
             <a:pPr algn="ctr"/>
+            <a:endParaRPr/>
           </a:p>
         </p:txBody>
       </p:sp>
@@ -9466,7 +9404,7 @@
           </a:fontRef>
         </p:style>
         <p:txBody>
-          <a:bodyPr rtlCol="0" anchor="ctr" lIns="0" rIns="0" tIns="0" bIns="0"/>
+          <a:bodyPr lIns="0" tIns="0" rIns="0" bIns="0" rtlCol="0" anchor="ctr"/>
           <a:lstStyle/>
           <a:p>
             <a:pPr algn="ctr"/>
@@ -9499,7 +9437,7 @@
           <a:noFill/>
         </p:spPr>
         <p:txBody>
-          <a:bodyPr wrap="square" lIns="0" rIns="0" tIns="0" bIns="0" anchor="t">
+          <a:bodyPr wrap="square" lIns="0" tIns="0" rIns="0" bIns="0" anchor="t">
             <a:spAutoFit/>
           </a:bodyPr>
           <a:lstStyle/>
@@ -9538,7 +9476,7 @@
           <a:noFill/>
         </p:spPr>
         <p:txBody>
-          <a:bodyPr wrap="square" lIns="0" rIns="0" tIns="0" bIns="0" anchor="t">
+          <a:bodyPr wrap="square" lIns="0" tIns="0" rIns="0" bIns="0" anchor="t">
             <a:spAutoFit/>
           </a:bodyPr>
           <a:lstStyle/>
@@ -9601,6 +9539,7 @@
           <a:lstStyle/>
           <a:p>
             <a:pPr algn="ctr"/>
+            <a:endParaRPr/>
           </a:p>
         </p:txBody>
       </p:sp>
@@ -9640,7 +9579,7 @@
           </a:fontRef>
         </p:style>
         <p:txBody>
-          <a:bodyPr rtlCol="0" anchor="ctr" lIns="0" rIns="0" tIns="0" bIns="0"/>
+          <a:bodyPr lIns="0" tIns="0" rIns="0" bIns="0" rtlCol="0" anchor="ctr"/>
           <a:lstStyle/>
           <a:p>
             <a:pPr algn="ctr"/>
@@ -9673,7 +9612,7 @@
           <a:noFill/>
         </p:spPr>
         <p:txBody>
-          <a:bodyPr wrap="square" lIns="0" rIns="0" tIns="0" bIns="0" anchor="t">
+          <a:bodyPr wrap="square" lIns="0" tIns="0" rIns="0" bIns="0" anchor="t">
             <a:spAutoFit/>
           </a:bodyPr>
           <a:lstStyle/>
@@ -9712,7 +9651,7 @@
           <a:noFill/>
         </p:spPr>
         <p:txBody>
-          <a:bodyPr wrap="square" lIns="0" rIns="0" tIns="0" bIns="0" anchor="t">
+          <a:bodyPr wrap="square" lIns="0" tIns="0" rIns="0" bIns="0" anchor="t">
             <a:spAutoFit/>
           </a:bodyPr>
           <a:lstStyle/>
@@ -9776,6 +9715,7 @@
           <a:lstStyle/>
           <a:p>
             <a:pPr algn="ctr"/>
+            <a:endParaRPr/>
           </a:p>
         </p:txBody>
       </p:sp>
@@ -9815,7 +9755,7 @@
           </a:fontRef>
         </p:style>
         <p:txBody>
-          <a:bodyPr rtlCol="0" anchor="ctr" lIns="0" rIns="0" tIns="0" bIns="0"/>
+          <a:bodyPr lIns="0" tIns="0" rIns="0" bIns="0" rtlCol="0" anchor="ctr"/>
           <a:lstStyle/>
           <a:p>
             <a:pPr algn="ctr"/>
@@ -9869,7 +9809,7 @@
           </a:fontRef>
         </p:style>
         <p:txBody>
-          <a:bodyPr rtlCol="0" anchor="ctr" lIns="0" rIns="0" tIns="0" bIns="0"/>
+          <a:bodyPr lIns="0" tIns="0" rIns="0" bIns="0" rtlCol="0" anchor="ctr"/>
           <a:lstStyle/>
           <a:p>
             <a:pPr algn="ctr"/>
@@ -9902,7 +9842,7 @@
           <a:noFill/>
         </p:spPr>
         <p:txBody>
-          <a:bodyPr wrap="square" lIns="0" rIns="0" tIns="0" bIns="0" anchor="t">
+          <a:bodyPr wrap="square" lIns="0" tIns="0" rIns="0" bIns="0" anchor="t">
             <a:spAutoFit/>
           </a:bodyPr>
           <a:lstStyle/>
@@ -9941,7 +9881,7 @@
           <a:noFill/>
         </p:spPr>
         <p:txBody>
-          <a:bodyPr wrap="square" lIns="0" rIns="0" tIns="0" bIns="0" anchor="t">
+          <a:bodyPr wrap="square" lIns="0" tIns="0" rIns="0" bIns="0" anchor="t">
             <a:spAutoFit/>
           </a:bodyPr>
           <a:lstStyle/>
@@ -10004,6 +9944,7 @@
           <a:lstStyle/>
           <a:p>
             <a:pPr algn="ctr"/>
+            <a:endParaRPr/>
           </a:p>
         </p:txBody>
       </p:sp>
@@ -10043,7 +9984,7 @@
           </a:fontRef>
         </p:style>
         <p:txBody>
-          <a:bodyPr rtlCol="0" anchor="ctr" lIns="0" rIns="0" tIns="0" bIns="0"/>
+          <a:bodyPr lIns="0" tIns="0" rIns="0" bIns="0" rtlCol="0" anchor="ctr"/>
           <a:lstStyle/>
           <a:p>
             <a:pPr algn="ctr"/>
@@ -10076,7 +10017,7 @@
           <a:noFill/>
         </p:spPr>
         <p:txBody>
-          <a:bodyPr wrap="square" lIns="0" rIns="0" tIns="0" bIns="0" anchor="t">
+          <a:bodyPr wrap="square" lIns="0" tIns="0" rIns="0" bIns="0" anchor="t">
             <a:spAutoFit/>
           </a:bodyPr>
           <a:lstStyle/>
@@ -10115,7 +10056,7 @@
           <a:noFill/>
         </p:spPr>
         <p:txBody>
-          <a:bodyPr wrap="square" lIns="0" rIns="0" tIns="0" bIns="0" anchor="t">
+          <a:bodyPr wrap="square" lIns="0" tIns="0" rIns="0" bIns="0" anchor="t">
             <a:spAutoFit/>
           </a:bodyPr>
           <a:lstStyle/>
@@ -10155,7 +10096,7 @@
           <a:noFill/>
         </p:spPr>
         <p:txBody>
-          <a:bodyPr wrap="square" lIns="0" rIns="0" tIns="0" bIns="0" anchor="t">
+          <a:bodyPr wrap="square" lIns="0" tIns="0" rIns="0" bIns="0" anchor="t">
             <a:spAutoFit/>
           </a:bodyPr>
           <a:lstStyle/>
@@ -10217,6 +10158,7 @@
           <a:lstStyle/>
           <a:p>
             <a:pPr algn="ctr"/>
+            <a:endParaRPr/>
           </a:p>
         </p:txBody>
       </p:sp>
@@ -10260,6 +10202,7 @@
           <a:lstStyle/>
           <a:p>
             <a:pPr algn="ctr"/>
+            <a:endParaRPr/>
           </a:p>
         </p:txBody>
       </p:sp>
@@ -10280,7 +10223,7 @@
           <a:noFill/>
         </p:spPr>
         <p:txBody>
-          <a:bodyPr wrap="square" lIns="0" rIns="0" tIns="0" bIns="0" anchor="t">
+          <a:bodyPr wrap="square" lIns="0" tIns="0" rIns="0" bIns="0" anchor="t">
             <a:spAutoFit/>
           </a:bodyPr>
           <a:lstStyle/>
@@ -10311,7 +10254,7 @@
           <p:nvPr/>
         </p:nvPicPr>
         <p:blipFill>
-          <a:blip r:embed="rId2"/>
+          <a:blip r:embed="rId3"/>
           <a:stretch>
             <a:fillRect/>
           </a:stretch>
@@ -10335,7 +10278,7 @@
 </file>
 
 <file path=ppt/slides/slide7.xml><?xml version="1.0" encoding="utf-8"?>
-<p:sld xmlns:a="http://schemas.openxmlformats.org/drawingml/2006/main" xmlns:p="http://schemas.openxmlformats.org/presentationml/2006/main" xmlns:r="http://schemas.openxmlformats.org/officeDocument/2006/relationships">
+<p:sld xmlns:a="http://schemas.openxmlformats.org/drawingml/2006/main" xmlns:r="http://schemas.openxmlformats.org/officeDocument/2006/relationships" xmlns:p="http://schemas.openxmlformats.org/presentationml/2006/main">
   <p:cSld>
     <p:spTree>
       <p:nvGrpSpPr>
@@ -10343,7 +10286,14 @@
         <p:cNvGrpSpPr/>
         <p:nvPr/>
       </p:nvGrpSpPr>
-      <p:grpSpPr/>
+      <p:grpSpPr>
+        <a:xfrm>
+          <a:off x="0" y="0"/>
+          <a:ext cx="0" cy="0"/>
+          <a:chOff x="0" y="0"/>
+          <a:chExt cx="0" cy="0"/>
+        </a:xfrm>
+      </p:grpSpPr>
       <p:sp>
         <p:nvSpPr>
           <p:cNvPr id="2" name="Rectangle 1"/>
@@ -10384,6 +10334,7 @@
           <a:lstStyle/>
           <a:p>
             <a:pPr algn="ctr"/>
+            <a:endParaRPr/>
           </a:p>
         </p:txBody>
       </p:sp>
@@ -10404,7 +10355,7 @@
           <a:noFill/>
         </p:spPr>
         <p:txBody>
-          <a:bodyPr wrap="square" lIns="0" tIns="0" bIns="0" rIns="0">
+          <a:bodyPr wrap="square" lIns="0" tIns="0" rIns="0" bIns="0">
             <a:spAutoFit/>
           </a:bodyPr>
           <a:lstStyle/>
@@ -10477,6 +10428,7 @@
           <a:lstStyle/>
           <a:p>
             <a:pPr algn="ctr"/>
+            <a:endParaRPr/>
           </a:p>
         </p:txBody>
       </p:sp>
@@ -10497,7 +10449,7 @@
           <a:noFill/>
         </p:spPr>
         <p:txBody>
-          <a:bodyPr wrap="square" lIns="0" rIns="0" tIns="0" bIns="0" anchor="ctr">
+          <a:bodyPr wrap="square" lIns="0" tIns="0" rIns="0" bIns="0" anchor="ctr">
             <a:spAutoFit/>
           </a:bodyPr>
           <a:lstStyle/>
@@ -10536,7 +10488,7 @@
           <a:noFill/>
         </p:spPr>
         <p:txBody>
-          <a:bodyPr wrap="square" lIns="0" rIns="0" tIns="0" bIns="0">
+          <a:bodyPr wrap="square" lIns="0" tIns="0" rIns="0" bIns="0">
             <a:spAutoFit/>
           </a:bodyPr>
           <a:lstStyle/>
@@ -10702,6 +10654,7 @@
           <a:lstStyle/>
           <a:p>
             <a:pPr algn="ctr"/>
+            <a:endParaRPr/>
           </a:p>
         </p:txBody>
       </p:sp>
@@ -10722,7 +10675,7 @@
           <a:noFill/>
         </p:spPr>
         <p:txBody>
-          <a:bodyPr wrap="square" lIns="0" rIns="0" tIns="0" bIns="0" anchor="ctr">
+          <a:bodyPr wrap="square" lIns="0" tIns="0" rIns="0" bIns="0" anchor="ctr">
             <a:spAutoFit/>
           </a:bodyPr>
           <a:lstStyle/>
@@ -10802,6 +10755,7 @@
           <a:lstStyle/>
           <a:p>
             <a:pPr algn="ctr"/>
+            <a:endParaRPr/>
           </a:p>
         </p:txBody>
       </p:sp>
@@ -10845,6 +10799,7 @@
           <a:lstStyle/>
           <a:p>
             <a:pPr algn="ctr"/>
+            <a:endParaRPr/>
           </a:p>
         </p:txBody>
       </p:sp>
@@ -10865,7 +10820,7 @@
           <a:noFill/>
         </p:spPr>
         <p:txBody>
-          <a:bodyPr wrap="square" lIns="0" rIns="0" tIns="0" bIns="0" anchor="t">
+          <a:bodyPr wrap="square" lIns="0" tIns="0" rIns="0" bIns="0" anchor="t">
             <a:spAutoFit/>
           </a:bodyPr>
           <a:lstStyle/>
@@ -10896,7 +10851,7 @@
           <p:nvPr/>
         </p:nvPicPr>
         <p:blipFill>
-          <a:blip r:embed="rId2"/>
+          <a:blip r:embed="rId3"/>
           <a:stretch>
             <a:fillRect/>
           </a:stretch>
@@ -10920,7 +10875,7 @@
 </file>
 
 <file path=ppt/slides/slide8.xml><?xml version="1.0" encoding="utf-8"?>
-<p:sld xmlns:a="http://schemas.openxmlformats.org/drawingml/2006/main" xmlns:p="http://schemas.openxmlformats.org/presentationml/2006/main" xmlns:r="http://schemas.openxmlformats.org/officeDocument/2006/relationships">
+<p:sld xmlns:a="http://schemas.openxmlformats.org/drawingml/2006/main" xmlns:r="http://schemas.openxmlformats.org/officeDocument/2006/relationships" xmlns:p="http://schemas.openxmlformats.org/presentationml/2006/main">
   <p:cSld>
     <p:spTree>
       <p:nvGrpSpPr>
@@ -10928,7 +10883,14 @@
         <p:cNvGrpSpPr/>
         <p:nvPr/>
       </p:nvGrpSpPr>
-      <p:grpSpPr/>
+      <p:grpSpPr>
+        <a:xfrm>
+          <a:off x="0" y="0"/>
+          <a:ext cx="0" cy="0"/>
+          <a:chOff x="0" y="0"/>
+          <a:chExt cx="0" cy="0"/>
+        </a:xfrm>
+      </p:grpSpPr>
       <p:sp>
         <p:nvSpPr>
           <p:cNvPr id="2" name="Rectangle 1"/>
@@ -10969,6 +10931,7 @@
           <a:lstStyle/>
           <a:p>
             <a:pPr algn="ctr"/>
+            <a:endParaRPr/>
           </a:p>
         </p:txBody>
       </p:sp>
@@ -10989,7 +10952,7 @@
           <a:noFill/>
         </p:spPr>
         <p:txBody>
-          <a:bodyPr wrap="square" lIns="0" rIns="0" tIns="0" bIns="0" anchor="t">
+          <a:bodyPr wrap="square" lIns="0" tIns="0" rIns="0" bIns="0" anchor="t">
             <a:spAutoFit/>
           </a:bodyPr>
           <a:lstStyle/>
@@ -11028,7 +10991,7 @@
           <a:noFill/>
         </p:spPr>
         <p:txBody>
-          <a:bodyPr wrap="square" lIns="0" rIns="0" tIns="0" bIns="0" anchor="t">
+          <a:bodyPr wrap="square" lIns="0" tIns="0" rIns="0" bIns="0" anchor="t">
             <a:spAutoFit/>
           </a:bodyPr>
           <a:lstStyle/>
@@ -11067,7 +11030,7 @@
           <a:noFill/>
         </p:spPr>
         <p:txBody>
-          <a:bodyPr wrap="square" lIns="0" rIns="0" tIns="0" bIns="0" anchor="t">
+          <a:bodyPr wrap="square" lIns="0" tIns="0" rIns="0" bIns="0" anchor="t">
             <a:spAutoFit/>
           </a:bodyPr>
           <a:lstStyle/>
@@ -11129,6 +11092,7 @@
           <a:lstStyle/>
           <a:p>
             <a:pPr algn="ctr"/>
+            <a:endParaRPr/>
           </a:p>
         </p:txBody>
       </p:sp>
@@ -11141,7 +11105,7 @@
 </file>
 
 <file path=ppt/slides/slide9.xml><?xml version="1.0" encoding="utf-8"?>
-<p:sld xmlns:a="http://schemas.openxmlformats.org/drawingml/2006/main" xmlns:p="http://schemas.openxmlformats.org/presentationml/2006/main" xmlns:r="http://schemas.openxmlformats.org/officeDocument/2006/relationships">
+<p:sld xmlns:a="http://schemas.openxmlformats.org/drawingml/2006/main" xmlns:r="http://schemas.openxmlformats.org/officeDocument/2006/relationships" xmlns:p="http://schemas.openxmlformats.org/presentationml/2006/main">
   <p:cSld>
     <p:spTree>
       <p:nvGrpSpPr>
@@ -11149,7 +11113,14 @@
         <p:cNvGrpSpPr/>
         <p:nvPr/>
       </p:nvGrpSpPr>
-      <p:grpSpPr/>
+      <p:grpSpPr>
+        <a:xfrm>
+          <a:off x="0" y="0"/>
+          <a:ext cx="0" cy="0"/>
+          <a:chOff x="0" y="0"/>
+          <a:chExt cx="0" cy="0"/>
+        </a:xfrm>
+      </p:grpSpPr>
       <p:sp>
         <p:nvSpPr>
           <p:cNvPr id="2" name="Rectangle 1"/>
@@ -11190,6 +11161,7 @@
           <a:lstStyle/>
           <a:p>
             <a:pPr algn="ctr"/>
+            <a:endParaRPr/>
           </a:p>
         </p:txBody>
       </p:sp>
@@ -11210,7 +11182,7 @@
           <a:noFill/>
         </p:spPr>
         <p:txBody>
-          <a:bodyPr wrap="square" lIns="0" tIns="0" bIns="0" rIns="0">
+          <a:bodyPr wrap="square" lIns="0" tIns="0" rIns="0" bIns="0">
             <a:spAutoFit/>
           </a:bodyPr>
           <a:lstStyle/>
@@ -11281,6 +11253,7 @@
           <a:lstStyle/>
           <a:p>
             <a:pPr algn="ctr"/>
+            <a:endParaRPr/>
           </a:p>
         </p:txBody>
       </p:sp>
@@ -11301,7 +11274,7 @@
           <a:noFill/>
         </p:spPr>
         <p:txBody>
-          <a:bodyPr wrap="square" lIns="0" rIns="0" tIns="0" bIns="0" anchor="t">
+          <a:bodyPr wrap="square" lIns="0" tIns="0" rIns="0" bIns="0" anchor="t">
             <a:spAutoFit/>
           </a:bodyPr>
           <a:lstStyle/>
@@ -11340,7 +11313,7 @@
           <a:noFill/>
         </p:spPr>
         <p:txBody>
-          <a:bodyPr wrap="square" lIns="0" rIns="0" tIns="0" bIns="0" anchor="t">
+          <a:bodyPr wrap="square" lIns="0" tIns="0" rIns="0" bIns="0" anchor="t">
             <a:spAutoFit/>
           </a:bodyPr>
           <a:lstStyle/>
@@ -11379,7 +11352,7 @@
           <a:noFill/>
         </p:spPr>
         <p:txBody>
-          <a:bodyPr wrap="square" lIns="0" rIns="0" tIns="0" bIns="0">
+          <a:bodyPr wrap="square" lIns="0" tIns="0" rIns="0" bIns="0">
             <a:spAutoFit/>
           </a:bodyPr>
           <a:lstStyle/>
@@ -11509,6 +11482,7 @@
           <a:lstStyle/>
           <a:p>
             <a:pPr algn="ctr"/>
+            <a:endParaRPr/>
           </a:p>
         </p:txBody>
       </p:sp>
@@ -11529,7 +11503,7 @@
           <a:noFill/>
         </p:spPr>
         <p:txBody>
-          <a:bodyPr wrap="square" lIns="0" rIns="0" tIns="0" bIns="0" anchor="t">
+          <a:bodyPr wrap="square" lIns="0" tIns="0" rIns="0" bIns="0" anchor="t">
             <a:spAutoFit/>
           </a:bodyPr>
           <a:lstStyle/>
@@ -11568,7 +11542,7 @@
           <a:noFill/>
         </p:spPr>
         <p:txBody>
-          <a:bodyPr wrap="square" lIns="0" rIns="0" tIns="0" bIns="0" anchor="t">
+          <a:bodyPr wrap="square" lIns="0" tIns="0" rIns="0" bIns="0" anchor="t">
             <a:spAutoFit/>
           </a:bodyPr>
           <a:lstStyle/>
@@ -11607,7 +11581,7 @@
           <a:noFill/>
         </p:spPr>
         <p:txBody>
-          <a:bodyPr wrap="square" lIns="0" rIns="0" tIns="0" bIns="0">
+          <a:bodyPr wrap="square" lIns="0" tIns="0" rIns="0" bIns="0">
             <a:spAutoFit/>
           </a:bodyPr>
           <a:lstStyle/>
@@ -11737,6 +11711,7 @@
           <a:lstStyle/>
           <a:p>
             <a:pPr algn="ctr"/>
+            <a:endParaRPr/>
           </a:p>
         </p:txBody>
       </p:sp>
@@ -11780,6 +11755,7 @@
           <a:lstStyle/>
           <a:p>
             <a:pPr algn="ctr"/>
+            <a:endParaRPr/>
           </a:p>
         </p:txBody>
       </p:sp>
@@ -11800,7 +11776,7 @@
           <a:noFill/>
         </p:spPr>
         <p:txBody>
-          <a:bodyPr wrap="square" lIns="0" rIns="0" tIns="0" bIns="0" anchor="t">
+          <a:bodyPr wrap="square" lIns="0" tIns="0" rIns="0" bIns="0" anchor="t">
             <a:spAutoFit/>
           </a:bodyPr>
           <a:lstStyle/>
@@ -11831,7 +11807,7 @@
           <p:nvPr/>
         </p:nvPicPr>
         <p:blipFill>
-          <a:blip r:embed="rId2"/>
+          <a:blip r:embed="rId3"/>
           <a:stretch>
             <a:fillRect/>
           </a:stretch>
@@ -12185,44 +12161,44 @@
         <a:sysClr val="window" lastClr="FFFFFF"/>
       </a:lt1>
       <a:dk2>
-        <a:srgbClr val="1F497D"/>
+        <a:srgbClr val="0E2841"/>
       </a:dk2>
       <a:lt2>
-        <a:srgbClr val="EEECE1"/>
+        <a:srgbClr val="E8E8E8"/>
       </a:lt2>
       <a:accent1>
-        <a:srgbClr val="4F81BD"/>
+        <a:srgbClr val="156082"/>
       </a:accent1>
       <a:accent2>
-        <a:srgbClr val="C0504D"/>
+        <a:srgbClr val="E97132"/>
       </a:accent2>
       <a:accent3>
-        <a:srgbClr val="9BBB59"/>
+        <a:srgbClr val="196B24"/>
       </a:accent3>
       <a:accent4>
-        <a:srgbClr val="8064A2"/>
+        <a:srgbClr val="0F9ED5"/>
       </a:accent4>
       <a:accent5>
-        <a:srgbClr val="4BACC6"/>
+        <a:srgbClr val="A02B93"/>
       </a:accent5>
       <a:accent6>
-        <a:srgbClr val="F79646"/>
+        <a:srgbClr val="4EA72E"/>
       </a:accent6>
       <a:hlink>
-        <a:srgbClr val="0000FF"/>
+        <a:srgbClr val="467886"/>
       </a:hlink>
       <a:folHlink>
-        <a:srgbClr val="800080"/>
+        <a:srgbClr val="96607D"/>
       </a:folHlink>
     </a:clrScheme>
     <a:fontScheme name="Office">
       <a:majorFont>
-        <a:latin typeface="Calibri"/>
+        <a:latin typeface="Aptos Display" panose="02110004020202020204"/>
         <a:ea typeface=""/>
         <a:cs typeface=""/>
-        <a:font script="Jpan" typeface="ＭＳ Ｐゴシック"/>
+        <a:font script="Jpan" typeface="游ゴシック Light"/>
         <a:font script="Hang" typeface="맑은 고딕"/>
-        <a:font script="Hans" typeface="宋体"/>
+        <a:font script="Hans" typeface="等线 Light"/>
         <a:font script="Hant" typeface="新細明體"/>
         <a:font script="Arab" typeface="Times New Roman"/>
         <a:font script="Hebr" typeface="Times New Roman"/>
@@ -12250,14 +12226,31 @@
         <a:font script="Viet" typeface="Times New Roman"/>
         <a:font script="Uigh" typeface="Microsoft Uighur"/>
         <a:font script="Geor" typeface="Sylfaen"/>
+        <a:font script="Armn" typeface="Arial"/>
+        <a:font script="Bugi" typeface="Leelawadee UI"/>
+        <a:font script="Bopo" typeface="Microsoft JhengHei"/>
+        <a:font script="Java" typeface="Javanese Text"/>
+        <a:font script="Lisu" typeface="Segoe UI"/>
+        <a:font script="Mymr" typeface="Myanmar Text"/>
+        <a:font script="Nkoo" typeface="Ebrima"/>
+        <a:font script="Olck" typeface="Nirmala UI"/>
+        <a:font script="Osma" typeface="Ebrima"/>
+        <a:font script="Phag" typeface="Phagspa"/>
+        <a:font script="Syrn" typeface="Estrangelo Edessa"/>
+        <a:font script="Syrj" typeface="Estrangelo Edessa"/>
+        <a:font script="Syre" typeface="Estrangelo Edessa"/>
+        <a:font script="Sora" typeface="Nirmala UI"/>
+        <a:font script="Tale" typeface="Microsoft Tai Le"/>
+        <a:font script="Talu" typeface="Microsoft New Tai Lue"/>
+        <a:font script="Tfng" typeface="Ebrima"/>
       </a:majorFont>
       <a:minorFont>
-        <a:latin typeface="Calibri"/>
+        <a:latin typeface="Aptos" panose="02110004020202020204"/>
         <a:ea typeface=""/>
         <a:cs typeface=""/>
-        <a:font script="Jpan" typeface="ＭＳ Ｐゴシック"/>
+        <a:font script="Jpan" typeface="游ゴシック"/>
         <a:font script="Hang" typeface="맑은 고딕"/>
-        <a:font script="Hans" typeface="宋体"/>
+        <a:font script="Hans" typeface="等线"/>
         <a:font script="Hant" typeface="新細明體"/>
         <a:font script="Arab" typeface="Arial"/>
         <a:font script="Hebr" typeface="Arial"/>
@@ -12285,6 +12278,23 @@
         <a:font script="Viet" typeface="Arial"/>
         <a:font script="Uigh" typeface="Microsoft Uighur"/>
         <a:font script="Geor" typeface="Sylfaen"/>
+        <a:font script="Armn" typeface="Arial"/>
+        <a:font script="Bugi" typeface="Leelawadee UI"/>
+        <a:font script="Bopo" typeface="Microsoft JhengHei"/>
+        <a:font script="Java" typeface="Javanese Text"/>
+        <a:font script="Lisu" typeface="Segoe UI"/>
+        <a:font script="Mymr" typeface="Myanmar Text"/>
+        <a:font script="Nkoo" typeface="Ebrima"/>
+        <a:font script="Olck" typeface="Nirmala UI"/>
+        <a:font script="Osma" typeface="Ebrima"/>
+        <a:font script="Phag" typeface="Phagspa"/>
+        <a:font script="Syrn" typeface="Estrangelo Edessa"/>
+        <a:font script="Syrj" typeface="Estrangelo Edessa"/>
+        <a:font script="Syre" typeface="Estrangelo Edessa"/>
+        <a:font script="Sora" typeface="Nirmala UI"/>
+        <a:font script="Tale" typeface="Microsoft Tai Le"/>
+        <a:font script="Talu" typeface="Microsoft New Tai Lue"/>
+        <a:font script="Tfng" typeface="Ebrima"/>
       </a:minorFont>
     </a:fontScheme>
     <a:fmtScheme name="Office">
@@ -12296,180 +12306,136 @@
           <a:gsLst>
             <a:gs pos="0">
               <a:schemeClr val="phClr">
-                <a:tint val="50000"/>
-                <a:satMod val="300000"/>
+                <a:lumMod val="110000"/>
+                <a:satMod val="105000"/>
+                <a:tint val="67000"/>
               </a:schemeClr>
             </a:gs>
-            <a:gs pos="35000">
+            <a:gs pos="50000">
               <a:schemeClr val="phClr">
-                <a:tint val="37000"/>
-                <a:satMod val="300000"/>
+                <a:lumMod val="105000"/>
+                <a:satMod val="103000"/>
+                <a:tint val="73000"/>
               </a:schemeClr>
             </a:gs>
             <a:gs pos="100000">
               <a:schemeClr val="phClr">
-                <a:tint val="15000"/>
-                <a:satMod val="350000"/>
+                <a:lumMod val="105000"/>
+                <a:satMod val="109000"/>
+                <a:tint val="81000"/>
               </a:schemeClr>
             </a:gs>
           </a:gsLst>
-          <a:lin ang="16200000" scaled="1"/>
+          <a:lin ang="5400000" scaled="0"/>
         </a:gradFill>
         <a:gradFill rotWithShape="1">
           <a:gsLst>
             <a:gs pos="0">
               <a:schemeClr val="phClr">
-                <a:tint val="100000"/>
+                <a:satMod val="103000"/>
+                <a:lumMod val="102000"/>
+                <a:tint val="94000"/>
+              </a:schemeClr>
+            </a:gs>
+            <a:gs pos="50000">
+              <a:schemeClr val="phClr">
+                <a:satMod val="110000"/>
+                <a:lumMod val="100000"/>
                 <a:shade val="100000"/>
-                <a:satMod val="130000"/>
               </a:schemeClr>
             </a:gs>
             <a:gs pos="100000">
               <a:schemeClr val="phClr">
-                <a:tint val="50000"/>
-                <a:shade val="100000"/>
-                <a:satMod val="350000"/>
+                <a:lumMod val="99000"/>
+                <a:satMod val="120000"/>
+                <a:shade val="78000"/>
               </a:schemeClr>
             </a:gs>
           </a:gsLst>
-          <a:lin ang="16200000" scaled="0"/>
+          <a:lin ang="5400000" scaled="0"/>
         </a:gradFill>
       </a:fillStyleLst>
       <a:lnStyleLst>
-        <a:ln w="9525" cap="flat" cmpd="sng" algn="ctr">
+        <a:ln w="12700" cap="flat" cmpd="sng" algn="ctr">
           <a:solidFill>
-            <a:schemeClr val="phClr">
-              <a:shade val="95000"/>
-              <a:satMod val="105000"/>
-            </a:schemeClr>
+            <a:schemeClr val="phClr"/>
           </a:solidFill>
           <a:prstDash val="solid"/>
+          <a:miter lim="800000"/>
+        </a:ln>
+        <a:ln w="19050" cap="flat" cmpd="sng" algn="ctr">
+          <a:solidFill>
+            <a:schemeClr val="phClr"/>
+          </a:solidFill>
+          <a:prstDash val="solid"/>
+          <a:miter lim="800000"/>
         </a:ln>
         <a:ln w="25400" cap="flat" cmpd="sng" algn="ctr">
           <a:solidFill>
             <a:schemeClr val="phClr"/>
           </a:solidFill>
           <a:prstDash val="solid"/>
-        </a:ln>
-        <a:ln w="38100" cap="flat" cmpd="sng" algn="ctr">
-          <a:solidFill>
-            <a:schemeClr val="phClr"/>
-          </a:solidFill>
-          <a:prstDash val="solid"/>
+          <a:miter lim="800000"/>
         </a:ln>
       </a:lnStyleLst>
       <a:effectStyleLst>
         <a:effectStyle>
+          <a:effectLst/>
+        </a:effectStyle>
+        <a:effectStyle>
+          <a:effectLst/>
+        </a:effectStyle>
+        <a:effectStyle>
           <a:effectLst>
-            <a:outerShdw blurRad="40000" dist="20000" dir="5400000" rotWithShape="0">
+            <a:outerShdw blurRad="57150" dist="19050" dir="5400000" algn="ctr" rotWithShape="0">
               <a:srgbClr val="000000">
-                <a:alpha val="38000"/>
+                <a:alpha val="63000"/>
               </a:srgbClr>
             </a:outerShdw>
           </a:effectLst>
-        </a:effectStyle>
-        <a:effectStyle>
-          <a:effectLst>
-            <a:outerShdw blurRad="40000" dist="23000" dir="5400000" rotWithShape="0">
-              <a:srgbClr val="000000">
-                <a:alpha val="35000"/>
-              </a:srgbClr>
-            </a:outerShdw>
-          </a:effectLst>
-        </a:effectStyle>
-        <a:effectStyle>
-          <a:effectLst>
-            <a:outerShdw blurRad="40000" dist="23000" dir="5400000" rotWithShape="0">
-              <a:srgbClr val="000000">
-                <a:alpha val="35000"/>
-              </a:srgbClr>
-            </a:outerShdw>
-          </a:effectLst>
-          <a:scene3d>
-            <a:camera prst="orthographicFront">
-              <a:rot lat="0" lon="0" rev="0"/>
-            </a:camera>
-            <a:lightRig rig="threePt" dir="t">
-              <a:rot lat="0" lon="0" rev="1200000"/>
-            </a:lightRig>
-          </a:scene3d>
-          <a:sp3d>
-            <a:bevelT w="63500" h="25400"/>
-          </a:sp3d>
         </a:effectStyle>
       </a:effectStyleLst>
       <a:bgFillStyleLst>
         <a:solidFill>
           <a:schemeClr val="phClr"/>
         </a:solidFill>
+        <a:solidFill>
+          <a:schemeClr val="phClr">
+            <a:tint val="95000"/>
+            <a:satMod val="170000"/>
+          </a:schemeClr>
+        </a:solidFill>
         <a:gradFill rotWithShape="1">
           <a:gsLst>
             <a:gs pos="0">
               <a:schemeClr val="phClr">
-                <a:tint val="40000"/>
-                <a:satMod val="350000"/>
+                <a:tint val="93000"/>
+                <a:satMod val="150000"/>
+                <a:shade val="98000"/>
+                <a:lumMod val="102000"/>
               </a:schemeClr>
             </a:gs>
-            <a:gs pos="40000">
+            <a:gs pos="50000">
               <a:schemeClr val="phClr">
-                <a:tint val="45000"/>
-                <a:shade val="99000"/>
-                <a:satMod val="350000"/>
+                <a:tint val="98000"/>
+                <a:satMod val="130000"/>
+                <a:shade val="90000"/>
+                <a:lumMod val="103000"/>
               </a:schemeClr>
             </a:gs>
             <a:gs pos="100000">
               <a:schemeClr val="phClr">
-                <a:shade val="20000"/>
-                <a:satMod val="255000"/>
+                <a:shade val="63000"/>
+                <a:satMod val="120000"/>
               </a:schemeClr>
             </a:gs>
           </a:gsLst>
-          <a:path path="circle">
-            <a:fillToRect l="50000" t="-80000" r="50000" b="180000"/>
-          </a:path>
-        </a:gradFill>
-        <a:gradFill rotWithShape="1">
-          <a:gsLst>
-            <a:gs pos="0">
-              <a:schemeClr val="phClr">
-                <a:tint val="80000"/>
-                <a:satMod val="300000"/>
-              </a:schemeClr>
-            </a:gs>
-            <a:gs pos="100000">
-              <a:schemeClr val="phClr">
-                <a:shade val="30000"/>
-                <a:satMod val="200000"/>
-              </a:schemeClr>
-            </a:gs>
-          </a:gsLst>
-          <a:path path="circle">
-            <a:fillToRect l="50000" t="50000" r="50000" b="50000"/>
-          </a:path>
+          <a:lin ang="5400000" scaled="0"/>
         </a:gradFill>
       </a:bgFillStyleLst>
     </a:fmtScheme>
   </a:themeElements>
   <a:objectDefaults>
-    <a:spDef>
-      <a:spPr/>
-      <a:bodyPr/>
-      <a:lstStyle/>
-      <a:style>
-        <a:lnRef idx="1">
-          <a:schemeClr val="accent1"/>
-        </a:lnRef>
-        <a:fillRef idx="3">
-          <a:schemeClr val="accent1"/>
-        </a:fillRef>
-        <a:effectRef idx="2">
-          <a:schemeClr val="accent1"/>
-        </a:effectRef>
-        <a:fontRef idx="minor">
-          <a:schemeClr val="lt1"/>
-        </a:fontRef>
-      </a:style>
-    </a:spDef>
     <a:lnDef>
       <a:spPr/>
       <a:bodyPr/>
@@ -12491,5 +12457,10 @@
     </a:lnDef>
   </a:objectDefaults>
   <a:extraClrSchemeLst/>
+  <a:extLst>
+    <a:ext uri="{05A4C25C-085E-4340-85A3-A5531E510DB2}">
+      <thm15:themeFamily xmlns:thm15="http://schemas.microsoft.com/office/thememl/2012/main" name="Office Theme" id="{2E142A2C-CD16-42D6-873A-C26D2A0506FA}" vid="{1BDDFF52-6CD6-40A5-AB3C-68EB2F1E4D0A}"/>
+    </a:ext>
+  </a:extLst>
 </a:theme>
 </file>
</xml_diff>